<commit_message>
docs(training): make the deck's markdown prettier-stable at the generator
The repo's pre-commit hook reformatted the generated lab-companion.md, so the
committed file no longer matched a rebuild. The generator now emits what
prettier writes (prettier --check exit 0; 0-line diff), and drizzle/0003_* is a
code span instead of an accidental emphasis opener. pptx rebuilt and validated.

Co-Authored-By: Claude Opus 5.5 (1M context) <noreply@anthropic.com>
</commit_message>
<xml_diff>
--- a/docs/ai-agent-training/slides/lab-companion.pptx
+++ b/docs/ai-agent-training/slides/lab-companion.pptx
@@ -8672,8 +8672,25 @@
                   <a:srgbClr val="1B1F24"/>
                 </a:solidFill>
               </a:rPr>
-              <a:t>you read the SQL in drizzle/0003_*</a:t>
-            </a:r>
+              <a:t>you read the SQL in </a:t>
+            </a:r>
+            <a:pPr indent="0" marL="0">
+              <a:buNone/>
+            </a:pPr>
+            <a:r>
+              <a:rPr lang="en-US" sz="1400" dirty="0">
+                <a:solidFill>
+                  <a:srgbClr val="1B1F24"/>
+                </a:solidFill>
+                <a:latin typeface="Courier New" pitchFamily="34" charset="0"/>
+                <a:ea typeface="Courier New" pitchFamily="34" charset="-122"/>
+                <a:cs typeface="Courier New" pitchFamily="34" charset="-120"/>
+              </a:rPr>
+              <a:t>drizzle/0003_*</a:t>
+            </a:r>
+            <a:pPr indent="0" marL="0">
+              <a:buNone/>
+            </a:pPr>
             <a:endParaRPr lang="en-US" sz="1400" dirty="0"/>
           </a:p>
         </p:txBody>

</xml_diff>

<commit_message>
docs(training): fix the snags a learner dry run found
A separate thread followed the six modules as a learner (branch edu/dry-run, port 3000
taken, corepack enable refused). All labs went green; the snags were about what the
material does not say. Fixed: where to change the port, the lab helper finding the app
from .env (it used to hit whatever answered on 3000), the users spec edit in module 2, the
rebuild before re-sending Postman in module 3, the stdio tool list in module 4, the
Inspector's second token line and ports, chapter commits as diffs to read, a Postman check
that passed with no rotation, the scaffold skill's missing markers and two type traps, and
the lint warning on every verify.

verify 69/61; lab split unchanged; collection 24 requests / 28 assertions, 0 failed.

Co-Authored-By: Claude Opus 5.5 (1M context) <noreply@anthropic.com>
</commit_message>
<xml_diff>
--- a/docs/ai-agent-training/slides/lab-companion.pptx
+++ b/docs/ai-agent-training/slides/lab-companion.pptx
@@ -2031,7 +2031,7 @@
           <a:p>
             <a:r>
               <a:rPr lang="en-US" dirty="0"/>
-              <a:t>The Inspector listens on loopback only (127.0.0.1:6274). Its URL carries an API token: a credential. The three example servers in its list can be ignored. Secret values: the helper prints them; never paste them anywhere but the header field.</a:t>
+              <a:t>The Inspector listens on loopback only (127.0.0.1, ports 6274, 6275, 6278). Its startup output shows its API token twice, in the URL and on the Auth token line: both are a credential. The three example servers in its list can be ignored. Secret values: the helper prints them; never paste them anywhere but the header field.</a:t>
             </a:r>
             <a:endParaRPr lang="en-US" dirty="0"/>
           </a:p>
@@ -4731,7 +4731,7 @@
                   <a:srgbClr val="1B1F24"/>
                 </a:solidFill>
               </a:rPr>
-              <a:t>pnpm: command not found</a:t>
+              <a:t>Port 3000 is already in use</a:t>
             </a:r>
             <a:endParaRPr lang="en-US" sz="1600" dirty="0"/>
           </a:p>
@@ -4745,82 +4745,7 @@
                   <a:srgbClr val="2B3440"/>
                 </a:solidFill>
               </a:rPr>
-              <a:t>Run </a:t>
-            </a:r>
-            <a:pPr indent="0" marL="0">
-              <a:buNone/>
-            </a:pPr>
-            <a:r>
-              <a:rPr lang="en-US" sz="1400" dirty="0">
-                <a:solidFill>
-                  <a:srgbClr val="2B3440"/>
-                </a:solidFill>
-                <a:latin typeface="Courier New" pitchFamily="34" charset="0"/>
-                <a:ea typeface="Courier New" pitchFamily="34" charset="-122"/>
-                <a:cs typeface="Courier New" pitchFamily="34" charset="-120"/>
-              </a:rPr>
-              <a:t>corepack enable</a:t>
-            </a:r>
-            <a:pPr indent="0" marL="0">
-              <a:buNone/>
-            </a:pPr>
-            <a:r>
-              <a:rPr lang="en-US" sz="1400" dirty="0">
-                <a:solidFill>
-                  <a:srgbClr val="2B3440"/>
-                </a:solidFill>
-              </a:rPr>
-              <a:t>, or write </a:t>
-            </a:r>
-            <a:pPr indent="0" marL="0">
-              <a:buNone/>
-            </a:pPr>
-            <a:r>
-              <a:rPr lang="en-US" sz="1400" dirty="0">
-                <a:solidFill>
-                  <a:srgbClr val="2B3440"/>
-                </a:solidFill>
-                <a:latin typeface="Courier New" pitchFamily="34" charset="0"/>
-                <a:ea typeface="Courier New" pitchFamily="34" charset="-122"/>
-                <a:cs typeface="Courier New" pitchFamily="34" charset="-120"/>
-              </a:rPr>
-              <a:t>corepack pnpm</a:t>
-            </a:r>
-            <a:pPr indent="0" marL="0">
-              <a:buNone/>
-            </a:pPr>
-            <a:r>
-              <a:rPr lang="en-US" sz="1400" dirty="0">
-                <a:solidFill>
-                  <a:srgbClr val="2B3440"/>
-                </a:solidFill>
-              </a:rPr>
-              <a:t> instead of </a:t>
-            </a:r>
-            <a:pPr indent="0" marL="0">
-              <a:buNone/>
-            </a:pPr>
-            <a:r>
-              <a:rPr lang="en-US" sz="1400" dirty="0">
-                <a:solidFill>
-                  <a:srgbClr val="2B3440"/>
-                </a:solidFill>
-                <a:latin typeface="Courier New" pitchFamily="34" charset="0"/>
-                <a:ea typeface="Courier New" pitchFamily="34" charset="-122"/>
-                <a:cs typeface="Courier New" pitchFamily="34" charset="-120"/>
-              </a:rPr>
-              <a:t>pnpm</a:t>
-            </a:r>
-            <a:pPr indent="0" marL="0">
-              <a:buNone/>
-            </a:pPr>
-            <a:r>
-              <a:rPr lang="en-US" sz="1400" dirty="0">
-                <a:solidFill>
-                  <a:srgbClr val="2B3440"/>
-                </a:solidFill>
-              </a:rPr>
-              <a:t>.</a:t>
+              <a:t>Set PORT=3100 in .env, then use 3100 in Postman (baseUrl) and every URL. The lab helper reads PORT from .env.</a:t>
             </a:r>
             <a:endParaRPr lang="en-US" sz="1600" dirty="0"/>
           </a:p>
@@ -5799,13 +5724,64 @@
             <a:r>
               <a:rPr lang="en-US" sz="1400" dirty="0">
                 <a:solidFill>
-                  <a:srgbClr val="E6EDF3"/>
+                  <a:srgbClr val="8B98A5"/>
                 </a:solidFill>
                 <a:latin typeface="Courier New" pitchFamily="34" charset="0"/>
                 <a:ea typeface="Courier New" pitchFamily="34" charset="-122"/>
                 <a:cs typeface="Courier New" pitchFamily="34" charset="-120"/>
               </a:rPr>
-              <a:t>pnpm verify</a:t>
+              <a:t># add an allowed and a refused phone case</a:t>
+            </a:r>
+            <a:endParaRPr lang="en-US" sz="1400" dirty="0"/>
+          </a:p>
+          <a:p>
+            <a:pPr indent="0" marL="0">
+              <a:buNone/>
+            </a:pPr>
+            <a:r>
+              <a:rPr lang="en-US" sz="1400" dirty="0">
+                <a:solidFill>
+                  <a:srgbClr val="8B98A5"/>
+                </a:solidFill>
+                <a:latin typeface="Courier New" pitchFamily="34" charset="0"/>
+                <a:ea typeface="Courier New" pitchFamily="34" charset="-122"/>
+                <a:cs typeface="Courier New" pitchFamily="34" charset="-120"/>
+              </a:rPr>
+              <a:t>#   to test/users.e2e-spec.ts</a:t>
+            </a:r>
+            <a:endParaRPr lang="en-US" sz="1400" dirty="0"/>
+          </a:p>
+          <a:p>
+            <a:pPr indent="0" marL="0">
+              <a:buNone/>
+            </a:pPr>
+            <a:r>
+              <a:rPr lang="en-US" sz="1400" dirty="0">
+                <a:solidFill>
+                  <a:srgbClr val="E6EDF3"/>
+                </a:solidFill>
+                <a:latin typeface="Courier New" pitchFamily="34" charset="0"/>
+                <a:ea typeface="Courier New" pitchFamily="34" charset="-122"/>
+                <a:cs typeface="Courier New" pitchFamily="34" charset="-120"/>
+              </a:rPr>
+              <a:t>pnpm verify   # TS2345 phone missing? add</a:t>
+            </a:r>
+            <a:endParaRPr lang="en-US" sz="1400" dirty="0"/>
+          </a:p>
+          <a:p>
+            <a:pPr indent="0" marL="0">
+              <a:buNone/>
+            </a:pPr>
+            <a:r>
+              <a:rPr lang="en-US" sz="1400" dirty="0">
+                <a:solidFill>
+                  <a:srgbClr val="8B98A5"/>
+                </a:solidFill>
+                <a:latin typeface="Courier New" pitchFamily="34" charset="0"/>
+                <a:ea typeface="Courier New" pitchFamily="34" charset="-122"/>
+                <a:cs typeface="Courier New" pitchFamily="34" charset="-120"/>
+              </a:rPr>
+              <a:t>#   phone: null to users.service.spec.ts payloads</a:t>
             </a:r>
             <a:endParaRPr lang="en-US" sz="1400" dirty="0"/>
           </a:p>
@@ -7766,7 +7742,7 @@
               <a:buNone/>
             </a:pPr>
             <a:r>
-              <a:rPr lang="en-US" sz="1100" dirty="0">
+              <a:rPr lang="en-US" sz="1400" dirty="0">
                 <a:solidFill>
                   <a:srgbClr val="8B98A5"/>
                 </a:solidFill>
@@ -7776,14 +7752,14 @@
               </a:rPr>
               <a:t># send folder 03, then the lab:</a:t>
             </a:r>
-            <a:endParaRPr lang="en-US" sz="1100" dirty="0"/>
-          </a:p>
-          <a:p>
-            <a:pPr indent="0" marL="0">
-              <a:buNone/>
-            </a:pPr>
-            <a:r>
-              <a:rPr lang="en-US" sz="1100" dirty="0">
+            <a:endParaRPr lang="en-US" sz="1400" dirty="0"/>
+          </a:p>
+          <a:p>
+            <a:pPr indent="0" marL="0">
+              <a:buNone/>
+            </a:pPr>
+            <a:r>
+              <a:rPr lang="en-US" sz="1400" dirty="0">
                 <a:solidFill>
                   <a:srgbClr val="8B98A5"/>
                 </a:solidFill>
@@ -7793,14 +7769,14 @@
               </a:rPr>
               <a:t># unknown emails get a different message</a:t>
             </a:r>
-            <a:endParaRPr lang="en-US" sz="1100" dirty="0"/>
-          </a:p>
-          <a:p>
-            <a:pPr indent="0" marL="0">
-              <a:buNone/>
-            </a:pPr>
-            <a:r>
-              <a:rPr lang="en-US" sz="1100" dirty="0">
+            <a:endParaRPr lang="en-US" sz="1400" dirty="0"/>
+          </a:p>
+          <a:p>
+            <a:pPr indent="0" marL="0">
+              <a:buNone/>
+            </a:pPr>
+            <a:r>
+              <a:rPr lang="en-US" sz="1400" dirty="0">
                 <a:solidFill>
                   <a:srgbClr val="E6EDF3"/>
                 </a:solidFill>
@@ -7810,31 +7786,31 @@
               </a:rPr>
               <a:t>pnpm test:e2e   # which test fails?</a:t>
             </a:r>
-            <a:endParaRPr lang="en-US" sz="1100" dirty="0"/>
-          </a:p>
-          <a:p>
-            <a:pPr indent="0" marL="0">
-              <a:buNone/>
-            </a:pPr>
-            <a:r>
-              <a:rPr lang="en-US" sz="1100" dirty="0">
-                <a:solidFill>
-                  <a:srgbClr val="8B98A5"/>
+            <a:endParaRPr lang="en-US" sz="1400" dirty="0"/>
+          </a:p>
+          <a:p>
+            <a:pPr indent="0" marL="0">
+              <a:buNone/>
+            </a:pPr>
+            <a:r>
+              <a:rPr lang="en-US" sz="1400" dirty="0">
+                <a:solidFill>
+                  <a:srgbClr val="E6EDF3"/>
                 </a:solidFill>
                 <a:latin typeface="Courier New" pitchFamily="34" charset="0"/>
                 <a:ea typeface="Courier New" pitchFamily="34" charset="-122"/>
                 <a:cs typeface="Courier New" pitchFamily="34" charset="-120"/>
               </a:rPr>
-              <a:t># re-send 03 in Postman, then revert</a:t>
-            </a:r>
-            <a:endParaRPr lang="en-US" sz="1100" dirty="0"/>
-          </a:p>
-          <a:p>
-            <a:pPr indent="0" marL="0">
-              <a:buNone/>
-            </a:pPr>
-            <a:r>
-              <a:rPr lang="en-US" sz="1100" dirty="0">
+              <a:t>pnpm lab 03     # red too</a:t>
+            </a:r>
+            <a:endParaRPr lang="en-US" sz="1400" dirty="0"/>
+          </a:p>
+          <a:p>
+            <a:pPr indent="0" marL="0">
+              <a:buNone/>
+            </a:pPr>
+            <a:r>
+              <a:rPr lang="en-US" sz="1400" dirty="0">
                 <a:solidFill>
                   <a:srgbClr val="8B98A5"/>
                 </a:solidFill>
@@ -7842,16 +7818,16 @@
                 <a:ea typeface="Courier New" pitchFamily="34" charset="-122"/>
                 <a:cs typeface="Courier New" pitchFamily="34" charset="-120"/>
               </a:rPr>
-              <a:t># then send folder 04</a:t>
-            </a:r>
-            <a:endParaRPr lang="en-US" sz="1100" dirty="0"/>
-          </a:p>
-          <a:p>
-            <a:pPr indent="0" marL="0">
-              <a:buNone/>
-            </a:pPr>
-            <a:r>
-              <a:rPr lang="en-US" sz="1100" dirty="0">
+              <a:t># restart the app (Ctrl+C), then:</a:t>
+            </a:r>
+            <a:endParaRPr lang="en-US" sz="1400" dirty="0"/>
+          </a:p>
+          <a:p>
+            <a:pPr indent="0" marL="0">
+              <a:buNone/>
+            </a:pPr>
+            <a:r>
+              <a:rPr lang="en-US" sz="1400" dirty="0">
                 <a:solidFill>
                   <a:srgbClr val="E6EDF3"/>
                 </a:solidFill>
@@ -7859,9 +7835,60 @@
                 <a:ea typeface="Courier New" pitchFamily="34" charset="-122"/>
                 <a:cs typeface="Courier New" pitchFamily="34" charset="-120"/>
               </a:rPr>
-              <a:t>pnpm lab 03   # green now; break it, see red, revert</a:t>
-            </a:r>
-            <a:endParaRPr lang="en-US" sz="1100" dirty="0"/>
+              <a:t>pnpm build &amp;&amp; pnpm start</a:t>
+            </a:r>
+            <a:endParaRPr lang="en-US" sz="1400" dirty="0"/>
+          </a:p>
+          <a:p>
+            <a:pPr indent="0" marL="0">
+              <a:buNone/>
+            </a:pPr>
+            <a:r>
+              <a:rPr lang="en-US" sz="1400" dirty="0">
+                <a:solidFill>
+                  <a:srgbClr val="8B98A5"/>
+                </a:solidFill>
+                <a:latin typeface="Courier New" pitchFamily="34" charset="0"/>
+                <a:ea typeface="Courier New" pitchFamily="34" charset="-122"/>
+                <a:cs typeface="Courier New" pitchFamily="34" charset="-120"/>
+              </a:rPr>
+              <a:t># re-send 03 in Postman: red. Revert,</a:t>
+            </a:r>
+            <a:endParaRPr lang="en-US" sz="1400" dirty="0"/>
+          </a:p>
+          <a:p>
+            <a:pPr indent="0" marL="0">
+              <a:buNone/>
+            </a:pPr>
+            <a:r>
+              <a:rPr lang="en-US" sz="1400" dirty="0">
+                <a:solidFill>
+                  <a:srgbClr val="8B98A5"/>
+                </a:solidFill>
+                <a:latin typeface="Courier New" pitchFamily="34" charset="0"/>
+                <a:ea typeface="Courier New" pitchFamily="34" charset="-122"/>
+                <a:cs typeface="Courier New" pitchFamily="34" charset="-120"/>
+              </a:rPr>
+              <a:t>#   rebuild, restart: all green again</a:t>
+            </a:r>
+            <a:endParaRPr lang="en-US" sz="1400" dirty="0"/>
+          </a:p>
+          <a:p>
+            <a:pPr indent="0" marL="0">
+              <a:buNone/>
+            </a:pPr>
+            <a:r>
+              <a:rPr lang="en-US" sz="1400" dirty="0">
+                <a:solidFill>
+                  <a:srgbClr val="8B98A5"/>
+                </a:solidFill>
+                <a:latin typeface="Courier New" pitchFamily="34" charset="0"/>
+                <a:ea typeface="Courier New" pitchFamily="34" charset="-122"/>
+                <a:cs typeface="Courier New" pitchFamily="34" charset="-120"/>
+              </a:rPr>
+              <a:t># then send folder 04</a:t>
+            </a:r>
+            <a:endParaRPr lang="en-US" sz="1400" dirty="0"/>
           </a:p>
         </p:txBody>
       </p:sp>
@@ -8024,7 +8051,7 @@
                   <a:srgbClr val="FFFFFF"/>
                 </a:solidFill>
               </a:rPr>
-              <a:t>3. Me: unknown email → the same 401</a:t>
+              <a:t>3. Me: wrong password → the same 401</a:t>
             </a:r>
             <a:endParaRPr lang="en-US" sz="1300" dirty="0"/>
           </a:p>
@@ -8038,7 +8065,21 @@
                   <a:srgbClr val="FFFFFF"/>
                 </a:solidFill>
               </a:rPr>
-              <a:t>4. Me (Basic auth)</a:t>
+              <a:t>4. Me: unknown email → the same 401</a:t>
+            </a:r>
+            <a:endParaRPr lang="en-US" sz="1300" dirty="0"/>
+          </a:p>
+          <a:p>
+            <a:pPr indent="0" marL="0">
+              <a:buNone/>
+            </a:pPr>
+            <a:r>
+              <a:rPr lang="en-US" sz="1300" dirty="0">
+                <a:solidFill>
+                  <a:srgbClr val="FFFFFF"/>
+                </a:solidFill>
+              </a:rPr>
+              <a:t>5. Me (Basic auth)</a:t>
             </a:r>
             <a:endParaRPr lang="en-US" sz="1300" dirty="0"/>
           </a:p>
@@ -11114,7 +11155,7 @@
         <p:spPr>
           <a:xfrm>
             <a:off x="457200" y="1097280"/>
-            <a:ext cx="8229600" cy="3520440"/>
+            <a:ext cx="5212080" cy="3520440"/>
           </a:xfrm>
           <a:prstGeom prst="roundRect">
             <a:avLst>
@@ -11216,7 +11257,7 @@
         <p:spPr>
           <a:xfrm>
             <a:off x="1280160" y="1152144"/>
-            <a:ext cx="7223760" cy="256032"/>
+            <a:ext cx="4206240" cy="256032"/>
           </a:xfrm>
           <a:prstGeom prst="rect">
             <a:avLst/>
@@ -11255,7 +11296,7 @@
         <p:spPr>
           <a:xfrm>
             <a:off x="685800" y="1481328"/>
-            <a:ext cx="7772400" cy="3017520"/>
+            <a:ext cx="4754880" cy="3017520"/>
           </a:xfrm>
           <a:prstGeom prst="rect">
             <a:avLst/>
@@ -11271,7 +11312,7 @@
               <a:buNone/>
             </a:pPr>
             <a:r>
-              <a:rPr lang="en-US" sz="1200" dirty="0">
+              <a:rPr lang="en-US" sz="1000" dirty="0">
                 <a:solidFill>
                   <a:srgbClr val="8B98A5"/>
                 </a:solidFill>
@@ -11281,14 +11322,14 @@
               </a:rPr>
               <a:t>// src/mcp/notes.tools.ts</a:t>
             </a:r>
-            <a:endParaRPr lang="en-US" sz="1200" dirty="0"/>
-          </a:p>
-          <a:p>
-            <a:pPr indent="0" marL="0">
-              <a:buNone/>
-            </a:pPr>
-            <a:r>
-              <a:rPr lang="en-US" sz="1200" dirty="0">
+            <a:endParaRPr lang="en-US" sz="1000" dirty="0"/>
+          </a:p>
+          <a:p>
+            <a:pPr indent="0" marL="0">
+              <a:buNone/>
+            </a:pPr>
+            <a:r>
+              <a:rPr lang="en-US" sz="1000" dirty="0">
                 <a:solidFill>
                   <a:srgbClr val="E6EDF3"/>
                 </a:solidFill>
@@ -11298,14 +11339,14 @@
               </a:rPr>
               <a:t>@Tool({</a:t>
             </a:r>
-            <a:endParaRPr lang="en-US" sz="1200" dirty="0"/>
-          </a:p>
-          <a:p>
-            <a:pPr indent="0" marL="0">
-              <a:buNone/>
-            </a:pPr>
-            <a:r>
-              <a:rPr lang="en-US" sz="1200" dirty="0">
+            <a:endParaRPr lang="en-US" sz="1000" dirty="0"/>
+          </a:p>
+          <a:p>
+            <a:pPr indent="0" marL="0">
+              <a:buNone/>
+            </a:pPr>
+            <a:r>
+              <a:rPr lang="en-US" sz="1000" dirty="0">
                 <a:solidFill>
                   <a:srgbClr val="E6EDF3"/>
                 </a:solidFill>
@@ -11315,14 +11356,14 @@
               </a:rPr>
               <a:t>  name: 'publish-note',</a:t>
             </a:r>
-            <a:endParaRPr lang="en-US" sz="1200" dirty="0"/>
-          </a:p>
-          <a:p>
-            <a:pPr indent="0" marL="0">
-              <a:buNone/>
-            </a:pPr>
-            <a:r>
-              <a:rPr lang="en-US" sz="1200" dirty="0">
+            <a:endParaRPr lang="en-US" sz="1000" dirty="0"/>
+          </a:p>
+          <a:p>
+            <a:pPr indent="0" marL="0">
+              <a:buNone/>
+            </a:pPr>
+            <a:r>
+              <a:rPr lang="en-US" sz="1000" dirty="0">
                 <a:solidFill>
                   <a:srgbClr val="E6EDF3"/>
                 </a:solidFill>
@@ -11332,14 +11373,14 @@
               </a:rPr>
               <a:t>  description: 'Publish a note. A published note needs a non-empty body.',</a:t>
             </a:r>
-            <a:endParaRPr lang="en-US" sz="1200" dirty="0"/>
-          </a:p>
-          <a:p>
-            <a:pPr indent="0" marL="0">
-              <a:buNone/>
-            </a:pPr>
-            <a:r>
-              <a:rPr lang="en-US" sz="1200" dirty="0">
+            <a:endParaRPr lang="en-US" sz="1000" dirty="0"/>
+          </a:p>
+          <a:p>
+            <a:pPr indent="0" marL="0">
+              <a:buNone/>
+            </a:pPr>
+            <a:r>
+              <a:rPr lang="en-US" sz="1000" dirty="0">
                 <a:solidFill>
                   <a:srgbClr val="E6EDF3"/>
                 </a:solidFill>
@@ -11349,14 +11390,14 @@
               </a:rPr>
               <a:t>  parameters: z.object({ id: z.string().uuid() }),</a:t>
             </a:r>
-            <a:endParaRPr lang="en-US" sz="1200" dirty="0"/>
-          </a:p>
-          <a:p>
-            <a:pPr indent="0" marL="0">
-              <a:buNone/>
-            </a:pPr>
-            <a:r>
-              <a:rPr lang="en-US" sz="1200" dirty="0">
+            <a:endParaRPr lang="en-US" sz="1000" dirty="0"/>
+          </a:p>
+          <a:p>
+            <a:pPr indent="0" marL="0">
+              <a:buNone/>
+            </a:pPr>
+            <a:r>
+              <a:rPr lang="en-US" sz="1000" dirty="0">
                 <a:solidFill>
                   <a:srgbClr val="E6EDF3"/>
                 </a:solidFill>
@@ -11366,14 +11407,14 @@
               </a:rPr>
               <a:t>})</a:t>
             </a:r>
-            <a:endParaRPr lang="en-US" sz="1200" dirty="0"/>
-          </a:p>
-          <a:p>
-            <a:pPr indent="0" marL="0">
-              <a:buNone/>
-            </a:pPr>
-            <a:r>
-              <a:rPr lang="en-US" sz="1200" dirty="0">
+            <a:endParaRPr lang="en-US" sz="1000" dirty="0"/>
+          </a:p>
+          <a:p>
+            <a:pPr indent="0" marL="0">
+              <a:buNone/>
+            </a:pPr>
+            <a:r>
+              <a:rPr lang="en-US" sz="1000" dirty="0">
                 <a:solidFill>
                   <a:srgbClr val="E6EDF3"/>
                 </a:solidFill>
@@ -11383,14 +11424,14 @@
               </a:rPr>
               <a:t>publishNote(@Payload() { id }: { id: string }): Promise&lt;ToolResult&gt; {</a:t>
             </a:r>
-            <a:endParaRPr lang="en-US" sz="1200" dirty="0"/>
-          </a:p>
-          <a:p>
-            <a:pPr indent="0" marL="0">
-              <a:buNone/>
-            </a:pPr>
-            <a:r>
-              <a:rPr lang="en-US" sz="1200" dirty="0">
+            <a:endParaRPr lang="en-US" sz="1000" dirty="0"/>
+          </a:p>
+          <a:p>
+            <a:pPr indent="0" marL="0">
+              <a:buNone/>
+            </a:pPr>
+            <a:r>
+              <a:rPr lang="en-US" sz="1000" dirty="0">
                 <a:solidFill>
                   <a:srgbClr val="E6EDF3"/>
                 </a:solidFill>
@@ -11400,14 +11441,14 @@
               </a:rPr>
               <a:t>  return runTool(() =&gt; this.notes.update(id, { status: 'published' }));</a:t>
             </a:r>
-            <a:endParaRPr lang="en-US" sz="1200" dirty="0"/>
-          </a:p>
-          <a:p>
-            <a:pPr indent="0" marL="0">
-              <a:buNone/>
-            </a:pPr>
-            <a:r>
-              <a:rPr lang="en-US" sz="1200" dirty="0">
+            <a:endParaRPr lang="en-US" sz="1000" dirty="0"/>
+          </a:p>
+          <a:p>
+            <a:pPr indent="0" marL="0">
+              <a:buNone/>
+            </a:pPr>
+            <a:r>
+              <a:rPr lang="en-US" sz="1000" dirty="0">
                 <a:solidFill>
                   <a:srgbClr val="E6EDF3"/>
                 </a:solidFill>
@@ -11417,24 +11458,240 @@
               </a:rPr>
               <a:t>}</a:t>
             </a:r>
-            <a:endParaRPr lang="en-US" sz="1200" dirty="0"/>
-          </a:p>
-          <a:p>
-            <a:pPr indent="0" marL="0">
-              <a:buNone/>
-            </a:pPr>
-            <a:r>
-              <a:rPr lang="en-US" sz="1200" dirty="0">
-                <a:solidFill>
-                  <a:srgbClr val="E6EDF3"/>
+            <a:endParaRPr lang="en-US" sz="1000" dirty="0"/>
+          </a:p>
+          <a:p>
+            <a:pPr indent="0" marL="0">
+              <a:buNone/>
+            </a:pPr>
+            <a:r>
+              <a:rPr lang="en-US" sz="1000" dirty="0">
+                <a:solidFill>
+                  <a:srgbClr val="8B98A5"/>
                 </a:solidFill>
                 <a:latin typeface="Courier New" pitchFamily="34" charset="0"/>
                 <a:ea typeface="Courier New" pitchFamily="34" charset="-122"/>
                 <a:cs typeface="Courier New" pitchFamily="34" charset="-120"/>
               </a:rPr>
+              <a:t># then, in the terminal:</a:t>
+            </a:r>
+            <a:endParaRPr lang="en-US" sz="1000" dirty="0"/>
+          </a:p>
+          <a:p>
+            <a:pPr indent="0" marL="0">
+              <a:buNone/>
+            </a:pPr>
+            <a:r>
+              <a:rPr lang="en-US" sz="1000" dirty="0">
+                <a:solidFill>
+                  <a:srgbClr val="E6EDF3"/>
+                </a:solidFill>
+                <a:latin typeface="Courier New" pitchFamily="34" charset="0"/>
+                <a:ea typeface="Courier New" pitchFamily="34" charset="-122"/>
+                <a:cs typeface="Courier New" pitchFamily="34" charset="-120"/>
+              </a:rPr>
+              <a:t>pnpm verify   # red until you add publish-note to</a:t>
+            </a:r>
+            <a:endParaRPr lang="en-US" sz="1000" dirty="0"/>
+          </a:p>
+          <a:p>
+            <a:pPr indent="0" marL="0">
+              <a:buNone/>
+            </a:pPr>
+            <a:r>
+              <a:rPr lang="en-US" sz="1000" dirty="0">
+                <a:solidFill>
+                  <a:srgbClr val="8B98A5"/>
+                </a:solidFill>
+                <a:latin typeface="Courier New" pitchFamily="34" charset="0"/>
+                <a:ea typeface="Courier New" pitchFamily="34" charset="-122"/>
+                <a:cs typeface="Courier New" pitchFamily="34" charset="-120"/>
+              </a:rPr>
+              <a:t>#   the tool list in test/mcp-stdio.e2e-spec.ts</a:t>
+            </a:r>
+            <a:endParaRPr lang="en-US" sz="1000" dirty="0"/>
+          </a:p>
+          <a:p>
+            <a:pPr indent="0" marL="0">
+              <a:buNone/>
+            </a:pPr>
+            <a:r>
+              <a:rPr lang="en-US" sz="1000" dirty="0">
+                <a:solidFill>
+                  <a:srgbClr val="E6EDF3"/>
+                </a:solidFill>
+                <a:latin typeface="Courier New" pitchFamily="34" charset="0"/>
+                <a:ea typeface="Courier New" pitchFamily="34" charset="-122"/>
+                <a:cs typeface="Courier New" pitchFamily="34" charset="-120"/>
+              </a:rPr>
               <a:t>pnpm lab 06   # the lab check: all green?</a:t>
             </a:r>
-            <a:endParaRPr lang="en-US" sz="1200" dirty="0"/>
+            <a:endParaRPr lang="en-US" sz="1000" dirty="0"/>
+          </a:p>
+        </p:txBody>
+      </p:sp>
+      <p:sp>
+        <p:nvSpPr>
+          <p:cNvPr id="9" name="postman"/>
+          <p:cNvSpPr/>
+          <p:nvPr/>
+        </p:nvSpPr>
+        <p:spPr>
+          <a:xfrm>
+            <a:off x="5852160" y="1097280"/>
+            <a:ext cx="2834640" cy="3520440"/>
+          </a:xfrm>
+          <a:prstGeom prst="roundRect">
+            <a:avLst>
+              <a:gd name="adj" fmla="val 2581"/>
+            </a:avLst>
+          </a:prstGeom>
+          <a:solidFill>
+            <a:srgbClr val="EF5B25"/>
+          </a:solidFill>
+          <a:ln w="12700">
+            <a:solidFill>
+              <a:srgbClr val="EF5B25"/>
+            </a:solidFill>
+            <a:prstDash val="solid"/>
+          </a:ln>
+        </p:spPr>
+      </p:sp>
+      <p:pic>
+        <p:nvPicPr>
+          <p:cNvPr id="10" name="Image 0" descr="preencoded.png">    </p:cNvPr>
+          <p:cNvPicPr>
+            <a:picLocks noChangeAspect="1"/>
+          </p:cNvPicPr>
+          <p:nvPr/>
+        </p:nvPicPr>
+        <p:blipFill>
+          <a:blip r:embed="rId1"/>
+          <a:stretch>
+            <a:fillRect/>
+          </a:stretch>
+        </p:blipFill>
+        <p:spPr>
+          <a:xfrm>
+            <a:off x="6035040" y="1252728"/>
+            <a:ext cx="237744" cy="237744"/>
+          </a:xfrm>
+          <a:prstGeom prst="rect">
+            <a:avLst/>
+          </a:prstGeom>
+        </p:spPr>
+      </p:pic>
+      <p:sp>
+        <p:nvSpPr>
+          <p:cNvPr id="11" name="Text 8"/>
+          <p:cNvSpPr txBox="1"/>
+          <p:nvPr/>
+        </p:nvSpPr>
+        <p:spPr>
+          <a:xfrm>
+            <a:off x="6355080" y="1207008"/>
+            <a:ext cx="2148840" cy="329184"/>
+          </a:xfrm>
+          <a:prstGeom prst="rect">
+            <a:avLst/>
+          </a:prstGeom>
+          <a:noFill/>
+          <a:ln/>
+        </p:spPr>
+        <p:txBody>
+          <a:bodyPr wrap="square" lIns="0" tIns="0" rIns="0" bIns="0" rtlCol="0" anchor="ctr"/>
+          <a:lstStyle/>
+          <a:p>
+            <a:pPr indent="0" marL="0">
+              <a:buNone/>
+            </a:pPr>
+            <a:r>
+              <a:rPr lang="en-US" sz="1600" b="1" dirty="0">
+                <a:solidFill>
+                  <a:srgbClr val="FFFFFF"/>
+                </a:solidFill>
+              </a:rPr>
+              <a:t>In Postman</a:t>
+            </a:r>
+            <a:endParaRPr lang="en-US" sz="1600" dirty="0"/>
+          </a:p>
+        </p:txBody>
+      </p:sp>
+      <p:sp>
+        <p:nvSpPr>
+          <p:cNvPr id="12" name="postman-requests"/>
+          <p:cNvSpPr txBox="1"/>
+          <p:nvPr/>
+        </p:nvSpPr>
+        <p:spPr>
+          <a:xfrm>
+            <a:off x="6035040" y="1645920"/>
+            <a:ext cx="2468880" cy="2834640"/>
+          </a:xfrm>
+          <a:prstGeom prst="rect">
+            <a:avLst/>
+          </a:prstGeom>
+          <a:noFill/>
+          <a:ln/>
+        </p:spPr>
+        <p:txBody>
+          <a:bodyPr wrap="square" lIns="0" tIns="0" rIns="0" bIns="0" rtlCol="0" anchor="t"/>
+          <a:lstStyle/>
+          <a:p>
+            <a:pPr indent="0" marL="0">
+              <a:buNone/>
+            </a:pPr>
+            <a:r>
+              <a:rPr lang="en-US" sz="1300" b="1" dirty="0">
+                <a:solidFill>
+                  <a:srgbClr val="FFFFFF"/>
+                </a:solidFill>
+              </a:rPr>
+              <a:t>06 · Notes over REST (module 4)</a:t>
+            </a:r>
+            <a:endParaRPr lang="en-US" sz="1300" dirty="0"/>
+          </a:p>
+          <a:p>
+            <a:pPr indent="0" marL="0">
+              <a:buNone/>
+            </a:pPr>
+            <a:r>
+              <a:rPr lang="en-US" sz="1300" dirty="0">
+                <a:solidFill>
+                  <a:srgbClr val="FFFFFF"/>
+                </a:solidFill>
+              </a:rPr>
+              <a:t>1. Create note (draft, empty body)</a:t>
+            </a:r>
+            <a:endParaRPr lang="en-US" sz="1300" dirty="0"/>
+          </a:p>
+          <a:p>
+            <a:pPr indent="0" marL="0">
+              <a:buNone/>
+            </a:pPr>
+            <a:r>
+              <a:rPr lang="en-US" sz="1300" dirty="0">
+                <a:solidFill>
+                  <a:srgbClr val="FFFFFF"/>
+                </a:solidFill>
+              </a:rPr>
+              <a:t>2. Publish it → 422 RULE_VIOLATION</a:t>
+            </a:r>
+            <a:endParaRPr lang="en-US" sz="1300" dirty="0"/>
+          </a:p>
+          <a:p>
+            <a:pPr indent="0" marL="0">
+              <a:buNone/>
+            </a:pPr>
+            <a:r>
+              <a:rPr lang="en-US" sz="1300" dirty="0">
+                <a:solidFill>
+                  <a:srgbClr val="FFFFFF"/>
+                </a:solidFill>
+              </a:rPr>
+              <a:t>3. Get note</a:t>
+            </a:r>
+            <a:endParaRPr lang="en-US" sz="1300" dirty="0"/>
           </a:p>
         </p:txBody>
       </p:sp>
@@ -14094,6 +14351,23 @@
                 <a:ea typeface="Courier New" pitchFamily="34" charset="-122"/>
                 <a:cs typeface="Courier New" pitchFamily="34" charset="-120"/>
               </a:rPr>
+              <a:t>#   (its test goes red: that is the point)</a:t>
+            </a:r>
+            <a:endParaRPr lang="en-US" sz="1100" dirty="0"/>
+          </a:p>
+          <a:p>
+            <a:pPr indent="0" marL="0">
+              <a:buNone/>
+            </a:pPr>
+            <a:r>
+              <a:rPr lang="en-US" sz="1100" dirty="0">
+                <a:solidFill>
+                  <a:srgbClr val="8B98A5"/>
+                </a:solidFill>
+                <a:latin typeface="Courier New" pitchFamily="34" charset="0"/>
+                <a:ea typeface="Courier New" pitchFamily="34" charset="-122"/>
+                <a:cs typeface="Courier New" pitchFamily="34" charset="-120"/>
+              </a:rPr>
               <a:t># then revert enableJsonResponse</a:t>
             </a:r>
             <a:endParaRPr lang="en-US" sz="1100" dirty="0"/>
@@ -15565,7 +15839,7 @@
                   <a:srgbClr val="2B3440"/>
                 </a:solidFill>
               </a:rPr>
-              <a:t>Add that name to MCP_ALLOWED_HOSTS: localhost,&lt;hostname&gt; (measured: 403 without, 200 with).</a:t>
+              <a:t>With valid device headers (without them it is 401: auth runs first). Add the name to MCP_ALLOWED_HOSTS: localhost,&lt;hostname&gt;.</a:t>
             </a:r>
             <a:endParaRPr lang="en-US" sz="1600" dirty="0"/>
           </a:p>
@@ -21802,7 +22076,7 @@
                 <a:ea typeface="Courier New" pitchFamily="34" charset="-122"/>
                 <a:cs typeface="Courier New" pitchFamily="34" charset="-120"/>
               </a:rPr>
-              <a:t>corepack enable &amp;&amp; pnpm install</a:t>
+              <a:t>corepack enable   # refused? use corepack pnpm</a:t>
             </a:r>
             <a:endParaRPr lang="en-US" sz="1400" dirty="0"/>
           </a:p>
@@ -21819,7 +22093,7 @@
                 <a:ea typeface="Courier New" pitchFamily="34" charset="-122"/>
                 <a:cs typeface="Courier New" pitchFamily="34" charset="-120"/>
               </a:rPr>
-              <a:t>cp .env.example .env</a:t>
+              <a:t>pnpm install</a:t>
             </a:r>
             <a:endParaRPr lang="en-US" sz="1400" dirty="0"/>
           </a:p>
@@ -21836,7 +22110,7 @@
                 <a:ea typeface="Courier New" pitchFamily="34" charset="-122"/>
                 <a:cs typeface="Courier New" pitchFamily="34" charset="-120"/>
               </a:rPr>
-              <a:t>pnpm build &amp;&amp; pnpm db:migrate</a:t>
+              <a:t>cp .env.example .env   # port busy? set PORT= here</a:t>
             </a:r>
             <a:endParaRPr lang="en-US" sz="1400" dirty="0"/>
           </a:p>
@@ -21853,7 +22127,7 @@
                 <a:ea typeface="Courier New" pitchFamily="34" charset="-122"/>
                 <a:cs typeface="Courier New" pitchFamily="34" charset="-120"/>
               </a:rPr>
-              <a:t>pnpm verify                # 69 + 61 tests</a:t>
+              <a:t>pnpm build &amp;&amp; pnpm db:migrate</a:t>
             </a:r>
             <a:endParaRPr lang="en-US" sz="1400" dirty="0"/>
           </a:p>
@@ -21864,13 +22138,47 @@
             <a:r>
               <a:rPr lang="en-US" sz="1400" dirty="0">
                 <a:solidFill>
-                  <a:srgbClr val="8B98A5"/>
+                  <a:srgbClr val="E6EDF3"/>
                 </a:solidFill>
                 <a:latin typeface="Courier New" pitchFamily="34" charset="0"/>
                 <a:ea typeface="Courier New" pitchFamily="34" charset="-122"/>
                 <a:cs typeface="Courier New" pitchFamily="34" charset="-120"/>
               </a:rPr>
-              <a:t># write specs/orders.md (copy specs/notes.md), then:</a:t>
+              <a:t>pnpm verify                # 69 + 61 tests</a:t>
+            </a:r>
+            <a:endParaRPr lang="en-US" sz="1400" dirty="0"/>
+          </a:p>
+          <a:p>
+            <a:pPr indent="0" marL="0">
+              <a:buNone/>
+            </a:pPr>
+            <a:r>
+              <a:rPr lang="en-US" sz="1400" dirty="0">
+                <a:solidFill>
+                  <a:srgbClr val="8B98A5"/>
+                </a:solidFill>
+                <a:latin typeface="Courier New" pitchFamily="34" charset="0"/>
+                <a:ea typeface="Courier New" pitchFamily="34" charset="-122"/>
+                <a:cs typeface="Courier New" pitchFamily="34" charset="-120"/>
+              </a:rPr>
+              <a:t># write specs/orders.md (copy specs/notes.md);</a:t>
+            </a:r>
+            <a:endParaRPr lang="en-US" sz="1400" dirty="0"/>
+          </a:p>
+          <a:p>
+            <a:pPr indent="0" marL="0">
+              <a:buNone/>
+            </a:pPr>
+            <a:r>
+              <a:rPr lang="en-US" sz="1400" dirty="0">
+                <a:solidFill>
+                  <a:srgbClr val="8B98A5"/>
+                </a:solidFill>
+                <a:latin typeface="Courier New" pitchFamily="34" charset="0"/>
+                <a:ea typeface="Courier New" pitchFamily="34" charset="-122"/>
+                <a:cs typeface="Courier New" pitchFamily="34" charset="-120"/>
+              </a:rPr>
+              <a:t>#   the contract: test/labs/README.md, 01. Then:</a:t>
             </a:r>
             <a:endParaRPr lang="en-US" sz="1400" dirty="0"/>
           </a:p>
@@ -22806,7 +23114,32 @@
                   <a:srgbClr val="1B1F24"/>
                 </a:solidFill>
               </a:rPr>
-              <a:t>delete one service rule: exactly one test goes red</a:t>
+              <a:t>delete O2 from the service: </a:t>
+            </a:r>
+            <a:pPr indent="0" marL="0">
+              <a:buNone/>
+            </a:pPr>
+            <a:r>
+              <a:rPr lang="en-US" sz="1400" dirty="0">
+                <a:solidFill>
+                  <a:srgbClr val="1B1F24"/>
+                </a:solidFill>
+                <a:latin typeface="Courier New" pitchFamily="34" charset="0"/>
+                <a:ea typeface="Courier New" pitchFamily="34" charset="-122"/>
+                <a:cs typeface="Courier New" pitchFamily="34" charset="-120"/>
+              </a:rPr>
+              <a:t>pnpm exec vitest run src/orders</a:t>
+            </a:r>
+            <a:pPr indent="0" marL="0">
+              <a:buNone/>
+            </a:pPr>
+            <a:r>
+              <a:rPr lang="en-US" sz="1400" dirty="0">
+                <a:solidFill>
+                  <a:srgbClr val="1B1F24"/>
+                </a:solidFill>
+              </a:rPr>
+              <a:t> shows one red test</a:t>
             </a:r>
             <a:endParaRPr lang="en-US" sz="1400" dirty="0"/>
           </a:p>

</xml_diff>

<commit_message>
deck: the two NestJS slides are simple block diagrams
Slide 3, request flow: Request → Middleware → Controller → Service → Database. Slide 4, who
calls whom: a Module holding Controller → Service → Repository, Middleware outside pointing
at the Controller, the Database beside the Repository. Explanations in the speaker notes.

Co-Authored-By: Claude Opus 5.5 (1M context) <noreply@anthropic.com>
</commit_message>
<xml_diff>
--- a/docs/ai-agent-training/slides/lab-companion.pptx
+++ b/docs/ai-agent-training/slides/lab-companion.pptx
@@ -1754,7 +1754,7 @@
           <a:p>
             <a:r>
               <a:rPr lang="en-US" dirty="0"/>
-              <a:t>Middleware runs before Nest even picks the route, so it sees every request; guards and pipes run per route, then the controller. The controller never decides a business rule: it calls the service. The arrow back is the same for errors: services throw, the exception filter maps the error to one HTTP shape. In module 1 the learner's agent builds the controller, service and repository; the middleware, the global pipe and the filter already exist.</a:t>
+              <a:t>Every request passes middleware first, then reaches a controller. The controller does no business logic: it calls a service. The service holds the rules and reads or writes the database (through a repository). The answer travels back the same way.</a:t>
             </a:r>
             <a:endParaRPr lang="en-US" dirty="0"/>
           </a:p>
@@ -1842,7 +1842,7 @@
           <a:p>
             <a:r>
               <a:rPr lang="en-US" dirty="0"/>
-              <a:t>A module is the unit nest g resource creates. It declares the controller and the providers; Nest creates each once and hands them to whoever asks in a constructor (dependency injection). The controller asks for the service, the service asks for the repository TOKEN, not a class, so the storage can be swapped in the module alone. Middleware is attached in a module too, with configure(consumer). AppModule imports every feature module.</a:t>
+              <a:t>A module groups one feature: its controller, its service and its repository. The controller calls the service; the service calls the repository; Nest connects them (dependency injection). Middleware sits outside the feature and runs before the controller. In module 1 your agent builds one module for users and one for notes.</a:t>
             </a:r>
             <a:endParaRPr lang="en-US" dirty="0"/>
           </a:p>
@@ -11542,7 +11542,7 @@
                   <a:srgbClr val="1B1F24"/>
                 </a:solidFill>
               </a:rPr>
-              <a:t>NestJS: the path of one request</a:t>
+              <a:t>NestJS: request flow</a:t>
             </a:r>
             <a:endParaRPr lang="en-US" sz="3200" dirty="0"/>
           </a:p>
@@ -11550,141 +11550,18 @@
       </p:sp>
       <p:sp>
         <p:nvSpPr>
-          <p:cNvPr id="3" name="step-1"/>
-          <p:cNvSpPr/>
-          <p:nvPr/>
-        </p:nvSpPr>
-        <p:spPr>
-          <a:xfrm>
-            <a:off x="457200" y="1234440"/>
-            <a:ext cx="1050254" cy="658368"/>
+          <p:cNvPr id="3" name="block-1"/>
+          <p:cNvSpPr/>
+          <p:nvPr/>
+        </p:nvSpPr>
+        <p:spPr>
+          <a:xfrm>
+            <a:off x="457200" y="1828800"/>
+            <a:ext cx="1316736" cy="1005840"/>
           </a:xfrm>
           <a:prstGeom prst="roundRect">
             <a:avLst>
-              <a:gd name="adj" fmla="val 11111"/>
-            </a:avLst>
-          </a:prstGeom>
-          <a:solidFill>
-            <a:srgbClr val="2B3440"/>
-          </a:solidFill>
-          <a:ln w="12700">
-            <a:solidFill>
-              <a:srgbClr val="2B3440"/>
-            </a:solidFill>
-            <a:prstDash val="solid"/>
-          </a:ln>
-        </p:spPr>
-      </p:sp>
-      <p:sp>
-        <p:nvSpPr>
-          <p:cNvPr id="4" name="Text 2"/>
-          <p:cNvSpPr txBox="1"/>
-          <p:nvPr/>
-        </p:nvSpPr>
-        <p:spPr>
-          <a:xfrm>
-            <a:off x="457200" y="1234440"/>
-            <a:ext cx="1050254" cy="658368"/>
-          </a:xfrm>
-          <a:prstGeom prst="rect">
-            <a:avLst/>
-          </a:prstGeom>
-          <a:noFill/>
-          <a:ln/>
-        </p:spPr>
-        <p:txBody>
-          <a:bodyPr wrap="square" lIns="25400" tIns="25400" rIns="25400" bIns="25400" rtlCol="0" anchor="ctr"/>
-          <a:lstStyle/>
-          <a:p>
-            <a:pPr algn="ctr" indent="0" marL="0">
-              <a:buNone/>
-            </a:pPr>
-            <a:r>
-              <a:rPr lang="en-US" sz="1200" b="1" dirty="0">
-                <a:solidFill>
-                  <a:srgbClr val="FFFFFF"/>
-                </a:solidFill>
-              </a:rPr>
-              <a:t>Client</a:t>
-            </a:r>
-            <a:endParaRPr lang="en-US" sz="1200" dirty="0"/>
-          </a:p>
-        </p:txBody>
-      </p:sp>
-      <p:sp>
-        <p:nvSpPr>
-          <p:cNvPr id="5" name="Shape 3"/>
-          <p:cNvSpPr/>
-          <p:nvPr/>
-        </p:nvSpPr>
-        <p:spPr>
-          <a:xfrm>
-            <a:off x="1507454" y="1563624"/>
-            <a:ext cx="146304" cy="0"/>
-          </a:xfrm>
-          <a:prstGeom prst="line">
-            <a:avLst/>
-          </a:prstGeom>
-          <a:noFill/>
-          <a:ln w="19050">
-            <a:solidFill>
-              <a:srgbClr val="64748B"/>
-            </a:solidFill>
-            <a:prstDash val="solid"/>
-            <a:tailEnd type="triangle"/>
-          </a:ln>
-        </p:spPr>
-      </p:sp>
-      <p:sp>
-        <p:nvSpPr>
-          <p:cNvPr id="6" name="Text 4"/>
-          <p:cNvSpPr txBox="1"/>
-          <p:nvPr/>
-        </p:nvSpPr>
-        <p:spPr>
-          <a:xfrm>
-            <a:off x="457200" y="2002536"/>
-            <a:ext cx="1050254" cy="1417320"/>
-          </a:xfrm>
-          <a:prstGeom prst="rect">
-            <a:avLst/>
-          </a:prstGeom>
-          <a:noFill/>
-          <a:ln/>
-        </p:spPr>
-        <p:txBody>
-          <a:bodyPr wrap="square" lIns="0" tIns="0" rIns="0" bIns="0" rtlCol="0" anchor="t"/>
-          <a:lstStyle/>
-          <a:p>
-            <a:pPr algn="ctr" indent="0" marL="0">
-              <a:buNone/>
-            </a:pPr>
-            <a:r>
-              <a:rPr lang="en-US" sz="1100" dirty="0">
-                <a:solidFill>
-                  <a:srgbClr val="2B3440"/>
-                </a:solidFill>
-              </a:rPr>
-              <a:t>Postman, curl, a browser</a:t>
-            </a:r>
-            <a:endParaRPr lang="en-US" sz="1100" dirty="0"/>
-          </a:p>
-        </p:txBody>
-      </p:sp>
-      <p:sp>
-        <p:nvSpPr>
-          <p:cNvPr id="7" name="step-2"/>
-          <p:cNvSpPr/>
-          <p:nvPr/>
-        </p:nvSpPr>
-        <p:spPr>
-          <a:xfrm>
-            <a:off x="1653758" y="1234440"/>
-            <a:ext cx="1050254" cy="658368"/>
-          </a:xfrm>
-          <a:prstGeom prst="roundRect">
-            <a:avLst>
-              <a:gd name="adj" fmla="val 11111"/>
+              <a:gd name="adj" fmla="val 9091"/>
             </a:avLst>
           </a:prstGeom>
           <a:solidFill>
@@ -11700,14 +11577,14 @@
       </p:sp>
       <p:sp>
         <p:nvSpPr>
-          <p:cNvPr id="8" name="Text 6"/>
+          <p:cNvPr id="4" name="Text 2"/>
           <p:cNvSpPr txBox="1"/>
           <p:nvPr/>
         </p:nvSpPr>
         <p:spPr>
           <a:xfrm>
-            <a:off x="1653758" y="1234440"/>
-            <a:ext cx="1050254" cy="658368"/>
+            <a:off x="457200" y="1828800"/>
+            <a:ext cx="1316736" cy="1005840"/>
           </a:xfrm>
           <a:prstGeom prst="rect">
             <a:avLst/>
@@ -11723,33 +11600,69 @@
               <a:buNone/>
             </a:pPr>
             <a:r>
-              <a:rPr lang="en-US" sz="1200" b="1" dirty="0">
+              <a:rPr lang="en-US" sz="1600" b="1" dirty="0">
                 <a:solidFill>
                   <a:srgbClr val="FFFFFF"/>
                 </a:solidFill>
               </a:rPr>
-              <a:t>Middleware</a:t>
-            </a:r>
-            <a:endParaRPr lang="en-US" sz="1200" dirty="0"/>
-          </a:p>
-        </p:txBody>
-      </p:sp>
-      <p:sp>
-        <p:nvSpPr>
-          <p:cNvPr id="9" name="Shape 7"/>
-          <p:cNvSpPr/>
-          <p:nvPr/>
-        </p:nvSpPr>
-        <p:spPr>
-          <a:xfrm>
-            <a:off x="2704011" y="1563624"/>
-            <a:ext cx="146304" cy="0"/>
+              <a:t>Request</a:t>
+            </a:r>
+            <a:endParaRPr lang="en-US" sz="1600" dirty="0"/>
+          </a:p>
+        </p:txBody>
+      </p:sp>
+      <p:sp>
+        <p:nvSpPr>
+          <p:cNvPr id="5" name="Text 3"/>
+          <p:cNvSpPr txBox="1"/>
+          <p:nvPr/>
+        </p:nvSpPr>
+        <p:spPr>
+          <a:xfrm>
+            <a:off x="457200" y="2971800"/>
+            <a:ext cx="1316736" cy="365760"/>
+          </a:xfrm>
+          <a:prstGeom prst="rect">
+            <a:avLst/>
+          </a:prstGeom>
+          <a:noFill/>
+          <a:ln/>
+        </p:spPr>
+        <p:txBody>
+          <a:bodyPr wrap="square" lIns="0" tIns="0" rIns="0" bIns="0" rtlCol="0" anchor="ctr"/>
+          <a:lstStyle/>
+          <a:p>
+            <a:pPr algn="ctr" indent="0" marL="0">
+              <a:buNone/>
+            </a:pPr>
+            <a:r>
+              <a:rPr lang="en-US" sz="1300" dirty="0">
+                <a:solidFill>
+                  <a:srgbClr val="2B3440"/>
+                </a:solidFill>
+              </a:rPr>
+              <a:t>from the client</a:t>
+            </a:r>
+            <a:endParaRPr lang="en-US" sz="1300" dirty="0"/>
+          </a:p>
+        </p:txBody>
+      </p:sp>
+      <p:sp>
+        <p:nvSpPr>
+          <p:cNvPr id="6" name="Shape 4"/>
+          <p:cNvSpPr/>
+          <p:nvPr/>
+        </p:nvSpPr>
+        <p:spPr>
+          <a:xfrm>
+            <a:off x="1828800" y="2331720"/>
+            <a:ext cx="301752" cy="0"/>
           </a:xfrm>
           <a:prstGeom prst="line">
             <a:avLst/>
           </a:prstGeom>
           <a:noFill/>
-          <a:ln w="19050">
+          <a:ln w="25400">
             <a:solidFill>
               <a:srgbClr val="64748B"/>
             </a:solidFill>
@@ -11760,54 +11673,18 @@
       </p:sp>
       <p:sp>
         <p:nvSpPr>
-          <p:cNvPr id="10" name="Text 8"/>
-          <p:cNvSpPr txBox="1"/>
-          <p:nvPr/>
-        </p:nvSpPr>
-        <p:spPr>
-          <a:xfrm>
-            <a:off x="1653758" y="2002536"/>
-            <a:ext cx="1050254" cy="1417320"/>
-          </a:xfrm>
-          <a:prstGeom prst="rect">
-            <a:avLst/>
-          </a:prstGeom>
-          <a:noFill/>
-          <a:ln/>
-        </p:spPr>
-        <p:txBody>
-          <a:bodyPr wrap="square" lIns="0" tIns="0" rIns="0" bIns="0" rtlCol="0" anchor="t"/>
-          <a:lstStyle/>
-          <a:p>
-            <a:pPr algn="ctr" indent="0" marL="0">
-              <a:buNone/>
-            </a:pPr>
-            <a:r>
-              <a:rPr lang="en-US" sz="1100" dirty="0">
-                <a:solidFill>
-                  <a:srgbClr val="2B3440"/>
-                </a:solidFill>
-              </a:rPr>
-              <a:t>runs first, on the raw request: logging, CORS, headers</a:t>
-            </a:r>
-            <a:endParaRPr lang="en-US" sz="1100" dirty="0"/>
-          </a:p>
-        </p:txBody>
-      </p:sp>
-      <p:sp>
-        <p:nvSpPr>
-          <p:cNvPr id="11" name="step-3"/>
-          <p:cNvSpPr/>
-          <p:nvPr/>
-        </p:nvSpPr>
-        <p:spPr>
-          <a:xfrm>
-            <a:off x="2850315" y="1234440"/>
-            <a:ext cx="1050254" cy="658368"/>
+          <p:cNvPr id="7" name="block-2"/>
+          <p:cNvSpPr/>
+          <p:nvPr/>
+        </p:nvSpPr>
+        <p:spPr>
+          <a:xfrm>
+            <a:off x="2185416" y="1828800"/>
+            <a:ext cx="1316736" cy="1005840"/>
           </a:xfrm>
           <a:prstGeom prst="roundRect">
             <a:avLst>
-              <a:gd name="adj" fmla="val 11111"/>
+              <a:gd name="adj" fmla="val 9091"/>
             </a:avLst>
           </a:prstGeom>
           <a:solidFill>
@@ -11823,14 +11700,14 @@
       </p:sp>
       <p:sp>
         <p:nvSpPr>
-          <p:cNvPr id="12" name="Text 10"/>
+          <p:cNvPr id="8" name="Text 6"/>
           <p:cNvSpPr txBox="1"/>
           <p:nvPr/>
         </p:nvSpPr>
         <p:spPr>
           <a:xfrm>
-            <a:off x="2850315" y="1234440"/>
-            <a:ext cx="1050254" cy="658368"/>
+            <a:off x="2185416" y="1828800"/>
+            <a:ext cx="1316736" cy="1005840"/>
           </a:xfrm>
           <a:prstGeom prst="rect">
             <a:avLst/>
@@ -11846,33 +11723,69 @@
               <a:buNone/>
             </a:pPr>
             <a:r>
-              <a:rPr lang="en-US" sz="1200" b="1" dirty="0">
+              <a:rPr lang="en-US" sz="1600" b="1" dirty="0">
                 <a:solidFill>
                   <a:srgbClr val="FFFFFF"/>
                 </a:solidFill>
               </a:rPr>
-              <a:t>Guards · Pipes</a:t>
-            </a:r>
-            <a:endParaRPr lang="en-US" sz="1200" dirty="0"/>
-          </a:p>
-        </p:txBody>
-      </p:sp>
-      <p:sp>
-        <p:nvSpPr>
-          <p:cNvPr id="13" name="Shape 11"/>
-          <p:cNvSpPr/>
-          <p:nvPr/>
-        </p:nvSpPr>
-        <p:spPr>
-          <a:xfrm>
-            <a:off x="3900569" y="1563624"/>
-            <a:ext cx="146304" cy="0"/>
+              <a:t>Middleware</a:t>
+            </a:r>
+            <a:endParaRPr lang="en-US" sz="1600" dirty="0"/>
+          </a:p>
+        </p:txBody>
+      </p:sp>
+      <p:sp>
+        <p:nvSpPr>
+          <p:cNvPr id="9" name="Text 7"/>
+          <p:cNvSpPr txBox="1"/>
+          <p:nvPr/>
+        </p:nvSpPr>
+        <p:spPr>
+          <a:xfrm>
+            <a:off x="2185416" y="2971800"/>
+            <a:ext cx="1316736" cy="365760"/>
+          </a:xfrm>
+          <a:prstGeom prst="rect">
+            <a:avLst/>
+          </a:prstGeom>
+          <a:noFill/>
+          <a:ln/>
+        </p:spPr>
+        <p:txBody>
+          <a:bodyPr wrap="square" lIns="0" tIns="0" rIns="0" bIns="0" rtlCol="0" anchor="ctr"/>
+          <a:lstStyle/>
+          <a:p>
+            <a:pPr algn="ctr" indent="0" marL="0">
+              <a:buNone/>
+            </a:pPr>
+            <a:r>
+              <a:rPr lang="en-US" sz="1300" dirty="0">
+                <a:solidFill>
+                  <a:srgbClr val="2B3440"/>
+                </a:solidFill>
+              </a:rPr>
+              <a:t>runs first</a:t>
+            </a:r>
+            <a:endParaRPr lang="en-US" sz="1300" dirty="0"/>
+          </a:p>
+        </p:txBody>
+      </p:sp>
+      <p:sp>
+        <p:nvSpPr>
+          <p:cNvPr id="10" name="Shape 8"/>
+          <p:cNvSpPr/>
+          <p:nvPr/>
+        </p:nvSpPr>
+        <p:spPr>
+          <a:xfrm>
+            <a:off x="3557016" y="2331720"/>
+            <a:ext cx="301752" cy="0"/>
           </a:xfrm>
           <a:prstGeom prst="line">
             <a:avLst/>
           </a:prstGeom>
           <a:noFill/>
-          <a:ln w="19050">
+          <a:ln w="25400">
             <a:solidFill>
               <a:srgbClr val="64748B"/>
             </a:solidFill>
@@ -11883,54 +11796,18 @@
       </p:sp>
       <p:sp>
         <p:nvSpPr>
-          <p:cNvPr id="14" name="Text 12"/>
-          <p:cNvSpPr txBox="1"/>
-          <p:nvPr/>
-        </p:nvSpPr>
-        <p:spPr>
-          <a:xfrm>
-            <a:off x="2850315" y="2002536"/>
-            <a:ext cx="1050254" cy="1417320"/>
-          </a:xfrm>
-          <a:prstGeom prst="rect">
-            <a:avLst/>
-          </a:prstGeom>
-          <a:noFill/>
-          <a:ln/>
-        </p:spPr>
-        <p:txBody>
-          <a:bodyPr wrap="square" lIns="0" tIns="0" rIns="0" bIns="0" rtlCol="0" anchor="t"/>
-          <a:lstStyle/>
-          <a:p>
-            <a:pPr algn="ctr" indent="0" marL="0">
-              <a:buNone/>
-            </a:pPr>
-            <a:r>
-              <a:rPr lang="en-US" sz="1100" dirty="0">
-                <a:solidFill>
-                  <a:srgbClr val="2B3440"/>
-                </a:solidFill>
-              </a:rPr>
-              <a:t>may it run? then parse the body: the global zod pipe, 400 if invalid</a:t>
-            </a:r>
-            <a:endParaRPr lang="en-US" sz="1100" dirty="0"/>
-          </a:p>
-        </p:txBody>
-      </p:sp>
-      <p:sp>
-        <p:nvSpPr>
-          <p:cNvPr id="15" name="step-4"/>
-          <p:cNvSpPr/>
-          <p:nvPr/>
-        </p:nvSpPr>
-        <p:spPr>
-          <a:xfrm>
-            <a:off x="4046873" y="1234440"/>
-            <a:ext cx="1050254" cy="658368"/>
+          <p:cNvPr id="11" name="block-3"/>
+          <p:cNvSpPr/>
+          <p:nvPr/>
+        </p:nvSpPr>
+        <p:spPr>
+          <a:xfrm>
+            <a:off x="3913632" y="1828800"/>
+            <a:ext cx="1316736" cy="1005840"/>
           </a:xfrm>
           <a:prstGeom prst="roundRect">
             <a:avLst>
-              <a:gd name="adj" fmla="val 11111"/>
+              <a:gd name="adj" fmla="val 9091"/>
             </a:avLst>
           </a:prstGeom>
           <a:solidFill>
@@ -11946,14 +11823,14 @@
       </p:sp>
       <p:sp>
         <p:nvSpPr>
-          <p:cNvPr id="16" name="Text 14"/>
+          <p:cNvPr id="12" name="Text 10"/>
           <p:cNvSpPr txBox="1"/>
           <p:nvPr/>
         </p:nvSpPr>
         <p:spPr>
           <a:xfrm>
-            <a:off x="4046873" y="1234440"/>
-            <a:ext cx="1050254" cy="658368"/>
+            <a:off x="3913632" y="1828800"/>
+            <a:ext cx="1316736" cy="1005840"/>
           </a:xfrm>
           <a:prstGeom prst="rect">
             <a:avLst/>
@@ -11969,33 +11846,69 @@
               <a:buNone/>
             </a:pPr>
             <a:r>
-              <a:rPr lang="en-US" sz="1200" b="1" dirty="0">
+              <a:rPr lang="en-US" sz="1600" b="1" dirty="0">
                 <a:solidFill>
                   <a:srgbClr val="FFFFFF"/>
                 </a:solidFill>
               </a:rPr>
               <a:t>Controller</a:t>
             </a:r>
-            <a:endParaRPr lang="en-US" sz="1200" dirty="0"/>
-          </a:p>
-        </p:txBody>
-      </p:sp>
-      <p:sp>
-        <p:nvSpPr>
-          <p:cNvPr id="17" name="Shape 15"/>
-          <p:cNvSpPr/>
-          <p:nvPr/>
-        </p:nvSpPr>
-        <p:spPr>
-          <a:xfrm>
-            <a:off x="5097127" y="1563624"/>
-            <a:ext cx="146304" cy="0"/>
+            <a:endParaRPr lang="en-US" sz="1600" dirty="0"/>
+          </a:p>
+        </p:txBody>
+      </p:sp>
+      <p:sp>
+        <p:nvSpPr>
+          <p:cNvPr id="13" name="Text 11"/>
+          <p:cNvSpPr txBox="1"/>
+          <p:nvPr/>
+        </p:nvSpPr>
+        <p:spPr>
+          <a:xfrm>
+            <a:off x="3913632" y="2971800"/>
+            <a:ext cx="1316736" cy="365760"/>
+          </a:xfrm>
+          <a:prstGeom prst="rect">
+            <a:avLst/>
+          </a:prstGeom>
+          <a:noFill/>
+          <a:ln/>
+        </p:spPr>
+        <p:txBody>
+          <a:bodyPr wrap="square" lIns="0" tIns="0" rIns="0" bIns="0" rtlCol="0" anchor="ctr"/>
+          <a:lstStyle/>
+          <a:p>
+            <a:pPr algn="ctr" indent="0" marL="0">
+              <a:buNone/>
+            </a:pPr>
+            <a:r>
+              <a:rPr lang="en-US" sz="1300" dirty="0">
+                <a:solidFill>
+                  <a:srgbClr val="2B3440"/>
+                </a:solidFill>
+              </a:rPr>
+              <a:t>the route</a:t>
+            </a:r>
+            <a:endParaRPr lang="en-US" sz="1300" dirty="0"/>
+          </a:p>
+        </p:txBody>
+      </p:sp>
+      <p:sp>
+        <p:nvSpPr>
+          <p:cNvPr id="14" name="Shape 12"/>
+          <p:cNvSpPr/>
+          <p:nvPr/>
+        </p:nvSpPr>
+        <p:spPr>
+          <a:xfrm>
+            <a:off x="5285232" y="2331720"/>
+            <a:ext cx="301752" cy="0"/>
           </a:xfrm>
           <a:prstGeom prst="line">
             <a:avLst/>
           </a:prstGeom>
           <a:noFill/>
-          <a:ln w="19050">
+          <a:ln w="25400">
             <a:solidFill>
               <a:srgbClr val="64748B"/>
             </a:solidFill>
@@ -12006,54 +11919,18 @@
       </p:sp>
       <p:sp>
         <p:nvSpPr>
-          <p:cNvPr id="18" name="Text 16"/>
-          <p:cNvSpPr txBox="1"/>
-          <p:nvPr/>
-        </p:nvSpPr>
-        <p:spPr>
-          <a:xfrm>
-            <a:off x="4046873" y="2002536"/>
-            <a:ext cx="1050254" cy="1417320"/>
-          </a:xfrm>
-          <a:prstGeom prst="rect">
-            <a:avLst/>
-          </a:prstGeom>
-          <a:noFill/>
-          <a:ln/>
-        </p:spPr>
-        <p:txBody>
-          <a:bodyPr wrap="square" lIns="0" tIns="0" rIns="0" bIns="0" rtlCol="0" anchor="t"/>
-          <a:lstStyle/>
-          <a:p>
-            <a:pPr algn="ctr" indent="0" marL="0">
-              <a:buNone/>
-            </a:pPr>
-            <a:r>
-              <a:rPr lang="en-US" sz="1100" dirty="0">
-                <a:solidFill>
-                  <a:srgbClr val="2B3440"/>
-                </a:solidFill>
-              </a:rPr>
-              <a:t>the route: parse, delegate, return. No rules here</a:t>
-            </a:r>
-            <a:endParaRPr lang="en-US" sz="1100" dirty="0"/>
-          </a:p>
-        </p:txBody>
-      </p:sp>
-      <p:sp>
-        <p:nvSpPr>
-          <p:cNvPr id="19" name="step-5"/>
-          <p:cNvSpPr/>
-          <p:nvPr/>
-        </p:nvSpPr>
-        <p:spPr>
-          <a:xfrm>
-            <a:off x="5243431" y="1234440"/>
-            <a:ext cx="1050254" cy="658368"/>
+          <p:cNvPr id="15" name="block-4"/>
+          <p:cNvSpPr/>
+          <p:nvPr/>
+        </p:nvSpPr>
+        <p:spPr>
+          <a:xfrm>
+            <a:off x="5641848" y="1828800"/>
+            <a:ext cx="1316736" cy="1005840"/>
           </a:xfrm>
           <a:prstGeom prst="roundRect">
             <a:avLst>
-              <a:gd name="adj" fmla="val 11111"/>
+              <a:gd name="adj" fmla="val 9091"/>
             </a:avLst>
           </a:prstGeom>
           <a:solidFill>
@@ -12069,14 +11946,14 @@
       </p:sp>
       <p:sp>
         <p:nvSpPr>
-          <p:cNvPr id="20" name="Text 18"/>
+          <p:cNvPr id="16" name="Text 14"/>
           <p:cNvSpPr txBox="1"/>
           <p:nvPr/>
         </p:nvSpPr>
         <p:spPr>
           <a:xfrm>
-            <a:off x="5243431" y="1234440"/>
-            <a:ext cx="1050254" cy="658368"/>
+            <a:off x="5641848" y="1828800"/>
+            <a:ext cx="1316736" cy="1005840"/>
           </a:xfrm>
           <a:prstGeom prst="rect">
             <a:avLst/>
@@ -12092,33 +11969,69 @@
               <a:buNone/>
             </a:pPr>
             <a:r>
-              <a:rPr lang="en-US" sz="1200" b="1" dirty="0">
+              <a:rPr lang="en-US" sz="1600" b="1" dirty="0">
                 <a:solidFill>
                   <a:srgbClr val="FFFFFF"/>
                 </a:solidFill>
               </a:rPr>
               <a:t>Service</a:t>
             </a:r>
-            <a:endParaRPr lang="en-US" sz="1200" dirty="0"/>
-          </a:p>
-        </p:txBody>
-      </p:sp>
-      <p:sp>
-        <p:nvSpPr>
-          <p:cNvPr id="21" name="Shape 19"/>
-          <p:cNvSpPr/>
-          <p:nvPr/>
-        </p:nvSpPr>
-        <p:spPr>
-          <a:xfrm>
-            <a:off x="6293685" y="1563624"/>
-            <a:ext cx="146304" cy="0"/>
+            <a:endParaRPr lang="en-US" sz="1600" dirty="0"/>
+          </a:p>
+        </p:txBody>
+      </p:sp>
+      <p:sp>
+        <p:nvSpPr>
+          <p:cNvPr id="17" name="Text 15"/>
+          <p:cNvSpPr txBox="1"/>
+          <p:nvPr/>
+        </p:nvSpPr>
+        <p:spPr>
+          <a:xfrm>
+            <a:off x="5641848" y="2971800"/>
+            <a:ext cx="1316736" cy="365760"/>
+          </a:xfrm>
+          <a:prstGeom prst="rect">
+            <a:avLst/>
+          </a:prstGeom>
+          <a:noFill/>
+          <a:ln/>
+        </p:spPr>
+        <p:txBody>
+          <a:bodyPr wrap="square" lIns="0" tIns="0" rIns="0" bIns="0" rtlCol="0" anchor="ctr"/>
+          <a:lstStyle/>
+          <a:p>
+            <a:pPr algn="ctr" indent="0" marL="0">
+              <a:buNone/>
+            </a:pPr>
+            <a:r>
+              <a:rPr lang="en-US" sz="1300" dirty="0">
+                <a:solidFill>
+                  <a:srgbClr val="2B3440"/>
+                </a:solidFill>
+              </a:rPr>
+              <a:t>the rules</a:t>
+            </a:r>
+            <a:endParaRPr lang="en-US" sz="1300" dirty="0"/>
+          </a:p>
+        </p:txBody>
+      </p:sp>
+      <p:sp>
+        <p:nvSpPr>
+          <p:cNvPr id="18" name="Shape 16"/>
+          <p:cNvSpPr/>
+          <p:nvPr/>
+        </p:nvSpPr>
+        <p:spPr>
+          <a:xfrm>
+            <a:off x="7013448" y="2331720"/>
+            <a:ext cx="301752" cy="0"/>
           </a:xfrm>
           <a:prstGeom prst="line">
             <a:avLst/>
           </a:prstGeom>
           <a:noFill/>
-          <a:ln w="19050">
+          <a:ln w="25400">
             <a:solidFill>
               <a:srgbClr val="64748B"/>
             </a:solidFill>
@@ -12129,62 +12042,26 @@
       </p:sp>
       <p:sp>
         <p:nvSpPr>
-          <p:cNvPr id="22" name="Text 20"/>
-          <p:cNvSpPr txBox="1"/>
-          <p:nvPr/>
-        </p:nvSpPr>
-        <p:spPr>
-          <a:xfrm>
-            <a:off x="5243431" y="2002536"/>
-            <a:ext cx="1050254" cy="1417320"/>
-          </a:xfrm>
-          <a:prstGeom prst="rect">
-            <a:avLst/>
-          </a:prstGeom>
-          <a:noFill/>
-          <a:ln/>
-        </p:spPr>
-        <p:txBody>
-          <a:bodyPr wrap="square" lIns="0" tIns="0" rIns="0" bIns="0" rtlCol="0" anchor="t"/>
-          <a:lstStyle/>
-          <a:p>
-            <a:pPr algn="ctr" indent="0" marL="0">
-              <a:buNone/>
-            </a:pPr>
-            <a:r>
-              <a:rPr lang="en-US" sz="1100" dirty="0">
-                <a:solidFill>
-                  <a:srgbClr val="2B3440"/>
-                </a:solidFill>
-              </a:rPr>
-              <a:t>the rules (R1–R4); throws a DomainError when one is broken</a:t>
-            </a:r>
-            <a:endParaRPr lang="en-US" sz="1100" dirty="0"/>
-          </a:p>
-        </p:txBody>
-      </p:sp>
-      <p:sp>
-        <p:nvSpPr>
-          <p:cNvPr id="23" name="step-6"/>
-          <p:cNvSpPr/>
-          <p:nvPr/>
-        </p:nvSpPr>
-        <p:spPr>
-          <a:xfrm>
-            <a:off x="6439989" y="1234440"/>
-            <a:ext cx="1050254" cy="658368"/>
+          <p:cNvPr id="19" name="block-5"/>
+          <p:cNvSpPr/>
+          <p:nvPr/>
+        </p:nvSpPr>
+        <p:spPr>
+          <a:xfrm>
+            <a:off x="7370064" y="1828800"/>
+            <a:ext cx="1316736" cy="1005840"/>
           </a:xfrm>
           <a:prstGeom prst="roundRect">
             <a:avLst>
-              <a:gd name="adj" fmla="val 11111"/>
+              <a:gd name="adj" fmla="val 9091"/>
             </a:avLst>
           </a:prstGeom>
           <a:solidFill>
-            <a:srgbClr val="1FB68A"/>
+            <a:srgbClr val="1B1F24"/>
           </a:solidFill>
           <a:ln w="12700">
             <a:solidFill>
-              <a:srgbClr val="1FB68A"/>
+              <a:srgbClr val="1B1F24"/>
             </a:solidFill>
             <a:prstDash val="solid"/>
           </a:ln>
@@ -12192,14 +12069,14 @@
       </p:sp>
       <p:sp>
         <p:nvSpPr>
-          <p:cNvPr id="24" name="Text 22"/>
+          <p:cNvPr id="20" name="Text 18"/>
           <p:cNvSpPr txBox="1"/>
           <p:nvPr/>
         </p:nvSpPr>
         <p:spPr>
           <a:xfrm>
-            <a:off x="6439989" y="1234440"/>
-            <a:ext cx="1050254" cy="658368"/>
+            <a:off x="7370064" y="1828800"/>
+            <a:ext cx="1316736" cy="1005840"/>
           </a:xfrm>
           <a:prstGeom prst="rect">
             <a:avLst/>
@@ -12215,51 +12092,27 @@
               <a:buNone/>
             </a:pPr>
             <a:r>
-              <a:rPr lang="en-US" sz="1200" b="1" dirty="0">
+              <a:rPr lang="en-US" sz="1600" b="1" dirty="0">
                 <a:solidFill>
                   <a:srgbClr val="FFFFFF"/>
                 </a:solidFill>
               </a:rPr>
-              <a:t>Repository</a:t>
-            </a:r>
-            <a:endParaRPr lang="en-US" sz="1200" dirty="0"/>
-          </a:p>
-        </p:txBody>
-      </p:sp>
-      <p:sp>
-        <p:nvSpPr>
-          <p:cNvPr id="25" name="Shape 23"/>
-          <p:cNvSpPr/>
-          <p:nvPr/>
-        </p:nvSpPr>
-        <p:spPr>
-          <a:xfrm>
-            <a:off x="7490242" y="1563624"/>
-            <a:ext cx="146304" cy="0"/>
-          </a:xfrm>
-          <a:prstGeom prst="line">
-            <a:avLst/>
-          </a:prstGeom>
-          <a:noFill/>
-          <a:ln w="19050">
-            <a:solidFill>
-              <a:srgbClr val="64748B"/>
-            </a:solidFill>
-            <a:prstDash val="solid"/>
-            <a:tailEnd type="triangle"/>
-          </a:ln>
-        </p:spPr>
-      </p:sp>
-      <p:sp>
-        <p:nvSpPr>
-          <p:cNvPr id="26" name="Text 24"/>
+              <a:t>Database</a:t>
+            </a:r>
+            <a:endParaRPr lang="en-US" sz="1600" dirty="0"/>
+          </a:p>
+        </p:txBody>
+      </p:sp>
+      <p:sp>
+        <p:nvSpPr>
+          <p:cNvPr id="21" name="Text 19"/>
           <p:cNvSpPr txBox="1"/>
           <p:nvPr/>
         </p:nvSpPr>
         <p:spPr>
           <a:xfrm>
-            <a:off x="6439989" y="2002536"/>
-            <a:ext cx="1050254" cy="1417320"/>
+            <a:off x="7370064" y="2971800"/>
+            <a:ext cx="1316736" cy="365760"/>
           </a:xfrm>
           <a:prstGeom prst="rect">
             <a:avLst/>
@@ -12268,216 +12121,21 @@
           <a:ln/>
         </p:spPr>
         <p:txBody>
-          <a:bodyPr wrap="square" lIns="0" tIns="0" rIns="0" bIns="0" rtlCol="0" anchor="t"/>
+          <a:bodyPr wrap="square" lIns="0" tIns="0" rIns="0" bIns="0" rtlCol="0" anchor="ctr"/>
           <a:lstStyle/>
           <a:p>
             <a:pPr algn="ctr" indent="0" marL="0">
               <a:buNone/>
             </a:pPr>
             <a:r>
-              <a:rPr lang="en-US" sz="1100" dirty="0">
+              <a:rPr lang="en-US" sz="1300" dirty="0">
                 <a:solidFill>
                   <a:srgbClr val="2B3440"/>
                 </a:solidFill>
               </a:rPr>
-              <a:t>SQL through drizzle, behind a token</a:t>
-            </a:r>
-            <a:endParaRPr lang="en-US" sz="1100" dirty="0"/>
-          </a:p>
-        </p:txBody>
-      </p:sp>
-      <p:sp>
-        <p:nvSpPr>
-          <p:cNvPr id="27" name="step-7"/>
-          <p:cNvSpPr/>
-          <p:nvPr/>
-        </p:nvSpPr>
-        <p:spPr>
-          <a:xfrm>
-            <a:off x="7636546" y="1234440"/>
-            <a:ext cx="1050254" cy="658368"/>
-          </a:xfrm>
-          <a:prstGeom prst="roundRect">
-            <a:avLst>
-              <a:gd name="adj" fmla="val 11111"/>
-            </a:avLst>
-          </a:prstGeom>
-          <a:solidFill>
-            <a:srgbClr val="2B3440"/>
-          </a:solidFill>
-          <a:ln w="12700">
-            <a:solidFill>
-              <a:srgbClr val="2B3440"/>
-            </a:solidFill>
-            <a:prstDash val="solid"/>
-          </a:ln>
-        </p:spPr>
-      </p:sp>
-      <p:sp>
-        <p:nvSpPr>
-          <p:cNvPr id="28" name="Text 26"/>
-          <p:cNvSpPr txBox="1"/>
-          <p:nvPr/>
-        </p:nvSpPr>
-        <p:spPr>
-          <a:xfrm>
-            <a:off x="7636546" y="1234440"/>
-            <a:ext cx="1050254" cy="658368"/>
-          </a:xfrm>
-          <a:prstGeom prst="rect">
-            <a:avLst/>
-          </a:prstGeom>
-          <a:noFill/>
-          <a:ln/>
-        </p:spPr>
-        <p:txBody>
-          <a:bodyPr wrap="square" lIns="25400" tIns="25400" rIns="25400" bIns="25400" rtlCol="0" anchor="ctr"/>
-          <a:lstStyle/>
-          <a:p>
-            <a:pPr algn="ctr" indent="0" marL="0">
-              <a:buNone/>
-            </a:pPr>
-            <a:r>
-              <a:rPr lang="en-US" sz="1200" b="1" dirty="0">
-                <a:solidFill>
-                  <a:srgbClr val="FFFFFF"/>
-                </a:solidFill>
-              </a:rPr>
               <a:t>SQLite</a:t>
             </a:r>
-            <a:endParaRPr lang="en-US" sz="1200" dirty="0"/>
-          </a:p>
-        </p:txBody>
-      </p:sp>
-      <p:sp>
-        <p:nvSpPr>
-          <p:cNvPr id="29" name="Text 27"/>
-          <p:cNvSpPr txBox="1"/>
-          <p:nvPr/>
-        </p:nvSpPr>
-        <p:spPr>
-          <a:xfrm>
-            <a:off x="7636546" y="2002536"/>
-            <a:ext cx="1050254" cy="1417320"/>
-          </a:xfrm>
-          <a:prstGeom prst="rect">
-            <a:avLst/>
-          </a:prstGeom>
-          <a:noFill/>
-          <a:ln/>
-        </p:spPr>
-        <p:txBody>
-          <a:bodyPr wrap="square" lIns="0" tIns="0" rIns="0" bIns="0" rtlCol="0" anchor="t"/>
-          <a:lstStyle/>
-          <a:p>
-            <a:pPr algn="ctr" indent="0" marL="0">
-              <a:buNone/>
-            </a:pPr>
-            <a:r>
-              <a:rPr lang="en-US" sz="1100" dirty="0">
-                <a:solidFill>
-                  <a:srgbClr val="2B3440"/>
-                </a:solidFill>
-              </a:rPr>
-              <a:t>data/app.db; unique keys and foreign keys enforce too</a:t>
-            </a:r>
-            <a:endParaRPr lang="en-US" sz="1100" dirty="0"/>
-          </a:p>
-        </p:txBody>
-      </p:sp>
-      <p:sp>
-        <p:nvSpPr>
-          <p:cNvPr id="30" name="Shape 28"/>
-          <p:cNvSpPr/>
-          <p:nvPr/>
-        </p:nvSpPr>
-        <p:spPr>
-          <a:xfrm>
-            <a:off x="982327" y="3520440"/>
-            <a:ext cx="7179346" cy="0"/>
-          </a:xfrm>
-          <a:prstGeom prst="line">
-            <a:avLst/>
-          </a:prstGeom>
-          <a:noFill/>
-          <a:ln w="25400">
-            <a:solidFill>
-              <a:srgbClr val="E69A28"/>
-            </a:solidFill>
-            <a:prstDash val="solid"/>
-            <a:headEnd type="triangle"/>
-          </a:ln>
-        </p:spPr>
-      </p:sp>
-      <p:sp>
-        <p:nvSpPr>
-          <p:cNvPr id="31" name="Text 29"/>
-          <p:cNvSpPr txBox="1"/>
-          <p:nvPr/>
-        </p:nvSpPr>
-        <p:spPr>
-          <a:xfrm>
-            <a:off x="457200" y="3639312"/>
-            <a:ext cx="8229600" cy="457200"/>
-          </a:xfrm>
-          <a:prstGeom prst="rect">
-            <a:avLst/>
-          </a:prstGeom>
-          <a:noFill/>
-          <a:ln/>
-        </p:spPr>
-        <p:txBody>
-          <a:bodyPr wrap="square" lIns="0" tIns="0" rIns="0" bIns="0" rtlCol="0" anchor="ctr"/>
-          <a:lstStyle/>
-          <a:p>
-            <a:pPr algn="ctr" indent="0" marL="0">
-              <a:buNone/>
-            </a:pPr>
-            <a:r>
-              <a:rPr lang="en-US" sz="1300" i="1" dirty="0">
-                <a:solidFill>
-                  <a:srgbClr val="1B1F24"/>
-                </a:solidFill>
-              </a:rPr>
-              <a:t>Response ←  a thrown DomainError is turned into 404 / 409 / 422 by DomainExceptionFilter, on the way back</a:t>
-            </a:r>
             <a:endParaRPr lang="en-US" sz="1300" dirty="0"/>
-          </a:p>
-        </p:txBody>
-      </p:sp>
-      <p:sp>
-        <p:nvSpPr>
-          <p:cNvPr id="32" name="Text 30"/>
-          <p:cNvSpPr txBox="1"/>
-          <p:nvPr/>
-        </p:nvSpPr>
-        <p:spPr>
-          <a:xfrm>
-            <a:off x="457200" y="4160520"/>
-            <a:ext cx="8229600" cy="320040"/>
-          </a:xfrm>
-          <a:prstGeom prst="rect">
-            <a:avLst/>
-          </a:prstGeom>
-          <a:noFill/>
-          <a:ln/>
-        </p:spPr>
-        <p:txBody>
-          <a:bodyPr wrap="square" lIns="0" tIns="0" rIns="0" bIns="0" rtlCol="0" anchor="ctr"/>
-          <a:lstStyle/>
-          <a:p>
-            <a:pPr indent="0" marL="0">
-              <a:buNone/>
-            </a:pPr>
-            <a:r>
-              <a:rPr lang="en-US" sz="1200" dirty="0">
-                <a:solidFill>
-                  <a:srgbClr val="64748B"/>
-                </a:solidFill>
-              </a:rPr>
-              <a:t>Mint: what your agent builds in module 1.  Dark: already in the base.</a:t>
-            </a:r>
-            <a:endParaRPr lang="en-US" sz="1200" dirty="0"/>
           </a:p>
         </p:txBody>
       </p:sp>
@@ -12583,7 +12241,7 @@
                   <a:srgbClr val="1B1F24"/>
                 </a:solidFill>
               </a:rPr>
-              <a:t>NestJS: how a module wires them</a:t>
+              <a:t>NestJS: who calls whom</a:t>
             </a:r>
             <a:endParaRPr lang="en-US" sz="3200" dirty="0"/>
           </a:p>
@@ -12591,155 +12249,18 @@
       </p:sp>
       <p:sp>
         <p:nvSpPr>
-          <p:cNvPr id="3" name="app-module"/>
-          <p:cNvSpPr/>
-          <p:nvPr/>
-        </p:nvSpPr>
-        <p:spPr>
-          <a:xfrm>
-            <a:off x="457200" y="1920240"/>
-            <a:ext cx="1554480" cy="822960"/>
+          <p:cNvPr id="3" name="module"/>
+          <p:cNvSpPr/>
+          <p:nvPr/>
+        </p:nvSpPr>
+        <p:spPr>
+          <a:xfrm>
+            <a:off x="3657600" y="1051560"/>
+            <a:ext cx="3108960" cy="3429000"/>
           </a:xfrm>
           <a:prstGeom prst="roundRect">
             <a:avLst>
-              <a:gd name="adj" fmla="val 8889"/>
-            </a:avLst>
-          </a:prstGeom>
-          <a:solidFill>
-            <a:srgbClr val="2B3440"/>
-          </a:solidFill>
-          <a:ln w="12700">
-            <a:solidFill>
-              <a:srgbClr val="2B3440"/>
-            </a:solidFill>
-            <a:prstDash val="solid"/>
-          </a:ln>
-        </p:spPr>
-      </p:sp>
-      <p:sp>
-        <p:nvSpPr>
-          <p:cNvPr id="4" name="Text 2"/>
-          <p:cNvSpPr txBox="1"/>
-          <p:nvPr/>
-        </p:nvSpPr>
-        <p:spPr>
-          <a:xfrm>
-            <a:off x="457200" y="1920240"/>
-            <a:ext cx="1554480" cy="822960"/>
-          </a:xfrm>
-          <a:prstGeom prst="rect">
-            <a:avLst/>
-          </a:prstGeom>
-          <a:noFill/>
-          <a:ln/>
-        </p:spPr>
-        <p:txBody>
-          <a:bodyPr wrap="square" lIns="38100" tIns="38100" rIns="38100" bIns="38100" rtlCol="0" anchor="ctr"/>
-          <a:lstStyle/>
-          <a:p>
-            <a:pPr algn="ctr" indent="0" marL="0">
-              <a:buNone/>
-            </a:pPr>
-            <a:r>
-              <a:rPr lang="en-US" sz="1300" b="1" dirty="0">
-                <a:solidFill>
-                  <a:srgbClr val="FFFFFF"/>
-                </a:solidFill>
-              </a:rPr>
-              <a:t>AppModule</a:t>
-            </a:r>
-            <a:endParaRPr lang="en-US" sz="1300" dirty="0"/>
-          </a:p>
-          <a:p>
-            <a:pPr algn="ctr" indent="0" marL="0">
-              <a:buNone/>
-            </a:pPr>
-            <a:r>
-              <a:rPr lang="en-US" sz="1000" dirty="0">
-                <a:solidFill>
-                  <a:srgbClr val="FFFFFF"/>
-                </a:solidFill>
-              </a:rPr>
-              <a:t>imports every feature module</a:t>
-            </a:r>
-            <a:endParaRPr lang="en-US" sz="1300" dirty="0"/>
-          </a:p>
-        </p:txBody>
-      </p:sp>
-      <p:sp>
-        <p:nvSpPr>
-          <p:cNvPr id="5" name="Shape 3"/>
-          <p:cNvSpPr/>
-          <p:nvPr/>
-        </p:nvSpPr>
-        <p:spPr>
-          <a:xfrm>
-            <a:off x="2011680" y="2331720"/>
-            <a:ext cx="502920" cy="0"/>
-          </a:xfrm>
-          <a:prstGeom prst="line">
-            <a:avLst/>
-          </a:prstGeom>
-          <a:noFill/>
-          <a:ln w="19050">
-            <a:solidFill>
-              <a:srgbClr val="64748B"/>
-            </a:solidFill>
-            <a:prstDash val="solid"/>
-            <a:tailEnd type="triangle"/>
-          </a:ln>
-        </p:spPr>
-      </p:sp>
-      <p:sp>
-        <p:nvSpPr>
-          <p:cNvPr id="6" name="Text 4"/>
-          <p:cNvSpPr txBox="1"/>
-          <p:nvPr/>
-        </p:nvSpPr>
-        <p:spPr>
-          <a:xfrm>
-            <a:off x="2011680" y="2011680"/>
-            <a:ext cx="548640" cy="274320"/>
-          </a:xfrm>
-          <a:prstGeom prst="rect">
-            <a:avLst/>
-          </a:prstGeom>
-          <a:noFill/>
-          <a:ln/>
-        </p:spPr>
-        <p:txBody>
-          <a:bodyPr wrap="square" lIns="0" tIns="0" rIns="0" bIns="0" rtlCol="0" anchor="ctr"/>
-          <a:lstStyle/>
-          <a:p>
-            <a:pPr indent="0" marL="0">
-              <a:buNone/>
-            </a:pPr>
-            <a:r>
-              <a:rPr lang="en-US" sz="1000" i="1" dirty="0">
-                <a:solidFill>
-                  <a:srgbClr val="64748B"/>
-                </a:solidFill>
-              </a:rPr>
-              <a:t>imports</a:t>
-            </a:r>
-            <a:endParaRPr lang="en-US" sz="1000" dirty="0"/>
-          </a:p>
-        </p:txBody>
-      </p:sp>
-      <p:sp>
-        <p:nvSpPr>
-          <p:cNvPr id="7" name="notes-module"/>
-          <p:cNvSpPr/>
-          <p:nvPr/>
-        </p:nvSpPr>
-        <p:spPr>
-          <a:xfrm>
-            <a:off x="2560320" y="1097280"/>
-            <a:ext cx="3291840" cy="3291840"/>
-          </a:xfrm>
-          <a:prstGeom prst="roundRect">
-            <a:avLst>
-              <a:gd name="adj" fmla="val 2778"/>
+              <a:gd name="adj" fmla="val 3529"/>
             </a:avLst>
           </a:prstGeom>
           <a:solidFill>
@@ -12755,14 +12276,14 @@
       </p:sp>
       <p:sp>
         <p:nvSpPr>
-          <p:cNvPr id="8" name="Text 6"/>
+          <p:cNvPr id="4" name="Text 2"/>
           <p:cNvSpPr txBox="1"/>
           <p:nvPr/>
         </p:nvSpPr>
         <p:spPr>
           <a:xfrm>
-            <a:off x="2697480" y="1143000"/>
-            <a:ext cx="3017520" cy="292608"/>
+            <a:off x="3794760" y="1097280"/>
+            <a:ext cx="2834640" cy="365760"/>
           </a:xfrm>
           <a:prstGeom prst="rect">
             <a:avLst/>
@@ -12778,31 +12299,31 @@
               <a:buNone/>
             </a:pPr>
             <a:r>
-              <a:rPr lang="en-US" sz="1100" b="1" dirty="0">
+              <a:rPr lang="en-US" sz="1400" b="1" dirty="0">
                 <a:solidFill>
                   <a:srgbClr val="1B1F24"/>
                 </a:solidFill>
               </a:rPr>
-              <a:t>NotesModule  (src/notes/notes.module.ts)</a:t>
-            </a:r>
-            <a:endParaRPr lang="en-US" sz="1100" dirty="0"/>
-          </a:p>
-        </p:txBody>
-      </p:sp>
-      <p:sp>
-        <p:nvSpPr>
-          <p:cNvPr id="9" name="controller"/>
-          <p:cNvSpPr/>
-          <p:nvPr/>
-        </p:nvSpPr>
-        <p:spPr>
-          <a:xfrm>
-            <a:off x="3017520" y="1508760"/>
-            <a:ext cx="2377440" cy="731520"/>
+              <a:t>Module</a:t>
+            </a:r>
+            <a:endParaRPr lang="en-US" sz="1400" dirty="0"/>
+          </a:p>
+        </p:txBody>
+      </p:sp>
+      <p:sp>
+        <p:nvSpPr>
+          <p:cNvPr id="5" name="controller"/>
+          <p:cNvSpPr/>
+          <p:nvPr/>
+        </p:nvSpPr>
+        <p:spPr>
+          <a:xfrm>
+            <a:off x="4069080" y="1508760"/>
+            <a:ext cx="2286000" cy="685800"/>
           </a:xfrm>
           <a:prstGeom prst="roundRect">
             <a:avLst>
-              <a:gd name="adj" fmla="val 10000"/>
+              <a:gd name="adj" fmla="val 13333"/>
             </a:avLst>
           </a:prstGeom>
           <a:solidFill>
@@ -12818,14 +12339,14 @@
       </p:sp>
       <p:sp>
         <p:nvSpPr>
-          <p:cNvPr id="10" name="Text 8"/>
+          <p:cNvPr id="6" name="Text 4"/>
           <p:cNvSpPr txBox="1"/>
           <p:nvPr/>
         </p:nvSpPr>
         <p:spPr>
           <a:xfrm>
-            <a:off x="3017520" y="1508760"/>
-            <a:ext cx="2377440" cy="731520"/>
+            <a:off x="4069080" y="1508760"/>
+            <a:ext cx="2286000" cy="685800"/>
           </a:xfrm>
           <a:prstGeom prst="rect">
             <a:avLst/>
@@ -12834,54 +12355,40 @@
           <a:ln/>
         </p:spPr>
         <p:txBody>
-          <a:bodyPr wrap="square" lIns="38100" tIns="38100" rIns="38100" bIns="38100" rtlCol="0" anchor="ctr"/>
+          <a:bodyPr wrap="square" lIns="25400" tIns="25400" rIns="25400" bIns="25400" rtlCol="0" anchor="ctr"/>
           <a:lstStyle/>
           <a:p>
             <a:pPr algn="ctr" indent="0" marL="0">
               <a:buNone/>
             </a:pPr>
             <a:r>
-              <a:rPr lang="en-US" sz="1300" b="1" dirty="0">
+              <a:rPr lang="en-US" sz="1600" b="1" dirty="0">
                 <a:solidFill>
                   <a:srgbClr val="FFFFFF"/>
                 </a:solidFill>
               </a:rPr>
-              <a:t>NotesController</a:t>
-            </a:r>
-            <a:endParaRPr lang="en-US" sz="1300" dirty="0"/>
-          </a:p>
-          <a:p>
-            <a:pPr algn="ctr" indent="0" marL="0">
-              <a:buNone/>
-            </a:pPr>
-            <a:r>
-              <a:rPr lang="en-US" sz="1000" dirty="0">
-                <a:solidFill>
-                  <a:srgbClr val="FFFFFF"/>
-                </a:solidFill>
-              </a:rPr>
-              <a:t>routes: parse, delegate, return</a:t>
-            </a:r>
-            <a:endParaRPr lang="en-US" sz="1300" dirty="0"/>
-          </a:p>
-        </p:txBody>
-      </p:sp>
-      <p:sp>
-        <p:nvSpPr>
-          <p:cNvPr id="11" name="Shape 9"/>
-          <p:cNvSpPr/>
-          <p:nvPr/>
-        </p:nvSpPr>
-        <p:spPr>
-          <a:xfrm>
-            <a:off x="4206240" y="2240280"/>
-            <a:ext cx="0" cy="274320"/>
+              <a:t>Controller</a:t>
+            </a:r>
+            <a:endParaRPr lang="en-US" sz="1600" dirty="0"/>
+          </a:p>
+        </p:txBody>
+      </p:sp>
+      <p:sp>
+        <p:nvSpPr>
+          <p:cNvPr id="7" name="Shape 5"/>
+          <p:cNvSpPr/>
+          <p:nvPr/>
+        </p:nvSpPr>
+        <p:spPr>
+          <a:xfrm>
+            <a:off x="5212080" y="2221992"/>
+            <a:ext cx="0" cy="292608"/>
           </a:xfrm>
           <a:prstGeom prst="line">
             <a:avLst/>
           </a:prstGeom>
           <a:noFill/>
-          <a:ln w="19050">
+          <a:ln w="25400">
             <a:solidFill>
               <a:srgbClr val="64748B"/>
             </a:solidFill>
@@ -12892,54 +12399,18 @@
       </p:sp>
       <p:sp>
         <p:nvSpPr>
-          <p:cNvPr id="12" name="Text 10"/>
-          <p:cNvSpPr txBox="1"/>
-          <p:nvPr/>
-        </p:nvSpPr>
-        <p:spPr>
-          <a:xfrm>
-            <a:off x="4297680" y="2258568"/>
-            <a:ext cx="731520" cy="274320"/>
-          </a:xfrm>
-          <a:prstGeom prst="rect">
-            <a:avLst/>
-          </a:prstGeom>
-          <a:noFill/>
-          <a:ln/>
-        </p:spPr>
-        <p:txBody>
-          <a:bodyPr wrap="square" lIns="0" tIns="0" rIns="0" bIns="0" rtlCol="0" anchor="ctr"/>
-          <a:lstStyle/>
-          <a:p>
-            <a:pPr indent="0" marL="0">
-              <a:buNone/>
-            </a:pPr>
-            <a:r>
-              <a:rPr lang="en-US" sz="1000" i="1" dirty="0">
-                <a:solidFill>
-                  <a:srgbClr val="64748B"/>
-                </a:solidFill>
-              </a:rPr>
-              <a:t>injects</a:t>
-            </a:r>
-            <a:endParaRPr lang="en-US" sz="1000" dirty="0"/>
-          </a:p>
-        </p:txBody>
-      </p:sp>
-      <p:sp>
-        <p:nvSpPr>
-          <p:cNvPr id="13" name="service"/>
-          <p:cNvSpPr/>
-          <p:nvPr/>
-        </p:nvSpPr>
-        <p:spPr>
-          <a:xfrm>
-            <a:off x="3017520" y="2514600"/>
-            <a:ext cx="2377440" cy="731520"/>
+          <p:cNvPr id="8" name="service"/>
+          <p:cNvSpPr/>
+          <p:nvPr/>
+        </p:nvSpPr>
+        <p:spPr>
+          <a:xfrm>
+            <a:off x="4069080" y="2542032"/>
+            <a:ext cx="2286000" cy="685800"/>
           </a:xfrm>
           <a:prstGeom prst="roundRect">
             <a:avLst>
-              <a:gd name="adj" fmla="val 10000"/>
+              <a:gd name="adj" fmla="val 13333"/>
             </a:avLst>
           </a:prstGeom>
           <a:solidFill>
@@ -12955,14 +12426,14 @@
       </p:sp>
       <p:sp>
         <p:nvSpPr>
-          <p:cNvPr id="14" name="Text 12"/>
+          <p:cNvPr id="9" name="Text 7"/>
           <p:cNvSpPr txBox="1"/>
           <p:nvPr/>
         </p:nvSpPr>
         <p:spPr>
           <a:xfrm>
-            <a:off x="3017520" y="2514600"/>
-            <a:ext cx="2377440" cy="731520"/>
+            <a:off x="4069080" y="2542032"/>
+            <a:ext cx="2286000" cy="685800"/>
           </a:xfrm>
           <a:prstGeom prst="rect">
             <a:avLst/>
@@ -12971,54 +12442,40 @@
           <a:ln/>
         </p:spPr>
         <p:txBody>
-          <a:bodyPr wrap="square" lIns="38100" tIns="38100" rIns="38100" bIns="38100" rtlCol="0" anchor="ctr"/>
+          <a:bodyPr wrap="square" lIns="25400" tIns="25400" rIns="25400" bIns="25400" rtlCol="0" anchor="ctr"/>
           <a:lstStyle/>
           <a:p>
             <a:pPr algn="ctr" indent="0" marL="0">
               <a:buNone/>
             </a:pPr>
             <a:r>
-              <a:rPr lang="en-US" sz="1300" b="1" dirty="0">
+              <a:rPr lang="en-US" sz="1600" b="1" dirty="0">
                 <a:solidFill>
                   <a:srgbClr val="FFFFFF"/>
                 </a:solidFill>
               </a:rPr>
-              <a:t>NotesService</a:t>
-            </a:r>
-            <a:endParaRPr lang="en-US" sz="1300" dirty="0"/>
-          </a:p>
-          <a:p>
-            <a:pPr algn="ctr" indent="0" marL="0">
-              <a:buNone/>
-            </a:pPr>
-            <a:r>
-              <a:rPr lang="en-US" sz="1000" dirty="0">
-                <a:solidFill>
-                  <a:srgbClr val="FFFFFF"/>
-                </a:solidFill>
-              </a:rPr>
-              <a:t>the rules; throws DomainError</a:t>
-            </a:r>
-            <a:endParaRPr lang="en-US" sz="1300" dirty="0"/>
-          </a:p>
-        </p:txBody>
-      </p:sp>
-      <p:sp>
-        <p:nvSpPr>
-          <p:cNvPr id="15" name="Shape 13"/>
-          <p:cNvSpPr/>
-          <p:nvPr/>
-        </p:nvSpPr>
-        <p:spPr>
-          <a:xfrm>
-            <a:off x="4206240" y="3246120"/>
-            <a:ext cx="0" cy="274320"/>
+              <a:t>Service</a:t>
+            </a:r>
+            <a:endParaRPr lang="en-US" sz="1600" dirty="0"/>
+          </a:p>
+        </p:txBody>
+      </p:sp>
+      <p:sp>
+        <p:nvSpPr>
+          <p:cNvPr id="10" name="Shape 8"/>
+          <p:cNvSpPr/>
+          <p:nvPr/>
+        </p:nvSpPr>
+        <p:spPr>
+          <a:xfrm>
+            <a:off x="5212080" y="3255264"/>
+            <a:ext cx="0" cy="292608"/>
           </a:xfrm>
           <a:prstGeom prst="line">
             <a:avLst/>
           </a:prstGeom>
           <a:noFill/>
-          <a:ln w="19050">
+          <a:ln w="25400">
             <a:solidFill>
               <a:srgbClr val="64748B"/>
             </a:solidFill>
@@ -13029,54 +12486,18 @@
       </p:sp>
       <p:sp>
         <p:nvSpPr>
-          <p:cNvPr id="16" name="Text 14"/>
-          <p:cNvSpPr txBox="1"/>
-          <p:nvPr/>
-        </p:nvSpPr>
-        <p:spPr>
-          <a:xfrm>
-            <a:off x="4297680" y="3264408"/>
-            <a:ext cx="1463040" cy="274320"/>
-          </a:xfrm>
-          <a:prstGeom prst="rect">
-            <a:avLst/>
-          </a:prstGeom>
-          <a:noFill/>
-          <a:ln/>
-        </p:spPr>
-        <p:txBody>
-          <a:bodyPr wrap="square" lIns="0" tIns="0" rIns="0" bIns="0" rtlCol="0" anchor="ctr"/>
-          <a:lstStyle/>
-          <a:p>
-            <a:pPr indent="0" marL="0">
-              <a:buNone/>
-            </a:pPr>
-            <a:r>
-              <a:rPr lang="en-US" sz="1000" i="1" dirty="0">
-                <a:solidFill>
-                  <a:srgbClr val="64748B"/>
-                </a:solidFill>
-              </a:rPr>
-              <a:t>injects the token</a:t>
-            </a:r>
-            <a:endParaRPr lang="en-US" sz="1000" dirty="0"/>
-          </a:p>
-        </p:txBody>
-      </p:sp>
-      <p:sp>
-        <p:nvSpPr>
-          <p:cNvPr id="17" name="repository"/>
-          <p:cNvSpPr/>
-          <p:nvPr/>
-        </p:nvSpPr>
-        <p:spPr>
-          <a:xfrm>
-            <a:off x="3017520" y="3520440"/>
-            <a:ext cx="2377440" cy="731520"/>
+          <p:cNvPr id="11" name="repository"/>
+          <p:cNvSpPr/>
+          <p:nvPr/>
+        </p:nvSpPr>
+        <p:spPr>
+          <a:xfrm>
+            <a:off x="4069080" y="3575304"/>
+            <a:ext cx="2286000" cy="685800"/>
           </a:xfrm>
           <a:prstGeom prst="roundRect">
             <a:avLst>
-              <a:gd name="adj" fmla="val 10000"/>
+              <a:gd name="adj" fmla="val 13333"/>
             </a:avLst>
           </a:prstGeom>
           <a:solidFill>
@@ -13092,14 +12513,14 @@
       </p:sp>
       <p:sp>
         <p:nvSpPr>
-          <p:cNvPr id="18" name="Text 16"/>
+          <p:cNvPr id="12" name="Text 10"/>
           <p:cNvSpPr txBox="1"/>
           <p:nvPr/>
         </p:nvSpPr>
         <p:spPr>
           <a:xfrm>
-            <a:off x="3017520" y="3520440"/>
-            <a:ext cx="2377440" cy="731520"/>
+            <a:off x="4069080" y="3575304"/>
+            <a:ext cx="2286000" cy="685800"/>
           </a:xfrm>
           <a:prstGeom prst="rect">
             <a:avLst/>
@@ -13108,52 +12529,38 @@
           <a:ln/>
         </p:spPr>
         <p:txBody>
-          <a:bodyPr wrap="square" lIns="38100" tIns="38100" rIns="38100" bIns="38100" rtlCol="0" anchor="ctr"/>
+          <a:bodyPr wrap="square" lIns="25400" tIns="25400" rIns="25400" bIns="25400" rtlCol="0" anchor="ctr"/>
           <a:lstStyle/>
           <a:p>
             <a:pPr algn="ctr" indent="0" marL="0">
               <a:buNone/>
             </a:pPr>
             <a:r>
-              <a:rPr lang="en-US" sz="1300" b="1" dirty="0">
+              <a:rPr lang="en-US" sz="1600" b="1" dirty="0">
                 <a:solidFill>
                   <a:srgbClr val="FFFFFF"/>
                 </a:solidFill>
               </a:rPr>
-              <a:t>DrizzleNotesRepository</a:t>
-            </a:r>
-            <a:endParaRPr lang="en-US" sz="1300" dirty="0"/>
-          </a:p>
-          <a:p>
-            <a:pPr algn="ctr" indent="0" marL="0">
-              <a:buNone/>
-            </a:pPr>
-            <a:r>
-              <a:rPr lang="en-US" sz="1000" dirty="0">
-                <a:solidFill>
-                  <a:srgbClr val="FFFFFF"/>
-                </a:solidFill>
-              </a:rPr>
-              <a:t>provided for NOTES_REPOSITORY</a:t>
-            </a:r>
-            <a:endParaRPr lang="en-US" sz="1300" dirty="0"/>
-          </a:p>
-        </p:txBody>
-      </p:sp>
-      <p:sp>
-        <p:nvSpPr>
-          <p:cNvPr id="19" name="middleware"/>
-          <p:cNvSpPr/>
-          <p:nvPr/>
-        </p:nvSpPr>
-        <p:spPr>
-          <a:xfrm>
-            <a:off x="6400800" y="1508760"/>
-            <a:ext cx="2286000" cy="731520"/>
+              <a:t>Repository</a:t>
+            </a:r>
+            <a:endParaRPr lang="en-US" sz="1600" dirty="0"/>
+          </a:p>
+        </p:txBody>
+      </p:sp>
+      <p:sp>
+        <p:nvSpPr>
+          <p:cNvPr id="13" name="middleware"/>
+          <p:cNvSpPr/>
+          <p:nvPr/>
+        </p:nvSpPr>
+        <p:spPr>
+          <a:xfrm>
+            <a:off x="914400" y="1508760"/>
+            <a:ext cx="2103120" cy="685800"/>
           </a:xfrm>
           <a:prstGeom prst="roundRect">
             <a:avLst>
-              <a:gd name="adj" fmla="val 10000"/>
+              <a:gd name="adj" fmla="val 13333"/>
             </a:avLst>
           </a:prstGeom>
           <a:solidFill>
@@ -13169,14 +12576,14 @@
       </p:sp>
       <p:sp>
         <p:nvSpPr>
-          <p:cNvPr id="20" name="Text 18"/>
+          <p:cNvPr id="14" name="Text 12"/>
           <p:cNvSpPr txBox="1"/>
           <p:nvPr/>
         </p:nvSpPr>
         <p:spPr>
           <a:xfrm>
-            <a:off x="6400800" y="1508760"/>
-            <a:ext cx="2286000" cy="731520"/>
+            <a:off x="914400" y="1508760"/>
+            <a:ext cx="2103120" cy="685800"/>
           </a:xfrm>
           <a:prstGeom prst="rect">
             <a:avLst/>
@@ -13185,112 +12592,62 @@
           <a:ln/>
         </p:spPr>
         <p:txBody>
-          <a:bodyPr wrap="square" lIns="38100" tIns="38100" rIns="38100" bIns="38100" rtlCol="0" anchor="ctr"/>
+          <a:bodyPr wrap="square" lIns="25400" tIns="25400" rIns="25400" bIns="25400" rtlCol="0" anchor="ctr"/>
           <a:lstStyle/>
           <a:p>
             <a:pPr algn="ctr" indent="0" marL="0">
               <a:buNone/>
             </a:pPr>
             <a:r>
-              <a:rPr lang="en-US" sz="1300" b="1" dirty="0">
+              <a:rPr lang="en-US" sz="1600" b="1" dirty="0">
                 <a:solidFill>
                   <a:srgbClr val="FFFFFF"/>
                 </a:solidFill>
               </a:rPr>
               <a:t>Middleware</a:t>
             </a:r>
-            <a:endParaRPr lang="en-US" sz="1300" dirty="0"/>
-          </a:p>
-          <a:p>
-            <a:pPr algn="ctr" indent="0" marL="0">
-              <a:buNone/>
-            </a:pPr>
-            <a:r>
-              <a:rPr lang="en-US" sz="1000" dirty="0">
-                <a:solidFill>
-                  <a:srgbClr val="FFFFFF"/>
-                </a:solidFill>
-              </a:rPr>
-              <a:t>consumer.apply(fn).forRoutes(…)</a:t>
-            </a:r>
-            <a:endParaRPr lang="en-US" sz="1300" dirty="0"/>
-          </a:p>
-        </p:txBody>
-      </p:sp>
-      <p:sp>
-        <p:nvSpPr>
-          <p:cNvPr id="21" name="Shape 19"/>
-          <p:cNvSpPr/>
-          <p:nvPr/>
-        </p:nvSpPr>
-        <p:spPr>
-          <a:xfrm>
-            <a:off x="5394960" y="1874520"/>
-            <a:ext cx="1005840" cy="0"/>
+            <a:endParaRPr lang="en-US" sz="1600" dirty="0"/>
+          </a:p>
+        </p:txBody>
+      </p:sp>
+      <p:sp>
+        <p:nvSpPr>
+          <p:cNvPr id="15" name="Shape 13"/>
+          <p:cNvSpPr/>
+          <p:nvPr/>
+        </p:nvSpPr>
+        <p:spPr>
+          <a:xfrm>
+            <a:off x="3044952" y="1856232"/>
+            <a:ext cx="996696" cy="0"/>
           </a:xfrm>
           <a:prstGeom prst="line">
             <a:avLst/>
           </a:prstGeom>
           <a:noFill/>
-          <a:ln w="19050">
+          <a:ln w="25400">
             <a:solidFill>
-              <a:srgbClr val="E69A28"/>
+              <a:srgbClr val="64748B"/>
             </a:solidFill>
             <a:prstDash val="solid"/>
-            <a:headEnd type="triangle"/>
+            <a:tailEnd type="triangle"/>
           </a:ln>
         </p:spPr>
       </p:sp>
       <p:sp>
         <p:nvSpPr>
-          <p:cNvPr id="22" name="Text 20"/>
-          <p:cNvSpPr txBox="1"/>
-          <p:nvPr/>
-        </p:nvSpPr>
-        <p:spPr>
-          <a:xfrm>
-            <a:off x="5532120" y="1572768"/>
-            <a:ext cx="822960" cy="274320"/>
-          </a:xfrm>
-          <a:prstGeom prst="rect">
-            <a:avLst/>
-          </a:prstGeom>
-          <a:noFill/>
-          <a:ln/>
-        </p:spPr>
-        <p:txBody>
-          <a:bodyPr wrap="square" lIns="0" tIns="0" rIns="0" bIns="0" rtlCol="0" anchor="ctr"/>
-          <a:lstStyle/>
-          <a:p>
-            <a:pPr indent="0" marL="0">
-              <a:buNone/>
-            </a:pPr>
-            <a:r>
-              <a:rPr lang="en-US" sz="1000" i="1" dirty="0">
-                <a:solidFill>
-                  <a:srgbClr val="E69A28"/>
-                </a:solidFill>
-              </a:rPr>
-              <a:t>runs first</a:t>
-            </a:r>
-            <a:endParaRPr lang="en-US" sz="1000" dirty="0"/>
-          </a:p>
-        </p:txBody>
-      </p:sp>
-      <p:sp>
-        <p:nvSpPr>
-          <p:cNvPr id="23" name="database-module"/>
-          <p:cNvSpPr/>
-          <p:nvPr/>
-        </p:nvSpPr>
-        <p:spPr>
-          <a:xfrm>
-            <a:off x="6400800" y="3520440"/>
-            <a:ext cx="2286000" cy="731520"/>
+          <p:cNvPr id="16" name="database"/>
+          <p:cNvSpPr/>
+          <p:nvPr/>
+        </p:nvSpPr>
+        <p:spPr>
+          <a:xfrm>
+            <a:off x="7315200" y="3575304"/>
+            <a:ext cx="1371600" cy="685800"/>
           </a:xfrm>
           <a:prstGeom prst="roundRect">
             <a:avLst>
-              <a:gd name="adj" fmla="val 10000"/>
+              <a:gd name="adj" fmla="val 13333"/>
             </a:avLst>
           </a:prstGeom>
           <a:solidFill>
@@ -13306,14 +12663,14 @@
       </p:sp>
       <p:sp>
         <p:nvSpPr>
-          <p:cNvPr id="24" name="Text 22"/>
+          <p:cNvPr id="17" name="Text 15"/>
           <p:cNvSpPr txBox="1"/>
           <p:nvPr/>
         </p:nvSpPr>
         <p:spPr>
           <a:xfrm>
-            <a:off x="6400800" y="3520440"/>
-            <a:ext cx="2286000" cy="731520"/>
+            <a:off x="7315200" y="3575304"/>
+            <a:ext cx="1371600" cy="685800"/>
           </a:xfrm>
           <a:prstGeom prst="rect">
             <a:avLst/>
@@ -13322,97 +12679,47 @@
           <a:ln/>
         </p:spPr>
         <p:txBody>
-          <a:bodyPr wrap="square" lIns="38100" tIns="38100" rIns="38100" bIns="38100" rtlCol="0" anchor="ctr"/>
+          <a:bodyPr wrap="square" lIns="25400" tIns="25400" rIns="25400" bIns="25400" rtlCol="0" anchor="ctr"/>
           <a:lstStyle/>
           <a:p>
             <a:pPr algn="ctr" indent="0" marL="0">
               <a:buNone/>
             </a:pPr>
             <a:r>
-              <a:rPr lang="en-US" sz="1300" b="1" dirty="0">
+              <a:rPr lang="en-US" sz="1600" b="1" dirty="0">
                 <a:solidFill>
                   <a:srgbClr val="FFFFFF"/>
                 </a:solidFill>
               </a:rPr>
-              <a:t>DatabaseModule</a:t>
-            </a:r>
-            <a:endParaRPr lang="en-US" sz="1300" dirty="0"/>
-          </a:p>
-          <a:p>
-            <a:pPr algn="ctr" indent="0" marL="0">
-              <a:buNone/>
-            </a:pPr>
-            <a:r>
-              <a:rPr lang="en-US" sz="1000" dirty="0">
-                <a:solidFill>
-                  <a:srgbClr val="FFFFFF"/>
-                </a:solidFill>
-              </a:rPr>
-              <a:t>the DB token, global</a:t>
-            </a:r>
-            <a:endParaRPr lang="en-US" sz="1300" dirty="0"/>
-          </a:p>
-        </p:txBody>
-      </p:sp>
-      <p:sp>
-        <p:nvSpPr>
-          <p:cNvPr id="25" name="Shape 23"/>
-          <p:cNvSpPr/>
-          <p:nvPr/>
-        </p:nvSpPr>
-        <p:spPr>
-          <a:xfrm>
-            <a:off x="5394960" y="3886200"/>
-            <a:ext cx="1005840" cy="0"/>
+              <a:t>Database</a:t>
+            </a:r>
+            <a:endParaRPr lang="en-US" sz="1600" dirty="0"/>
+          </a:p>
+        </p:txBody>
+      </p:sp>
+      <p:sp>
+        <p:nvSpPr>
+          <p:cNvPr id="18" name="Shape 16"/>
+          <p:cNvSpPr/>
+          <p:nvPr/>
+        </p:nvSpPr>
+        <p:spPr>
+          <a:xfrm>
+            <a:off x="6382512" y="3922776"/>
+            <a:ext cx="905256" cy="0"/>
           </a:xfrm>
           <a:prstGeom prst="line">
             <a:avLst/>
           </a:prstGeom>
           <a:noFill/>
-          <a:ln w="19050">
+          <a:ln w="25400">
             <a:solidFill>
               <a:srgbClr val="64748B"/>
             </a:solidFill>
             <a:prstDash val="solid"/>
-            <a:headEnd type="triangle"/>
+            <a:tailEnd type="triangle"/>
           </a:ln>
         </p:spPr>
-      </p:sp>
-      <p:sp>
-        <p:nvSpPr>
-          <p:cNvPr id="26" name="Text 24"/>
-          <p:cNvSpPr txBox="1"/>
-          <p:nvPr/>
-        </p:nvSpPr>
-        <p:spPr>
-          <a:xfrm>
-            <a:off x="457200" y="4462272"/>
-            <a:ext cx="8229600" cy="274320"/>
-          </a:xfrm>
-          <a:prstGeom prst="rect">
-            <a:avLst/>
-          </a:prstGeom>
-          <a:noFill/>
-          <a:ln/>
-        </p:spPr>
-        <p:txBody>
-          <a:bodyPr wrap="square" lIns="0" tIns="0" rIns="0" bIns="0" rtlCol="0" anchor="ctr"/>
-          <a:lstStyle/>
-          <a:p>
-            <a:pPr indent="0" marL="0">
-              <a:buNone/>
-            </a:pPr>
-            <a:r>
-              <a:rPr lang="en-US" sz="1200" i="1" dirty="0">
-                <a:solidFill>
-                  <a:srgbClr val="64748B"/>
-                </a:solidFill>
-              </a:rPr>
-              <a:t>Inject a token, not a class: the module decides the storage.</a:t>
-            </a:r>
-            <a:endParaRPr lang="en-US" sz="1200" dirty="0"/>
-          </a:p>
-        </p:txBody>
       </p:sp>
       <p:sp>
         <p:nvSpPr>

</xml_diff>

<commit_message>
course: the module 2 MCP server reads and writes (create-user, delete-note, guarded execute)
The SQL MCP now has write tools so Claude Desktop can query and change the learner's
SQLite data. execute runs one INSERT/UPDATE/DELETE (no DDL, PRAGMA, SELECT, multiple
statements or unbounded UPDATE/DELETE), foreign keys on. Tools carry read-only and
destructive annotations.

Lab 02 grew to 16 checks; each of the 5 SQL guards, removed one at a time, turns it red.
Module 2 rebuilt by a fresh agent from the module 1 checkpoint; patch regenerated.
Measured with npm ci from a clean base: 20/5, 43/49, 46/58, labs 31/31.

Co-Authored-By: Claude Opus 5.5 (1M context) <noreply@anthropic.com>
</commit_message>
<xml_diff>
--- a/docs/ai-agent-training/slides/lab-companion.pptx
+++ b/docs/ai-agent-training/slides/lab-companion.pptx
@@ -874,7 +874,7 @@
           <a:p>
             <a:r>
               <a:rPr lang="en-US" dirty="0"/>
-              <a:t>The labs run on an empty in-memory database; this step proves the resources also serve the seeded rows. Then pnpm db:seed puts the data back.</a:t>
+              <a:t>The labs run on an empty in-memory database; this step proves the resources also serve the seeded rows. Then npm run db:seed puts the data back.</a:t>
             </a:r>
             <a:endParaRPr lang="en-US" dirty="0"/>
           </a:p>
@@ -1226,7 +1226,7 @@
           <a:p>
             <a:r>
               <a:rPr lang="en-US" dirty="0"/>
-              <a:t>Measured: a fresh agent got lab 02 10/10 (lab 01 still 15/15) and verify 60 unit / 55 e2e. Its query guard has two layers, each proven by removing it: one SELECT/WITH statement (libSQL silently runs only the first of two), and a query_only connection (a delete hidden in a WITH emptied the copy without it). It also found that the default database path is relative to the working directory.</a:t>
+              <a:t>Measured: a fresh agent got labs 31/31 and verify 46 unit / 58 e2e. Five SQL guards, each removed once and caught by lab 02: query is one SELECT/WITH statement (libSQL silently drops a second) run under PRAGMA query_only (a WITH can hide a delete); execute is one statement, only INSERT/UPDATE/DELETE, and UPDATE/DELETE need a WHERE. Its own e2e test missed two of the five: the lab checks come from the spec, not the code. The typed write tools call UsersService and NotesService, so removing a rule there turns the MCP checks red too. execute keeps foreign keys on but does not apply the service rules; its description says so.</a:t>
             </a:r>
             <a:endParaRPr lang="en-US" dirty="0"/>
           </a:p>
@@ -1314,7 +1314,7 @@
           <a:p>
             <a:r>
               <a:rPr lang="en-US" dirty="0"/>
-              <a:t>Claude Desktop starts the server from its own folder with a minimal PATH, so the entry needs absolute paths for node, the server and the database: the script prints them. Quit Claude Desktop completely (not just the window) before reopening. The lab runs on a COPY of data/app.db; Claude Desktop writes to the real one, and pnpm db:seed puts it back.</a:t>
+              <a:t>Claude Desktop starts the server from its own folder with a minimal PATH, so the entry needs absolute paths for node, the server and the database: the script prints them. Quit Claude Desktop completely (not just the window) before reopening. The lab runs on a COPY of data/app.db; Claude Desktop writes to the real one, and npm run db:seed puts it back.</a:t>
             </a:r>
             <a:endParaRPr lang="en-US" dirty="0"/>
           </a:p>
@@ -3399,7 +3399,7 @@
                 <a:ea typeface="Courier New" pitchFamily="34" charset="-122"/>
                 <a:cs typeface="Courier New" pitchFamily="34" charset="-120"/>
               </a:rPr>
-              <a:t>$ pnpm verify</a:t>
+              <a:t>$ npm run verify</a:t>
             </a:r>
             <a:endParaRPr lang="en-US" sz="1200" dirty="0"/>
           </a:p>
@@ -4124,7 +4124,7 @@
                   <a:srgbClr val="1B1F24"/>
                 </a:solidFill>
               </a:rPr>
-              <a:t>switches to corepack pnpm if pnpm is missing</a:t>
+              <a:t>passes script flags after --</a:t>
             </a:r>
             <a:endParaRPr lang="en-US" sz="1200" dirty="0"/>
           </a:p>
@@ -4501,7 +4501,7 @@
                 <a:ea typeface="Courier New" pitchFamily="34" charset="-122"/>
                 <a:cs typeface="Courier New" pitchFamily="34" charset="-120"/>
               </a:rPr>
-              <a:t>specs/users.md. Done when pnpm verify is green.</a:t>
+              <a:t>specs/users.md. Done when npm run verify is green.</a:t>
             </a:r>
             <a:endParaRPr lang="en-US" sz="1100" dirty="0"/>
           </a:p>
@@ -5254,7 +5254,7 @@
                 <a:ea typeface="Courier New" pitchFamily="34" charset="-122"/>
                 <a:cs typeface="Courier New" pitchFamily="34" charset="-120"/>
               </a:rPr>
-              <a:t>when pnpm lab 01 and pnpm verify are green.</a:t>
+              <a:t>when npm run lab 01 and npm run verify are green.</a:t>
             </a:r>
             <a:endParaRPr lang="en-US" sz="1000" dirty="0"/>
           </a:p>
@@ -5918,7 +5918,7 @@
                 <a:ea typeface="Courier New" pitchFamily="34" charset="-122"/>
                 <a:cs typeface="Courier New" pitchFamily="34" charset="-120"/>
               </a:rPr>
-              <a:t>pnpm verify       # read both Tests lines</a:t>
+              <a:t>npm run verify       # read both Tests lines</a:t>
             </a:r>
             <a:endParaRPr lang="en-US" sz="1200" dirty="0"/>
           </a:p>
@@ -5935,7 +5935,7 @@
                 <a:ea typeface="Courier New" pitchFamily="34" charset="-122"/>
                 <a:cs typeface="Courier New" pitchFamily="34" charset="-120"/>
               </a:rPr>
-              <a:t>pnpm build</a:t>
+              <a:t>npm run build</a:t>
             </a:r>
             <a:endParaRPr lang="en-US" sz="1200" dirty="0"/>
           </a:p>
@@ -5952,7 +5952,7 @@
                 <a:ea typeface="Courier New" pitchFamily="34" charset="-122"/>
                 <a:cs typeface="Courier New" pitchFamily="34" charset="-120"/>
               </a:rPr>
-              <a:t>pnpm start</a:t>
+              <a:t>npm run start</a:t>
             </a:r>
             <a:endParaRPr lang="en-US" sz="1200" dirty="0"/>
           </a:p>
@@ -6003,7 +6003,7 @@
                 <a:ea typeface="Courier New" pitchFamily="34" charset="-122"/>
                 <a:cs typeface="Courier New" pitchFamily="34" charset="-120"/>
               </a:rPr>
-              <a:t>pnpm lab 01   # the lab check: all green?</a:t>
+              <a:t>npm run lab 01   # the lab check: all green?</a:t>
             </a:r>
             <a:endParaRPr lang="en-US" sz="1200" dirty="0"/>
           </a:p>
@@ -6498,7 +6498,7 @@
                 <a:ea typeface="Courier New" pitchFamily="34" charset="-122"/>
                 <a:cs typeface="Courier New" pitchFamily="34" charset="-120"/>
               </a:rPr>
-              <a:t># pnpm verify (base: 20 unit, 5 e2e)</a:t>
+              <a:t># npm run verify (base: 20 unit, 5 e2e)</a:t>
             </a:r>
             <a:endParaRPr lang="en-US" sz="1200" dirty="0"/>
           </a:p>
@@ -6549,7 +6549,7 @@
                 <a:ea typeface="Courier New" pitchFamily="34" charset="-122"/>
                 <a:cs typeface="Courier New" pitchFamily="34" charset="-120"/>
               </a:rPr>
-              <a:t># pnpm lab 01</a:t>
+              <a:t># npm run lab 01</a:t>
             </a:r>
             <a:endParaRPr lang="en-US" sz="1200" dirty="0"/>
           </a:p>
@@ -6744,7 +6744,7 @@
                 <a:ea typeface="Courier New" pitchFamily="34" charset="-122"/>
                 <a:cs typeface="Courier New" pitchFamily="34" charset="-120"/>
               </a:rPr>
-              <a:t>pnpm lab 01</a:t>
+              <a:t>npm run lab 01</a:t>
             </a:r>
             <a:pPr indent="0" marL="0">
               <a:buNone/>
@@ -7159,7 +7159,7 @@
                   <a:srgbClr val="2B3440"/>
                 </a:solidFill>
               </a:rPr>
-              <a:t>The table is provided: there is nothing to generate. pnpm verify (check:migrations) proves it.</a:t>
+              <a:t>The table is provided: there is nothing to generate. npm run verify (check:migrations) proves it.</a:t>
             </a:r>
             <a:endParaRPr lang="en-US" sz="1600" dirty="0"/>
           </a:p>
@@ -7595,7 +7595,7 @@
                   <a:srgbClr val="CBD5E1"/>
                 </a:solidFill>
               </a:rPr>
-              <a:t>Your agent builds an MCP server that reads and writes the database; you connect it to Claude Desktop and ask Claude about the data.</a:t>
+              <a:t>Your agent builds an MCP server that queries and changes the database; you connect it to Claude Desktop and have Claude read and write your data.</a:t>
             </a:r>
             <a:endParaRPr lang="en-US" sz="1800" dirty="0"/>
           </a:p>
@@ -7901,7 +7901,7 @@
                   <a:srgbClr val="2B3440"/>
                 </a:solidFill>
               </a:rPr>
-              <a:t>The goal: your Claude Desktop app answers questions from this database. The model writes the SQL, so the server decides what may run.</a:t>
+              <a:t>The goal: your Claude Desktop app queries and changes this database. The model writes the SQL, so the server decides what may run.</a:t>
             </a:r>
             <a:endParaRPr lang="en-US" sz="1400" dirty="0"/>
           </a:p>
@@ -8098,7 +8098,7 @@
                 <a:ea typeface="Courier New" pitchFamily="34" charset="-122"/>
                 <a:cs typeface="Courier New" pitchFamily="34" charset="-120"/>
               </a:rPr>
-              <a:t>server in specs/mcp.md. Done when pnpm lab 02 and pnpm</a:t>
+              <a:t>server in specs/mcp.md. Done when npm run lab 02 and npm</a:t>
             </a:r>
             <a:endParaRPr lang="en-US" sz="1000" dirty="0"/>
           </a:p>
@@ -8115,7 +8115,7 @@
                 <a:ea typeface="Courier New" pitchFamily="34" charset="-122"/>
                 <a:cs typeface="Courier New" pitchFamily="34" charset="-120"/>
               </a:rPr>
-              <a:t>verify are green; then show me how to connect it to Claude</a:t>
+              <a:t>run verify are green; then show me how to connect it to</a:t>
             </a:r>
             <a:endParaRPr lang="en-US" sz="1000" dirty="0"/>
           </a:p>
@@ -8132,7 +8132,24 @@
                 <a:ea typeface="Courier New" pitchFamily="34" charset="-122"/>
                 <a:cs typeface="Courier New" pitchFamily="34" charset="-120"/>
               </a:rPr>
-              <a:t>Desktop, and two questions I could ask it.</a:t>
+              <a:t>Claude Desktop, one question I could ask it and one change</a:t>
+            </a:r>
+            <a:endParaRPr lang="en-US" sz="1000" dirty="0"/>
+          </a:p>
+          <a:p>
+            <a:pPr indent="0" marL="0">
+              <a:buNone/>
+            </a:pPr>
+            <a:r>
+              <a:rPr lang="en-US" sz="1000" dirty="0">
+                <a:solidFill>
+                  <a:srgbClr val="E6EDF3"/>
+                </a:solidFill>
+                <a:latin typeface="Courier New" pitchFamily="34" charset="0"/>
+                <a:ea typeface="Courier New" pitchFamily="34" charset="-122"/>
+                <a:cs typeface="Courier New" pitchFamily="34" charset="-120"/>
+              </a:rPr>
+              <a:t>I could ask it to make.</a:t>
             </a:r>
             <a:endParaRPr lang="en-US" sz="1000" dirty="0"/>
           </a:p>
@@ -8338,7 +8355,7 @@
                   <a:srgbClr val="1B1F24"/>
                 </a:solidFill>
               </a:rPr>
-              <a:t>write tools call NotesService: no rule copied</a:t>
+              <a:t>typed write tools call the module 1 services</a:t>
             </a:r>
             <a:endParaRPr lang="en-US" sz="1200" dirty="0"/>
           </a:p>
@@ -8423,7 +8440,7 @@
                   <a:srgbClr val="1B1F24"/>
                 </a:solidFill>
               </a:rPr>
-              <a:t>query read-only in two layers</a:t>
+              <a:t>query and execute each guarded in layers</a:t>
             </a:r>
             <a:endParaRPr lang="en-US" sz="1200" dirty="0"/>
           </a:p>
@@ -8796,7 +8813,7 @@
                 <a:ea typeface="Courier New" pitchFamily="34" charset="-122"/>
                 <a:cs typeface="Courier New" pitchFamily="34" charset="-120"/>
               </a:rPr>
-              <a:t>pnpm verify</a:t>
+              <a:t>npm run verify</a:t>
             </a:r>
             <a:endParaRPr lang="en-US" sz="1400" dirty="0"/>
           </a:p>
@@ -8813,7 +8830,7 @@
                 <a:ea typeface="Courier New" pitchFamily="34" charset="-122"/>
                 <a:cs typeface="Courier New" pitchFamily="34" charset="-120"/>
               </a:rPr>
-              <a:t>pnpm build</a:t>
+              <a:t>npm run build</a:t>
             </a:r>
             <a:endParaRPr lang="en-US" sz="1400" dirty="0"/>
           </a:p>
@@ -8909,13 +8926,47 @@
             <a:r>
               <a:rPr lang="en-US" sz="1400" dirty="0">
                 <a:solidFill>
-                  <a:srgbClr val="E6EDF3"/>
+                  <a:srgbClr val="8B98A5"/>
                 </a:solidFill>
                 <a:latin typeface="Courier New" pitchFamily="34" charset="0"/>
                 <a:ea typeface="Courier New" pitchFamily="34" charset="-122"/>
                 <a:cs typeface="Courier New" pitchFamily="34" charset="-120"/>
               </a:rPr>
-              <a:t>pnpm lab 02   # the lab check: all green?</a:t>
+              <a:t># "Add a user Ada, ada@example.com, with</a:t>
+            </a:r>
+            <a:endParaRPr lang="en-US" sz="1400" dirty="0"/>
+          </a:p>
+          <a:p>
+            <a:pPr indent="0" marL="0">
+              <a:buNone/>
+            </a:pPr>
+            <a:r>
+              <a:rPr lang="en-US" sz="1400" dirty="0">
+                <a:solidFill>
+                  <a:srgbClr val="8B98A5"/>
+                </a:solidFill>
+                <a:latin typeface="Courier New" pitchFamily="34" charset="0"/>
+                <a:ea typeface="Courier New" pitchFamily="34" charset="-122"/>
+                <a:cs typeface="Courier New" pitchFamily="34" charset="-120"/>
+              </a:rPr>
+              <a:t>#   a note due next Friday"</a:t>
+            </a:r>
+            <a:endParaRPr lang="en-US" sz="1400" dirty="0"/>
+          </a:p>
+          <a:p>
+            <a:pPr indent="0" marL="0">
+              <a:buNone/>
+            </a:pPr>
+            <a:r>
+              <a:rPr lang="en-US" sz="1400" dirty="0">
+                <a:solidFill>
+                  <a:srgbClr val="E6EDF3"/>
+                </a:solidFill>
+                <a:latin typeface="Courier New" pitchFamily="34" charset="0"/>
+                <a:ea typeface="Courier New" pitchFamily="34" charset="-122"/>
+                <a:cs typeface="Courier New" pitchFamily="34" charset="-120"/>
+              </a:rPr>
+              <a:t>npm run lab 02   # the lab check: all green?</a:t>
             </a:r>
             <a:endParaRPr lang="en-US" sz="1400" dirty="0"/>
           </a:p>
@@ -9203,7 +9254,7 @@
                 <a:ea typeface="Courier New" pitchFamily="34" charset="-122"/>
                 <a:cs typeface="Courier New" pitchFamily="34" charset="-120"/>
               </a:rPr>
-              <a:t># pnpm verify; pnpm lab 01 02</a:t>
+              <a:t># npm run verify; npm run lab</a:t>
             </a:r>
             <a:endParaRPr lang="en-US" sz="1200" dirty="0"/>
           </a:p>
@@ -9220,7 +9271,7 @@
                 <a:ea typeface="Courier New" pitchFamily="34" charset="-122"/>
                 <a:cs typeface="Courier New" pitchFamily="34" charset="-120"/>
               </a:rPr>
-              <a:t>Tests  60 passed (60) · 58 passed (58)</a:t>
+              <a:t>Tests  46 passed (46) · 58 passed (58)</a:t>
             </a:r>
             <a:endParaRPr lang="en-US" sz="1200" dirty="0"/>
           </a:p>
@@ -9237,7 +9288,7 @@
                 <a:ea typeface="Courier New" pitchFamily="34" charset="-122"/>
                 <a:cs typeface="Courier New" pitchFamily="34" charset="-120"/>
               </a:rPr>
-              <a:t>Tests  25 passed (25)</a:t>
+              <a:t>Tests  31 passed (31)</a:t>
             </a:r>
             <a:endParaRPr lang="en-US" sz="1200" dirty="0"/>
           </a:p>
@@ -9271,7 +9322,7 @@
                 <a:ea typeface="Courier New" pitchFamily="34" charset="-122"/>
                 <a:cs typeface="Courier New" pitchFamily="34" charset="-120"/>
               </a:rPr>
-              <a:t>server: notes-db</a:t>
+              <a:t>create-user · create-note · share-note</a:t>
             </a:r>
             <a:endParaRPr lang="en-US" sz="1200" dirty="0"/>
           </a:p>
@@ -9288,7 +9339,7 @@
                 <a:ea typeface="Courier New" pitchFamily="34" charset="-122"/>
                 <a:cs typeface="Courier New" pitchFamily="34" charset="-120"/>
               </a:rPr>
-              <a:t>users 25 · notes 200 · note_shares 120</a:t>
+              <a:t>execute update … where id = … → 1 row</a:t>
             </a:r>
             <a:endParaRPr lang="en-US" sz="1200" dirty="0"/>
           </a:p>
@@ -9305,7 +9356,7 @@
                 <a:ea typeface="Courier New" pitchFamily="34" charset="-122"/>
                 <a:cs typeface="Courier New" pitchFamily="34" charset="-120"/>
               </a:rPr>
-              <a:t># query: delete from notes</a:t>
+              <a:t># execute: delete from notes</a:t>
             </a:r>
             <a:endParaRPr lang="en-US" sz="1200" dirty="0"/>
           </a:p>
@@ -9322,7 +9373,7 @@
                 <a:ea typeface="Courier New" pitchFamily="34" charset="-122"/>
                 <a:cs typeface="Courier New" pitchFamily="34" charset="-120"/>
               </a:rPr>
-              <a:t>READ_ONLY: only a single SELECT …</a:t>
+              <a:t>NOT_ALLOWED: DELETE without a WHERE …</a:t>
             </a:r>
             <a:endParaRPr lang="en-US" sz="1200" dirty="0"/>
           </a:p>
@@ -9449,7 +9500,7 @@
                 <a:ea typeface="Courier New" pitchFamily="34" charset="-122"/>
                 <a:cs typeface="Courier New" pitchFamily="34" charset="-120"/>
               </a:rPr>
-              <a:t>pnpm lab 02</a:t>
+              <a:t>npm run lab 02</a:t>
             </a:r>
             <a:pPr indent="0" marL="0">
               <a:buNone/>
@@ -9545,7 +9596,7 @@
                   <a:srgbClr val="1B1F24"/>
                 </a:solidFill>
               </a:rPr>
-              <a:t>a write sent to query is READ_ONLY</a:t>
+              <a:t>query refuses a write, execute an unbounded one</a:t>
             </a:r>
             <a:endParaRPr lang="en-US" sz="1400" dirty="0"/>
           </a:p>
@@ -9630,7 +9681,7 @@
                   <a:srgbClr val="1B1F24"/>
                 </a:solidFill>
               </a:rPr>
-              <a:t>Claude Desktop answers a question about the data</a:t>
+              <a:t>Claude Desktop answers a question and makes a change</a:t>
             </a:r>
             <a:endParaRPr lang="en-US" sz="1400" dirty="0"/>
           </a:p>
@@ -10366,7 +10417,7 @@
                   <a:srgbClr val="2B3440"/>
                 </a:solidFill>
               </a:rPr>
-              <a:t>pnpm verify + pnpm lab NN: read the counts</a:t>
+              <a:t>npm run verify + npm run lab NN: read the counts</a:t>
             </a:r>
             <a:endParaRPr lang="en-US" sz="1400" dirty="0"/>
           </a:p>
@@ -10769,7 +10820,7 @@
                   <a:srgbClr val="2B3440"/>
                 </a:solidFill>
               </a:rPr>
-              <a:t>A write can hide inside a WITH. Ask for a query_only connection too, and a test that tries it.</a:t>
+              <a:t>A write can hide inside a WITH. Ask for PRAGMA query_only too, and a test that tries it.</a:t>
             </a:r>
             <a:endParaRPr lang="en-US" sz="1600" dirty="0"/>
           </a:p>
@@ -10881,7 +10932,7 @@
                   <a:srgbClr val="1B1F24"/>
                 </a:solidFill>
               </a:rPr>
-              <a:t>Claude sees no tables</a:t>
+              <a:t>execute runs any SQL it is given</a:t>
             </a:r>
             <a:endParaRPr lang="en-US" sz="1600" dirty="0"/>
           </a:p>
@@ -10895,7 +10946,7 @@
                   <a:srgbClr val="2B3440"/>
                 </a:solidFill>
               </a:rPr>
-              <a:t>The server started in another folder and got an empty database. Use absolute paths; the server should exit when the file is missing.</a:t>
+              <a:t>One statement, INSERT/UPDATE/DELETE only, a WHERE on UPDATE and DELETE. Ask for a test per refusal.</a:t>
             </a:r>
             <a:endParaRPr lang="en-US" sz="1600" dirty="0"/>
           </a:p>
@@ -11007,7 +11058,7 @@
                   <a:srgbClr val="1B1F24"/>
                 </a:solidFill>
               </a:rPr>
-              <a:t>It copies the notes rules into the tools</a:t>
+              <a:t>Claude sees no tables</a:t>
             </a:r>
             <a:endParaRPr lang="en-US" sz="1600" dirty="0"/>
           </a:p>
@@ -11021,7 +11072,7 @@
                   <a:srgbClr val="2B3440"/>
                 </a:solidFill>
               </a:rPr>
-              <a:t>One rule, two copies, one will drift. The tools should call NotesService.</a:t>
+              <a:t>The server started in another folder and got an empty database. Use absolute paths; the server should exit when the file is missing.</a:t>
             </a:r>
             <a:endParaRPr lang="en-US" sz="1600" dirty="0"/>
           </a:p>
@@ -13079,7 +13130,7 @@
                   <a:srgbClr val="2B3440"/>
                 </a:solidFill>
               </a:rPr>
-              <a:t>Every command runs in boilerplate\nest-ai-starter, one per line. </a:t>
+              <a:t>Every command runs in boilerplate\nest-ai-starter, one per line. npm ships with Node; scripts run as </a:t>
             </a:r>
             <a:pPr indent="0" marL="0">
               <a:buNone/>
@@ -13093,32 +13144,7 @@
                 <a:ea typeface="Courier New" pitchFamily="34" charset="-122"/>
                 <a:cs typeface="Courier New" pitchFamily="34" charset="-120"/>
               </a:rPr>
-              <a:t>corepack enable</a:t>
-            </a:r>
-            <a:pPr indent="0" marL="0">
-              <a:buNone/>
-            </a:pPr>
-            <a:r>
-              <a:rPr lang="en-US" sz="1400" dirty="0">
-                <a:solidFill>
-                  <a:srgbClr val="2B3440"/>
-                </a:solidFill>
-              </a:rPr>
-              <a:t> needs an administrator terminal; otherwise write </a:t>
-            </a:r>
-            <a:pPr indent="0" marL="0">
-              <a:buNone/>
-            </a:pPr>
-            <a:r>
-              <a:rPr lang="en-US" sz="1400" dirty="0">
-                <a:solidFill>
-                  <a:srgbClr val="2B3440"/>
-                </a:solidFill>
-                <a:latin typeface="Courier New" pitchFamily="34" charset="0"/>
-                <a:ea typeface="Courier New" pitchFamily="34" charset="-122"/>
-                <a:cs typeface="Courier New" pitchFamily="34" charset="-120"/>
-              </a:rPr>
-              <a:t>corepack pnpm</a:t>
+              <a:t>npm run &lt;name&gt;</a:t>
             </a:r>
             <a:pPr indent="0" marL="0">
               <a:buNone/>
@@ -13341,7 +13367,7 @@
                 <a:ea typeface="Courier New" pitchFamily="34" charset="-122"/>
                 <a:cs typeface="Courier New" pitchFamily="34" charset="-120"/>
               </a:rPr>
-              <a:t>pnpm db:seed</a:t>
+              <a:t>npm run db:seed</a:t>
             </a:r>
             <a:pPr indent="0" marL="0">
               <a:buNone/>
@@ -13771,7 +13797,7 @@
                 <a:ea typeface="Courier New" pitchFamily="34" charset="-122"/>
                 <a:cs typeface="Courier New" pitchFamily="34" charset="-120"/>
               </a:rPr>
-              <a:t>pnpm db:seed</a:t>
+              <a:t>npm run db:seed</a:t>
             </a:r>
             <a:pPr indent="0" marL="0">
               <a:buNone/>
@@ -13995,7 +14021,7 @@
                 <a:ea typeface="Courier New" pitchFamily="34" charset="-122"/>
                 <a:cs typeface="Courier New" pitchFamily="34" charset="-120"/>
               </a:rPr>
-              <a:t>pnpm lab 01</a:t>
+              <a:t>npm run lab 01</a:t>
             </a:r>
             <a:pPr indent="0" marL="0">
               <a:buNone/>
@@ -14020,7 +14046,7 @@
                 <a:ea typeface="Courier New" pitchFamily="34" charset="-122"/>
                 <a:cs typeface="Courier New" pitchFamily="34" charset="-120"/>
               </a:rPr>
-              <a:t>pnpm lab</a:t>
+              <a:t>npm run lab</a:t>
             </a:r>
             <a:pPr indent="0" marL="0">
               <a:buNone/>

</xml_diff>

<commit_message>
deck: about 15 minutes per module for Claude Code
Module times 60' and 45' become 15' each in the deck, the outline and the speaker note
(about 30 minutes of labs). Still estimates.

Co-Authored-By: Claude Opus 5.5 (1M context) <noreply@anthropic.com>
</commit_message>
<xml_diff>
--- a/docs/ai-agent-training/slides/lab-companion.pptx
+++ b/docs/ai-agent-training/slides/lab-companion.pptx
@@ -2194,7 +2194,7 @@
           <a:p>
             <a:r>
               <a:rPr lang="en-US" dirty="0"/>
-              <a:t>Two modules, about 105 minutes of labs. Times are ESTIMATES: nobody has run these labs with an audience yet. Adjust after the first session.</a:t>
+              <a:t>Two modules, about 15 minutes each for Claude Code to build, so about 30 minutes of labs. Times are ESTIMATES: nobody has run these labs with an audience yet. Adjust after the first session.</a:t>
             </a:r>
             <a:endParaRPr lang="en-US" dirty="0"/>
           </a:p>
@@ -7707,7 +7707,7 @@
                   <a:srgbClr val="FFFFFF"/>
                 </a:solidFill>
               </a:rPr>
-              <a:t>45 min</a:t>
+              <a:t>15 min</a:t>
             </a:r>
             <a:endParaRPr lang="en-US" sz="2200" dirty="0"/>
           </a:p>
@@ -14501,7 +14501,7 @@
                   <a:srgbClr val="64748B"/>
                 </a:solidFill>
               </a:rPr>
-              <a:t>60'</a:t>
+              <a:t>15'</a:t>
             </a:r>
             <a:endParaRPr lang="en-US" sz="1400" dirty="0"/>
           </a:p>
@@ -14614,7 +14614,7 @@
                   <a:srgbClr val="64748B"/>
                 </a:solidFill>
               </a:rPr>
-              <a:t>45'</a:t>
+              <a:t>15'</a:t>
             </a:r>
             <a:endParaRPr lang="en-US" sz="1400" dirty="0"/>
           </a:p>
@@ -14910,7 +14910,7 @@
                   <a:srgbClr val="FFFFFF"/>
                 </a:solidFill>
               </a:rPr>
-              <a:t>60 min</a:t>
+              <a:t>15 min</a:t>
             </a:r>
             <a:endParaRPr lang="en-US" sz="2200" dirty="0"/>
           </a:p>

</xml_diff>

<commit_message>
deck: a REST-vs-MCP diagram opens module 2
MCP tools take the controller's place over the same services; query/execute go straight to
the database. Transport stated as it is: JSON-RPC over stdio here, Streamable HTTP for a
remote server.

Co-Authored-By: Claude Opus 5.5 (1M context) <noreply@anthropic.com>
</commit_message>
<xml_diff>
--- a/docs/ai-agent-training/slides/lab-companion.pptx
+++ b/docs/ai-agent-training/slides/lab-companion.pptx
@@ -26,9 +26,10 @@
     <p:sldId id="274" r:id="rId20"/>
     <p:sldId id="275" r:id="rId21"/>
     <p:sldId id="276" r:id="rId22"/>
+    <p:sldId id="277" r:id="rId23"/>
   </p:sldIdLst>
   <p:notesMasterIdLst>
-    <p:notesMasterId r:id="rId23"/>
+    <p:notesMasterId r:id="rId24"/>
   </p:notesMasterIdLst>
   <p:sldSz cx="9144000" cy="5143500"/>
   <p:notesSz cx="5143500" cy="9144000"/>
@@ -1226,7 +1227,7 @@
           <a:p>
             <a:r>
               <a:rPr lang="en-US" dirty="0"/>
-              <a:t>Measured: a fresh agent got labs 31/31 and verify 46 unit / 58 e2e. Five SQL guards, each removed once and caught by lab 02: query is one SELECT/WITH statement (libSQL silently drops a second) run under PRAGMA query_only (a WITH can hide a delete); execute is one statement, only INSERT/UPDATE/DELETE, and UPDATE/DELETE need a WHERE. Its own e2e test missed two of the five: the lab checks come from the spec, not the code. The typed write tools call UsersService and NotesService, so removing a rule there turns the MCP checks red too. execute keeps foreign keys on but does not apply the service rules; its description says so.</a:t>
+              <a:t>Module 1 built the REST front door: an HTTP request reaches a controller, the controller calls a service, the service holds the rules. Module 2 adds a second front door for an AI client. The MCP server takes the controller's place: each tool parses its input and calls the SAME UsersService and NotesService, so the rules exist once. Measured: removing the never-shared-with-the-owner rule from NotesService turns both the REST tests and the MCP checks red. Two tools are the exception: query and execute run SQL a model wrote, straight on the database, so the server guards them itself. On the wire, MCP is JSON-RPC messages, not REST routes. They travel over a transport: stdio when Claude Desktop starts the server on your machine (what we build), or Streamable HTTP for a server you reach over the network. So MCP can ride on HTTP, but it is not built on REST.</a:t>
             </a:r>
             <a:endParaRPr lang="en-US" dirty="0"/>
           </a:p>
@@ -1314,7 +1315,7 @@
           <a:p>
             <a:r>
               <a:rPr lang="en-US" dirty="0"/>
-              <a:t>Claude Desktop starts the server from its own folder with a minimal PATH, so the entry needs absolute paths for node, the server and the database: the script prints them. Quit Claude Desktop completely (not just the window) before reopening. The lab runs on a COPY of data/app.db; Claude Desktop writes to the real one, and npm run db:seed puts it back.</a:t>
+              <a:t>Measured: a fresh agent got labs 31/31 and verify 46 unit / 58 e2e. Five SQL guards, each removed once and caught by lab 02: query is one SELECT/WITH statement (libSQL silently drops a second) run under PRAGMA query_only (a WITH can hide a delete); execute is one statement, only INSERT/UPDATE/DELETE, and UPDATE/DELETE need a WHERE. Its own e2e test missed two of the five: the lab checks come from the spec, not the code. The typed write tools call UsersService and NotesService, so removing a rule there turns the MCP checks red too. execute keeps foreign keys on but does not apply the service rules; its description says so.</a:t>
             </a:r>
             <a:endParaRPr lang="en-US" dirty="0"/>
           </a:p>
@@ -1402,7 +1403,7 @@
           <a:p>
             <a:r>
               <a:rPr lang="en-US" dirty="0"/>
-              <a:t/>
+              <a:t>Claude Desktop starts the server from its own folder with a minimal PATH, so the entry needs absolute paths for node, the server and the database: the script prints them. Quit Claude Desktop completely (not just the window) before reopening. The lab runs on a COPY of data/app.db; Claude Desktop writes to the real one, and npm run db:seed puts it back.</a:t>
             </a:r>
             <a:endParaRPr lang="en-US" dirty="0"/>
           </a:p>
@@ -1666,7 +1667,7 @@
           <a:p>
             <a:r>
               <a:rPr lang="en-US" dirty="0"/>
-              <a:t>Close by asking each learner for one thing their agent got wrong, and how they found out: a count, a red test, the SQL.</a:t>
+              <a:t/>
             </a:r>
             <a:endParaRPr lang="en-US" dirty="0"/>
           </a:p>
@@ -1690,6 +1691,94 @@
             <a:fld id="{F7021451-1387-4CA6-816F-3879F97B5CBC}" type="slidenum">
               <a:rPr lang="en-US"/>
               <a:t>21</a:t>
+            </a:fld>
+            <a:endParaRPr lang="en-US"/>
+          </a:p>
+        </p:txBody>
+      </p:sp>
+    </p:spTree>
+    <p:extLst>
+      <p:ext uri="{BB962C8B-B14F-4D97-AF65-F5344CB8AC3E}">
+        <p14:creationId xmlns:p14="http://schemas.microsoft.com/office/powerpoint/2010/main" val="1024086991"/>
+      </p:ext>
+    </p:extLst>
+  </p:cSld>
+  <p:clrMapOvr>
+    <a:masterClrMapping/>
+  </p:clrMapOvr>
+</p:notes>
+</file>
+
+<file path=ppt/notesSlides/notesSlide22.xml><?xml version="1.0" encoding="utf-8"?>
+<p:notes xmlns:a="http://schemas.openxmlformats.org/drawingml/2006/main" xmlns:r="http://schemas.openxmlformats.org/officeDocument/2006/relationships" xmlns:p="http://schemas.openxmlformats.org/presentationml/2006/main">
+  <p:cSld>
+    <p:spTree>
+      <p:nvGrpSpPr>
+        <p:cNvPr id="1" name=""/>
+        <p:cNvGrpSpPr/>
+        <p:nvPr/>
+      </p:nvGrpSpPr>
+      <p:grpSpPr>
+        <a:xfrm>
+          <a:off x="0" y="0"/>
+          <a:ext cx="0" cy="0"/>
+          <a:chOff x="0" y="0"/>
+          <a:chExt cx="0" cy="0"/>
+        </a:xfrm>
+      </p:grpSpPr>
+      <p:sp>
+        <p:nvSpPr>
+          <p:cNvPr id="2" name="Slide Image Placeholder 1"/>
+          <p:cNvSpPr>
+            <a:spLocks noGrp="1" noRot="1" noChangeAspect="1"/>
+          </p:cNvSpPr>
+          <p:nvPr>
+            <p:ph type="sldImg"/>
+          </p:nvPr>
+        </p:nvSpPr>
+        <p:spPr/>
+      </p:sp>
+      <p:sp>
+        <p:nvSpPr>
+          <p:cNvPr id="3" name="Notes Placeholder 2"/>
+          <p:cNvSpPr>
+            <a:spLocks noGrp="1"/>
+          </p:cNvSpPr>
+          <p:nvPr>
+            <p:ph type="body" idx="1"/>
+          </p:nvPr>
+        </p:nvSpPr>
+        <p:spPr/>
+        <p:txBody>
+          <a:bodyPr/>
+          <a:lstStyle/>
+          <a:p>
+            <a:r>
+              <a:rPr lang="en-US" dirty="0"/>
+              <a:t>Close by asking each learner for one thing their agent got wrong, and how they found out: a count, a red test, the SQL.</a:t>
+            </a:r>
+            <a:endParaRPr lang="en-US" dirty="0"/>
+          </a:p>
+        </p:txBody>
+      </p:sp>
+      <p:sp>
+        <p:nvSpPr>
+          <p:cNvPr id="4" name="Slide Number Placeholder 3"/>
+          <p:cNvSpPr>
+            <a:spLocks noGrp="1"/>
+          </p:cNvSpPr>
+          <p:nvPr>
+            <p:ph type="sldNum" sz="quarter" idx="10"/>
+          </p:nvPr>
+        </p:nvSpPr>
+        <p:spPr/>
+        <p:txBody>
+          <a:bodyPr/>
+          <a:lstStyle/>
+          <a:p>
+            <a:fld id="{F7021451-1387-4CA6-816F-3879F97B5CBC}" type="slidenum">
+              <a:rPr lang="en-US"/>
+              <a:t>22</a:t>
             </a:fld>
             <a:endParaRPr lang="en-US"/>
           </a:p>
@@ -7829,7 +7918,7 @@
                   <a:srgbClr val="1B1F24"/>
                 </a:solidFill>
               </a:rPr>
-              <a:t>Instruction: an MCP server on your data</a:t>
+              <a:t>MCP next to REST: a second front door</a:t>
             </a:r>
             <a:endParaRPr lang="en-US" sz="3200" dirty="0"/>
           </a:p>
@@ -7837,17 +7926,337 @@
       </p:sp>
       <p:sp>
         <p:nvSpPr>
-          <p:cNvPr id="3" name="Shape 1"/>
-          <p:cNvSpPr/>
-          <p:nvPr/>
-        </p:nvSpPr>
-        <p:spPr>
-          <a:xfrm>
-            <a:off x="457200" y="1051560"/>
-            <a:ext cx="73152" cy="548640"/>
-          </a:xfrm>
-          <a:prstGeom prst="rect">
-            <a:avLst/>
+          <p:cNvPr id="3" name="Text 1"/>
+          <p:cNvSpPr txBox="1"/>
+          <p:nvPr/>
+        </p:nvSpPr>
+        <p:spPr>
+          <a:xfrm>
+            <a:off x="457200" y="914400"/>
+            <a:ext cx="2743200" cy="274320"/>
+          </a:xfrm>
+          <a:prstGeom prst="rect">
+            <a:avLst/>
+          </a:prstGeom>
+          <a:noFill/>
+          <a:ln/>
+        </p:spPr>
+        <p:txBody>
+          <a:bodyPr wrap="square" lIns="0" tIns="0" rIns="0" bIns="0" rtlCol="0" anchor="ctr"/>
+          <a:lstStyle/>
+          <a:p>
+            <a:pPr indent="0" marL="0">
+              <a:buNone/>
+            </a:pPr>
+            <a:r>
+              <a:rPr lang="en-US" sz="1200" b="1" dirty="0">
+                <a:solidFill>
+                  <a:srgbClr val="1B1F24"/>
+                </a:solidFill>
+              </a:rPr>
+              <a:t>REST · module 1</a:t>
+            </a:r>
+            <a:endParaRPr lang="en-US" sz="1200" dirty="0"/>
+          </a:p>
+        </p:txBody>
+      </p:sp>
+      <p:sp>
+        <p:nvSpPr>
+          <p:cNvPr id="4" name="Text 2"/>
+          <p:cNvSpPr txBox="1"/>
+          <p:nvPr/>
+        </p:nvSpPr>
+        <p:spPr>
+          <a:xfrm>
+            <a:off x="5943600" y="914400"/>
+            <a:ext cx="2743200" cy="274320"/>
+          </a:xfrm>
+          <a:prstGeom prst="rect">
+            <a:avLst/>
+          </a:prstGeom>
+          <a:noFill/>
+          <a:ln/>
+        </p:spPr>
+        <p:txBody>
+          <a:bodyPr wrap="square" lIns="0" tIns="0" rIns="0" bIns="0" rtlCol="0" anchor="ctr"/>
+          <a:lstStyle/>
+          <a:p>
+            <a:pPr algn="r" indent="0" marL="0">
+              <a:buNone/>
+            </a:pPr>
+            <a:r>
+              <a:rPr lang="en-US" sz="1200" b="1" dirty="0">
+                <a:solidFill>
+                  <a:srgbClr val="1B1F24"/>
+                </a:solidFill>
+              </a:rPr>
+              <a:t>MCP · module 2</a:t>
+            </a:r>
+            <a:endParaRPr lang="en-US" sz="1200" dirty="0"/>
+          </a:p>
+        </p:txBody>
+      </p:sp>
+      <p:sp>
+        <p:nvSpPr>
+          <p:cNvPr id="5" name="rest-client"/>
+          <p:cNvSpPr/>
+          <p:nvPr/>
+        </p:nvSpPr>
+        <p:spPr>
+          <a:xfrm>
+            <a:off x="457200" y="1234440"/>
+            <a:ext cx="2743200" cy="502920"/>
+          </a:xfrm>
+          <a:prstGeom prst="roundRect">
+            <a:avLst>
+              <a:gd name="adj" fmla="val 18182"/>
+            </a:avLst>
+          </a:prstGeom>
+          <a:solidFill>
+            <a:srgbClr val="1B1F24"/>
+          </a:solidFill>
+          <a:ln w="12700">
+            <a:solidFill>
+              <a:srgbClr val="1B1F24"/>
+            </a:solidFill>
+            <a:prstDash val="solid"/>
+          </a:ln>
+        </p:spPr>
+      </p:sp>
+      <p:sp>
+        <p:nvSpPr>
+          <p:cNvPr id="6" name="Text 4"/>
+          <p:cNvSpPr txBox="1"/>
+          <p:nvPr/>
+        </p:nvSpPr>
+        <p:spPr>
+          <a:xfrm>
+            <a:off x="457200" y="1234440"/>
+            <a:ext cx="2743200" cy="502920"/>
+          </a:xfrm>
+          <a:prstGeom prst="rect">
+            <a:avLst/>
+          </a:prstGeom>
+          <a:noFill/>
+          <a:ln/>
+        </p:spPr>
+        <p:txBody>
+          <a:bodyPr wrap="square" lIns="25400" tIns="25400" rIns="25400" bIns="25400" rtlCol="0" anchor="ctr"/>
+          <a:lstStyle/>
+          <a:p>
+            <a:pPr algn="ctr" indent="0" marL="0">
+              <a:buNone/>
+            </a:pPr>
+            <a:r>
+              <a:rPr lang="en-US" sz="1400" b="1" dirty="0">
+                <a:solidFill>
+                  <a:srgbClr val="FFFFFF"/>
+                </a:solidFill>
+              </a:rPr>
+              <a:t>Browser · /playground</a:t>
+            </a:r>
+            <a:endParaRPr lang="en-US" sz="1400" dirty="0"/>
+          </a:p>
+        </p:txBody>
+      </p:sp>
+      <p:sp>
+        <p:nvSpPr>
+          <p:cNvPr id="7" name="mcp-client"/>
+          <p:cNvSpPr/>
+          <p:nvPr/>
+        </p:nvSpPr>
+        <p:spPr>
+          <a:xfrm>
+            <a:off x="5943600" y="1234440"/>
+            <a:ext cx="2743200" cy="502920"/>
+          </a:xfrm>
+          <a:prstGeom prst="roundRect">
+            <a:avLst>
+              <a:gd name="adj" fmla="val 18182"/>
+            </a:avLst>
+          </a:prstGeom>
+          <a:solidFill>
+            <a:srgbClr val="1B1F24"/>
+          </a:solidFill>
+          <a:ln w="12700">
+            <a:solidFill>
+              <a:srgbClr val="1B1F24"/>
+            </a:solidFill>
+            <a:prstDash val="solid"/>
+          </a:ln>
+        </p:spPr>
+      </p:sp>
+      <p:sp>
+        <p:nvSpPr>
+          <p:cNvPr id="8" name="Text 6"/>
+          <p:cNvSpPr txBox="1"/>
+          <p:nvPr/>
+        </p:nvSpPr>
+        <p:spPr>
+          <a:xfrm>
+            <a:off x="5943600" y="1234440"/>
+            <a:ext cx="2743200" cy="502920"/>
+          </a:xfrm>
+          <a:prstGeom prst="rect">
+            <a:avLst/>
+          </a:prstGeom>
+          <a:noFill/>
+          <a:ln/>
+        </p:spPr>
+        <p:txBody>
+          <a:bodyPr wrap="square" lIns="25400" tIns="25400" rIns="25400" bIns="25400" rtlCol="0" anchor="ctr"/>
+          <a:lstStyle/>
+          <a:p>
+            <a:pPr algn="ctr" indent="0" marL="0">
+              <a:buNone/>
+            </a:pPr>
+            <a:r>
+              <a:rPr lang="en-US" sz="1400" b="1" dirty="0">
+                <a:solidFill>
+                  <a:srgbClr val="FFFFFF"/>
+                </a:solidFill>
+              </a:rPr>
+              <a:t>Claude Desktop</a:t>
+            </a:r>
+            <a:endParaRPr lang="en-US" sz="1400" dirty="0"/>
+          </a:p>
+        </p:txBody>
+      </p:sp>
+      <p:sp>
+        <p:nvSpPr>
+          <p:cNvPr id="9" name="Shape 7"/>
+          <p:cNvSpPr/>
+          <p:nvPr/>
+        </p:nvSpPr>
+        <p:spPr>
+          <a:xfrm>
+            <a:off x="1828800" y="1764792"/>
+            <a:ext cx="0" cy="475488"/>
+          </a:xfrm>
+          <a:prstGeom prst="line">
+            <a:avLst/>
+          </a:prstGeom>
+          <a:noFill/>
+          <a:ln w="25400">
+            <a:solidFill>
+              <a:srgbClr val="64748B"/>
+            </a:solidFill>
+            <a:prstDash val="solid"/>
+            <a:tailEnd type="triangle"/>
+          </a:ln>
+        </p:spPr>
+      </p:sp>
+      <p:sp>
+        <p:nvSpPr>
+          <p:cNvPr id="10" name="Text 8"/>
+          <p:cNvSpPr txBox="1"/>
+          <p:nvPr/>
+        </p:nvSpPr>
+        <p:spPr>
+          <a:xfrm>
+            <a:off x="1965960" y="1810512"/>
+            <a:ext cx="1463040" cy="411480"/>
+          </a:xfrm>
+          <a:prstGeom prst="rect">
+            <a:avLst/>
+          </a:prstGeom>
+          <a:noFill/>
+          <a:ln/>
+        </p:spPr>
+        <p:txBody>
+          <a:bodyPr wrap="square" lIns="0" tIns="0" rIns="0" bIns="0" rtlCol="0" anchor="ctr"/>
+          <a:lstStyle/>
+          <a:p>
+            <a:pPr indent="0" marL="0">
+              <a:buNone/>
+            </a:pPr>
+            <a:r>
+              <a:rPr lang="en-US" sz="1000" dirty="0">
+                <a:solidFill>
+                  <a:srgbClr val="2B3440"/>
+                </a:solidFill>
+              </a:rPr>
+              <a:t>HTTP: GET /api/v1/notes</a:t>
+            </a:r>
+            <a:endParaRPr lang="en-US" sz="1000" dirty="0"/>
+          </a:p>
+        </p:txBody>
+      </p:sp>
+      <p:sp>
+        <p:nvSpPr>
+          <p:cNvPr id="11" name="Shape 9"/>
+          <p:cNvSpPr/>
+          <p:nvPr/>
+        </p:nvSpPr>
+        <p:spPr>
+          <a:xfrm>
+            <a:off x="7315200" y="1764792"/>
+            <a:ext cx="0" cy="475488"/>
+          </a:xfrm>
+          <a:prstGeom prst="line">
+            <a:avLst/>
+          </a:prstGeom>
+          <a:noFill/>
+          <a:ln w="25400">
+            <a:solidFill>
+              <a:srgbClr val="64748B"/>
+            </a:solidFill>
+            <a:prstDash val="solid"/>
+            <a:tailEnd type="triangle"/>
+          </a:ln>
+        </p:spPr>
+      </p:sp>
+      <p:sp>
+        <p:nvSpPr>
+          <p:cNvPr id="12" name="Text 10"/>
+          <p:cNvSpPr txBox="1"/>
+          <p:nvPr/>
+        </p:nvSpPr>
+        <p:spPr>
+          <a:xfrm>
+            <a:off x="5394960" y="1810512"/>
+            <a:ext cx="1783080" cy="411480"/>
+          </a:xfrm>
+          <a:prstGeom prst="rect">
+            <a:avLst/>
+          </a:prstGeom>
+          <a:noFill/>
+          <a:ln/>
+        </p:spPr>
+        <p:txBody>
+          <a:bodyPr wrap="square" lIns="0" tIns="0" rIns="0" bIns="0" rtlCol="0" anchor="ctr"/>
+          <a:lstStyle/>
+          <a:p>
+            <a:pPr algn="r" indent="0" marL="0">
+              <a:buNone/>
+            </a:pPr>
+            <a:r>
+              <a:rPr lang="en-US" sz="1000" dirty="0">
+                <a:solidFill>
+                  <a:srgbClr val="2B3440"/>
+                </a:solidFill>
+              </a:rPr>
+              <a:t>JSON-RPC over stdio: tools/call</a:t>
+            </a:r>
+            <a:endParaRPr lang="en-US" sz="1000" dirty="0"/>
+          </a:p>
+        </p:txBody>
+      </p:sp>
+      <p:sp>
+        <p:nvSpPr>
+          <p:cNvPr id="13" name="controller"/>
+          <p:cNvSpPr/>
+          <p:nvPr/>
+        </p:nvSpPr>
+        <p:spPr>
+          <a:xfrm>
+            <a:off x="457200" y="2286000"/>
+            <a:ext cx="2743200" cy="594360"/>
+          </a:xfrm>
+          <a:prstGeom prst="roundRect">
+            <a:avLst>
+              <a:gd name="adj" fmla="val 15385"/>
+            </a:avLst>
           </a:prstGeom>
           <a:solidFill>
             <a:srgbClr val="1FB68A"/>
@@ -7862,14 +8271,14 @@
       </p:sp>
       <p:sp>
         <p:nvSpPr>
-          <p:cNvPr id="4" name="proctor"/>
+          <p:cNvPr id="14" name="Text 12"/>
           <p:cNvSpPr txBox="1"/>
           <p:nvPr/>
         </p:nvSpPr>
         <p:spPr>
           <a:xfrm>
-            <a:off x="640080" y="1024128"/>
-            <a:ext cx="8046720" cy="603504"/>
+            <a:off x="457200" y="2286000"/>
+            <a:ext cx="2743200" cy="594360"/>
           </a:xfrm>
           <a:prstGeom prst="rect">
             <a:avLst/>
@@ -7878,49 +8287,236 @@
           <a:ln/>
         </p:spPr>
         <p:txBody>
-          <a:bodyPr wrap="square" lIns="0" tIns="0" rIns="0" bIns="0" rtlCol="0" anchor="ctr"/>
-          <a:lstStyle/>
-          <a:p>
-            <a:pPr indent="0" marL="0">
-              <a:buNone/>
-            </a:pPr>
-            <a:r>
-              <a:rPr lang="en-US" sz="1400" b="1" i="1" dirty="0">
-                <a:solidFill>
-                  <a:srgbClr val="1B1F24"/>
-                </a:solidFill>
-              </a:rPr>
-              <a:t>Proctor: </a:t>
-            </a:r>
-            <a:pPr indent="0" marL="0">
-              <a:buNone/>
-            </a:pPr>
-            <a:r>
-              <a:rPr lang="en-US" sz="1400" i="1" dirty="0">
-                <a:solidFill>
-                  <a:srgbClr val="2B3440"/>
-                </a:solidFill>
-              </a:rPr>
-              <a:t>The goal: your Claude Desktop app queries and changes this database. The model writes the SQL, so the server decides what may run.</a:t>
-            </a:r>
-            <a:endParaRPr lang="en-US" sz="1400" dirty="0"/>
-          </a:p>
-        </p:txBody>
-      </p:sp>
-      <p:sp>
-        <p:nvSpPr>
-          <p:cNvPr id="5" name="terminal"/>
-          <p:cNvSpPr/>
-          <p:nvPr/>
-        </p:nvSpPr>
-        <p:spPr>
-          <a:xfrm>
-            <a:off x="457200" y="1737360"/>
-            <a:ext cx="5212080" cy="2880360"/>
+          <a:bodyPr wrap="square" lIns="25400" tIns="25400" rIns="25400" bIns="25400" rtlCol="0" anchor="ctr"/>
+          <a:lstStyle/>
+          <a:p>
+            <a:pPr algn="ctr" indent="0" marL="0">
+              <a:buNone/>
+            </a:pPr>
+            <a:r>
+              <a:rPr lang="en-US" sz="1500" b="1" dirty="0">
+                <a:solidFill>
+                  <a:srgbClr val="FFFFFF"/>
+                </a:solidFill>
+              </a:rPr>
+              <a:t>Controller (routes)</a:t>
+            </a:r>
+            <a:endParaRPr lang="en-US" sz="1500" dirty="0"/>
+          </a:p>
+        </p:txBody>
+      </p:sp>
+      <p:sp>
+        <p:nvSpPr>
+          <p:cNvPr id="15" name="mcp-tools"/>
+          <p:cNvSpPr/>
+          <p:nvPr/>
+        </p:nvSpPr>
+        <p:spPr>
+          <a:xfrm>
+            <a:off x="5943600" y="2286000"/>
+            <a:ext cx="2743200" cy="594360"/>
           </a:xfrm>
           <a:prstGeom prst="roundRect">
             <a:avLst>
-              <a:gd name="adj" fmla="val 2540"/>
+              <a:gd name="adj" fmla="val 15385"/>
+            </a:avLst>
+          </a:prstGeom>
+          <a:solidFill>
+            <a:srgbClr val="E69A28"/>
+          </a:solidFill>
+          <a:ln w="12700">
+            <a:solidFill>
+              <a:srgbClr val="E69A28"/>
+            </a:solidFill>
+            <a:prstDash val="solid"/>
+          </a:ln>
+        </p:spPr>
+      </p:sp>
+      <p:sp>
+        <p:nvSpPr>
+          <p:cNvPr id="16" name="Text 14"/>
+          <p:cNvSpPr txBox="1"/>
+          <p:nvPr/>
+        </p:nvSpPr>
+        <p:spPr>
+          <a:xfrm>
+            <a:off x="5943600" y="2286000"/>
+            <a:ext cx="2743200" cy="594360"/>
+          </a:xfrm>
+          <a:prstGeom prst="rect">
+            <a:avLst/>
+          </a:prstGeom>
+          <a:noFill/>
+          <a:ln/>
+        </p:spPr>
+        <p:txBody>
+          <a:bodyPr wrap="square" lIns="25400" tIns="25400" rIns="25400" bIns="25400" rtlCol="0" anchor="ctr"/>
+          <a:lstStyle/>
+          <a:p>
+            <a:pPr algn="ctr" indent="0" marL="0">
+              <a:buNone/>
+            </a:pPr>
+            <a:r>
+              <a:rPr lang="en-US" sz="1500" b="1" dirty="0">
+                <a:solidFill>
+                  <a:srgbClr val="FFFFFF"/>
+                </a:solidFill>
+              </a:rPr>
+              <a:t>MCP server (tools)</a:t>
+            </a:r>
+            <a:endParaRPr lang="en-US" sz="1500" dirty="0"/>
+          </a:p>
+        </p:txBody>
+      </p:sp>
+      <p:sp>
+        <p:nvSpPr>
+          <p:cNvPr id="17" name="Shape 15"/>
+          <p:cNvSpPr/>
+          <p:nvPr/>
+        </p:nvSpPr>
+        <p:spPr>
+          <a:xfrm>
+            <a:off x="1828800" y="2907792"/>
+            <a:ext cx="1828800" cy="338328"/>
+          </a:xfrm>
+          <a:prstGeom prst="line">
+            <a:avLst/>
+          </a:prstGeom>
+          <a:noFill/>
+          <a:ln w="25400">
+            <a:solidFill>
+              <a:srgbClr val="64748B"/>
+            </a:solidFill>
+            <a:prstDash val="solid"/>
+            <a:tailEnd type="triangle"/>
+          </a:ln>
+        </p:spPr>
+      </p:sp>
+      <p:sp>
+        <p:nvSpPr>
+          <p:cNvPr id="18" name="Shape 16"/>
+          <p:cNvSpPr/>
+          <p:nvPr/>
+        </p:nvSpPr>
+        <p:spPr>
+          <a:xfrm flipH="1">
+            <a:off x="5486400" y="2907792"/>
+            <a:ext cx="1828800" cy="338328"/>
+          </a:xfrm>
+          <a:prstGeom prst="line">
+            <a:avLst/>
+          </a:prstGeom>
+          <a:noFill/>
+          <a:ln w="25400">
+            <a:solidFill>
+              <a:srgbClr val="64748B"/>
+            </a:solidFill>
+            <a:prstDash val="solid"/>
+            <a:tailEnd type="triangle"/>
+          </a:ln>
+        </p:spPr>
+      </p:sp>
+      <p:sp>
+        <p:nvSpPr>
+          <p:cNvPr id="19" name="services"/>
+          <p:cNvSpPr/>
+          <p:nvPr/>
+        </p:nvSpPr>
+        <p:spPr>
+          <a:xfrm>
+            <a:off x="2743200" y="3246120"/>
+            <a:ext cx="3657600" cy="548640"/>
+          </a:xfrm>
+          <a:prstGeom prst="roundRect">
+            <a:avLst>
+              <a:gd name="adj" fmla="val 16667"/>
+            </a:avLst>
+          </a:prstGeom>
+          <a:solidFill>
+            <a:srgbClr val="1FB68A"/>
+          </a:solidFill>
+          <a:ln w="12700">
+            <a:solidFill>
+              <a:srgbClr val="1FB68A"/>
+            </a:solidFill>
+            <a:prstDash val="solid"/>
+          </a:ln>
+        </p:spPr>
+      </p:sp>
+      <p:sp>
+        <p:nvSpPr>
+          <p:cNvPr id="20" name="Text 18"/>
+          <p:cNvSpPr txBox="1"/>
+          <p:nvPr/>
+        </p:nvSpPr>
+        <p:spPr>
+          <a:xfrm>
+            <a:off x="2743200" y="3246120"/>
+            <a:ext cx="3657600" cy="548640"/>
+          </a:xfrm>
+          <a:prstGeom prst="rect">
+            <a:avLst/>
+          </a:prstGeom>
+          <a:noFill/>
+          <a:ln/>
+        </p:spPr>
+        <p:txBody>
+          <a:bodyPr wrap="square" lIns="25400" tIns="25400" rIns="25400" bIns="25400" rtlCol="0" anchor="ctr"/>
+          <a:lstStyle/>
+          <a:p>
+            <a:pPr algn="ctr" indent="0" marL="0">
+              <a:buNone/>
+            </a:pPr>
+            <a:r>
+              <a:rPr lang="en-US" sz="1500" b="1" dirty="0">
+                <a:solidFill>
+                  <a:srgbClr val="FFFFFF"/>
+                </a:solidFill>
+              </a:rPr>
+              <a:t>Services: the rules (module 1)</a:t>
+            </a:r>
+            <a:endParaRPr lang="en-US" sz="1500" dirty="0"/>
+          </a:p>
+        </p:txBody>
+      </p:sp>
+      <p:sp>
+        <p:nvSpPr>
+          <p:cNvPr id="21" name="Shape 19"/>
+          <p:cNvSpPr/>
+          <p:nvPr/>
+        </p:nvSpPr>
+        <p:spPr>
+          <a:xfrm>
+            <a:off x="4572000" y="3813048"/>
+            <a:ext cx="0" cy="274320"/>
+          </a:xfrm>
+          <a:prstGeom prst="line">
+            <a:avLst/>
+          </a:prstGeom>
+          <a:noFill/>
+          <a:ln w="25400">
+            <a:solidFill>
+              <a:srgbClr val="64748B"/>
+            </a:solidFill>
+            <a:prstDash val="solid"/>
+            <a:tailEnd type="triangle"/>
+          </a:ln>
+        </p:spPr>
+      </p:sp>
+      <p:sp>
+        <p:nvSpPr>
+          <p:cNvPr id="22" name="database"/>
+          <p:cNvSpPr/>
+          <p:nvPr/>
+        </p:nvSpPr>
+        <p:spPr>
+          <a:xfrm>
+            <a:off x="2743200" y="4114800"/>
+            <a:ext cx="3657600" cy="457200"/>
+          </a:xfrm>
+          <a:prstGeom prst="roundRect">
+            <a:avLst>
+              <a:gd name="adj" fmla="val 20000"/>
             </a:avLst>
           </a:prstGeom>
           <a:solidFill>
@@ -7936,89 +8532,97 @@
       </p:sp>
       <p:sp>
         <p:nvSpPr>
-          <p:cNvPr id="6" name="Shape 4"/>
-          <p:cNvSpPr/>
-          <p:nvPr/>
-        </p:nvSpPr>
-        <p:spPr>
-          <a:xfrm>
-            <a:off x="640080" y="1865376"/>
-            <a:ext cx="109728" cy="109728"/>
-          </a:xfrm>
-          <a:prstGeom prst="ellipse">
-            <a:avLst/>
-          </a:prstGeom>
-          <a:solidFill>
-            <a:srgbClr val="E5484D"/>
-          </a:solidFill>
-          <a:ln w="12700">
-            <a:solidFill>
-              <a:srgbClr val="E5484D"/>
-            </a:solidFill>
-            <a:prstDash val="solid"/>
-          </a:ln>
-        </p:spPr>
-      </p:sp>
-      <p:sp>
-        <p:nvSpPr>
-          <p:cNvPr id="7" name="Shape 5"/>
-          <p:cNvSpPr/>
-          <p:nvPr/>
-        </p:nvSpPr>
-        <p:spPr>
-          <a:xfrm>
-            <a:off x="822960" y="1865376"/>
-            <a:ext cx="109728" cy="109728"/>
-          </a:xfrm>
-          <a:prstGeom prst="ellipse">
-            <a:avLst/>
-          </a:prstGeom>
-          <a:solidFill>
-            <a:srgbClr val="E69A28"/>
-          </a:solidFill>
-          <a:ln w="12700">
+          <p:cNvPr id="23" name="Text 21"/>
+          <p:cNvSpPr txBox="1"/>
+          <p:nvPr/>
+        </p:nvSpPr>
+        <p:spPr>
+          <a:xfrm>
+            <a:off x="2743200" y="4114800"/>
+            <a:ext cx="3657600" cy="457200"/>
+          </a:xfrm>
+          <a:prstGeom prst="rect">
+            <a:avLst/>
+          </a:prstGeom>
+          <a:noFill/>
+          <a:ln/>
+        </p:spPr>
+        <p:txBody>
+          <a:bodyPr wrap="square" lIns="25400" tIns="25400" rIns="25400" bIns="25400" rtlCol="0" anchor="ctr"/>
+          <a:lstStyle/>
+          <a:p>
+            <a:pPr algn="ctr" indent="0" marL="0">
+              <a:buNone/>
+            </a:pPr>
+            <a:r>
+              <a:rPr lang="en-US" sz="1400" b="1" dirty="0">
+                <a:solidFill>
+                  <a:srgbClr val="FFFFFF"/>
+                </a:solidFill>
+              </a:rPr>
+              <a:t>Repository → data/app.db</a:t>
+            </a:r>
+            <a:endParaRPr lang="en-US" sz="1400" dirty="0"/>
+          </a:p>
+        </p:txBody>
+      </p:sp>
+      <p:sp>
+        <p:nvSpPr>
+          <p:cNvPr id="24" name="Shape 22"/>
+          <p:cNvSpPr/>
+          <p:nvPr/>
+        </p:nvSpPr>
+        <p:spPr>
+          <a:xfrm>
+            <a:off x="8412480" y="2907792"/>
+            <a:ext cx="0" cy="1435608"/>
+          </a:xfrm>
+          <a:prstGeom prst="line">
+            <a:avLst/>
+          </a:prstGeom>
+          <a:noFill/>
+          <a:ln w="19050">
             <a:solidFill>
               <a:srgbClr val="E69A28"/>
             </a:solidFill>
-            <a:prstDash val="solid"/>
+            <a:prstDash val="dash"/>
           </a:ln>
         </p:spPr>
       </p:sp>
       <p:sp>
         <p:nvSpPr>
-          <p:cNvPr id="8" name="Shape 6"/>
-          <p:cNvSpPr/>
-          <p:nvPr/>
-        </p:nvSpPr>
-        <p:spPr>
-          <a:xfrm>
-            <a:off x="1005840" y="1865376"/>
-            <a:ext cx="109728" cy="109728"/>
-          </a:xfrm>
-          <a:prstGeom prst="ellipse">
-            <a:avLst/>
-          </a:prstGeom>
-          <a:solidFill>
-            <a:srgbClr val="1FB68A"/>
-          </a:solidFill>
-          <a:ln w="12700">
+          <p:cNvPr id="25" name="Shape 23"/>
+          <p:cNvSpPr/>
+          <p:nvPr/>
+        </p:nvSpPr>
+        <p:spPr>
+          <a:xfrm flipH="1">
+            <a:off x="6428232" y="4343400"/>
+            <a:ext cx="1984248" cy="0"/>
+          </a:xfrm>
+          <a:prstGeom prst="line">
+            <a:avLst/>
+          </a:prstGeom>
+          <a:noFill/>
+          <a:ln w="19050">
             <a:solidFill>
-              <a:srgbClr val="1FB68A"/>
+              <a:srgbClr val="E69A28"/>
             </a:solidFill>
-            <a:prstDash val="solid"/>
+            <a:prstDash val="dash"/>
+            <a:tailEnd type="triangle"/>
           </a:ln>
         </p:spPr>
       </p:sp>
       <p:sp>
         <p:nvSpPr>
-          <p:cNvPr id="9" name="Text 7"/>
+          <p:cNvPr id="26" name="Text 24"/>
           <p:cNvSpPr txBox="1"/>
           <p:nvPr/>
         </p:nvSpPr>
         <p:spPr>
           <a:xfrm>
-            <a:off x="1280160" y="1792224"/>
-            <a:ext cx="4206240" cy="256032"/>
+            <a:off x="6583680" y="3246120"/>
+            <a:ext cx="1737360" cy="548640"/>
           </a:xfrm>
           <a:prstGeom prst="rect">
             <a:avLst/>
@@ -8030,19 +8634,16 @@
           <a:bodyPr wrap="square" lIns="0" tIns="0" rIns="0" bIns="0" rtlCol="0" anchor="ctr"/>
           <a:lstStyle/>
           <a:p>
-            <a:pPr algn="r" indent="0" marL="0">
+            <a:pPr indent="0" marL="0">
               <a:buNone/>
             </a:pPr>
             <a:r>
               <a:rPr lang="en-US" sz="1000" dirty="0">
                 <a:solidFill>
-                  <a:srgbClr val="8B98A5"/>
-                </a:solidFill>
-                <a:latin typeface="Calibri" pitchFamily="34" charset="0"/>
-                <a:ea typeface="Calibri" pitchFamily="34" charset="-122"/>
-                <a:cs typeface="Calibri" pitchFamily="34" charset="-120"/>
-              </a:rPr>
-              <a:t>instruction · give it to your agent</a:t>
+                  <a:srgbClr val="2B3440"/>
+                </a:solidFill>
+              </a:rPr>
+              <a:t>query · execute: SQL straight to the database, guarded by the server</a:t>
             </a:r>
             <a:endParaRPr lang="en-US" sz="1000" dirty="0"/>
           </a:p>
@@ -8050,14 +8651,14 @@
       </p:sp>
       <p:sp>
         <p:nvSpPr>
-          <p:cNvPr id="10" name="terminal-text"/>
+          <p:cNvPr id="27" name="Text 25"/>
           <p:cNvSpPr txBox="1"/>
           <p:nvPr/>
         </p:nvSpPr>
         <p:spPr>
           <a:xfrm>
-            <a:off x="685800" y="2121408"/>
-            <a:ext cx="4754880" cy="2377440"/>
+            <a:off x="457200" y="3291840"/>
+            <a:ext cx="2148840" cy="1280160"/>
           </a:xfrm>
           <a:prstGeom prst="rect">
             <a:avLst/>
@@ -8066,7 +8667,7 @@
           <a:ln/>
         </p:spPr>
         <p:txBody>
-          <a:bodyPr wrap="square" lIns="0" tIns="0" rIns="0" bIns="0" rtlCol="0" anchor="t"/>
+          <a:bodyPr wrap="square" lIns="0" tIns="0" rIns="0" bIns="0" rtlCol="0" anchor="ctr"/>
           <a:lstStyle/>
           <a:p>
             <a:pPr indent="0" marL="0">
@@ -8075,459 +8676,12 @@
             <a:r>
               <a:rPr lang="en-US" sz="1000" dirty="0">
                 <a:solidFill>
-                  <a:srgbClr val="E6EDF3"/>
-                </a:solidFill>
-                <a:latin typeface="Courier New" pitchFamily="34" charset="0"/>
-                <a:ea typeface="Courier New" pitchFamily="34" charset="-122"/>
-                <a:cs typeface="Courier New" pitchFamily="34" charset="-120"/>
-              </a:rPr>
-              <a:t>I want to use this data from Claude Desktop. Build the MCP</a:t>
+                  <a:srgbClr val="2B3440"/>
+                </a:solidFill>
+              </a:rPr>
+              <a:t>Same services, same rules: MCP replaces the controller, not the app. MCP messages are JSON-RPC; the transport is stdio here (Claude Desktop starts the server) or Streamable HTTP for a remote server.</a:t>
             </a:r>
             <a:endParaRPr lang="en-US" sz="1000" dirty="0"/>
-          </a:p>
-          <a:p>
-            <a:pPr indent="0" marL="0">
-              <a:buNone/>
-            </a:pPr>
-            <a:r>
-              <a:rPr lang="en-US" sz="1000" dirty="0">
-                <a:solidFill>
-                  <a:srgbClr val="E6EDF3"/>
-                </a:solidFill>
-                <a:latin typeface="Courier New" pitchFamily="34" charset="0"/>
-                <a:ea typeface="Courier New" pitchFamily="34" charset="-122"/>
-                <a:cs typeface="Courier New" pitchFamily="34" charset="-120"/>
-              </a:rPr>
-              <a:t>server in specs/mcp.md. Done when npm run lab 02 and npm</a:t>
-            </a:r>
-            <a:endParaRPr lang="en-US" sz="1000" dirty="0"/>
-          </a:p>
-          <a:p>
-            <a:pPr indent="0" marL="0">
-              <a:buNone/>
-            </a:pPr>
-            <a:r>
-              <a:rPr lang="en-US" sz="1000" dirty="0">
-                <a:solidFill>
-                  <a:srgbClr val="E6EDF3"/>
-                </a:solidFill>
-                <a:latin typeface="Courier New" pitchFamily="34" charset="0"/>
-                <a:ea typeface="Courier New" pitchFamily="34" charset="-122"/>
-                <a:cs typeface="Courier New" pitchFamily="34" charset="-120"/>
-              </a:rPr>
-              <a:t>run verify are green; then show me how to connect it to</a:t>
-            </a:r>
-            <a:endParaRPr lang="en-US" sz="1000" dirty="0"/>
-          </a:p>
-          <a:p>
-            <a:pPr indent="0" marL="0">
-              <a:buNone/>
-            </a:pPr>
-            <a:r>
-              <a:rPr lang="en-US" sz="1000" dirty="0">
-                <a:solidFill>
-                  <a:srgbClr val="E6EDF3"/>
-                </a:solidFill>
-                <a:latin typeface="Courier New" pitchFamily="34" charset="0"/>
-                <a:ea typeface="Courier New" pitchFamily="34" charset="-122"/>
-                <a:cs typeface="Courier New" pitchFamily="34" charset="-120"/>
-              </a:rPr>
-              <a:t>Claude Desktop, one question I could ask it and one change</a:t>
-            </a:r>
-            <a:endParaRPr lang="en-US" sz="1000" dirty="0"/>
-          </a:p>
-          <a:p>
-            <a:pPr indent="0" marL="0">
-              <a:buNone/>
-            </a:pPr>
-            <a:r>
-              <a:rPr lang="en-US" sz="1000" dirty="0">
-                <a:solidFill>
-                  <a:srgbClr val="E6EDF3"/>
-                </a:solidFill>
-                <a:latin typeface="Courier New" pitchFamily="34" charset="0"/>
-                <a:ea typeface="Courier New" pitchFamily="34" charset="-122"/>
-                <a:cs typeface="Courier New" pitchFamily="34" charset="-120"/>
-              </a:rPr>
-              <a:t>I could ask it to make.</a:t>
-            </a:r>
-            <a:endParaRPr lang="en-US" sz="1000" dirty="0"/>
-          </a:p>
-        </p:txBody>
-      </p:sp>
-      <p:sp>
-        <p:nvSpPr>
-          <p:cNvPr id="11" name="Text 9"/>
-          <p:cNvSpPr txBox="1"/>
-          <p:nvPr/>
-        </p:nvSpPr>
-        <p:spPr>
-          <a:xfrm>
-            <a:off x="5897880" y="1737360"/>
-            <a:ext cx="2788920" cy="365760"/>
-          </a:xfrm>
-          <a:prstGeom prst="rect">
-            <a:avLst/>
-          </a:prstGeom>
-          <a:noFill/>
-          <a:ln/>
-        </p:spPr>
-        <p:txBody>
-          <a:bodyPr wrap="square" lIns="0" tIns="0" rIns="0" bIns="0" rtlCol="0" anchor="ctr"/>
-          <a:lstStyle/>
-          <a:p>
-            <a:pPr indent="0" marL="0">
-              <a:buNone/>
-            </a:pPr>
-            <a:r>
-              <a:rPr lang="en-US" sz="1600" b="1" dirty="0">
-                <a:solidFill>
-                  <a:srgbClr val="1B1F24"/>
-                </a:solidFill>
-              </a:rPr>
-              <a:t>Watch its approach</a:t>
-            </a:r>
-            <a:endParaRPr lang="en-US" sz="1600" dirty="0"/>
-          </a:p>
-        </p:txBody>
-      </p:sp>
-      <p:sp>
-        <p:nvSpPr>
-          <p:cNvPr id="12" name="Shape 10"/>
-          <p:cNvSpPr/>
-          <p:nvPr/>
-        </p:nvSpPr>
-        <p:spPr>
-          <a:xfrm>
-            <a:off x="5897880" y="2231136"/>
-            <a:ext cx="292608" cy="292608"/>
-          </a:xfrm>
-          <a:prstGeom prst="ellipse">
-            <a:avLst/>
-          </a:prstGeom>
-          <a:solidFill>
-            <a:srgbClr val="1FB68A"/>
-          </a:solidFill>
-          <a:ln w="12700">
-            <a:solidFill>
-              <a:srgbClr val="1FB68A"/>
-            </a:solidFill>
-            <a:prstDash val="solid"/>
-          </a:ln>
-        </p:spPr>
-      </p:sp>
-      <p:pic>
-        <p:nvPicPr>
-          <p:cNvPr id="13" name="Image 0" descr="preencoded.png">    </p:cNvPr>
-          <p:cNvPicPr>
-            <a:picLocks noChangeAspect="1"/>
-          </p:cNvPicPr>
-          <p:nvPr/>
-        </p:nvPicPr>
-        <p:blipFill>
-          <a:blip r:embed="rId1"/>
-          <a:stretch>
-            <a:fillRect/>
-          </a:stretch>
-        </p:blipFill>
-        <p:spPr>
-          <a:xfrm>
-            <a:off x="5962254" y="2295510"/>
-            <a:ext cx="163860" cy="163860"/>
-          </a:xfrm>
-          <a:prstGeom prst="rect">
-            <a:avLst/>
-          </a:prstGeom>
-        </p:spPr>
-      </p:pic>
-      <p:sp>
-        <p:nvSpPr>
-          <p:cNvPr id="14" name="Text 11"/>
-          <p:cNvSpPr txBox="1"/>
-          <p:nvPr/>
-        </p:nvSpPr>
-        <p:spPr>
-          <a:xfrm>
-            <a:off x="6309360" y="2194560"/>
-            <a:ext cx="2377440" cy="566928"/>
-          </a:xfrm>
-          <a:prstGeom prst="rect">
-            <a:avLst/>
-          </a:prstGeom>
-          <a:noFill/>
-          <a:ln/>
-        </p:spPr>
-        <p:txBody>
-          <a:bodyPr wrap="square" lIns="0" tIns="0" rIns="0" bIns="0" rtlCol="0" anchor="t"/>
-          <a:lstStyle/>
-          <a:p>
-            <a:pPr indent="0" marL="0">
-              <a:buNone/>
-            </a:pPr>
-            <a:r>
-              <a:rPr lang="en-US" sz="1200" dirty="0">
-                <a:solidFill>
-                  <a:srgbClr val="1B1F24"/>
-                </a:solidFill>
-              </a:rPr>
-              <a:t>reads the installed SDK, not its memory</a:t>
-            </a:r>
-            <a:endParaRPr lang="en-US" sz="1200" dirty="0"/>
-          </a:p>
-        </p:txBody>
-      </p:sp>
-      <p:sp>
-        <p:nvSpPr>
-          <p:cNvPr id="15" name="Shape 12"/>
-          <p:cNvSpPr/>
-          <p:nvPr/>
-        </p:nvSpPr>
-        <p:spPr>
-          <a:xfrm>
-            <a:off x="5897880" y="2834640"/>
-            <a:ext cx="292608" cy="292608"/>
-          </a:xfrm>
-          <a:prstGeom prst="ellipse">
-            <a:avLst/>
-          </a:prstGeom>
-          <a:solidFill>
-            <a:srgbClr val="1FB68A"/>
-          </a:solidFill>
-          <a:ln w="12700">
-            <a:solidFill>
-              <a:srgbClr val="1FB68A"/>
-            </a:solidFill>
-            <a:prstDash val="solid"/>
-          </a:ln>
-        </p:spPr>
-      </p:sp>
-      <p:pic>
-        <p:nvPicPr>
-          <p:cNvPr id="16" name="Image 1" descr="preencoded.png">    </p:cNvPr>
-          <p:cNvPicPr>
-            <a:picLocks noChangeAspect="1"/>
-          </p:cNvPicPr>
-          <p:nvPr/>
-        </p:nvPicPr>
-        <p:blipFill>
-          <a:blip r:embed="rId2"/>
-          <a:stretch>
-            <a:fillRect/>
-          </a:stretch>
-        </p:blipFill>
-        <p:spPr>
-          <a:xfrm>
-            <a:off x="5962254" y="2899014"/>
-            <a:ext cx="163860" cy="163860"/>
-          </a:xfrm>
-          <a:prstGeom prst="rect">
-            <a:avLst/>
-          </a:prstGeom>
-        </p:spPr>
-      </p:pic>
-      <p:sp>
-        <p:nvSpPr>
-          <p:cNvPr id="17" name="Text 13"/>
-          <p:cNvSpPr txBox="1"/>
-          <p:nvPr/>
-        </p:nvSpPr>
-        <p:spPr>
-          <a:xfrm>
-            <a:off x="6309360" y="2798064"/>
-            <a:ext cx="2377440" cy="566928"/>
-          </a:xfrm>
-          <a:prstGeom prst="rect">
-            <a:avLst/>
-          </a:prstGeom>
-          <a:noFill/>
-          <a:ln/>
-        </p:spPr>
-        <p:txBody>
-          <a:bodyPr wrap="square" lIns="0" tIns="0" rIns="0" bIns="0" rtlCol="0" anchor="t"/>
-          <a:lstStyle/>
-          <a:p>
-            <a:pPr indent="0" marL="0">
-              <a:buNone/>
-            </a:pPr>
-            <a:r>
-              <a:rPr lang="en-US" sz="1200" dirty="0">
-                <a:solidFill>
-                  <a:srgbClr val="1B1F24"/>
-                </a:solidFill>
-              </a:rPr>
-              <a:t>typed write tools call the module 1 services</a:t>
-            </a:r>
-            <a:endParaRPr lang="en-US" sz="1200" dirty="0"/>
-          </a:p>
-        </p:txBody>
-      </p:sp>
-      <p:sp>
-        <p:nvSpPr>
-          <p:cNvPr id="18" name="Shape 14"/>
-          <p:cNvSpPr/>
-          <p:nvPr/>
-        </p:nvSpPr>
-        <p:spPr>
-          <a:xfrm>
-            <a:off x="5897880" y="3438144"/>
-            <a:ext cx="292608" cy="292608"/>
-          </a:xfrm>
-          <a:prstGeom prst="ellipse">
-            <a:avLst/>
-          </a:prstGeom>
-          <a:solidFill>
-            <a:srgbClr val="1FB68A"/>
-          </a:solidFill>
-          <a:ln w="12700">
-            <a:solidFill>
-              <a:srgbClr val="1FB68A"/>
-            </a:solidFill>
-            <a:prstDash val="solid"/>
-          </a:ln>
-        </p:spPr>
-      </p:sp>
-      <p:pic>
-        <p:nvPicPr>
-          <p:cNvPr id="19" name="Image 2" descr="preencoded.png">    </p:cNvPr>
-          <p:cNvPicPr>
-            <a:picLocks noChangeAspect="1"/>
-          </p:cNvPicPr>
-          <p:nvPr/>
-        </p:nvPicPr>
-        <p:blipFill>
-          <a:blip r:embed="rId3"/>
-          <a:stretch>
-            <a:fillRect/>
-          </a:stretch>
-        </p:blipFill>
-        <p:spPr>
-          <a:xfrm>
-            <a:off x="5962254" y="3502518"/>
-            <a:ext cx="163860" cy="163860"/>
-          </a:xfrm>
-          <a:prstGeom prst="rect">
-            <a:avLst/>
-          </a:prstGeom>
-        </p:spPr>
-      </p:pic>
-      <p:sp>
-        <p:nvSpPr>
-          <p:cNvPr id="20" name="Text 15"/>
-          <p:cNvSpPr txBox="1"/>
-          <p:nvPr/>
-        </p:nvSpPr>
-        <p:spPr>
-          <a:xfrm>
-            <a:off x="6309360" y="3401568"/>
-            <a:ext cx="2377440" cy="566928"/>
-          </a:xfrm>
-          <a:prstGeom prst="rect">
-            <a:avLst/>
-          </a:prstGeom>
-          <a:noFill/>
-          <a:ln/>
-        </p:spPr>
-        <p:txBody>
-          <a:bodyPr wrap="square" lIns="0" tIns="0" rIns="0" bIns="0" rtlCol="0" anchor="t"/>
-          <a:lstStyle/>
-          <a:p>
-            <a:pPr indent="0" marL="0">
-              <a:buNone/>
-            </a:pPr>
-            <a:r>
-              <a:rPr lang="en-US" sz="1200" dirty="0">
-                <a:solidFill>
-                  <a:srgbClr val="1B1F24"/>
-                </a:solidFill>
-              </a:rPr>
-              <a:t>query and execute each guarded in layers</a:t>
-            </a:r>
-            <a:endParaRPr lang="en-US" sz="1200" dirty="0"/>
-          </a:p>
-        </p:txBody>
-      </p:sp>
-      <p:sp>
-        <p:nvSpPr>
-          <p:cNvPr id="21" name="Shape 16"/>
-          <p:cNvSpPr/>
-          <p:nvPr/>
-        </p:nvSpPr>
-        <p:spPr>
-          <a:xfrm>
-            <a:off x="5897880" y="4041648"/>
-            <a:ext cx="292608" cy="292608"/>
-          </a:xfrm>
-          <a:prstGeom prst="ellipse">
-            <a:avLst/>
-          </a:prstGeom>
-          <a:solidFill>
-            <a:srgbClr val="1FB68A"/>
-          </a:solidFill>
-          <a:ln w="12700">
-            <a:solidFill>
-              <a:srgbClr val="1FB68A"/>
-            </a:solidFill>
-            <a:prstDash val="solid"/>
-          </a:ln>
-        </p:spPr>
-      </p:sp>
-      <p:pic>
-        <p:nvPicPr>
-          <p:cNvPr id="22" name="Image 3" descr="preencoded.png">    </p:cNvPr>
-          <p:cNvPicPr>
-            <a:picLocks noChangeAspect="1"/>
-          </p:cNvPicPr>
-          <p:nvPr/>
-        </p:nvPicPr>
-        <p:blipFill>
-          <a:blip r:embed="rId4"/>
-          <a:stretch>
-            <a:fillRect/>
-          </a:stretch>
-        </p:blipFill>
-        <p:spPr>
-          <a:xfrm>
-            <a:off x="5962254" y="4106022"/>
-            <a:ext cx="163860" cy="163860"/>
-          </a:xfrm>
-          <a:prstGeom prst="rect">
-            <a:avLst/>
-          </a:prstGeom>
-        </p:spPr>
-      </p:pic>
-      <p:sp>
-        <p:nvSpPr>
-          <p:cNvPr id="23" name="Text 17"/>
-          <p:cNvSpPr txBox="1"/>
-          <p:nvPr/>
-        </p:nvSpPr>
-        <p:spPr>
-          <a:xfrm>
-            <a:off x="6309360" y="4005072"/>
-            <a:ext cx="2377440" cy="566928"/>
-          </a:xfrm>
-          <a:prstGeom prst="rect">
-            <a:avLst/>
-          </a:prstGeom>
-          <a:noFill/>
-          <a:ln/>
-        </p:spPr>
-        <p:txBody>
-          <a:bodyPr wrap="square" lIns="0" tIns="0" rIns="0" bIns="0" rtlCol="0" anchor="t"/>
-          <a:lstStyle/>
-          <a:p>
-            <a:pPr indent="0" marL="0">
-              <a:buNone/>
-            </a:pPr>
-            <a:r>
-              <a:rPr lang="en-US" sz="1200" dirty="0">
-                <a:solidFill>
-                  <a:srgbClr val="1B1F24"/>
-                </a:solidFill>
-              </a:rPr>
-              <a:t>gives the Claude Desktop entry with absolute paths</a:t>
-            </a:r>
-            <a:endParaRPr lang="en-US" sz="1200" dirty="0"/>
           </a:p>
         </p:txBody>
       </p:sp>
@@ -8633,7 +8787,7 @@
                   <a:srgbClr val="1B1F24"/>
                 </a:solidFill>
               </a:rPr>
-              <a:t>Check it: module 2</a:t>
+              <a:t>Instruction: an MCP server on your data</a:t>
             </a:r>
             <a:endParaRPr lang="en-US" sz="3200" dirty="0"/>
           </a:p>
@@ -8641,18 +8795,90 @@
       </p:sp>
       <p:sp>
         <p:nvSpPr>
-          <p:cNvPr id="3" name="terminal"/>
-          <p:cNvSpPr/>
-          <p:nvPr/>
-        </p:nvSpPr>
-        <p:spPr>
-          <a:xfrm>
-            <a:off x="457200" y="1097280"/>
-            <a:ext cx="8229600" cy="3520440"/>
+          <p:cNvPr id="3" name="Shape 1"/>
+          <p:cNvSpPr/>
+          <p:nvPr/>
+        </p:nvSpPr>
+        <p:spPr>
+          <a:xfrm>
+            <a:off x="457200" y="1051560"/>
+            <a:ext cx="73152" cy="548640"/>
+          </a:xfrm>
+          <a:prstGeom prst="rect">
+            <a:avLst/>
+          </a:prstGeom>
+          <a:solidFill>
+            <a:srgbClr val="1FB68A"/>
+          </a:solidFill>
+          <a:ln w="12700">
+            <a:solidFill>
+              <a:srgbClr val="1FB68A"/>
+            </a:solidFill>
+            <a:prstDash val="solid"/>
+          </a:ln>
+        </p:spPr>
+      </p:sp>
+      <p:sp>
+        <p:nvSpPr>
+          <p:cNvPr id="4" name="proctor"/>
+          <p:cNvSpPr txBox="1"/>
+          <p:nvPr/>
+        </p:nvSpPr>
+        <p:spPr>
+          <a:xfrm>
+            <a:off x="640080" y="1024128"/>
+            <a:ext cx="8046720" cy="603504"/>
+          </a:xfrm>
+          <a:prstGeom prst="rect">
+            <a:avLst/>
+          </a:prstGeom>
+          <a:noFill/>
+          <a:ln/>
+        </p:spPr>
+        <p:txBody>
+          <a:bodyPr wrap="square" lIns="0" tIns="0" rIns="0" bIns="0" rtlCol="0" anchor="ctr"/>
+          <a:lstStyle/>
+          <a:p>
+            <a:pPr indent="0" marL="0">
+              <a:buNone/>
+            </a:pPr>
+            <a:r>
+              <a:rPr lang="en-US" sz="1400" b="1" i="1" dirty="0">
+                <a:solidFill>
+                  <a:srgbClr val="1B1F24"/>
+                </a:solidFill>
+              </a:rPr>
+              <a:t>Proctor: </a:t>
+            </a:r>
+            <a:pPr indent="0" marL="0">
+              <a:buNone/>
+            </a:pPr>
+            <a:r>
+              <a:rPr lang="en-US" sz="1400" i="1" dirty="0">
+                <a:solidFill>
+                  <a:srgbClr val="2B3440"/>
+                </a:solidFill>
+              </a:rPr>
+              <a:t>The goal: your Claude Desktop app queries and changes this database. The model writes the SQL, so the server decides what may run.</a:t>
+            </a:r>
+            <a:endParaRPr lang="en-US" sz="1400" dirty="0"/>
+          </a:p>
+        </p:txBody>
+      </p:sp>
+      <p:sp>
+        <p:nvSpPr>
+          <p:cNvPr id="5" name="terminal"/>
+          <p:cNvSpPr/>
+          <p:nvPr/>
+        </p:nvSpPr>
+        <p:spPr>
+          <a:xfrm>
+            <a:off x="457200" y="1737360"/>
+            <a:ext cx="5212080" cy="2880360"/>
           </a:xfrm>
           <a:prstGeom prst="roundRect">
             <a:avLst>
-              <a:gd name="adj" fmla="val 2078"/>
+              <a:gd name="adj" fmla="val 2540"/>
             </a:avLst>
           </a:prstGeom>
           <a:solidFill>
@@ -8668,13 +8894,13 @@
       </p:sp>
       <p:sp>
         <p:nvSpPr>
-          <p:cNvPr id="4" name="Shape 2"/>
-          <p:cNvSpPr/>
-          <p:nvPr/>
-        </p:nvSpPr>
-        <p:spPr>
-          <a:xfrm>
-            <a:off x="640080" y="1225296"/>
+          <p:cNvPr id="6" name="Shape 4"/>
+          <p:cNvSpPr/>
+          <p:nvPr/>
+        </p:nvSpPr>
+        <p:spPr>
+          <a:xfrm>
+            <a:off x="640080" y="1865376"/>
             <a:ext cx="109728" cy="109728"/>
           </a:xfrm>
           <a:prstGeom prst="ellipse">
@@ -8693,13 +8919,13 @@
       </p:sp>
       <p:sp>
         <p:nvSpPr>
-          <p:cNvPr id="5" name="Shape 3"/>
-          <p:cNvSpPr/>
-          <p:nvPr/>
-        </p:nvSpPr>
-        <p:spPr>
-          <a:xfrm>
-            <a:off x="822960" y="1225296"/>
+          <p:cNvPr id="7" name="Shape 5"/>
+          <p:cNvSpPr/>
+          <p:nvPr/>
+        </p:nvSpPr>
+        <p:spPr>
+          <a:xfrm>
+            <a:off x="822960" y="1865376"/>
             <a:ext cx="109728" cy="109728"/>
           </a:xfrm>
           <a:prstGeom prst="ellipse">
@@ -8718,13 +8944,13 @@
       </p:sp>
       <p:sp>
         <p:nvSpPr>
-          <p:cNvPr id="6" name="Shape 4"/>
-          <p:cNvSpPr/>
-          <p:nvPr/>
-        </p:nvSpPr>
-        <p:spPr>
-          <a:xfrm>
-            <a:off x="1005840" y="1225296"/>
+          <p:cNvPr id="8" name="Shape 6"/>
+          <p:cNvSpPr/>
+          <p:nvPr/>
+        </p:nvSpPr>
+        <p:spPr>
+          <a:xfrm>
+            <a:off x="1005840" y="1865376"/>
             <a:ext cx="109728" cy="109728"/>
           </a:xfrm>
           <a:prstGeom prst="ellipse">
@@ -8743,14 +8969,14 @@
       </p:sp>
       <p:sp>
         <p:nvSpPr>
-          <p:cNvPr id="7" name="Text 5"/>
+          <p:cNvPr id="9" name="Text 7"/>
           <p:cNvSpPr txBox="1"/>
           <p:nvPr/>
         </p:nvSpPr>
         <p:spPr>
           <a:xfrm>
-            <a:off x="1280160" y="1152144"/>
-            <a:ext cx="7223760" cy="256032"/>
+            <a:off x="1280160" y="1792224"/>
+            <a:ext cx="4206240" cy="256032"/>
           </a:xfrm>
           <a:prstGeom prst="rect">
             <a:avLst/>
@@ -8774,7 +9000,7 @@
                 <a:ea typeface="Calibri" pitchFamily="34" charset="-122"/>
                 <a:cs typeface="Calibri" pitchFamily="34" charset="-120"/>
               </a:rPr>
-              <a:t>module 2 · run this</a:t>
+              <a:t>instruction · give it to your agent</a:t>
             </a:r>
             <a:endParaRPr lang="en-US" sz="1000" dirty="0"/>
           </a:p>
@@ -8782,14 +9008,14 @@
       </p:sp>
       <p:sp>
         <p:nvSpPr>
-          <p:cNvPr id="8" name="terminal-text"/>
+          <p:cNvPr id="10" name="terminal-text"/>
           <p:cNvSpPr txBox="1"/>
           <p:nvPr/>
         </p:nvSpPr>
         <p:spPr>
           <a:xfrm>
-            <a:off x="685800" y="1481328"/>
-            <a:ext cx="7772400" cy="3017520"/>
+            <a:off x="685800" y="2121408"/>
+            <a:ext cx="4754880" cy="2377440"/>
           </a:xfrm>
           <a:prstGeom prst="rect">
             <a:avLst/>
@@ -8805,7 +9031,7 @@
               <a:buNone/>
             </a:pPr>
             <a:r>
-              <a:rPr lang="en-US" sz="1400" dirty="0">
+              <a:rPr lang="en-US" sz="1000" dirty="0">
                 <a:solidFill>
                   <a:srgbClr val="E6EDF3"/>
                 </a:solidFill>
@@ -8813,16 +9039,16 @@
                 <a:ea typeface="Courier New" pitchFamily="34" charset="-122"/>
                 <a:cs typeface="Courier New" pitchFamily="34" charset="-120"/>
               </a:rPr>
-              <a:t>npm run verify</a:t>
-            </a:r>
-            <a:endParaRPr lang="en-US" sz="1400" dirty="0"/>
+              <a:t>I want to use this data from Claude Desktop. Build the MCP</a:t>
+            </a:r>
+            <a:endParaRPr lang="en-US" sz="1000" dirty="0"/>
           </a:p>
           <a:p>
             <a:pPr indent="0" marL="0">
               <a:buNone/>
             </a:pPr>
             <a:r>
-              <a:rPr lang="en-US" sz="1400" dirty="0">
+              <a:rPr lang="en-US" sz="1000" dirty="0">
                 <a:solidFill>
                   <a:srgbClr val="E6EDF3"/>
                 </a:solidFill>
@@ -8830,16 +9056,16 @@
                 <a:ea typeface="Courier New" pitchFamily="34" charset="-122"/>
                 <a:cs typeface="Courier New" pitchFamily="34" charset="-120"/>
               </a:rPr>
-              <a:t>npm run build</a:t>
-            </a:r>
-            <a:endParaRPr lang="en-US" sz="1400" dirty="0"/>
+              <a:t>server in specs/mcp.md. Done when npm run lab 02 and npm</a:t>
+            </a:r>
+            <a:endParaRPr lang="en-US" sz="1000" dirty="0"/>
           </a:p>
           <a:p>
             <a:pPr indent="0" marL="0">
               <a:buNone/>
             </a:pPr>
             <a:r>
-              <a:rPr lang="en-US" sz="1400" dirty="0">
+              <a:rPr lang="en-US" sz="1000" dirty="0">
                 <a:solidFill>
                   <a:srgbClr val="E6EDF3"/>
                 </a:solidFill>
@@ -8847,128 +9073,419 @@
                 <a:ea typeface="Courier New" pitchFamily="34" charset="-122"/>
                 <a:cs typeface="Courier New" pitchFamily="34" charset="-120"/>
               </a:rPr>
-              <a:t>node scripts\claude-desktop-config.mjs</a:t>
-            </a:r>
-            <a:endParaRPr lang="en-US" sz="1400" dirty="0"/>
+              <a:t>run verify are green; then show me how to connect it to</a:t>
+            </a:r>
+            <a:endParaRPr lang="en-US" sz="1000" dirty="0"/>
           </a:p>
           <a:p>
             <a:pPr indent="0" marL="0">
               <a:buNone/>
             </a:pPr>
             <a:r>
-              <a:rPr lang="en-US" sz="1400" dirty="0">
-                <a:solidFill>
-                  <a:srgbClr val="8B98A5"/>
+              <a:rPr lang="en-US" sz="1000" dirty="0">
+                <a:solidFill>
+                  <a:srgbClr val="E6EDF3"/>
                 </a:solidFill>
                 <a:latin typeface="Courier New" pitchFamily="34" charset="0"/>
                 <a:ea typeface="Courier New" pitchFamily="34" charset="-122"/>
                 <a:cs typeface="Courier New" pitchFamily="34" charset="-120"/>
               </a:rPr>
-              <a:t># paste the entry into the config file it names,</a:t>
-            </a:r>
-            <a:endParaRPr lang="en-US" sz="1400" dirty="0"/>
+              <a:t>Claude Desktop, one question I could ask it and one change</a:t>
+            </a:r>
+            <a:endParaRPr lang="en-US" sz="1000" dirty="0"/>
           </a:p>
           <a:p>
             <a:pPr indent="0" marL="0">
               <a:buNone/>
             </a:pPr>
             <a:r>
-              <a:rPr lang="en-US" sz="1400" dirty="0">
-                <a:solidFill>
-                  <a:srgbClr val="8B98A5"/>
+              <a:rPr lang="en-US" sz="1000" dirty="0">
+                <a:solidFill>
+                  <a:srgbClr val="E6EDF3"/>
                 </a:solidFill>
                 <a:latin typeface="Courier New" pitchFamily="34" charset="0"/>
                 <a:ea typeface="Courier New" pitchFamily="34" charset="-122"/>
                 <a:cs typeface="Courier New" pitchFamily="34" charset="-120"/>
               </a:rPr>
-              <a:t># quit and reopen Claude Desktop, then ask:</a:t>
-            </a:r>
-            <a:endParaRPr lang="en-US" sz="1400" dirty="0"/>
-          </a:p>
+              <a:t>I could ask it to make.</a:t>
+            </a:r>
+            <a:endParaRPr lang="en-US" sz="1000" dirty="0"/>
+          </a:p>
+        </p:txBody>
+      </p:sp>
+      <p:sp>
+        <p:nvSpPr>
+          <p:cNvPr id="11" name="Text 9"/>
+          <p:cNvSpPr txBox="1"/>
+          <p:nvPr/>
+        </p:nvSpPr>
+        <p:spPr>
+          <a:xfrm>
+            <a:off x="5897880" y="1737360"/>
+            <a:ext cx="2788920" cy="365760"/>
+          </a:xfrm>
+          <a:prstGeom prst="rect">
+            <a:avLst/>
+          </a:prstGeom>
+          <a:noFill/>
+          <a:ln/>
+        </p:spPr>
+        <p:txBody>
+          <a:bodyPr wrap="square" lIns="0" tIns="0" rIns="0" bIns="0" rtlCol="0" anchor="ctr"/>
+          <a:lstStyle/>
           <a:p>
             <a:pPr indent="0" marL="0">
               <a:buNone/>
             </a:pPr>
             <a:r>
-              <a:rPr lang="en-US" sz="1400" dirty="0">
-                <a:solidFill>
-                  <a:srgbClr val="8B98A5"/>
-                </a:solidFill>
-                <a:latin typeface="Courier New" pitchFamily="34" charset="0"/>
-                <a:ea typeface="Courier New" pitchFamily="34" charset="-122"/>
-                <a:cs typeface="Courier New" pitchFamily="34" charset="-120"/>
-              </a:rPr>
-              <a:t># "Which open notes are shared with more</a:t>
-            </a:r>
-            <a:endParaRPr lang="en-US" sz="1400" dirty="0"/>
-          </a:p>
+              <a:rPr lang="en-US" sz="1600" b="1" dirty="0">
+                <a:solidFill>
+                  <a:srgbClr val="1B1F24"/>
+                </a:solidFill>
+              </a:rPr>
+              <a:t>Watch its approach</a:t>
+            </a:r>
+            <a:endParaRPr lang="en-US" sz="1600" dirty="0"/>
+          </a:p>
+        </p:txBody>
+      </p:sp>
+      <p:sp>
+        <p:nvSpPr>
+          <p:cNvPr id="12" name="Shape 10"/>
+          <p:cNvSpPr/>
+          <p:nvPr/>
+        </p:nvSpPr>
+        <p:spPr>
+          <a:xfrm>
+            <a:off x="5897880" y="2231136"/>
+            <a:ext cx="292608" cy="292608"/>
+          </a:xfrm>
+          <a:prstGeom prst="ellipse">
+            <a:avLst/>
+          </a:prstGeom>
+          <a:solidFill>
+            <a:srgbClr val="1FB68A"/>
+          </a:solidFill>
+          <a:ln w="12700">
+            <a:solidFill>
+              <a:srgbClr val="1FB68A"/>
+            </a:solidFill>
+            <a:prstDash val="solid"/>
+          </a:ln>
+        </p:spPr>
+      </p:sp>
+      <p:pic>
+        <p:nvPicPr>
+          <p:cNvPr id="13" name="Image 0" descr="preencoded.png">    </p:cNvPr>
+          <p:cNvPicPr>
+            <a:picLocks noChangeAspect="1"/>
+          </p:cNvPicPr>
+          <p:nvPr/>
+        </p:nvPicPr>
+        <p:blipFill>
+          <a:blip r:embed="rId1"/>
+          <a:stretch>
+            <a:fillRect/>
+          </a:stretch>
+        </p:blipFill>
+        <p:spPr>
+          <a:xfrm>
+            <a:off x="5962254" y="2295510"/>
+            <a:ext cx="163860" cy="163860"/>
+          </a:xfrm>
+          <a:prstGeom prst="rect">
+            <a:avLst/>
+          </a:prstGeom>
+        </p:spPr>
+      </p:pic>
+      <p:sp>
+        <p:nvSpPr>
+          <p:cNvPr id="14" name="Text 11"/>
+          <p:cNvSpPr txBox="1"/>
+          <p:nvPr/>
+        </p:nvSpPr>
+        <p:spPr>
+          <a:xfrm>
+            <a:off x="6309360" y="2194560"/>
+            <a:ext cx="2377440" cy="566928"/>
+          </a:xfrm>
+          <a:prstGeom prst="rect">
+            <a:avLst/>
+          </a:prstGeom>
+          <a:noFill/>
+          <a:ln/>
+        </p:spPr>
+        <p:txBody>
+          <a:bodyPr wrap="square" lIns="0" tIns="0" rIns="0" bIns="0" rtlCol="0" anchor="t"/>
+          <a:lstStyle/>
           <a:p>
             <a:pPr indent="0" marL="0">
               <a:buNone/>
             </a:pPr>
             <a:r>
-              <a:rPr lang="en-US" sz="1400" dirty="0">
-                <a:solidFill>
-                  <a:srgbClr val="8B98A5"/>
-                </a:solidFill>
-                <a:latin typeface="Courier New" pitchFamily="34" charset="0"/>
-                <a:ea typeface="Courier New" pitchFamily="34" charset="-122"/>
-                <a:cs typeface="Courier New" pitchFamily="34" charset="-120"/>
-              </a:rPr>
-              <a:t>#   than one person?"</a:t>
-            </a:r>
-            <a:endParaRPr lang="en-US" sz="1400" dirty="0"/>
-          </a:p>
+              <a:rPr lang="en-US" sz="1200" dirty="0">
+                <a:solidFill>
+                  <a:srgbClr val="1B1F24"/>
+                </a:solidFill>
+              </a:rPr>
+              <a:t>reads the installed SDK, not its memory</a:t>
+            </a:r>
+            <a:endParaRPr lang="en-US" sz="1200" dirty="0"/>
+          </a:p>
+        </p:txBody>
+      </p:sp>
+      <p:sp>
+        <p:nvSpPr>
+          <p:cNvPr id="15" name="Shape 12"/>
+          <p:cNvSpPr/>
+          <p:nvPr/>
+        </p:nvSpPr>
+        <p:spPr>
+          <a:xfrm>
+            <a:off x="5897880" y="2834640"/>
+            <a:ext cx="292608" cy="292608"/>
+          </a:xfrm>
+          <a:prstGeom prst="ellipse">
+            <a:avLst/>
+          </a:prstGeom>
+          <a:solidFill>
+            <a:srgbClr val="1FB68A"/>
+          </a:solidFill>
+          <a:ln w="12700">
+            <a:solidFill>
+              <a:srgbClr val="1FB68A"/>
+            </a:solidFill>
+            <a:prstDash val="solid"/>
+          </a:ln>
+        </p:spPr>
+      </p:sp>
+      <p:pic>
+        <p:nvPicPr>
+          <p:cNvPr id="16" name="Image 1" descr="preencoded.png">    </p:cNvPr>
+          <p:cNvPicPr>
+            <a:picLocks noChangeAspect="1"/>
+          </p:cNvPicPr>
+          <p:nvPr/>
+        </p:nvPicPr>
+        <p:blipFill>
+          <a:blip r:embed="rId2"/>
+          <a:stretch>
+            <a:fillRect/>
+          </a:stretch>
+        </p:blipFill>
+        <p:spPr>
+          <a:xfrm>
+            <a:off x="5962254" y="2899014"/>
+            <a:ext cx="163860" cy="163860"/>
+          </a:xfrm>
+          <a:prstGeom prst="rect">
+            <a:avLst/>
+          </a:prstGeom>
+        </p:spPr>
+      </p:pic>
+      <p:sp>
+        <p:nvSpPr>
+          <p:cNvPr id="17" name="Text 13"/>
+          <p:cNvSpPr txBox="1"/>
+          <p:nvPr/>
+        </p:nvSpPr>
+        <p:spPr>
+          <a:xfrm>
+            <a:off x="6309360" y="2798064"/>
+            <a:ext cx="2377440" cy="566928"/>
+          </a:xfrm>
+          <a:prstGeom prst="rect">
+            <a:avLst/>
+          </a:prstGeom>
+          <a:noFill/>
+          <a:ln/>
+        </p:spPr>
+        <p:txBody>
+          <a:bodyPr wrap="square" lIns="0" tIns="0" rIns="0" bIns="0" rtlCol="0" anchor="t"/>
+          <a:lstStyle/>
           <a:p>
             <a:pPr indent="0" marL="0">
               <a:buNone/>
             </a:pPr>
             <a:r>
-              <a:rPr lang="en-US" sz="1400" dirty="0">
-                <a:solidFill>
-                  <a:srgbClr val="8B98A5"/>
-                </a:solidFill>
-                <a:latin typeface="Courier New" pitchFamily="34" charset="0"/>
-                <a:ea typeface="Courier New" pitchFamily="34" charset="-122"/>
-                <a:cs typeface="Courier New" pitchFamily="34" charset="-120"/>
-              </a:rPr>
-              <a:t># "Add a user Ada, ada@example.com, with</a:t>
-            </a:r>
-            <a:endParaRPr lang="en-US" sz="1400" dirty="0"/>
-          </a:p>
+              <a:rPr lang="en-US" sz="1200" dirty="0">
+                <a:solidFill>
+                  <a:srgbClr val="1B1F24"/>
+                </a:solidFill>
+              </a:rPr>
+              <a:t>typed write tools call the module 1 services</a:t>
+            </a:r>
+            <a:endParaRPr lang="en-US" sz="1200" dirty="0"/>
+          </a:p>
+        </p:txBody>
+      </p:sp>
+      <p:sp>
+        <p:nvSpPr>
+          <p:cNvPr id="18" name="Shape 14"/>
+          <p:cNvSpPr/>
+          <p:nvPr/>
+        </p:nvSpPr>
+        <p:spPr>
+          <a:xfrm>
+            <a:off x="5897880" y="3438144"/>
+            <a:ext cx="292608" cy="292608"/>
+          </a:xfrm>
+          <a:prstGeom prst="ellipse">
+            <a:avLst/>
+          </a:prstGeom>
+          <a:solidFill>
+            <a:srgbClr val="1FB68A"/>
+          </a:solidFill>
+          <a:ln w="12700">
+            <a:solidFill>
+              <a:srgbClr val="1FB68A"/>
+            </a:solidFill>
+            <a:prstDash val="solid"/>
+          </a:ln>
+        </p:spPr>
+      </p:sp>
+      <p:pic>
+        <p:nvPicPr>
+          <p:cNvPr id="19" name="Image 2" descr="preencoded.png">    </p:cNvPr>
+          <p:cNvPicPr>
+            <a:picLocks noChangeAspect="1"/>
+          </p:cNvPicPr>
+          <p:nvPr/>
+        </p:nvPicPr>
+        <p:blipFill>
+          <a:blip r:embed="rId3"/>
+          <a:stretch>
+            <a:fillRect/>
+          </a:stretch>
+        </p:blipFill>
+        <p:spPr>
+          <a:xfrm>
+            <a:off x="5962254" y="3502518"/>
+            <a:ext cx="163860" cy="163860"/>
+          </a:xfrm>
+          <a:prstGeom prst="rect">
+            <a:avLst/>
+          </a:prstGeom>
+        </p:spPr>
+      </p:pic>
+      <p:sp>
+        <p:nvSpPr>
+          <p:cNvPr id="20" name="Text 15"/>
+          <p:cNvSpPr txBox="1"/>
+          <p:nvPr/>
+        </p:nvSpPr>
+        <p:spPr>
+          <a:xfrm>
+            <a:off x="6309360" y="3401568"/>
+            <a:ext cx="2377440" cy="566928"/>
+          </a:xfrm>
+          <a:prstGeom prst="rect">
+            <a:avLst/>
+          </a:prstGeom>
+          <a:noFill/>
+          <a:ln/>
+        </p:spPr>
+        <p:txBody>
+          <a:bodyPr wrap="square" lIns="0" tIns="0" rIns="0" bIns="0" rtlCol="0" anchor="t"/>
+          <a:lstStyle/>
           <a:p>
             <a:pPr indent="0" marL="0">
               <a:buNone/>
             </a:pPr>
             <a:r>
-              <a:rPr lang="en-US" sz="1400" dirty="0">
-                <a:solidFill>
-                  <a:srgbClr val="8B98A5"/>
-                </a:solidFill>
-                <a:latin typeface="Courier New" pitchFamily="34" charset="0"/>
-                <a:ea typeface="Courier New" pitchFamily="34" charset="-122"/>
-                <a:cs typeface="Courier New" pitchFamily="34" charset="-120"/>
-              </a:rPr>
-              <a:t>#   a note due next Friday"</a:t>
-            </a:r>
-            <a:endParaRPr lang="en-US" sz="1400" dirty="0"/>
-          </a:p>
+              <a:rPr lang="en-US" sz="1200" dirty="0">
+                <a:solidFill>
+                  <a:srgbClr val="1B1F24"/>
+                </a:solidFill>
+              </a:rPr>
+              <a:t>query and execute each guarded in layers</a:t>
+            </a:r>
+            <a:endParaRPr lang="en-US" sz="1200" dirty="0"/>
+          </a:p>
+        </p:txBody>
+      </p:sp>
+      <p:sp>
+        <p:nvSpPr>
+          <p:cNvPr id="21" name="Shape 16"/>
+          <p:cNvSpPr/>
+          <p:nvPr/>
+        </p:nvSpPr>
+        <p:spPr>
+          <a:xfrm>
+            <a:off x="5897880" y="4041648"/>
+            <a:ext cx="292608" cy="292608"/>
+          </a:xfrm>
+          <a:prstGeom prst="ellipse">
+            <a:avLst/>
+          </a:prstGeom>
+          <a:solidFill>
+            <a:srgbClr val="1FB68A"/>
+          </a:solidFill>
+          <a:ln w="12700">
+            <a:solidFill>
+              <a:srgbClr val="1FB68A"/>
+            </a:solidFill>
+            <a:prstDash val="solid"/>
+          </a:ln>
+        </p:spPr>
+      </p:sp>
+      <p:pic>
+        <p:nvPicPr>
+          <p:cNvPr id="22" name="Image 3" descr="preencoded.png">    </p:cNvPr>
+          <p:cNvPicPr>
+            <a:picLocks noChangeAspect="1"/>
+          </p:cNvPicPr>
+          <p:nvPr/>
+        </p:nvPicPr>
+        <p:blipFill>
+          <a:blip r:embed="rId4"/>
+          <a:stretch>
+            <a:fillRect/>
+          </a:stretch>
+        </p:blipFill>
+        <p:spPr>
+          <a:xfrm>
+            <a:off x="5962254" y="4106022"/>
+            <a:ext cx="163860" cy="163860"/>
+          </a:xfrm>
+          <a:prstGeom prst="rect">
+            <a:avLst/>
+          </a:prstGeom>
+        </p:spPr>
+      </p:pic>
+      <p:sp>
+        <p:nvSpPr>
+          <p:cNvPr id="23" name="Text 17"/>
+          <p:cNvSpPr txBox="1"/>
+          <p:nvPr/>
+        </p:nvSpPr>
+        <p:spPr>
+          <a:xfrm>
+            <a:off x="6309360" y="4005072"/>
+            <a:ext cx="2377440" cy="566928"/>
+          </a:xfrm>
+          <a:prstGeom prst="rect">
+            <a:avLst/>
+          </a:prstGeom>
+          <a:noFill/>
+          <a:ln/>
+        </p:spPr>
+        <p:txBody>
+          <a:bodyPr wrap="square" lIns="0" tIns="0" rIns="0" bIns="0" rtlCol="0" anchor="t"/>
+          <a:lstStyle/>
           <a:p>
             <a:pPr indent="0" marL="0">
               <a:buNone/>
             </a:pPr>
             <a:r>
-              <a:rPr lang="en-US" sz="1400" dirty="0">
-                <a:solidFill>
-                  <a:srgbClr val="E6EDF3"/>
-                </a:solidFill>
-                <a:latin typeface="Courier New" pitchFamily="34" charset="0"/>
-                <a:ea typeface="Courier New" pitchFamily="34" charset="-122"/>
-                <a:cs typeface="Courier New" pitchFamily="34" charset="-120"/>
-              </a:rPr>
-              <a:t>npm run lab 02   # the lab check: all green?</a:t>
-            </a:r>
-            <a:endParaRPr lang="en-US" sz="1400" dirty="0"/>
+              <a:rPr lang="en-US" sz="1200" dirty="0">
+                <a:solidFill>
+                  <a:srgbClr val="1B1F24"/>
+                </a:solidFill>
+              </a:rPr>
+              <a:t>gives the Claude Desktop entry with absolute paths</a:t>
+            </a:r>
+            <a:endParaRPr lang="en-US" sz="1200" dirty="0"/>
           </a:p>
         </p:txBody>
       </p:sp>
@@ -9074,7 +9591,7 @@
                   <a:srgbClr val="1B1F24"/>
                 </a:solidFill>
               </a:rPr>
-              <a:t>Checkpoint: Claude Desktop, your data</a:t>
+              <a:t>Check it: module 2</a:t>
             </a:r>
             <a:endParaRPr lang="en-US" sz="3200" dirty="0"/>
           </a:p>
@@ -9089,7 +9606,7 @@
         <p:spPr>
           <a:xfrm>
             <a:off x="457200" y="1097280"/>
-            <a:ext cx="5029200" cy="3520440"/>
+            <a:ext cx="8229600" cy="3520440"/>
           </a:xfrm>
           <a:prstGeom prst="roundRect">
             <a:avLst>
@@ -9191,7 +9708,7 @@
         <p:spPr>
           <a:xfrm>
             <a:off x="1280160" y="1152144"/>
-            <a:ext cx="4023360" cy="256032"/>
+            <a:ext cx="7223760" cy="256032"/>
           </a:xfrm>
           <a:prstGeom prst="rect">
             <a:avLst/>
@@ -9215,7 +9732,7 @@
                 <a:ea typeface="Calibri" pitchFamily="34" charset="-122"/>
                 <a:cs typeface="Calibri" pitchFamily="34" charset="-120"/>
               </a:rPr>
-              <a:t>output: captured</a:t>
+              <a:t>module 2 · run this</a:t>
             </a:r>
             <a:endParaRPr lang="en-US" sz="1000" dirty="0"/>
           </a:p>
@@ -9230,7 +9747,7 @@
         <p:spPr>
           <a:xfrm>
             <a:off x="685800" y="1481328"/>
-            <a:ext cx="4572000" cy="3017520"/>
+            <a:ext cx="7772400" cy="3017520"/>
           </a:xfrm>
           <a:prstGeom prst="rect">
             <a:avLst/>
@@ -9246,24 +9763,24 @@
               <a:buNone/>
             </a:pPr>
             <a:r>
-              <a:rPr lang="en-US" sz="1200" dirty="0">
-                <a:solidFill>
-                  <a:srgbClr val="8B98A5"/>
+              <a:rPr lang="en-US" sz="1400" dirty="0">
+                <a:solidFill>
+                  <a:srgbClr val="E6EDF3"/>
                 </a:solidFill>
                 <a:latin typeface="Courier New" pitchFamily="34" charset="0"/>
                 <a:ea typeface="Courier New" pitchFamily="34" charset="-122"/>
                 <a:cs typeface="Courier New" pitchFamily="34" charset="-120"/>
               </a:rPr>
-              <a:t># npm run verify; npm run lab</a:t>
-            </a:r>
-            <a:endParaRPr lang="en-US" sz="1200" dirty="0"/>
+              <a:t>npm run verify</a:t>
+            </a:r>
+            <a:endParaRPr lang="en-US" sz="1400" dirty="0"/>
           </a:p>
           <a:p>
             <a:pPr indent="0" marL="0">
               <a:buNone/>
             </a:pPr>
             <a:r>
-              <a:rPr lang="en-US" sz="1200" dirty="0">
+              <a:rPr lang="en-US" sz="1400" dirty="0">
                 <a:solidFill>
                   <a:srgbClr val="E6EDF3"/>
                 </a:solidFill>
@@ -9271,16 +9788,16 @@
                 <a:ea typeface="Courier New" pitchFamily="34" charset="-122"/>
                 <a:cs typeface="Courier New" pitchFamily="34" charset="-120"/>
               </a:rPr>
-              <a:t>Tests  46 passed (46) · 58 passed (58)</a:t>
-            </a:r>
-            <a:endParaRPr lang="en-US" sz="1200" dirty="0"/>
+              <a:t>npm run build</a:t>
+            </a:r>
+            <a:endParaRPr lang="en-US" sz="1400" dirty="0"/>
           </a:p>
           <a:p>
             <a:pPr indent="0" marL="0">
               <a:buNone/>
             </a:pPr>
             <a:r>
-              <a:rPr lang="en-US" sz="1200" dirty="0">
+              <a:rPr lang="en-US" sz="1400" dirty="0">
                 <a:solidFill>
                   <a:srgbClr val="E6EDF3"/>
                 </a:solidFill>
@@ -9288,16 +9805,16 @@
                 <a:ea typeface="Courier New" pitchFamily="34" charset="-122"/>
                 <a:cs typeface="Courier New" pitchFamily="34" charset="-120"/>
               </a:rPr>
-              <a:t>Tests  31 passed (31)</a:t>
-            </a:r>
-            <a:endParaRPr lang="en-US" sz="1200" dirty="0"/>
+              <a:t>node scripts\claude-desktop-config.mjs</a:t>
+            </a:r>
+            <a:endParaRPr lang="en-US" sz="1400" dirty="0"/>
           </a:p>
           <a:p>
             <a:pPr indent="0" marL="0">
               <a:buNone/>
             </a:pPr>
             <a:r>
-              <a:rPr lang="en-US" sz="1200" dirty="0">
+              <a:rPr lang="en-US" sz="1400" dirty="0">
                 <a:solidFill>
                   <a:srgbClr val="8B98A5"/>
                 </a:solidFill>
@@ -9305,50 +9822,50 @@
                 <a:ea typeface="Courier New" pitchFamily="34" charset="-122"/>
                 <a:cs typeface="Courier New" pitchFamily="34" charset="-120"/>
               </a:rPr>
-              <a:t># started as Claude Desktop does it</a:t>
-            </a:r>
-            <a:endParaRPr lang="en-US" sz="1200" dirty="0"/>
+              <a:t># paste the entry into the config file it names,</a:t>
+            </a:r>
+            <a:endParaRPr lang="en-US" sz="1400" dirty="0"/>
           </a:p>
           <a:p>
             <a:pPr indent="0" marL="0">
               <a:buNone/>
             </a:pPr>
             <a:r>
-              <a:rPr lang="en-US" sz="1200" dirty="0">
-                <a:solidFill>
-                  <a:srgbClr val="E6EDF3"/>
+              <a:rPr lang="en-US" sz="1400" dirty="0">
+                <a:solidFill>
+                  <a:srgbClr val="8B98A5"/>
                 </a:solidFill>
                 <a:latin typeface="Courier New" pitchFamily="34" charset="0"/>
                 <a:ea typeface="Courier New" pitchFamily="34" charset="-122"/>
                 <a:cs typeface="Courier New" pitchFamily="34" charset="-120"/>
               </a:rPr>
-              <a:t>create-user · create-note · share-note</a:t>
-            </a:r>
-            <a:endParaRPr lang="en-US" sz="1200" dirty="0"/>
+              <a:t># quit and reopen Claude Desktop, then ask:</a:t>
+            </a:r>
+            <a:endParaRPr lang="en-US" sz="1400" dirty="0"/>
           </a:p>
           <a:p>
             <a:pPr indent="0" marL="0">
               <a:buNone/>
             </a:pPr>
             <a:r>
-              <a:rPr lang="en-US" sz="1200" dirty="0">
-                <a:solidFill>
-                  <a:srgbClr val="E6EDF3"/>
+              <a:rPr lang="en-US" sz="1400" dirty="0">
+                <a:solidFill>
+                  <a:srgbClr val="8B98A5"/>
                 </a:solidFill>
                 <a:latin typeface="Courier New" pitchFamily="34" charset="0"/>
                 <a:ea typeface="Courier New" pitchFamily="34" charset="-122"/>
                 <a:cs typeface="Courier New" pitchFamily="34" charset="-120"/>
               </a:rPr>
-              <a:t>execute update … where id = … → 1 row</a:t>
-            </a:r>
-            <a:endParaRPr lang="en-US" sz="1200" dirty="0"/>
+              <a:t># "Which open notes are shared with more</a:t>
+            </a:r>
+            <a:endParaRPr lang="en-US" sz="1400" dirty="0"/>
           </a:p>
           <a:p>
             <a:pPr indent="0" marL="0">
               <a:buNone/>
             </a:pPr>
             <a:r>
-              <a:rPr lang="en-US" sz="1200" dirty="0">
+              <a:rPr lang="en-US" sz="1400" dirty="0">
                 <a:solidFill>
                   <a:srgbClr val="8B98A5"/>
                 </a:solidFill>
@@ -9356,332 +9873,58 @@
                 <a:ea typeface="Courier New" pitchFamily="34" charset="-122"/>
                 <a:cs typeface="Courier New" pitchFamily="34" charset="-120"/>
               </a:rPr>
-              <a:t># execute: delete from notes</a:t>
-            </a:r>
-            <a:endParaRPr lang="en-US" sz="1200" dirty="0"/>
+              <a:t>#   than one person?"</a:t>
+            </a:r>
+            <a:endParaRPr lang="en-US" sz="1400" dirty="0"/>
           </a:p>
           <a:p>
             <a:pPr indent="0" marL="0">
               <a:buNone/>
             </a:pPr>
             <a:r>
-              <a:rPr lang="en-US" sz="1200" dirty="0">
-                <a:solidFill>
-                  <a:srgbClr val="E6EDF3"/>
+              <a:rPr lang="en-US" sz="1400" dirty="0">
+                <a:solidFill>
+                  <a:srgbClr val="8B98A5"/>
                 </a:solidFill>
                 <a:latin typeface="Courier New" pitchFamily="34" charset="0"/>
                 <a:ea typeface="Courier New" pitchFamily="34" charset="-122"/>
                 <a:cs typeface="Courier New" pitchFamily="34" charset="-120"/>
               </a:rPr>
-              <a:t>NOT_ALLOWED: DELETE without a WHERE …</a:t>
-            </a:r>
-            <a:endParaRPr lang="en-US" sz="1200" dirty="0"/>
-          </a:p>
-        </p:txBody>
-      </p:sp>
-      <p:sp>
-        <p:nvSpPr>
-          <p:cNvPr id="9" name="Text 7"/>
-          <p:cNvSpPr txBox="1"/>
-          <p:nvPr/>
-        </p:nvSpPr>
-        <p:spPr>
-          <a:xfrm>
-            <a:off x="5852160" y="1097280"/>
-            <a:ext cx="2834640" cy="411480"/>
-          </a:xfrm>
-          <a:prstGeom prst="rect">
-            <a:avLst/>
-          </a:prstGeom>
-          <a:noFill/>
-          <a:ln/>
-        </p:spPr>
-        <p:txBody>
-          <a:bodyPr wrap="square" lIns="0" tIns="0" rIns="0" bIns="0" rtlCol="0" anchor="ctr"/>
-          <a:lstStyle/>
+              <a:t># "Add a user Ada, ada@example.com, with</a:t>
+            </a:r>
+            <a:endParaRPr lang="en-US" sz="1400" dirty="0"/>
+          </a:p>
           <a:p>
             <a:pPr indent="0" marL="0">
               <a:buNone/>
             </a:pPr>
             <a:r>
-              <a:rPr lang="en-US" sz="2000" b="1" dirty="0">
-                <a:solidFill>
-                  <a:srgbClr val="1B1F24"/>
-                </a:solidFill>
-              </a:rPr>
-              <a:t>Done when</a:t>
-            </a:r>
-            <a:endParaRPr lang="en-US" sz="2000" dirty="0"/>
-          </a:p>
-        </p:txBody>
-      </p:sp>
-      <p:sp>
-        <p:nvSpPr>
-          <p:cNvPr id="10" name="Shape 8"/>
-          <p:cNvSpPr/>
-          <p:nvPr/>
-        </p:nvSpPr>
-        <p:spPr>
-          <a:xfrm>
-            <a:off x="5852160" y="1645920"/>
-            <a:ext cx="384048" cy="384048"/>
-          </a:xfrm>
-          <a:prstGeom prst="ellipse">
-            <a:avLst/>
-          </a:prstGeom>
-          <a:solidFill>
-            <a:srgbClr val="1FB68A"/>
-          </a:solidFill>
-          <a:ln w="12700">
-            <a:solidFill>
-              <a:srgbClr val="1FB68A"/>
-            </a:solidFill>
-            <a:prstDash val="solid"/>
-          </a:ln>
-        </p:spPr>
-      </p:sp>
-      <p:pic>
-        <p:nvPicPr>
-          <p:cNvPr id="11" name="Image 0" descr="preencoded.png">    </p:cNvPr>
-          <p:cNvPicPr>
-            <a:picLocks noChangeAspect="1"/>
-          </p:cNvPicPr>
-          <p:nvPr/>
-        </p:nvPicPr>
-        <p:blipFill>
-          <a:blip r:embed="rId1"/>
-          <a:stretch>
-            <a:fillRect/>
-          </a:stretch>
-        </p:blipFill>
-        <p:spPr>
-          <a:xfrm>
-            <a:off x="5936651" y="1730411"/>
-            <a:ext cx="215067" cy="215067"/>
-          </a:xfrm>
-          <a:prstGeom prst="rect">
-            <a:avLst/>
-          </a:prstGeom>
-        </p:spPr>
-      </p:pic>
-      <p:sp>
-        <p:nvSpPr>
-          <p:cNvPr id="12" name="Text 9"/>
-          <p:cNvSpPr txBox="1"/>
-          <p:nvPr/>
-        </p:nvSpPr>
-        <p:spPr>
-          <a:xfrm>
-            <a:off x="6355080" y="1609344"/>
-            <a:ext cx="2331720" cy="868680"/>
-          </a:xfrm>
-          <a:prstGeom prst="rect">
-            <a:avLst/>
-          </a:prstGeom>
-          <a:noFill/>
-          <a:ln/>
-        </p:spPr>
-        <p:txBody>
-          <a:bodyPr wrap="square" lIns="0" tIns="0" rIns="0" bIns="0" rtlCol="0" anchor="t"/>
-          <a:lstStyle/>
-          <a:p>
-            <a:pPr indent="0" marL="0">
-              <a:buNone/>
-            </a:pPr>
-            <a:pPr indent="0" marL="0">
-              <a:buNone/>
-            </a:pPr>
-            <a:r>
               <a:rPr lang="en-US" sz="1400" dirty="0">
                 <a:solidFill>
-                  <a:srgbClr val="1B1F24"/>
+                  <a:srgbClr val="8B98A5"/>
                 </a:solidFill>
                 <a:latin typeface="Courier New" pitchFamily="34" charset="0"/>
                 <a:ea typeface="Courier New" pitchFamily="34" charset="-122"/>
                 <a:cs typeface="Courier New" pitchFamily="34" charset="-120"/>
               </a:rPr>
-              <a:t>npm run lab 02</a:t>
-            </a:r>
+              <a:t>#   a note due next Friday"</a:t>
+            </a:r>
+            <a:endParaRPr lang="en-US" sz="1400" dirty="0"/>
+          </a:p>
+          <a:p>
             <a:pPr indent="0" marL="0">
               <a:buNone/>
             </a:pPr>
             <a:r>
               <a:rPr lang="en-US" sz="1400" dirty="0">
                 <a:solidFill>
-                  <a:srgbClr val="1B1F24"/>
-                </a:solidFill>
-              </a:rPr>
-              <a:t>: every test passes</a:t>
-            </a:r>
-            <a:endParaRPr lang="en-US" sz="1400" dirty="0"/>
-          </a:p>
-        </p:txBody>
-      </p:sp>
-      <p:sp>
-        <p:nvSpPr>
-          <p:cNvPr id="13" name="Shape 10"/>
-          <p:cNvSpPr/>
-          <p:nvPr/>
-        </p:nvSpPr>
-        <p:spPr>
-          <a:xfrm>
-            <a:off x="5852160" y="2606040"/>
-            <a:ext cx="384048" cy="384048"/>
-          </a:xfrm>
-          <a:prstGeom prst="ellipse">
-            <a:avLst/>
-          </a:prstGeom>
-          <a:solidFill>
-            <a:srgbClr val="1FB68A"/>
-          </a:solidFill>
-          <a:ln w="12700">
-            <a:solidFill>
-              <a:srgbClr val="1FB68A"/>
-            </a:solidFill>
-            <a:prstDash val="solid"/>
-          </a:ln>
-        </p:spPr>
-      </p:sp>
-      <p:pic>
-        <p:nvPicPr>
-          <p:cNvPr id="14" name="Image 1" descr="preencoded.png">    </p:cNvPr>
-          <p:cNvPicPr>
-            <a:picLocks noChangeAspect="1"/>
-          </p:cNvPicPr>
-          <p:nvPr/>
-        </p:nvPicPr>
-        <p:blipFill>
-          <a:blip r:embed="rId2"/>
-          <a:stretch>
-            <a:fillRect/>
-          </a:stretch>
-        </p:blipFill>
-        <p:spPr>
-          <a:xfrm>
-            <a:off x="5936651" y="2690531"/>
-            <a:ext cx="215067" cy="215067"/>
-          </a:xfrm>
-          <a:prstGeom prst="rect">
-            <a:avLst/>
-          </a:prstGeom>
-        </p:spPr>
-      </p:pic>
-      <p:sp>
-        <p:nvSpPr>
-          <p:cNvPr id="15" name="Text 11"/>
-          <p:cNvSpPr txBox="1"/>
-          <p:nvPr/>
-        </p:nvSpPr>
-        <p:spPr>
-          <a:xfrm>
-            <a:off x="6355080" y="2569464"/>
-            <a:ext cx="2331720" cy="868680"/>
-          </a:xfrm>
-          <a:prstGeom prst="rect">
-            <a:avLst/>
-          </a:prstGeom>
-          <a:noFill/>
-          <a:ln/>
-        </p:spPr>
-        <p:txBody>
-          <a:bodyPr wrap="square" lIns="0" tIns="0" rIns="0" bIns="0" rtlCol="0" anchor="t"/>
-          <a:lstStyle/>
-          <a:p>
-            <a:pPr indent="0" marL="0">
-              <a:buNone/>
-            </a:pPr>
-            <a:r>
-              <a:rPr lang="en-US" sz="1400" dirty="0">
-                <a:solidFill>
-                  <a:srgbClr val="1B1F24"/>
-                </a:solidFill>
-              </a:rPr>
-              <a:t>query refuses a write, execute an unbounded one</a:t>
-            </a:r>
-            <a:endParaRPr lang="en-US" sz="1400" dirty="0"/>
-          </a:p>
-        </p:txBody>
-      </p:sp>
-      <p:sp>
-        <p:nvSpPr>
-          <p:cNvPr id="16" name="Shape 12"/>
-          <p:cNvSpPr/>
-          <p:nvPr/>
-        </p:nvSpPr>
-        <p:spPr>
-          <a:xfrm>
-            <a:off x="5852160" y="3566160"/>
-            <a:ext cx="384048" cy="384048"/>
-          </a:xfrm>
-          <a:prstGeom prst="ellipse">
-            <a:avLst/>
-          </a:prstGeom>
-          <a:solidFill>
-            <a:srgbClr val="1FB68A"/>
-          </a:solidFill>
-          <a:ln w="12700">
-            <a:solidFill>
-              <a:srgbClr val="1FB68A"/>
-            </a:solidFill>
-            <a:prstDash val="solid"/>
-          </a:ln>
-        </p:spPr>
-      </p:sp>
-      <p:pic>
-        <p:nvPicPr>
-          <p:cNvPr id="17" name="Image 2" descr="preencoded.png">    </p:cNvPr>
-          <p:cNvPicPr>
-            <a:picLocks noChangeAspect="1"/>
-          </p:cNvPicPr>
-          <p:nvPr/>
-        </p:nvPicPr>
-        <p:blipFill>
-          <a:blip r:embed="rId3"/>
-          <a:stretch>
-            <a:fillRect/>
-          </a:stretch>
-        </p:blipFill>
-        <p:spPr>
-          <a:xfrm>
-            <a:off x="5936651" y="3650651"/>
-            <a:ext cx="215067" cy="215067"/>
-          </a:xfrm>
-          <a:prstGeom prst="rect">
-            <a:avLst/>
-          </a:prstGeom>
-        </p:spPr>
-      </p:pic>
-      <p:sp>
-        <p:nvSpPr>
-          <p:cNvPr id="18" name="Text 13"/>
-          <p:cNvSpPr txBox="1"/>
-          <p:nvPr/>
-        </p:nvSpPr>
-        <p:spPr>
-          <a:xfrm>
-            <a:off x="6355080" y="3529584"/>
-            <a:ext cx="2331720" cy="868680"/>
-          </a:xfrm>
-          <a:prstGeom prst="rect">
-            <a:avLst/>
-          </a:prstGeom>
-          <a:noFill/>
-          <a:ln/>
-        </p:spPr>
-        <p:txBody>
-          <a:bodyPr wrap="square" lIns="0" tIns="0" rIns="0" bIns="0" rtlCol="0" anchor="t"/>
-          <a:lstStyle/>
-          <a:p>
-            <a:pPr indent="0" marL="0">
-              <a:buNone/>
-            </a:pPr>
-            <a:r>
-              <a:rPr lang="en-US" sz="1400" dirty="0">
-                <a:solidFill>
-                  <a:srgbClr val="1B1F24"/>
-                </a:solidFill>
-              </a:rPr>
-              <a:t>Claude Desktop answers a question and makes a change</a:t>
+                  <a:srgbClr val="E6EDF3"/>
+                </a:solidFill>
+                <a:latin typeface="Courier New" pitchFamily="34" charset="0"/>
+                <a:ea typeface="Courier New" pitchFamily="34" charset="-122"/>
+                <a:cs typeface="Courier New" pitchFamily="34" charset="-120"/>
+              </a:rPr>
+              <a:t>npm run lab 02   # the lab check: all green?</a:t>
             </a:r>
             <a:endParaRPr lang="en-US" sz="1400" dirty="0"/>
           </a:p>
@@ -10694,7 +10937,7 @@
                   <a:srgbClr val="1B1F24"/>
                 </a:solidFill>
               </a:rPr>
-              <a:t>When the agent goes wrong: module 2</a:t>
+              <a:t>Checkpoint: Claude Desktop, your data</a:t>
             </a:r>
             <a:endParaRPr lang="en-US" sz="3200" dirty="0"/>
           </a:p>
@@ -10702,26 +10945,26 @@
       </p:sp>
       <p:sp>
         <p:nvSpPr>
-          <p:cNvPr id="3" name="snag-1"/>
+          <p:cNvPr id="3" name="terminal"/>
           <p:cNvSpPr/>
           <p:nvPr/>
         </p:nvSpPr>
         <p:spPr>
           <a:xfrm>
             <a:off x="457200" y="1097280"/>
-            <a:ext cx="8229600" cy="1051560"/>
+            <a:ext cx="5029200" cy="3520440"/>
           </a:xfrm>
           <a:prstGeom prst="roundRect">
             <a:avLst>
-              <a:gd name="adj" fmla="val 6957"/>
+              <a:gd name="adj" fmla="val 2078"/>
             </a:avLst>
           </a:prstGeom>
           <a:solidFill>
-            <a:srgbClr val="F1F5F9"/>
+            <a:srgbClr val="1B1F24"/>
           </a:solidFill>
           <a:ln w="12700">
             <a:solidFill>
-              <a:srgbClr val="F1F5F9"/>
+              <a:srgbClr val="1B1F24"/>
             </a:solidFill>
             <a:prstDash val="solid"/>
           </a:ln>
@@ -10735,8 +10978,33 @@
         </p:nvSpPr>
         <p:spPr>
           <a:xfrm>
-            <a:off x="685800" y="1371600"/>
-            <a:ext cx="502920" cy="502920"/>
+            <a:off x="640080" y="1225296"/>
+            <a:ext cx="109728" cy="109728"/>
+          </a:xfrm>
+          <a:prstGeom prst="ellipse">
+            <a:avLst/>
+          </a:prstGeom>
+          <a:solidFill>
+            <a:srgbClr val="E5484D"/>
+          </a:solidFill>
+          <a:ln w="12700">
+            <a:solidFill>
+              <a:srgbClr val="E5484D"/>
+            </a:solidFill>
+            <a:prstDash val="solid"/>
+          </a:ln>
+        </p:spPr>
+      </p:sp>
+      <p:sp>
+        <p:nvSpPr>
+          <p:cNvPr id="5" name="Shape 3"/>
+          <p:cNvSpPr/>
+          <p:nvPr/>
+        </p:nvSpPr>
+        <p:spPr>
+          <a:xfrm>
+            <a:off x="822960" y="1225296"/>
+            <a:ext cx="109728" cy="109728"/>
           </a:xfrm>
           <a:prstGeom prst="ellipse">
             <a:avLst/>
@@ -10752,9 +11020,292 @@
           </a:ln>
         </p:spPr>
       </p:sp>
+      <p:sp>
+        <p:nvSpPr>
+          <p:cNvPr id="6" name="Shape 4"/>
+          <p:cNvSpPr/>
+          <p:nvPr/>
+        </p:nvSpPr>
+        <p:spPr>
+          <a:xfrm>
+            <a:off x="1005840" y="1225296"/>
+            <a:ext cx="109728" cy="109728"/>
+          </a:xfrm>
+          <a:prstGeom prst="ellipse">
+            <a:avLst/>
+          </a:prstGeom>
+          <a:solidFill>
+            <a:srgbClr val="1FB68A"/>
+          </a:solidFill>
+          <a:ln w="12700">
+            <a:solidFill>
+              <a:srgbClr val="1FB68A"/>
+            </a:solidFill>
+            <a:prstDash val="solid"/>
+          </a:ln>
+        </p:spPr>
+      </p:sp>
+      <p:sp>
+        <p:nvSpPr>
+          <p:cNvPr id="7" name="Text 5"/>
+          <p:cNvSpPr txBox="1"/>
+          <p:nvPr/>
+        </p:nvSpPr>
+        <p:spPr>
+          <a:xfrm>
+            <a:off x="1280160" y="1152144"/>
+            <a:ext cx="4023360" cy="256032"/>
+          </a:xfrm>
+          <a:prstGeom prst="rect">
+            <a:avLst/>
+          </a:prstGeom>
+          <a:noFill/>
+          <a:ln/>
+        </p:spPr>
+        <p:txBody>
+          <a:bodyPr wrap="square" lIns="0" tIns="0" rIns="0" bIns="0" rtlCol="0" anchor="ctr"/>
+          <a:lstStyle/>
+          <a:p>
+            <a:pPr algn="r" indent="0" marL="0">
+              <a:buNone/>
+            </a:pPr>
+            <a:r>
+              <a:rPr lang="en-US" sz="1000" dirty="0">
+                <a:solidFill>
+                  <a:srgbClr val="8B98A5"/>
+                </a:solidFill>
+                <a:latin typeface="Calibri" pitchFamily="34" charset="0"/>
+                <a:ea typeface="Calibri" pitchFamily="34" charset="-122"/>
+                <a:cs typeface="Calibri" pitchFamily="34" charset="-120"/>
+              </a:rPr>
+              <a:t>output: captured</a:t>
+            </a:r>
+            <a:endParaRPr lang="en-US" sz="1000" dirty="0"/>
+          </a:p>
+        </p:txBody>
+      </p:sp>
+      <p:sp>
+        <p:nvSpPr>
+          <p:cNvPr id="8" name="terminal-text"/>
+          <p:cNvSpPr txBox="1"/>
+          <p:nvPr/>
+        </p:nvSpPr>
+        <p:spPr>
+          <a:xfrm>
+            <a:off x="685800" y="1481328"/>
+            <a:ext cx="4572000" cy="3017520"/>
+          </a:xfrm>
+          <a:prstGeom prst="rect">
+            <a:avLst/>
+          </a:prstGeom>
+          <a:noFill/>
+          <a:ln/>
+        </p:spPr>
+        <p:txBody>
+          <a:bodyPr wrap="square" lIns="0" tIns="0" rIns="0" bIns="0" rtlCol="0" anchor="t"/>
+          <a:lstStyle/>
+          <a:p>
+            <a:pPr indent="0" marL="0">
+              <a:buNone/>
+            </a:pPr>
+            <a:r>
+              <a:rPr lang="en-US" sz="1200" dirty="0">
+                <a:solidFill>
+                  <a:srgbClr val="8B98A5"/>
+                </a:solidFill>
+                <a:latin typeface="Courier New" pitchFamily="34" charset="0"/>
+                <a:ea typeface="Courier New" pitchFamily="34" charset="-122"/>
+                <a:cs typeface="Courier New" pitchFamily="34" charset="-120"/>
+              </a:rPr>
+              <a:t># npm run verify; npm run lab</a:t>
+            </a:r>
+            <a:endParaRPr lang="en-US" sz="1200" dirty="0"/>
+          </a:p>
+          <a:p>
+            <a:pPr indent="0" marL="0">
+              <a:buNone/>
+            </a:pPr>
+            <a:r>
+              <a:rPr lang="en-US" sz="1200" dirty="0">
+                <a:solidFill>
+                  <a:srgbClr val="E6EDF3"/>
+                </a:solidFill>
+                <a:latin typeface="Courier New" pitchFamily="34" charset="0"/>
+                <a:ea typeface="Courier New" pitchFamily="34" charset="-122"/>
+                <a:cs typeface="Courier New" pitchFamily="34" charset="-120"/>
+              </a:rPr>
+              <a:t>Tests  46 passed (46) · 58 passed (58)</a:t>
+            </a:r>
+            <a:endParaRPr lang="en-US" sz="1200" dirty="0"/>
+          </a:p>
+          <a:p>
+            <a:pPr indent="0" marL="0">
+              <a:buNone/>
+            </a:pPr>
+            <a:r>
+              <a:rPr lang="en-US" sz="1200" dirty="0">
+                <a:solidFill>
+                  <a:srgbClr val="E6EDF3"/>
+                </a:solidFill>
+                <a:latin typeface="Courier New" pitchFamily="34" charset="0"/>
+                <a:ea typeface="Courier New" pitchFamily="34" charset="-122"/>
+                <a:cs typeface="Courier New" pitchFamily="34" charset="-120"/>
+              </a:rPr>
+              <a:t>Tests  31 passed (31)</a:t>
+            </a:r>
+            <a:endParaRPr lang="en-US" sz="1200" dirty="0"/>
+          </a:p>
+          <a:p>
+            <a:pPr indent="0" marL="0">
+              <a:buNone/>
+            </a:pPr>
+            <a:r>
+              <a:rPr lang="en-US" sz="1200" dirty="0">
+                <a:solidFill>
+                  <a:srgbClr val="8B98A5"/>
+                </a:solidFill>
+                <a:latin typeface="Courier New" pitchFamily="34" charset="0"/>
+                <a:ea typeface="Courier New" pitchFamily="34" charset="-122"/>
+                <a:cs typeface="Courier New" pitchFamily="34" charset="-120"/>
+              </a:rPr>
+              <a:t># started as Claude Desktop does it</a:t>
+            </a:r>
+            <a:endParaRPr lang="en-US" sz="1200" dirty="0"/>
+          </a:p>
+          <a:p>
+            <a:pPr indent="0" marL="0">
+              <a:buNone/>
+            </a:pPr>
+            <a:r>
+              <a:rPr lang="en-US" sz="1200" dirty="0">
+                <a:solidFill>
+                  <a:srgbClr val="E6EDF3"/>
+                </a:solidFill>
+                <a:latin typeface="Courier New" pitchFamily="34" charset="0"/>
+                <a:ea typeface="Courier New" pitchFamily="34" charset="-122"/>
+                <a:cs typeface="Courier New" pitchFamily="34" charset="-120"/>
+              </a:rPr>
+              <a:t>create-user · create-note · share-note</a:t>
+            </a:r>
+            <a:endParaRPr lang="en-US" sz="1200" dirty="0"/>
+          </a:p>
+          <a:p>
+            <a:pPr indent="0" marL="0">
+              <a:buNone/>
+            </a:pPr>
+            <a:r>
+              <a:rPr lang="en-US" sz="1200" dirty="0">
+                <a:solidFill>
+                  <a:srgbClr val="E6EDF3"/>
+                </a:solidFill>
+                <a:latin typeface="Courier New" pitchFamily="34" charset="0"/>
+                <a:ea typeface="Courier New" pitchFamily="34" charset="-122"/>
+                <a:cs typeface="Courier New" pitchFamily="34" charset="-120"/>
+              </a:rPr>
+              <a:t>execute update … where id = … → 1 row</a:t>
+            </a:r>
+            <a:endParaRPr lang="en-US" sz="1200" dirty="0"/>
+          </a:p>
+          <a:p>
+            <a:pPr indent="0" marL="0">
+              <a:buNone/>
+            </a:pPr>
+            <a:r>
+              <a:rPr lang="en-US" sz="1200" dirty="0">
+                <a:solidFill>
+                  <a:srgbClr val="8B98A5"/>
+                </a:solidFill>
+                <a:latin typeface="Courier New" pitchFamily="34" charset="0"/>
+                <a:ea typeface="Courier New" pitchFamily="34" charset="-122"/>
+                <a:cs typeface="Courier New" pitchFamily="34" charset="-120"/>
+              </a:rPr>
+              <a:t># execute: delete from notes</a:t>
+            </a:r>
+            <a:endParaRPr lang="en-US" sz="1200" dirty="0"/>
+          </a:p>
+          <a:p>
+            <a:pPr indent="0" marL="0">
+              <a:buNone/>
+            </a:pPr>
+            <a:r>
+              <a:rPr lang="en-US" sz="1200" dirty="0">
+                <a:solidFill>
+                  <a:srgbClr val="E6EDF3"/>
+                </a:solidFill>
+                <a:latin typeface="Courier New" pitchFamily="34" charset="0"/>
+                <a:ea typeface="Courier New" pitchFamily="34" charset="-122"/>
+                <a:cs typeface="Courier New" pitchFamily="34" charset="-120"/>
+              </a:rPr>
+              <a:t>NOT_ALLOWED: DELETE without a WHERE …</a:t>
+            </a:r>
+            <a:endParaRPr lang="en-US" sz="1200" dirty="0"/>
+          </a:p>
+        </p:txBody>
+      </p:sp>
+      <p:sp>
+        <p:nvSpPr>
+          <p:cNvPr id="9" name="Text 7"/>
+          <p:cNvSpPr txBox="1"/>
+          <p:nvPr/>
+        </p:nvSpPr>
+        <p:spPr>
+          <a:xfrm>
+            <a:off x="5852160" y="1097280"/>
+            <a:ext cx="2834640" cy="411480"/>
+          </a:xfrm>
+          <a:prstGeom prst="rect">
+            <a:avLst/>
+          </a:prstGeom>
+          <a:noFill/>
+          <a:ln/>
+        </p:spPr>
+        <p:txBody>
+          <a:bodyPr wrap="square" lIns="0" tIns="0" rIns="0" bIns="0" rtlCol="0" anchor="ctr"/>
+          <a:lstStyle/>
+          <a:p>
+            <a:pPr indent="0" marL="0">
+              <a:buNone/>
+            </a:pPr>
+            <a:r>
+              <a:rPr lang="en-US" sz="2000" b="1" dirty="0">
+                <a:solidFill>
+                  <a:srgbClr val="1B1F24"/>
+                </a:solidFill>
+              </a:rPr>
+              <a:t>Done when</a:t>
+            </a:r>
+            <a:endParaRPr lang="en-US" sz="2000" dirty="0"/>
+          </a:p>
+        </p:txBody>
+      </p:sp>
+      <p:sp>
+        <p:nvSpPr>
+          <p:cNvPr id="10" name="Shape 8"/>
+          <p:cNvSpPr/>
+          <p:nvPr/>
+        </p:nvSpPr>
+        <p:spPr>
+          <a:xfrm>
+            <a:off x="5852160" y="1645920"/>
+            <a:ext cx="384048" cy="384048"/>
+          </a:xfrm>
+          <a:prstGeom prst="ellipse">
+            <a:avLst/>
+          </a:prstGeom>
+          <a:solidFill>
+            <a:srgbClr val="1FB68A"/>
+          </a:solidFill>
+          <a:ln w="12700">
+            <a:solidFill>
+              <a:srgbClr val="1FB68A"/>
+            </a:solidFill>
+            <a:prstDash val="solid"/>
+          </a:ln>
+        </p:spPr>
+      </p:sp>
       <p:pic>
         <p:nvPicPr>
-          <p:cNvPr id="5" name="Image 0" descr="preencoded.png">    </p:cNvPr>
+          <p:cNvPr id="11" name="Image 0" descr="preencoded.png">    </p:cNvPr>
           <p:cNvPicPr>
             <a:picLocks noChangeAspect="1"/>
           </p:cNvPicPr>
@@ -10768,8 +11319,8 @@
         </p:blipFill>
         <p:spPr>
           <a:xfrm>
-            <a:off x="796442" y="1482242"/>
-            <a:ext cx="281635" cy="281635"/>
+            <a:off x="5936651" y="1730411"/>
+            <a:ext cx="215067" cy="215067"/>
           </a:xfrm>
           <a:prstGeom prst="rect">
             <a:avLst/>
@@ -10778,14 +11329,14 @@
       </p:pic>
       <p:sp>
         <p:nvSpPr>
-          <p:cNvPr id="6" name="Text 3"/>
+          <p:cNvPr id="12" name="Text 9"/>
           <p:cNvSpPr txBox="1"/>
           <p:nvPr/>
         </p:nvSpPr>
         <p:spPr>
           <a:xfrm>
-            <a:off x="1417320" y="1188720"/>
-            <a:ext cx="7086600" cy="868680"/>
+            <a:off x="6355080" y="1609344"/>
+            <a:ext cx="2331720" cy="868680"/>
           </a:xfrm>
           <a:prstGeom prst="rect">
             <a:avLst/>
@@ -10794,93 +11345,69 @@
           <a:ln/>
         </p:spPr>
         <p:txBody>
-          <a:bodyPr wrap="square" lIns="0" tIns="0" rIns="0" bIns="0" rtlCol="0" anchor="ctr"/>
+          <a:bodyPr wrap="square" lIns="0" tIns="0" rIns="0" bIns="0" rtlCol="0" anchor="t"/>
           <a:lstStyle/>
           <a:p>
             <a:pPr indent="0" marL="0">
               <a:buNone/>
             </a:pPr>
-            <a:r>
-              <a:rPr lang="en-US" sz="1600" b="1" dirty="0">
+            <a:pPr indent="0" marL="0">
+              <a:buNone/>
+            </a:pPr>
+            <a:r>
+              <a:rPr lang="en-US" sz="1400" dirty="0">
                 <a:solidFill>
                   <a:srgbClr val="1B1F24"/>
                 </a:solidFill>
-              </a:rPr>
-              <a:t>query checks the SQL string only</a:t>
-            </a:r>
-            <a:endParaRPr lang="en-US" sz="1600" dirty="0"/>
-          </a:p>
-          <a:p>
+                <a:latin typeface="Courier New" pitchFamily="34" charset="0"/>
+                <a:ea typeface="Courier New" pitchFamily="34" charset="-122"/>
+                <a:cs typeface="Courier New" pitchFamily="34" charset="-120"/>
+              </a:rPr>
+              <a:t>npm run lab 02</a:t>
+            </a:r>
             <a:pPr indent="0" marL="0">
               <a:buNone/>
             </a:pPr>
             <a:r>
               <a:rPr lang="en-US" sz="1400" dirty="0">
                 <a:solidFill>
-                  <a:srgbClr val="2B3440"/>
-                </a:solidFill>
-              </a:rPr>
-              <a:t>A write can hide inside a WITH. Ask for PRAGMA query_only too, and a test that tries it.</a:t>
-            </a:r>
-            <a:endParaRPr lang="en-US" sz="1600" dirty="0"/>
-          </a:p>
-        </p:txBody>
-      </p:sp>
-      <p:sp>
-        <p:nvSpPr>
-          <p:cNvPr id="7" name="snag-2"/>
-          <p:cNvSpPr/>
-          <p:nvPr/>
-        </p:nvSpPr>
-        <p:spPr>
-          <a:xfrm>
-            <a:off x="457200" y="2286000"/>
-            <a:ext cx="8229600" cy="1051560"/>
-          </a:xfrm>
-          <a:prstGeom prst="roundRect">
-            <a:avLst>
-              <a:gd name="adj" fmla="val 6957"/>
-            </a:avLst>
+                  <a:srgbClr val="1B1F24"/>
+                </a:solidFill>
+              </a:rPr>
+              <a:t>: every test passes</a:t>
+            </a:r>
+            <a:endParaRPr lang="en-US" sz="1400" dirty="0"/>
+          </a:p>
+        </p:txBody>
+      </p:sp>
+      <p:sp>
+        <p:nvSpPr>
+          <p:cNvPr id="13" name="Shape 10"/>
+          <p:cNvSpPr/>
+          <p:nvPr/>
+        </p:nvSpPr>
+        <p:spPr>
+          <a:xfrm>
+            <a:off x="5852160" y="2606040"/>
+            <a:ext cx="384048" cy="384048"/>
+          </a:xfrm>
+          <a:prstGeom prst="ellipse">
+            <a:avLst/>
           </a:prstGeom>
           <a:solidFill>
-            <a:srgbClr val="F1F5F9"/>
+            <a:srgbClr val="1FB68A"/>
           </a:solidFill>
           <a:ln w="12700">
             <a:solidFill>
-              <a:srgbClr val="F1F5F9"/>
+              <a:srgbClr val="1FB68A"/>
             </a:solidFill>
             <a:prstDash val="solid"/>
           </a:ln>
         </p:spPr>
       </p:sp>
-      <p:sp>
-        <p:nvSpPr>
-          <p:cNvPr id="8" name="Shape 5"/>
-          <p:cNvSpPr/>
-          <p:nvPr/>
-        </p:nvSpPr>
-        <p:spPr>
-          <a:xfrm>
-            <a:off x="685800" y="2560320"/>
-            <a:ext cx="502920" cy="502920"/>
-          </a:xfrm>
-          <a:prstGeom prst="ellipse">
-            <a:avLst/>
-          </a:prstGeom>
-          <a:solidFill>
-            <a:srgbClr val="E69A28"/>
-          </a:solidFill>
-          <a:ln w="12700">
-            <a:solidFill>
-              <a:srgbClr val="E69A28"/>
-            </a:solidFill>
-            <a:prstDash val="solid"/>
-          </a:ln>
-        </p:spPr>
-      </p:sp>
       <p:pic>
         <p:nvPicPr>
-          <p:cNvPr id="9" name="Image 1" descr="preencoded.png">    </p:cNvPr>
+          <p:cNvPr id="14" name="Image 1" descr="preencoded.png">    </p:cNvPr>
           <p:cNvPicPr>
             <a:picLocks noChangeAspect="1"/>
           </p:cNvPicPr>
@@ -10894,8 +11421,8 @@
         </p:blipFill>
         <p:spPr>
           <a:xfrm>
-            <a:off x="796442" y="2670962"/>
-            <a:ext cx="281635" cy="281635"/>
+            <a:off x="5936651" y="2690531"/>
+            <a:ext cx="215067" cy="215067"/>
           </a:xfrm>
           <a:prstGeom prst="rect">
             <a:avLst/>
@@ -10904,14 +11431,14 @@
       </p:pic>
       <p:sp>
         <p:nvSpPr>
-          <p:cNvPr id="10" name="Text 6"/>
+          <p:cNvPr id="15" name="Text 11"/>
           <p:cNvSpPr txBox="1"/>
           <p:nvPr/>
         </p:nvSpPr>
         <p:spPr>
           <a:xfrm>
-            <a:off x="1417320" y="2377440"/>
-            <a:ext cx="7086600" cy="868680"/>
+            <a:off x="6355080" y="2569464"/>
+            <a:ext cx="2331720" cy="868680"/>
           </a:xfrm>
           <a:prstGeom prst="rect">
             <a:avLst/>
@@ -10920,93 +11447,52 @@
           <a:ln/>
         </p:spPr>
         <p:txBody>
-          <a:bodyPr wrap="square" lIns="0" tIns="0" rIns="0" bIns="0" rtlCol="0" anchor="ctr"/>
+          <a:bodyPr wrap="square" lIns="0" tIns="0" rIns="0" bIns="0" rtlCol="0" anchor="t"/>
           <a:lstStyle/>
           <a:p>
             <a:pPr indent="0" marL="0">
               <a:buNone/>
             </a:pPr>
             <a:r>
-              <a:rPr lang="en-US" sz="1600" b="1" dirty="0">
+              <a:rPr lang="en-US" sz="1400" dirty="0">
                 <a:solidFill>
                   <a:srgbClr val="1B1F24"/>
                 </a:solidFill>
               </a:rPr>
-              <a:t>execute runs any SQL it is given</a:t>
-            </a:r>
-            <a:endParaRPr lang="en-US" sz="1600" dirty="0"/>
-          </a:p>
-          <a:p>
-            <a:pPr indent="0" marL="0">
-              <a:buNone/>
-            </a:pPr>
-            <a:r>
-              <a:rPr lang="en-US" sz="1400" dirty="0">
-                <a:solidFill>
-                  <a:srgbClr val="2B3440"/>
-                </a:solidFill>
-              </a:rPr>
-              <a:t>One statement, INSERT/UPDATE/DELETE only, a WHERE on UPDATE and DELETE. Ask for a test per refusal.</a:t>
-            </a:r>
-            <a:endParaRPr lang="en-US" sz="1600" dirty="0"/>
-          </a:p>
-        </p:txBody>
-      </p:sp>
-      <p:sp>
-        <p:nvSpPr>
-          <p:cNvPr id="11" name="snag-3"/>
-          <p:cNvSpPr/>
-          <p:nvPr/>
-        </p:nvSpPr>
-        <p:spPr>
-          <a:xfrm>
-            <a:off x="457200" y="3474720"/>
-            <a:ext cx="8229600" cy="1051560"/>
-          </a:xfrm>
-          <a:prstGeom prst="roundRect">
-            <a:avLst>
-              <a:gd name="adj" fmla="val 6957"/>
-            </a:avLst>
+              <a:t>query refuses a write, execute an unbounded one</a:t>
+            </a:r>
+            <a:endParaRPr lang="en-US" sz="1400" dirty="0"/>
+          </a:p>
+        </p:txBody>
+      </p:sp>
+      <p:sp>
+        <p:nvSpPr>
+          <p:cNvPr id="16" name="Shape 12"/>
+          <p:cNvSpPr/>
+          <p:nvPr/>
+        </p:nvSpPr>
+        <p:spPr>
+          <a:xfrm>
+            <a:off x="5852160" y="3566160"/>
+            <a:ext cx="384048" cy="384048"/>
+          </a:xfrm>
+          <a:prstGeom prst="ellipse">
+            <a:avLst/>
           </a:prstGeom>
           <a:solidFill>
-            <a:srgbClr val="F1F5F9"/>
+            <a:srgbClr val="1FB68A"/>
           </a:solidFill>
           <a:ln w="12700">
             <a:solidFill>
-              <a:srgbClr val="F1F5F9"/>
+              <a:srgbClr val="1FB68A"/>
             </a:solidFill>
             <a:prstDash val="solid"/>
           </a:ln>
         </p:spPr>
       </p:sp>
-      <p:sp>
-        <p:nvSpPr>
-          <p:cNvPr id="12" name="Shape 8"/>
-          <p:cNvSpPr/>
-          <p:nvPr/>
-        </p:nvSpPr>
-        <p:spPr>
-          <a:xfrm>
-            <a:off x="685800" y="3749040"/>
-            <a:ext cx="502920" cy="502920"/>
-          </a:xfrm>
-          <a:prstGeom prst="ellipse">
-            <a:avLst/>
-          </a:prstGeom>
-          <a:solidFill>
-            <a:srgbClr val="E69A28"/>
-          </a:solidFill>
-          <a:ln w="12700">
-            <a:solidFill>
-              <a:srgbClr val="E69A28"/>
-            </a:solidFill>
-            <a:prstDash val="solid"/>
-          </a:ln>
-        </p:spPr>
-      </p:sp>
       <p:pic>
         <p:nvPicPr>
-          <p:cNvPr id="13" name="Image 2" descr="preencoded.png">    </p:cNvPr>
+          <p:cNvPr id="17" name="Image 2" descr="preencoded.png">    </p:cNvPr>
           <p:cNvPicPr>
             <a:picLocks noChangeAspect="1"/>
           </p:cNvPicPr>
@@ -11020,8 +11506,8 @@
         </p:blipFill>
         <p:spPr>
           <a:xfrm>
-            <a:off x="796442" y="3859682"/>
-            <a:ext cx="281635" cy="281635"/>
+            <a:off x="5936651" y="3650651"/>
+            <a:ext cx="215067" cy="215067"/>
           </a:xfrm>
           <a:prstGeom prst="rect">
             <a:avLst/>
@@ -11030,14 +11516,14 @@
       </p:pic>
       <p:sp>
         <p:nvSpPr>
-          <p:cNvPr id="14" name="Text 9"/>
+          <p:cNvPr id="18" name="Text 13"/>
           <p:cNvSpPr txBox="1"/>
           <p:nvPr/>
         </p:nvSpPr>
         <p:spPr>
           <a:xfrm>
-            <a:off x="1417320" y="3566160"/>
-            <a:ext cx="7086600" cy="868680"/>
+            <a:off x="6355080" y="3529584"/>
+            <a:ext cx="2331720" cy="868680"/>
           </a:xfrm>
           <a:prstGeom prst="rect">
             <a:avLst/>
@@ -11046,161 +11532,21 @@
           <a:ln/>
         </p:spPr>
         <p:txBody>
-          <a:bodyPr wrap="square" lIns="0" tIns="0" rIns="0" bIns="0" rtlCol="0" anchor="ctr"/>
+          <a:bodyPr wrap="square" lIns="0" tIns="0" rIns="0" bIns="0" rtlCol="0" anchor="t"/>
           <a:lstStyle/>
           <a:p>
             <a:pPr indent="0" marL="0">
               <a:buNone/>
             </a:pPr>
             <a:r>
-              <a:rPr lang="en-US" sz="1600" b="1" dirty="0">
+              <a:rPr lang="en-US" sz="1400" dirty="0">
                 <a:solidFill>
                   <a:srgbClr val="1B1F24"/>
                 </a:solidFill>
               </a:rPr>
-              <a:t>Claude sees no tables</a:t>
-            </a:r>
-            <a:endParaRPr lang="en-US" sz="1600" dirty="0"/>
-          </a:p>
-          <a:p>
-            <a:pPr indent="0" marL="0">
-              <a:buNone/>
-            </a:pPr>
-            <a:r>
-              <a:rPr lang="en-US" sz="1400" dirty="0">
-                <a:solidFill>
-                  <a:srgbClr val="2B3440"/>
-                </a:solidFill>
-              </a:rPr>
-              <a:t>The server started in another folder and got an empty database. Use absolute paths; the server should exit when the file is missing.</a:t>
-            </a:r>
-            <a:endParaRPr lang="en-US" sz="1600" dirty="0"/>
-          </a:p>
-        </p:txBody>
-      </p:sp>
-      <p:sp>
-        <p:nvSpPr>
-          <p:cNvPr id="15" name="snag-4"/>
-          <p:cNvSpPr/>
-          <p:nvPr/>
-        </p:nvSpPr>
-        <p:spPr>
-          <a:xfrm>
-            <a:off x="457200" y="4663440"/>
-            <a:ext cx="8229600" cy="1051560"/>
-          </a:xfrm>
-          <a:prstGeom prst="roundRect">
-            <a:avLst>
-              <a:gd name="adj" fmla="val 6957"/>
-            </a:avLst>
-          </a:prstGeom>
-          <a:solidFill>
-            <a:srgbClr val="F1F5F9"/>
-          </a:solidFill>
-          <a:ln w="12700">
-            <a:solidFill>
-              <a:srgbClr val="F1F5F9"/>
-            </a:solidFill>
-            <a:prstDash val="solid"/>
-          </a:ln>
-        </p:spPr>
-      </p:sp>
-      <p:sp>
-        <p:nvSpPr>
-          <p:cNvPr id="16" name="Shape 11"/>
-          <p:cNvSpPr/>
-          <p:nvPr/>
-        </p:nvSpPr>
-        <p:spPr>
-          <a:xfrm>
-            <a:off x="685800" y="4937760"/>
-            <a:ext cx="502920" cy="502920"/>
-          </a:xfrm>
-          <a:prstGeom prst="ellipse">
-            <a:avLst/>
-          </a:prstGeom>
-          <a:solidFill>
-            <a:srgbClr val="E69A28"/>
-          </a:solidFill>
-          <a:ln w="12700">
-            <a:solidFill>
-              <a:srgbClr val="E69A28"/>
-            </a:solidFill>
-            <a:prstDash val="solid"/>
-          </a:ln>
-        </p:spPr>
-      </p:sp>
-      <p:pic>
-        <p:nvPicPr>
-          <p:cNvPr id="17" name="Image 3" descr="preencoded.png">    </p:cNvPr>
-          <p:cNvPicPr>
-            <a:picLocks noChangeAspect="1"/>
-          </p:cNvPicPr>
-          <p:nvPr/>
-        </p:nvPicPr>
-        <p:blipFill>
-          <a:blip r:embed="rId4"/>
-          <a:stretch>
-            <a:fillRect/>
-          </a:stretch>
-        </p:blipFill>
-        <p:spPr>
-          <a:xfrm>
-            <a:off x="796442" y="5048402"/>
-            <a:ext cx="281635" cy="281635"/>
-          </a:xfrm>
-          <a:prstGeom prst="rect">
-            <a:avLst/>
-          </a:prstGeom>
-        </p:spPr>
-      </p:pic>
-      <p:sp>
-        <p:nvSpPr>
-          <p:cNvPr id="18" name="Text 12"/>
-          <p:cNvSpPr txBox="1"/>
-          <p:nvPr/>
-        </p:nvSpPr>
-        <p:spPr>
-          <a:xfrm>
-            <a:off x="1417320" y="4754880"/>
-            <a:ext cx="7086600" cy="868680"/>
-          </a:xfrm>
-          <a:prstGeom prst="rect">
-            <a:avLst/>
-          </a:prstGeom>
-          <a:noFill/>
-          <a:ln/>
-        </p:spPr>
-        <p:txBody>
-          <a:bodyPr wrap="square" lIns="0" tIns="0" rIns="0" bIns="0" rtlCol="0" anchor="ctr"/>
-          <a:lstStyle/>
-          <a:p>
-            <a:pPr indent="0" marL="0">
-              <a:buNone/>
-            </a:pPr>
-            <a:r>
-              <a:rPr lang="en-US" sz="1600" b="1" dirty="0">
-                <a:solidFill>
-                  <a:srgbClr val="1B1F24"/>
-                </a:solidFill>
-              </a:rPr>
-              <a:t>Claude Desktop shows no notes-db tools</a:t>
-            </a:r>
-            <a:endParaRPr lang="en-US" sz="1600" dirty="0"/>
-          </a:p>
-          <a:p>
-            <a:pPr indent="0" marL="0">
-              <a:buNone/>
-            </a:pPr>
-            <a:r>
-              <a:rPr lang="en-US" sz="1400" dirty="0">
-                <a:solidFill>
-                  <a:srgbClr val="2B3440"/>
-                </a:solidFill>
-              </a:rPr>
-              <a:t>A relative path or a bare node in the entry. Use the script's absolute paths, then quit Claude Desktop fully and reopen.</a:t>
-            </a:r>
-            <a:endParaRPr lang="en-US" sz="1600" dirty="0"/>
+              <a:t>Claude Desktop answers a question and makes a change</a:t>
+            </a:r>
+            <a:endParaRPr lang="en-US" sz="1400" dirty="0"/>
           </a:p>
         </p:txBody>
       </p:sp>
@@ -11260,6 +11606,618 @@
 <file path=ppt/slides/slide21.xml><?xml version="1.0" encoding="utf-8"?>
 <p:sld xmlns:a="http://schemas.openxmlformats.org/drawingml/2006/main" xmlns:r="http://schemas.openxmlformats.org/officeDocument/2006/relationships" xmlns:p="http://schemas.openxmlformats.org/presentationml/2006/main">
   <p:cSld name="Slide 21">
+    <p:spTree>
+      <p:nvGrpSpPr>
+        <p:cNvPr id="1" name=""/>
+        <p:cNvGrpSpPr/>
+        <p:nvPr/>
+      </p:nvGrpSpPr>
+      <p:grpSpPr>
+        <a:xfrm>
+          <a:off x="0" y="0"/>
+          <a:ext cx="0" cy="0"/>
+          <a:chOff x="0" y="0"/>
+          <a:chExt cx="0" cy="0"/>
+        </a:xfrm>
+      </p:grpSpPr>
+      <p:sp>
+        <p:nvSpPr>
+          <p:cNvPr id="2" name="Text 0"/>
+          <p:cNvSpPr/>
+          <p:nvPr>
+            <p:ph idx="100" type="title" hasCustomPrompt="1"/>
+          </p:nvPr>
+        </p:nvSpPr>
+        <p:spPr>
+          <a:xfrm>
+            <a:off x="457200" y="274320"/>
+            <a:ext cx="8229600" cy="685800"/>
+          </a:xfrm>
+          <a:prstGeom prst="rect">
+            <a:avLst/>
+          </a:prstGeom>
+          <a:noFill/>
+          <a:ln/>
+        </p:spPr>
+        <p:txBody>
+          <a:bodyPr wrap="square" lIns="0" tIns="0" rIns="0" bIns="0" rtlCol="0" anchor="ctr"/>
+          <a:lstStyle/>
+          <a:p>
+            <a:pPr algn="l" indent="0" marL="0">
+              <a:buNone/>
+            </a:pPr>
+            <a:r>
+              <a:rPr lang="en-US" sz="3200" b="1" dirty="0">
+                <a:solidFill>
+                  <a:srgbClr val="1B1F24"/>
+                </a:solidFill>
+              </a:rPr>
+              <a:t>When the agent goes wrong: module 2</a:t>
+            </a:r>
+            <a:endParaRPr lang="en-US" sz="3200" dirty="0"/>
+          </a:p>
+        </p:txBody>
+      </p:sp>
+      <p:sp>
+        <p:nvSpPr>
+          <p:cNvPr id="3" name="snag-1"/>
+          <p:cNvSpPr/>
+          <p:nvPr/>
+        </p:nvSpPr>
+        <p:spPr>
+          <a:xfrm>
+            <a:off x="457200" y="1097280"/>
+            <a:ext cx="8229600" cy="1051560"/>
+          </a:xfrm>
+          <a:prstGeom prst="roundRect">
+            <a:avLst>
+              <a:gd name="adj" fmla="val 6957"/>
+            </a:avLst>
+          </a:prstGeom>
+          <a:solidFill>
+            <a:srgbClr val="F1F5F9"/>
+          </a:solidFill>
+          <a:ln w="12700">
+            <a:solidFill>
+              <a:srgbClr val="F1F5F9"/>
+            </a:solidFill>
+            <a:prstDash val="solid"/>
+          </a:ln>
+        </p:spPr>
+      </p:sp>
+      <p:sp>
+        <p:nvSpPr>
+          <p:cNvPr id="4" name="Shape 2"/>
+          <p:cNvSpPr/>
+          <p:nvPr/>
+        </p:nvSpPr>
+        <p:spPr>
+          <a:xfrm>
+            <a:off x="685800" y="1371600"/>
+            <a:ext cx="502920" cy="502920"/>
+          </a:xfrm>
+          <a:prstGeom prst="ellipse">
+            <a:avLst/>
+          </a:prstGeom>
+          <a:solidFill>
+            <a:srgbClr val="E69A28"/>
+          </a:solidFill>
+          <a:ln w="12700">
+            <a:solidFill>
+              <a:srgbClr val="E69A28"/>
+            </a:solidFill>
+            <a:prstDash val="solid"/>
+          </a:ln>
+        </p:spPr>
+      </p:sp>
+      <p:pic>
+        <p:nvPicPr>
+          <p:cNvPr id="5" name="Image 0" descr="preencoded.png">    </p:cNvPr>
+          <p:cNvPicPr>
+            <a:picLocks noChangeAspect="1"/>
+          </p:cNvPicPr>
+          <p:nvPr/>
+        </p:nvPicPr>
+        <p:blipFill>
+          <a:blip r:embed="rId1"/>
+          <a:stretch>
+            <a:fillRect/>
+          </a:stretch>
+        </p:blipFill>
+        <p:spPr>
+          <a:xfrm>
+            <a:off x="796442" y="1482242"/>
+            <a:ext cx="281635" cy="281635"/>
+          </a:xfrm>
+          <a:prstGeom prst="rect">
+            <a:avLst/>
+          </a:prstGeom>
+        </p:spPr>
+      </p:pic>
+      <p:sp>
+        <p:nvSpPr>
+          <p:cNvPr id="6" name="Text 3"/>
+          <p:cNvSpPr txBox="1"/>
+          <p:nvPr/>
+        </p:nvSpPr>
+        <p:spPr>
+          <a:xfrm>
+            <a:off x="1417320" y="1188720"/>
+            <a:ext cx="7086600" cy="868680"/>
+          </a:xfrm>
+          <a:prstGeom prst="rect">
+            <a:avLst/>
+          </a:prstGeom>
+          <a:noFill/>
+          <a:ln/>
+        </p:spPr>
+        <p:txBody>
+          <a:bodyPr wrap="square" lIns="0" tIns="0" rIns="0" bIns="0" rtlCol="0" anchor="ctr"/>
+          <a:lstStyle/>
+          <a:p>
+            <a:pPr indent="0" marL="0">
+              <a:buNone/>
+            </a:pPr>
+            <a:r>
+              <a:rPr lang="en-US" sz="1600" b="1" dirty="0">
+                <a:solidFill>
+                  <a:srgbClr val="1B1F24"/>
+                </a:solidFill>
+              </a:rPr>
+              <a:t>query checks the SQL string only</a:t>
+            </a:r>
+            <a:endParaRPr lang="en-US" sz="1600" dirty="0"/>
+          </a:p>
+          <a:p>
+            <a:pPr indent="0" marL="0">
+              <a:buNone/>
+            </a:pPr>
+            <a:r>
+              <a:rPr lang="en-US" sz="1400" dirty="0">
+                <a:solidFill>
+                  <a:srgbClr val="2B3440"/>
+                </a:solidFill>
+              </a:rPr>
+              <a:t>A write can hide inside a WITH. Ask for PRAGMA query_only too, and a test that tries it.</a:t>
+            </a:r>
+            <a:endParaRPr lang="en-US" sz="1600" dirty="0"/>
+          </a:p>
+        </p:txBody>
+      </p:sp>
+      <p:sp>
+        <p:nvSpPr>
+          <p:cNvPr id="7" name="snag-2"/>
+          <p:cNvSpPr/>
+          <p:nvPr/>
+        </p:nvSpPr>
+        <p:spPr>
+          <a:xfrm>
+            <a:off x="457200" y="2286000"/>
+            <a:ext cx="8229600" cy="1051560"/>
+          </a:xfrm>
+          <a:prstGeom prst="roundRect">
+            <a:avLst>
+              <a:gd name="adj" fmla="val 6957"/>
+            </a:avLst>
+          </a:prstGeom>
+          <a:solidFill>
+            <a:srgbClr val="F1F5F9"/>
+          </a:solidFill>
+          <a:ln w="12700">
+            <a:solidFill>
+              <a:srgbClr val="F1F5F9"/>
+            </a:solidFill>
+            <a:prstDash val="solid"/>
+          </a:ln>
+        </p:spPr>
+      </p:sp>
+      <p:sp>
+        <p:nvSpPr>
+          <p:cNvPr id="8" name="Shape 5"/>
+          <p:cNvSpPr/>
+          <p:nvPr/>
+        </p:nvSpPr>
+        <p:spPr>
+          <a:xfrm>
+            <a:off x="685800" y="2560320"/>
+            <a:ext cx="502920" cy="502920"/>
+          </a:xfrm>
+          <a:prstGeom prst="ellipse">
+            <a:avLst/>
+          </a:prstGeom>
+          <a:solidFill>
+            <a:srgbClr val="E69A28"/>
+          </a:solidFill>
+          <a:ln w="12700">
+            <a:solidFill>
+              <a:srgbClr val="E69A28"/>
+            </a:solidFill>
+            <a:prstDash val="solid"/>
+          </a:ln>
+        </p:spPr>
+      </p:sp>
+      <p:pic>
+        <p:nvPicPr>
+          <p:cNvPr id="9" name="Image 1" descr="preencoded.png">    </p:cNvPr>
+          <p:cNvPicPr>
+            <a:picLocks noChangeAspect="1"/>
+          </p:cNvPicPr>
+          <p:nvPr/>
+        </p:nvPicPr>
+        <p:blipFill>
+          <a:blip r:embed="rId2"/>
+          <a:stretch>
+            <a:fillRect/>
+          </a:stretch>
+        </p:blipFill>
+        <p:spPr>
+          <a:xfrm>
+            <a:off x="796442" y="2670962"/>
+            <a:ext cx="281635" cy="281635"/>
+          </a:xfrm>
+          <a:prstGeom prst="rect">
+            <a:avLst/>
+          </a:prstGeom>
+        </p:spPr>
+      </p:pic>
+      <p:sp>
+        <p:nvSpPr>
+          <p:cNvPr id="10" name="Text 6"/>
+          <p:cNvSpPr txBox="1"/>
+          <p:nvPr/>
+        </p:nvSpPr>
+        <p:spPr>
+          <a:xfrm>
+            <a:off x="1417320" y="2377440"/>
+            <a:ext cx="7086600" cy="868680"/>
+          </a:xfrm>
+          <a:prstGeom prst="rect">
+            <a:avLst/>
+          </a:prstGeom>
+          <a:noFill/>
+          <a:ln/>
+        </p:spPr>
+        <p:txBody>
+          <a:bodyPr wrap="square" lIns="0" tIns="0" rIns="0" bIns="0" rtlCol="0" anchor="ctr"/>
+          <a:lstStyle/>
+          <a:p>
+            <a:pPr indent="0" marL="0">
+              <a:buNone/>
+            </a:pPr>
+            <a:r>
+              <a:rPr lang="en-US" sz="1600" b="1" dirty="0">
+                <a:solidFill>
+                  <a:srgbClr val="1B1F24"/>
+                </a:solidFill>
+              </a:rPr>
+              <a:t>execute runs any SQL it is given</a:t>
+            </a:r>
+            <a:endParaRPr lang="en-US" sz="1600" dirty="0"/>
+          </a:p>
+          <a:p>
+            <a:pPr indent="0" marL="0">
+              <a:buNone/>
+            </a:pPr>
+            <a:r>
+              <a:rPr lang="en-US" sz="1400" dirty="0">
+                <a:solidFill>
+                  <a:srgbClr val="2B3440"/>
+                </a:solidFill>
+              </a:rPr>
+              <a:t>One statement, INSERT/UPDATE/DELETE only, a WHERE on UPDATE and DELETE. Ask for a test per refusal.</a:t>
+            </a:r>
+            <a:endParaRPr lang="en-US" sz="1600" dirty="0"/>
+          </a:p>
+        </p:txBody>
+      </p:sp>
+      <p:sp>
+        <p:nvSpPr>
+          <p:cNvPr id="11" name="snag-3"/>
+          <p:cNvSpPr/>
+          <p:nvPr/>
+        </p:nvSpPr>
+        <p:spPr>
+          <a:xfrm>
+            <a:off x="457200" y="3474720"/>
+            <a:ext cx="8229600" cy="1051560"/>
+          </a:xfrm>
+          <a:prstGeom prst="roundRect">
+            <a:avLst>
+              <a:gd name="adj" fmla="val 6957"/>
+            </a:avLst>
+          </a:prstGeom>
+          <a:solidFill>
+            <a:srgbClr val="F1F5F9"/>
+          </a:solidFill>
+          <a:ln w="12700">
+            <a:solidFill>
+              <a:srgbClr val="F1F5F9"/>
+            </a:solidFill>
+            <a:prstDash val="solid"/>
+          </a:ln>
+        </p:spPr>
+      </p:sp>
+      <p:sp>
+        <p:nvSpPr>
+          <p:cNvPr id="12" name="Shape 8"/>
+          <p:cNvSpPr/>
+          <p:nvPr/>
+        </p:nvSpPr>
+        <p:spPr>
+          <a:xfrm>
+            <a:off x="685800" y="3749040"/>
+            <a:ext cx="502920" cy="502920"/>
+          </a:xfrm>
+          <a:prstGeom prst="ellipse">
+            <a:avLst/>
+          </a:prstGeom>
+          <a:solidFill>
+            <a:srgbClr val="E69A28"/>
+          </a:solidFill>
+          <a:ln w="12700">
+            <a:solidFill>
+              <a:srgbClr val="E69A28"/>
+            </a:solidFill>
+            <a:prstDash val="solid"/>
+          </a:ln>
+        </p:spPr>
+      </p:sp>
+      <p:pic>
+        <p:nvPicPr>
+          <p:cNvPr id="13" name="Image 2" descr="preencoded.png">    </p:cNvPr>
+          <p:cNvPicPr>
+            <a:picLocks noChangeAspect="1"/>
+          </p:cNvPicPr>
+          <p:nvPr/>
+        </p:nvPicPr>
+        <p:blipFill>
+          <a:blip r:embed="rId3"/>
+          <a:stretch>
+            <a:fillRect/>
+          </a:stretch>
+        </p:blipFill>
+        <p:spPr>
+          <a:xfrm>
+            <a:off x="796442" y="3859682"/>
+            <a:ext cx="281635" cy="281635"/>
+          </a:xfrm>
+          <a:prstGeom prst="rect">
+            <a:avLst/>
+          </a:prstGeom>
+        </p:spPr>
+      </p:pic>
+      <p:sp>
+        <p:nvSpPr>
+          <p:cNvPr id="14" name="Text 9"/>
+          <p:cNvSpPr txBox="1"/>
+          <p:nvPr/>
+        </p:nvSpPr>
+        <p:spPr>
+          <a:xfrm>
+            <a:off x="1417320" y="3566160"/>
+            <a:ext cx="7086600" cy="868680"/>
+          </a:xfrm>
+          <a:prstGeom prst="rect">
+            <a:avLst/>
+          </a:prstGeom>
+          <a:noFill/>
+          <a:ln/>
+        </p:spPr>
+        <p:txBody>
+          <a:bodyPr wrap="square" lIns="0" tIns="0" rIns="0" bIns="0" rtlCol="0" anchor="ctr"/>
+          <a:lstStyle/>
+          <a:p>
+            <a:pPr indent="0" marL="0">
+              <a:buNone/>
+            </a:pPr>
+            <a:r>
+              <a:rPr lang="en-US" sz="1600" b="1" dirty="0">
+                <a:solidFill>
+                  <a:srgbClr val="1B1F24"/>
+                </a:solidFill>
+              </a:rPr>
+              <a:t>Claude sees no tables</a:t>
+            </a:r>
+            <a:endParaRPr lang="en-US" sz="1600" dirty="0"/>
+          </a:p>
+          <a:p>
+            <a:pPr indent="0" marL="0">
+              <a:buNone/>
+            </a:pPr>
+            <a:r>
+              <a:rPr lang="en-US" sz="1400" dirty="0">
+                <a:solidFill>
+                  <a:srgbClr val="2B3440"/>
+                </a:solidFill>
+              </a:rPr>
+              <a:t>The server started in another folder and got an empty database. Use absolute paths; the server should exit when the file is missing.</a:t>
+            </a:r>
+            <a:endParaRPr lang="en-US" sz="1600" dirty="0"/>
+          </a:p>
+        </p:txBody>
+      </p:sp>
+      <p:sp>
+        <p:nvSpPr>
+          <p:cNvPr id="15" name="snag-4"/>
+          <p:cNvSpPr/>
+          <p:nvPr/>
+        </p:nvSpPr>
+        <p:spPr>
+          <a:xfrm>
+            <a:off x="457200" y="4663440"/>
+            <a:ext cx="8229600" cy="1051560"/>
+          </a:xfrm>
+          <a:prstGeom prst="roundRect">
+            <a:avLst>
+              <a:gd name="adj" fmla="val 6957"/>
+            </a:avLst>
+          </a:prstGeom>
+          <a:solidFill>
+            <a:srgbClr val="F1F5F9"/>
+          </a:solidFill>
+          <a:ln w="12700">
+            <a:solidFill>
+              <a:srgbClr val="F1F5F9"/>
+            </a:solidFill>
+            <a:prstDash val="solid"/>
+          </a:ln>
+        </p:spPr>
+      </p:sp>
+      <p:sp>
+        <p:nvSpPr>
+          <p:cNvPr id="16" name="Shape 11"/>
+          <p:cNvSpPr/>
+          <p:nvPr/>
+        </p:nvSpPr>
+        <p:spPr>
+          <a:xfrm>
+            <a:off x="685800" y="4937760"/>
+            <a:ext cx="502920" cy="502920"/>
+          </a:xfrm>
+          <a:prstGeom prst="ellipse">
+            <a:avLst/>
+          </a:prstGeom>
+          <a:solidFill>
+            <a:srgbClr val="E69A28"/>
+          </a:solidFill>
+          <a:ln w="12700">
+            <a:solidFill>
+              <a:srgbClr val="E69A28"/>
+            </a:solidFill>
+            <a:prstDash val="solid"/>
+          </a:ln>
+        </p:spPr>
+      </p:sp>
+      <p:pic>
+        <p:nvPicPr>
+          <p:cNvPr id="17" name="Image 3" descr="preencoded.png">    </p:cNvPr>
+          <p:cNvPicPr>
+            <a:picLocks noChangeAspect="1"/>
+          </p:cNvPicPr>
+          <p:nvPr/>
+        </p:nvPicPr>
+        <p:blipFill>
+          <a:blip r:embed="rId4"/>
+          <a:stretch>
+            <a:fillRect/>
+          </a:stretch>
+        </p:blipFill>
+        <p:spPr>
+          <a:xfrm>
+            <a:off x="796442" y="5048402"/>
+            <a:ext cx="281635" cy="281635"/>
+          </a:xfrm>
+          <a:prstGeom prst="rect">
+            <a:avLst/>
+          </a:prstGeom>
+        </p:spPr>
+      </p:pic>
+      <p:sp>
+        <p:nvSpPr>
+          <p:cNvPr id="18" name="Text 12"/>
+          <p:cNvSpPr txBox="1"/>
+          <p:nvPr/>
+        </p:nvSpPr>
+        <p:spPr>
+          <a:xfrm>
+            <a:off x="1417320" y="4754880"/>
+            <a:ext cx="7086600" cy="868680"/>
+          </a:xfrm>
+          <a:prstGeom prst="rect">
+            <a:avLst/>
+          </a:prstGeom>
+          <a:noFill/>
+          <a:ln/>
+        </p:spPr>
+        <p:txBody>
+          <a:bodyPr wrap="square" lIns="0" tIns="0" rIns="0" bIns="0" rtlCol="0" anchor="ctr"/>
+          <a:lstStyle/>
+          <a:p>
+            <a:pPr indent="0" marL="0">
+              <a:buNone/>
+            </a:pPr>
+            <a:r>
+              <a:rPr lang="en-US" sz="1600" b="1" dirty="0">
+                <a:solidFill>
+                  <a:srgbClr val="1B1F24"/>
+                </a:solidFill>
+              </a:rPr>
+              <a:t>Claude Desktop shows no notes-db tools</a:t>
+            </a:r>
+            <a:endParaRPr lang="en-US" sz="1600" dirty="0"/>
+          </a:p>
+          <a:p>
+            <a:pPr indent="0" marL="0">
+              <a:buNone/>
+            </a:pPr>
+            <a:r>
+              <a:rPr lang="en-US" sz="1400" dirty="0">
+                <a:solidFill>
+                  <a:srgbClr val="2B3440"/>
+                </a:solidFill>
+              </a:rPr>
+              <a:t>A relative path or a bare node in the entry. Use the script's absolute paths, then quit Claude Desktop fully and reopen.</a:t>
+            </a:r>
+            <a:endParaRPr lang="en-US" sz="1600" dirty="0"/>
+          </a:p>
+        </p:txBody>
+      </p:sp>
+      <p:sp>
+        <p:nvSpPr>
+          <p:cNvPr id="25" name="Slide Number Placeholder 0"/>
+          <p:cNvSpPr>
+            <a:spLocks noGrp="1"/>
+          </p:cNvSpPr>
+          <p:nvPr>
+            <p:ph type="sldNum" sz="quarter" idx="4294967295"/>
+          </p:nvPr>
+        </p:nvSpPr>
+        <p:spPr>
+          <a:xfrm>
+            <a:off x="8229600" y="4754880"/>
+            <a:ext cx="457200" cy="274320"/>
+          </a:xfrm>
+          <a:prstGeom prst="rect">
+            <a:avLst/>
+          </a:prstGeom>
+          <a:extLst>
+            <a:ext uri="{C572A759-6A51-4108-AA02-DFA0A04FC94B}">
+              <ma14:wrappingTextBoxFlag xmlns:ma14="http://schemas.microsoft.com/office/mac/drawingml/2011/main" val="0"/>
+            </a:ext>
+          </a:extLst>
+        </p:spPr>
+        <p:txBody>
+          <a:bodyPr/>
+          <a:lstStyle>
+            <a:lvl1pPr>
+              <a:defRPr sz="1000">
+                <a:solidFill>
+                  <a:srgbClr val="64748B"/>
+                </a:solidFill>
+              </a:defRPr>
+            </a:lvl1pPr>
+          </a:lstStyle>
+          <a:p>
+            <a:pPr algn="r"/>
+            <a:fld id="{F7021451-1387-4CA6-816F-3879F97B5CBC}" type="slidenum">
+              <a:rPr b="0" lang="en-US"/>
+              <a:t>21</a:t>
+            </a:fld>
+            <a:endParaRPr lang="en-US"/>
+          </a:p>
+        </p:txBody>
+      </p:sp>
+    </p:spTree>
+  </p:cSld>
+  <p:clrMapOvr>
+    <a:masterClrMapping/>
+  </p:clrMapOvr>
+</p:sld>
+</file>
+
+<file path=ppt/slides/slide22.xml><?xml version="1.0" encoding="utf-8"?>
+<p:sld xmlns:a="http://schemas.openxmlformats.org/drawingml/2006/main" xmlns:r="http://schemas.openxmlformats.org/officeDocument/2006/relationships" xmlns:p="http://schemas.openxmlformats.org/presentationml/2006/main">
+  <p:cSld name="Slide 22">
     <p:spTree>
       <p:nvGrpSpPr>
         <p:cNvPr id="1" name=""/>

</xml_diff>

<commit_message>
course: tests first, then the playground; no curl in the checks
Learners on Windows may not have curl. Module 1's check runs verify and lab 01, then starts
the app and opens /playground; module 2 runs lab 02 right after verify. Chapter 00 and the
starter README follow the same order.

Co-Authored-By: Claude Opus 5.5 (1M context) <noreply@anthropic.com>
</commit_message>
<xml_diff>
--- a/docs/ai-agent-training/slides/lab-companion.pptx
+++ b/docs/ai-agent-training/slides/lab-companion.pptx
@@ -875,7 +875,7 @@
           <a:p>
             <a:r>
               <a:rPr lang="en-US" dirty="0"/>
-              <a:t>The labs run on an empty in-memory database; this step proves the resources also serve the seeded rows. Then npm run db:seed puts the data back.</a:t>
+              <a:t>Tests first: verify and the lab check run on an empty in-memory database, so a green result there is the proof the code works. Only then start the app and open the playground: it sends every module 1 request to the running app with one click and shows each answer, proving the resources also serve the seeded rows. Nobody needs curl. The playground writes to data/app.db; npm run db:seed puts the data back.</a:t>
             </a:r>
             <a:endParaRPr lang="en-US" dirty="0"/>
           </a:p>
@@ -2019,7 +2019,7 @@
           <a:p>
             <a:r>
               <a:rPr lang="en-US" dirty="0"/>
-              <a:t>The audience is on Windows. Windows PowerShell 5.1 has no &amp;&amp; (PowerShell 7 does), so every command is on its own line; curl is curl.exe there (plain curl is Invoke-WebRequest). The base starts its tools with node and their JS entry, because the node_modules\.bin shims are .cmd files on Windows; measured on Linux, not yet on a Windows machine.</a:t>
+              <a:t>The audience is on Windows. Windows PowerShell 5.1 has no &amp;&amp; (PowerShell 7 does), so every command is on its own line. Nobody needs curl: the playground page sends the requests. The base starts its tools with node and their JS entry, because the node_modules\.bin shims are .cmd files on Windows; measured on Linux, not yet on a Windows machine.</a:t>
             </a:r>
             <a:endParaRPr lang="en-US" dirty="0"/>
           </a:p>
@@ -6001,13 +6001,13 @@
             <a:r>
               <a:rPr lang="en-US" sz="1200" dirty="0">
                 <a:solidFill>
-                  <a:srgbClr val="E6EDF3"/>
+                  <a:srgbClr val="8B98A5"/>
                 </a:solidFill>
                 <a:latin typeface="Courier New" pitchFamily="34" charset="0"/>
                 <a:ea typeface="Courier New" pitchFamily="34" charset="-122"/>
                 <a:cs typeface="Courier New" pitchFamily="34" charset="-120"/>
               </a:rPr>
-              <a:t>npm run verify       # read both Tests lines</a:t>
+              <a:t># 1. the tests first</a:t>
             </a:r>
             <a:endParaRPr lang="en-US" sz="1200" dirty="0"/>
           </a:p>
@@ -6024,7 +6024,7 @@
                 <a:ea typeface="Courier New" pitchFamily="34" charset="-122"/>
                 <a:cs typeface="Courier New" pitchFamily="34" charset="-120"/>
               </a:rPr>
-              <a:t>npm run build</a:t>
+              <a:t>npm run verify       # read both Tests lines</a:t>
             </a:r>
             <a:endParaRPr lang="en-US" sz="1200" dirty="0"/>
           </a:p>
@@ -6041,7 +6041,7 @@
                 <a:ea typeface="Courier New" pitchFamily="34" charset="-122"/>
                 <a:cs typeface="Courier New" pitchFamily="34" charset="-120"/>
               </a:rPr>
-              <a:t>npm run start</a:t>
+              <a:t>npm run lab 01       # the lab check: all green?</a:t>
             </a:r>
             <a:endParaRPr lang="en-US" sz="1200" dirty="0"/>
           </a:p>
@@ -6058,7 +6058,7 @@
                 <a:ea typeface="Courier New" pitchFamily="34" charset="-122"/>
                 <a:cs typeface="Courier New" pitchFamily="34" charset="-120"/>
               </a:rPr>
-              <a:t># second terminal: the seeded rows</a:t>
+              <a:t># 2. then the app on the seeded data</a:t>
             </a:r>
             <a:endParaRPr lang="en-US" sz="1200" dirty="0"/>
           </a:p>
@@ -6075,7 +6075,7 @@
                 <a:ea typeface="Courier New" pitchFamily="34" charset="-122"/>
                 <a:cs typeface="Courier New" pitchFamily="34" charset="-120"/>
               </a:rPr>
-              <a:t>curl.exe "localhost:3000/api/v1/notes?status=done"</a:t>
+              <a:t>npm run build</a:t>
             </a:r>
             <a:endParaRPr lang="en-US" sz="1200" dirty="0"/>
           </a:p>
@@ -6092,7 +6092,41 @@
                 <a:ea typeface="Courier New" pitchFamily="34" charset="-122"/>
                 <a:cs typeface="Courier New" pitchFamily="34" charset="-120"/>
               </a:rPr>
-              <a:t>npm run lab 01   # the lab check: all green?</a:t>
+              <a:t>npm start</a:t>
+            </a:r>
+            <a:endParaRPr lang="en-US" sz="1200" dirty="0"/>
+          </a:p>
+          <a:p>
+            <a:pPr indent="0" marL="0">
+              <a:buNone/>
+            </a:pPr>
+            <a:r>
+              <a:rPr lang="en-US" sz="1200" dirty="0">
+                <a:solidFill>
+                  <a:srgbClr val="8B98A5"/>
+                </a:solidFill>
+                <a:latin typeface="Courier New" pitchFamily="34" charset="0"/>
+                <a:ea typeface="Courier New" pitchFamily="34" charset="-122"/>
+                <a:cs typeface="Courier New" pitchFamily="34" charset="-120"/>
+              </a:rPr>
+              <a:t># 3. open localhost:3000/playground</a:t>
+            </a:r>
+            <a:endParaRPr lang="en-US" sz="1200" dirty="0"/>
+          </a:p>
+          <a:p>
+            <a:pPr indent="0" marL="0">
+              <a:buNone/>
+            </a:pPr>
+            <a:r>
+              <a:rPr lang="en-US" sz="1200" dirty="0">
+                <a:solidFill>
+                  <a:srgbClr val="8B98A5"/>
+                </a:solidFill>
+                <a:latin typeface="Courier New" pitchFamily="34" charset="0"/>
+                <a:ea typeface="Courier New" pitchFamily="34" charset="-122"/>
+                <a:cs typeface="Courier New" pitchFamily="34" charset="-120"/>
+              </a:rPr>
+              <a:t>#    and click Run all in order</a:t>
             </a:r>
             <a:endParaRPr lang="en-US" sz="1200" dirty="0"/>
           </a:p>
@@ -6672,7 +6706,7 @@
                 <a:ea typeface="Courier New" pitchFamily="34" charset="-122"/>
                 <a:cs typeface="Courier New" pitchFamily="34" charset="-120"/>
               </a:rPr>
-              <a:t># the app on the seeded file</a:t>
+              <a:t># /playground on the seeded file</a:t>
             </a:r>
             <a:endParaRPr lang="en-US" sz="1200" dirty="0"/>
           </a:p>
@@ -9788,7 +9822,7 @@
                 <a:ea typeface="Courier New" pitchFamily="34" charset="-122"/>
                 <a:cs typeface="Courier New" pitchFamily="34" charset="-120"/>
               </a:rPr>
-              <a:t>npm run build</a:t>
+              <a:t>npm run lab 02       # the lab check: all green?</a:t>
             </a:r>
             <a:endParaRPr lang="en-US" sz="1400" dirty="0"/>
           </a:p>
@@ -9805,7 +9839,7 @@
                 <a:ea typeface="Courier New" pitchFamily="34" charset="-122"/>
                 <a:cs typeface="Courier New" pitchFamily="34" charset="-120"/>
               </a:rPr>
-              <a:t>node scripts\claude-desktop-config.mjs</a:t>
+              <a:t>npm run build</a:t>
             </a:r>
             <a:endParaRPr lang="en-US" sz="1400" dirty="0"/>
           </a:p>
@@ -9816,13 +9850,13 @@
             <a:r>
               <a:rPr lang="en-US" sz="1400" dirty="0">
                 <a:solidFill>
-                  <a:srgbClr val="8B98A5"/>
+                  <a:srgbClr val="E6EDF3"/>
                 </a:solidFill>
                 <a:latin typeface="Courier New" pitchFamily="34" charset="0"/>
                 <a:ea typeface="Courier New" pitchFamily="34" charset="-122"/>
                 <a:cs typeface="Courier New" pitchFamily="34" charset="-120"/>
               </a:rPr>
-              <a:t># paste the entry into the config file it names,</a:t>
+              <a:t>node scripts\claude-desktop-config.mjs</a:t>
             </a:r>
             <a:endParaRPr lang="en-US" sz="1400" dirty="0"/>
           </a:p>
@@ -9839,7 +9873,7 @@
                 <a:ea typeface="Courier New" pitchFamily="34" charset="-122"/>
                 <a:cs typeface="Courier New" pitchFamily="34" charset="-120"/>
               </a:rPr>
-              <a:t># quit and reopen Claude Desktop, then ask:</a:t>
+              <a:t># paste the entry into the config file it names,</a:t>
             </a:r>
             <a:endParaRPr lang="en-US" sz="1400" dirty="0"/>
           </a:p>
@@ -9856,7 +9890,7 @@
                 <a:ea typeface="Courier New" pitchFamily="34" charset="-122"/>
                 <a:cs typeface="Courier New" pitchFamily="34" charset="-120"/>
               </a:rPr>
-              <a:t># "Which open notes are shared with more</a:t>
+              <a:t># quit and reopen Claude Desktop, then ask:</a:t>
             </a:r>
             <a:endParaRPr lang="en-US" sz="1400" dirty="0"/>
           </a:p>
@@ -9873,7 +9907,7 @@
                 <a:ea typeface="Courier New" pitchFamily="34" charset="-122"/>
                 <a:cs typeface="Courier New" pitchFamily="34" charset="-120"/>
               </a:rPr>
-              <a:t>#   than one person?"</a:t>
+              <a:t># "Which open notes are shared with more</a:t>
             </a:r>
             <a:endParaRPr lang="en-US" sz="1400" dirty="0"/>
           </a:p>
@@ -9890,7 +9924,7 @@
                 <a:ea typeface="Courier New" pitchFamily="34" charset="-122"/>
                 <a:cs typeface="Courier New" pitchFamily="34" charset="-120"/>
               </a:rPr>
-              <a:t># "Add a user Ada, ada@example.com, with</a:t>
+              <a:t>#   than one person?"</a:t>
             </a:r>
             <a:endParaRPr lang="en-US" sz="1400" dirty="0"/>
           </a:p>
@@ -9907,7 +9941,7 @@
                 <a:ea typeface="Courier New" pitchFamily="34" charset="-122"/>
                 <a:cs typeface="Courier New" pitchFamily="34" charset="-120"/>
               </a:rPr>
-              <a:t>#   a note due next Friday"</a:t>
+              <a:t># "Add a user Ada, ada@example.com, with</a:t>
             </a:r>
             <a:endParaRPr lang="en-US" sz="1400" dirty="0"/>
           </a:p>
@@ -9918,13 +9952,13 @@
             <a:r>
               <a:rPr lang="en-US" sz="1400" dirty="0">
                 <a:solidFill>
-                  <a:srgbClr val="E6EDF3"/>
+                  <a:srgbClr val="8B98A5"/>
                 </a:solidFill>
                 <a:latin typeface="Courier New" pitchFamily="34" charset="0"/>
                 <a:ea typeface="Courier New" pitchFamily="34" charset="-122"/>
                 <a:cs typeface="Courier New" pitchFamily="34" charset="-120"/>
               </a:rPr>
-              <a:t>npm run lab 02   # the lab check: all green?</a:t>
+              <a:t>#   a note due next Friday"</a:t>
             </a:r>
             <a:endParaRPr lang="en-US" sz="1400" dirty="0"/>
           </a:p>

</xml_diff>

<commit_message>
starter + deck: fixes from the module 1 dry run, and dry run 2
No .env now serves the seeded data in development; a taken port ends with one line
naming the fix. Dry run 2: verify 44/49, lab 01 15/15, Run all 19/19; its 1280x720
screenshots replace run 1's; slide 13/14 wording from what the learner sees.
</commit_message>
<xml_diff>
--- a/docs/ai-agent-training/slides/lab-companion.pptx
+++ b/docs/ai-agent-training/slides/lab-companion.pptx
@@ -964,7 +964,7 @@
           <a:p>
             <a:r>
               <a:rPr lang="en-US" dirty="0"/>
-              <a:t>Captured in a dry run of the previous slide, in Chromium at 1280x720: base plus the module 1 checkpoint, verify 43 unit / 49 e2e, lab 01 15/15, then Run all in order: 19 of 19 cards green in about 3 seconds, no page errors. With DevTools open the 409 and 422 requests show in red as failed loads; that is expected, they are the rule checks. If List users comes back empty, the app is on the in-memory database: .env is missing (copy .env.example, chapter 00). npm run db:seed puts the data back afterwards.</a:t>
+              <a:t>Captured in a dry run of the previous slide, in Chromium at 1280x720: base plus the module 1 checkpoint and no .env, verify 44 unit / 49 e2e, lab 01 15/15, then Run all in order: 19 of 19 cards green, no page errors, List users showing the 25 seeded users. With DevTools open the two 409 and three 422 requests show in red as failed loads; that is expected, they are the rule checks. If port 3000 is taken, npm start prints "successfully started" and THEN fails: the last line says the port is in use. Set PORT in .env and use that port in the URL. A missing .env does not matter: in development the app uses data/app.db by default. npm run db:seed puts the data back afterwards.</a:t>
             </a:r>
             <a:endParaRPr lang="en-US" dirty="0"/>
           </a:p>
@@ -6088,7 +6088,7 @@
               <a:buNone/>
             </a:pPr>
             <a:r>
-              <a:rPr lang="en-US" sz="1200" dirty="0">
+              <a:rPr lang="en-US" sz="1100" dirty="0">
                 <a:solidFill>
                   <a:srgbClr val="8B98A5"/>
                 </a:solidFill>
@@ -6098,14 +6098,14 @@
               </a:rPr>
               <a:t># 1. the tests first</a:t>
             </a:r>
-            <a:endParaRPr lang="en-US" sz="1200" dirty="0"/>
-          </a:p>
-          <a:p>
-            <a:pPr indent="0" marL="0">
-              <a:buNone/>
-            </a:pPr>
-            <a:r>
-              <a:rPr lang="en-US" sz="1200" dirty="0">
+            <a:endParaRPr lang="en-US" sz="1100" dirty="0"/>
+          </a:p>
+          <a:p>
+            <a:pPr indent="0" marL="0">
+              <a:buNone/>
+            </a:pPr>
+            <a:r>
+              <a:rPr lang="en-US" sz="1100" dirty="0">
                 <a:solidFill>
                   <a:srgbClr val="E6EDF3"/>
                 </a:solidFill>
@@ -6115,14 +6115,14 @@
               </a:rPr>
               <a:t>npm run verify       # read both Tests lines</a:t>
             </a:r>
-            <a:endParaRPr lang="en-US" sz="1200" dirty="0"/>
-          </a:p>
-          <a:p>
-            <a:pPr indent="0" marL="0">
-              <a:buNone/>
-            </a:pPr>
-            <a:r>
-              <a:rPr lang="en-US" sz="1200" dirty="0">
+            <a:endParaRPr lang="en-US" sz="1100" dirty="0"/>
+          </a:p>
+          <a:p>
+            <a:pPr indent="0" marL="0">
+              <a:buNone/>
+            </a:pPr>
+            <a:r>
+              <a:rPr lang="en-US" sz="1100" dirty="0">
                 <a:solidFill>
                   <a:srgbClr val="E6EDF3"/>
                 </a:solidFill>
@@ -6132,14 +6132,14 @@
               </a:rPr>
               <a:t>npm run lab 01       # the lab check: all green?</a:t>
             </a:r>
-            <a:endParaRPr lang="en-US" sz="1200" dirty="0"/>
-          </a:p>
-          <a:p>
-            <a:pPr indent="0" marL="0">
-              <a:buNone/>
-            </a:pPr>
-            <a:r>
-              <a:rPr lang="en-US" sz="1200" dirty="0">
+            <a:endParaRPr lang="en-US" sz="1100" dirty="0"/>
+          </a:p>
+          <a:p>
+            <a:pPr indent="0" marL="0">
+              <a:buNone/>
+            </a:pPr>
+            <a:r>
+              <a:rPr lang="en-US" sz="1100" dirty="0">
                 <a:solidFill>
                   <a:srgbClr val="8B98A5"/>
                 </a:solidFill>
@@ -6149,14 +6149,14 @@
               </a:rPr>
               <a:t># 2. then the app on the seeded data</a:t>
             </a:r>
-            <a:endParaRPr lang="en-US" sz="1200" dirty="0"/>
-          </a:p>
-          <a:p>
-            <a:pPr indent="0" marL="0">
-              <a:buNone/>
-            </a:pPr>
-            <a:r>
-              <a:rPr lang="en-US" sz="1200" dirty="0">
+            <a:endParaRPr lang="en-US" sz="1100" dirty="0"/>
+          </a:p>
+          <a:p>
+            <a:pPr indent="0" marL="0">
+              <a:buNone/>
+            </a:pPr>
+            <a:r>
+              <a:rPr lang="en-US" sz="1100" dirty="0">
                 <a:solidFill>
                   <a:srgbClr val="8B98A5"/>
                 </a:solidFill>
@@ -6164,16 +6164,16 @@
                 <a:ea typeface="Courier New" pitchFamily="34" charset="-122"/>
                 <a:cs typeface="Courier New" pitchFamily="34" charset="-120"/>
               </a:rPr>
-              <a:t>#    (.env from setup; port busy? PORT=)</a:t>
-            </a:r>
-            <a:endParaRPr lang="en-US" sz="1200" dirty="0"/>
-          </a:p>
-          <a:p>
-            <a:pPr indent="0" marL="0">
-              <a:buNone/>
-            </a:pPr>
-            <a:r>
-              <a:rPr lang="en-US" sz="1200" dirty="0">
+              <a:t>#    (port taken? the last line says so: PORT= in .env)</a:t>
+            </a:r>
+            <a:endParaRPr lang="en-US" sz="1100" dirty="0"/>
+          </a:p>
+          <a:p>
+            <a:pPr indent="0" marL="0">
+              <a:buNone/>
+            </a:pPr>
+            <a:r>
+              <a:rPr lang="en-US" sz="1100" dirty="0">
                 <a:solidFill>
                   <a:srgbClr val="E6EDF3"/>
                 </a:solidFill>
@@ -6183,14 +6183,14 @@
               </a:rPr>
               <a:t>npm run build</a:t>
             </a:r>
-            <a:endParaRPr lang="en-US" sz="1200" dirty="0"/>
-          </a:p>
-          <a:p>
-            <a:pPr indent="0" marL="0">
-              <a:buNone/>
-            </a:pPr>
-            <a:r>
-              <a:rPr lang="en-US" sz="1200" dirty="0">
+            <a:endParaRPr lang="en-US" sz="1100" dirty="0"/>
+          </a:p>
+          <a:p>
+            <a:pPr indent="0" marL="0">
+              <a:buNone/>
+            </a:pPr>
+            <a:r>
+              <a:rPr lang="en-US" sz="1100" dirty="0">
                 <a:solidFill>
                   <a:srgbClr val="E6EDF3"/>
                 </a:solidFill>
@@ -6200,14 +6200,14 @@
               </a:rPr>
               <a:t>npm start</a:t>
             </a:r>
-            <a:endParaRPr lang="en-US" sz="1200" dirty="0"/>
-          </a:p>
-          <a:p>
-            <a:pPr indent="0" marL="0">
-              <a:buNone/>
-            </a:pPr>
-            <a:r>
-              <a:rPr lang="en-US" sz="1200" dirty="0">
+            <a:endParaRPr lang="en-US" sz="1100" dirty="0"/>
+          </a:p>
+          <a:p>
+            <a:pPr indent="0" marL="0">
+              <a:buNone/>
+            </a:pPr>
+            <a:r>
+              <a:rPr lang="en-US" sz="1100" dirty="0">
                 <a:solidFill>
                   <a:srgbClr val="8B98A5"/>
                 </a:solidFill>
@@ -6215,16 +6215,16 @@
                 <a:ea typeface="Courier New" pitchFamily="34" charset="-122"/>
                 <a:cs typeface="Courier New" pitchFamily="34" charset="-120"/>
               </a:rPr>
-              <a:t># 3. open localhost:3000/playground</a:t>
-            </a:r>
-            <a:endParaRPr lang="en-US" sz="1200" dirty="0"/>
-          </a:p>
-          <a:p>
-            <a:pPr indent="0" marL="0">
-              <a:buNone/>
-            </a:pPr>
-            <a:r>
-              <a:rPr lang="en-US" sz="1200" dirty="0">
+              <a:t># 3. open localhost:3000/playground (or your PORT)</a:t>
+            </a:r>
+            <a:endParaRPr lang="en-US" sz="1100" dirty="0"/>
+          </a:p>
+          <a:p>
+            <a:pPr indent="0" marL="0">
+              <a:buNone/>
+            </a:pPr>
+            <a:r>
+              <a:rPr lang="en-US" sz="1100" dirty="0">
                 <a:solidFill>
                   <a:srgbClr val="8B98A5"/>
                 </a:solidFill>
@@ -6234,7 +6234,7 @@
               </a:rPr>
               <a:t>#    and click Run all in order</a:t>
             </a:r>
-            <a:endParaRPr lang="en-US" sz="1200" dirty="0"/>
+            <a:endParaRPr lang="en-US" sz="1100" dirty="0"/>
           </a:p>
         </p:txBody>
       </p:sp>
@@ -6731,7 +6731,7 @@
                   <a:srgbClr val="2B3440"/>
                 </a:solidFill>
               </a:rPr>
-              <a:t>Every card has a ✓: 19 of 19 in our dry run</a:t>
+              <a:t>19 of 19 cards ✓ in our dry run</a:t>
             </a:r>
             <a:endParaRPr lang="en-US" sz="1200" dirty="0"/>
           </a:p>
@@ -6745,7 +6745,7 @@
         </p:nvSpPr>
         <p:spPr>
           <a:xfrm>
-            <a:off x="6827520" y="2350008"/>
+            <a:off x="6827520" y="2176272"/>
             <a:ext cx="274320" cy="274320"/>
           </a:xfrm>
           <a:prstGeom prst="ellipse">
@@ -6778,7 +6778,7 @@
         </p:blipFill>
         <p:spPr>
           <a:xfrm>
-            <a:off x="6887870" y="2410358"/>
+            <a:off x="6887870" y="2236622"/>
             <a:ext cx="153619" cy="153619"/>
           </a:xfrm>
           <a:prstGeom prst="rect">
@@ -6794,7 +6794,7 @@
         </p:nvSpPr>
         <p:spPr>
           <a:xfrm>
-            <a:off x="7193280" y="2286000"/>
+            <a:off x="7193280" y="2112264"/>
             <a:ext cx="1493520" cy="685800"/>
           </a:xfrm>
           <a:prstGeom prst="rect">
@@ -6816,7 +6816,7 @@
                   <a:srgbClr val="2B3440"/>
                 </a:solidFill>
               </a:rPr>
-              <a:t>Variables filled: each id is carried to the next request</a:t>
+              <a:t>Variables filled: the ids carry over</a:t>
             </a:r>
             <a:endParaRPr lang="en-US" sz="1200" dirty="0"/>
           </a:p>
@@ -6830,7 +6830,7 @@
         </p:nvSpPr>
         <p:spPr>
           <a:xfrm>
-            <a:off x="6827520" y="3127248"/>
+            <a:off x="6827520" y="2779776"/>
             <a:ext cx="274320" cy="274320"/>
           </a:xfrm>
           <a:prstGeom prst="ellipse">
@@ -6863,7 +6863,7 @@
         </p:blipFill>
         <p:spPr>
           <a:xfrm>
-            <a:off x="6887870" y="3187598"/>
+            <a:off x="6887870" y="2840126"/>
             <a:ext cx="153619" cy="153619"/>
           </a:xfrm>
           <a:prstGeom prst="rect">
@@ -6879,7 +6879,7 @@
         </p:nvSpPr>
         <p:spPr>
           <a:xfrm>
-            <a:off x="7193280" y="3063240"/>
+            <a:off x="7193280" y="2715768"/>
             <a:ext cx="1493520" cy="685800"/>
           </a:xfrm>
           <a:prstGeom prst="rect">
@@ -6901,7 +6901,7 @@
                   <a:srgbClr val="2B3440"/>
                 </a:solidFill>
               </a:rPr>
-              <a:t>The 409 and 422 cards get a ✓ too: the rule refused, as the spec says</a:t>
+              <a:t>409 and 422 cards ✓ too: the rule said no</a:t>
             </a:r>
             <a:endParaRPr lang="en-US" sz="1200" dirty="0"/>
           </a:p>
@@ -6915,7 +6915,7 @@
         </p:nvSpPr>
         <p:spPr>
           <a:xfrm>
-            <a:off x="6827520" y="3904488"/>
+            <a:off x="6827520" y="3383280"/>
             <a:ext cx="274320" cy="274320"/>
           </a:xfrm>
           <a:prstGeom prst="ellipse">
@@ -6948,7 +6948,7 @@
         </p:blipFill>
         <p:spPr>
           <a:xfrm>
-            <a:off x="6887870" y="3964838"/>
+            <a:off x="6887870" y="3443630"/>
             <a:ext cx="153619" cy="153619"/>
           </a:xfrm>
           <a:prstGeom prst="rect">
@@ -6964,7 +6964,7 @@
         </p:nvSpPr>
         <p:spPr>
           <a:xfrm>
-            <a:off x="7193280" y="3840480"/>
+            <a:off x="7193280" y="3319272"/>
             <a:ext cx="1493520" cy="685800"/>
           </a:xfrm>
           <a:prstGeom prst="rect">
@@ -6986,7 +6986,92 @@
                   <a:srgbClr val="2B3440"/>
                 </a:solidFill>
               </a:rPr>
-              <a:t>List users shows the seeded rows from data/app.db</a:t>
+              <a:t>Red in DevTools for those: expected</a:t>
+            </a:r>
+            <a:endParaRPr lang="en-US" sz="1200" dirty="0"/>
+          </a:p>
+        </p:txBody>
+      </p:sp>
+      <p:sp>
+        <p:nvSpPr>
+          <p:cNvPr id="18" name="Shape 11"/>
+          <p:cNvSpPr/>
+          <p:nvPr/>
+        </p:nvSpPr>
+        <p:spPr>
+          <a:xfrm>
+            <a:off x="6827520" y="3986784"/>
+            <a:ext cx="274320" cy="274320"/>
+          </a:xfrm>
+          <a:prstGeom prst="ellipse">
+            <a:avLst/>
+          </a:prstGeom>
+          <a:solidFill>
+            <a:srgbClr val="1FB68A"/>
+          </a:solidFill>
+          <a:ln w="12700">
+            <a:solidFill>
+              <a:srgbClr val="1FB68A"/>
+            </a:solidFill>
+            <a:prstDash val="solid"/>
+          </a:ln>
+        </p:spPr>
+      </p:sp>
+      <p:pic>
+        <p:nvPicPr>
+          <p:cNvPr id="19" name="Image 5" descr="preencoded.png">    </p:cNvPr>
+          <p:cNvPicPr>
+            <a:picLocks noChangeAspect="1"/>
+          </p:cNvPicPr>
+          <p:nvPr/>
+        </p:nvPicPr>
+        <p:blipFill>
+          <a:blip r:embed="rId6"/>
+          <a:stretch>
+            <a:fillRect/>
+          </a:stretch>
+        </p:blipFill>
+        <p:spPr>
+          <a:xfrm>
+            <a:off x="6887870" y="4047134"/>
+            <a:ext cx="153619" cy="153619"/>
+          </a:xfrm>
+          <a:prstGeom prst="rect">
+            <a:avLst/>
+          </a:prstGeom>
+        </p:spPr>
+      </p:pic>
+      <p:sp>
+        <p:nvSpPr>
+          <p:cNvPr id="20" name="Text 12"/>
+          <p:cNvSpPr txBox="1"/>
+          <p:nvPr/>
+        </p:nvSpPr>
+        <p:spPr>
+          <a:xfrm>
+            <a:off x="7193280" y="3922776"/>
+            <a:ext cx="1493520" cy="685800"/>
+          </a:xfrm>
+          <a:prstGeom prst="rect">
+            <a:avLst/>
+          </a:prstGeom>
+          <a:noFill/>
+          <a:ln/>
+        </p:spPr>
+        <p:txBody>
+          <a:bodyPr wrap="square" lIns="0" tIns="0" rIns="0" bIns="0" rtlCol="0" anchor="t"/>
+          <a:lstStyle/>
+          <a:p>
+            <a:pPr indent="0" marL="0">
+              <a:buNone/>
+            </a:pPr>
+            <a:r>
+              <a:rPr lang="en-US" sz="1200" dirty="0">
+                <a:solidFill>
+                  <a:srgbClr val="2B3440"/>
+                </a:solidFill>
+              </a:rPr>
+              <a:t>List users shows the 25 seeded users</a:t>
             </a:r>
             <a:endParaRPr lang="en-US" sz="1200" dirty="0"/>
           </a:p>

</xml_diff>

<commit_message>
course: a guided run - the agent stops after each instruction
CLAUDE.md tells the agent to finish the current instruction (WORKLOG entry included),
report and stop; later specs and red later labs are not work until named. Every
instruction slide ends 'Then stop and wait for my next instruction', and both checkpoints
check that the agent stopped. Tested with fresh agents on Instructions 1 and 2.

Co-Authored-By: Claude Opus 5.5 (1M context) <noreply@anthropic.com>
</commit_message>
<xml_diff>
--- a/docs/ai-agent-training/slides/lab-companion.pptx
+++ b/docs/ai-agent-training/slides/lab-companion.pptx
@@ -4422,7 +4422,7 @@
                 <a:ea typeface="Courier New" pitchFamily="34" charset="-122"/>
                 <a:cs typeface="Courier New" pitchFamily="34" charset="-120"/>
               </a:rPr>
-              <a:t>database.</a:t>
+              <a:t>database. Then stop and wait for my next instruction.</a:t>
             </a:r>
             <a:endParaRPr lang="en-US" sz="1100" dirty="0"/>
           </a:p>
@@ -5175,7 +5175,24 @@
                 <a:ea typeface="Courier New" pitchFamily="34" charset="-122"/>
                 <a:cs typeface="Courier New" pitchFamily="34" charset="-120"/>
               </a:rPr>
-              <a:t>specs/users.md. Done when npm run verify is green.</a:t>
+              <a:t>specs/users.md. Done when npm run verify is green. Then</a:t>
+            </a:r>
+            <a:endParaRPr lang="en-US" sz="1100" dirty="0"/>
+          </a:p>
+          <a:p>
+            <a:pPr indent="0" marL="0">
+              <a:buNone/>
+            </a:pPr>
+            <a:r>
+              <a:rPr lang="en-US" sz="1100" dirty="0">
+                <a:solidFill>
+                  <a:srgbClr val="E6EDF3"/>
+                </a:solidFill>
+                <a:latin typeface="Courier New" pitchFamily="34" charset="0"/>
+                <a:ea typeface="Courier New" pitchFamily="34" charset="-122"/>
+                <a:cs typeface="Courier New" pitchFamily="34" charset="-120"/>
+              </a:rPr>
+              <a:t>stop and wait for my next instruction.</a:t>
             </a:r>
             <a:endParaRPr lang="en-US" sz="1100" dirty="0"/>
           </a:p>
@@ -5928,7 +5945,24 @@
                 <a:ea typeface="Courier New" pitchFamily="34" charset="-122"/>
                 <a:cs typeface="Courier New" pitchFamily="34" charset="-120"/>
               </a:rPr>
-              <a:t>when npm run lab 01 and npm run verify are green.</a:t>
+              <a:t>when npm run lab 01 and npm run verify are green. Then</a:t>
+            </a:r>
+            <a:endParaRPr lang="en-US" sz="1000" dirty="0"/>
+          </a:p>
+          <a:p>
+            <a:pPr indent="0" marL="0">
+              <a:buNone/>
+            </a:pPr>
+            <a:r>
+              <a:rPr lang="en-US" sz="1000" dirty="0">
+                <a:solidFill>
+                  <a:srgbClr val="E6EDF3"/>
+                </a:solidFill>
+                <a:latin typeface="Courier New" pitchFamily="34" charset="0"/>
+                <a:ea typeface="Courier New" pitchFamily="34" charset="-122"/>
+                <a:cs typeface="Courier New" pitchFamily="34" charset="-120"/>
+              </a:rPr>
+              <a:t>stop and wait for my next instruction.</a:t>
             </a:r>
             <a:endParaRPr lang="en-US" sz="1000" dirty="0"/>
           </a:p>
@@ -8126,7 +8160,7 @@
         </p:nvSpPr>
         <p:spPr>
           <a:xfrm>
-            <a:off x="5852160" y="2606040"/>
+            <a:off x="5852160" y="2377440"/>
             <a:ext cx="384048" cy="384048"/>
           </a:xfrm>
           <a:prstGeom prst="ellipse">
@@ -8159,7 +8193,7 @@
         </p:blipFill>
         <p:spPr>
           <a:xfrm>
-            <a:off x="5936651" y="2690531"/>
+            <a:off x="5936651" y="2461931"/>
             <a:ext cx="215067" cy="215067"/>
           </a:xfrm>
           <a:prstGeom prst="rect">
@@ -8175,7 +8209,7 @@
         </p:nvSpPr>
         <p:spPr>
           <a:xfrm>
-            <a:off x="6355080" y="2569464"/>
+            <a:off x="6355080" y="2340864"/>
             <a:ext cx="2331720" cy="868680"/>
           </a:xfrm>
           <a:prstGeom prst="rect">
@@ -8211,7 +8245,7 @@
         </p:nvSpPr>
         <p:spPr>
           <a:xfrm>
-            <a:off x="5852160" y="3566160"/>
+            <a:off x="5852160" y="3108960"/>
             <a:ext cx="384048" cy="384048"/>
           </a:xfrm>
           <a:prstGeom prst="ellipse">
@@ -8244,7 +8278,7 @@
         </p:blipFill>
         <p:spPr>
           <a:xfrm>
-            <a:off x="5936651" y="3650651"/>
+            <a:off x="5936651" y="3193451"/>
             <a:ext cx="215067" cy="215067"/>
           </a:xfrm>
           <a:prstGeom prst="rect">
@@ -8260,7 +8294,7 @@
         </p:nvSpPr>
         <p:spPr>
           <a:xfrm>
-            <a:off x="6355080" y="3529584"/>
+            <a:off x="6355080" y="3072384"/>
             <a:ext cx="2331720" cy="868680"/>
           </a:xfrm>
           <a:prstGeom prst="rect">
@@ -8283,6 +8317,91 @@
                 </a:solidFill>
               </a:rPr>
               <a:t>the app lists the seeded rows</a:t>
+            </a:r>
+            <a:endParaRPr lang="en-US" sz="1400" dirty="0"/>
+          </a:p>
+        </p:txBody>
+      </p:sp>
+      <p:sp>
+        <p:nvSpPr>
+          <p:cNvPr id="19" name="Shape 14"/>
+          <p:cNvSpPr/>
+          <p:nvPr/>
+        </p:nvSpPr>
+        <p:spPr>
+          <a:xfrm>
+            <a:off x="5852160" y="3840480"/>
+            <a:ext cx="384048" cy="384048"/>
+          </a:xfrm>
+          <a:prstGeom prst="ellipse">
+            <a:avLst/>
+          </a:prstGeom>
+          <a:solidFill>
+            <a:srgbClr val="1FB68A"/>
+          </a:solidFill>
+          <a:ln w="12700">
+            <a:solidFill>
+              <a:srgbClr val="1FB68A"/>
+            </a:solidFill>
+            <a:prstDash val="solid"/>
+          </a:ln>
+        </p:spPr>
+      </p:sp>
+      <p:pic>
+        <p:nvPicPr>
+          <p:cNvPr id="20" name="Image 3" descr="preencoded.png">    </p:cNvPr>
+          <p:cNvPicPr>
+            <a:picLocks noChangeAspect="1"/>
+          </p:cNvPicPr>
+          <p:nvPr/>
+        </p:nvPicPr>
+        <p:blipFill>
+          <a:blip r:embed="rId4"/>
+          <a:stretch>
+            <a:fillRect/>
+          </a:stretch>
+        </p:blipFill>
+        <p:spPr>
+          <a:xfrm>
+            <a:off x="5936651" y="3924971"/>
+            <a:ext cx="215067" cy="215067"/>
+          </a:xfrm>
+          <a:prstGeom prst="rect">
+            <a:avLst/>
+          </a:prstGeom>
+        </p:spPr>
+      </p:pic>
+      <p:sp>
+        <p:nvSpPr>
+          <p:cNvPr id="21" name="Text 15"/>
+          <p:cNvSpPr txBox="1"/>
+          <p:nvPr/>
+        </p:nvSpPr>
+        <p:spPr>
+          <a:xfrm>
+            <a:off x="6355080" y="3803904"/>
+            <a:ext cx="2331720" cy="868680"/>
+          </a:xfrm>
+          <a:prstGeom prst="rect">
+            <a:avLst/>
+          </a:prstGeom>
+          <a:noFill/>
+          <a:ln/>
+        </p:spPr>
+        <p:txBody>
+          <a:bodyPr wrap="square" lIns="0" tIns="0" rIns="0" bIns="0" rtlCol="0" anchor="t"/>
+          <a:lstStyle/>
+          <a:p>
+            <a:pPr indent="0" marL="0">
+              <a:buNone/>
+            </a:pPr>
+            <a:r>
+              <a:rPr lang="en-US" sz="1400" dirty="0">
+                <a:solidFill>
+                  <a:srgbClr val="1B1F24"/>
+                </a:solidFill>
+              </a:rPr>
+              <a:t>your agent stopped: no MCP server yet, lab 02 still red</a:t>
             </a:r>
             <a:endParaRPr lang="en-US" sz="1400" dirty="0"/>
           </a:p>
@@ -10526,7 +10645,7 @@
                   <a:srgbClr val="2B3440"/>
                 </a:solidFill>
               </a:rPr>
-              <a:t>works out how from the repo, then builds it</a:t>
+              <a:t>works out how from the repo, builds it, then stops</a:t>
             </a:r>
             <a:endParaRPr lang="en-US" sz="1400" dirty="0"/>
           </a:p>
@@ -11280,7 +11399,24 @@
                 <a:ea typeface="Courier New" pitchFamily="34" charset="-122"/>
                 <a:cs typeface="Courier New" pitchFamily="34" charset="-120"/>
               </a:rPr>
-              <a:t>I could ask it to make.</a:t>
+              <a:t>I could ask it to make. Then stop and wait for my next</a:t>
+            </a:r>
+            <a:endParaRPr lang="en-US" sz="1000" dirty="0"/>
+          </a:p>
+          <a:p>
+            <a:pPr indent="0" marL="0">
+              <a:buNone/>
+            </a:pPr>
+            <a:r>
+              <a:rPr lang="en-US" sz="1000" dirty="0">
+                <a:solidFill>
+                  <a:srgbClr val="E6EDF3"/>
+                </a:solidFill>
+                <a:latin typeface="Courier New" pitchFamily="34" charset="0"/>
+                <a:ea typeface="Courier New" pitchFamily="34" charset="-122"/>
+                <a:cs typeface="Courier New" pitchFamily="34" charset="-120"/>
+              </a:rPr>
+              <a:t>instruction.</a:t>
             </a:r>
             <a:endParaRPr lang="en-US" sz="1000" dirty="0"/>
           </a:p>
@@ -12656,7 +12792,7 @@
         </p:nvSpPr>
         <p:spPr>
           <a:xfrm>
-            <a:off x="5852160" y="2606040"/>
+            <a:off x="5852160" y="2377440"/>
             <a:ext cx="384048" cy="384048"/>
           </a:xfrm>
           <a:prstGeom prst="ellipse">
@@ -12689,7 +12825,7 @@
         </p:blipFill>
         <p:spPr>
           <a:xfrm>
-            <a:off x="5936651" y="2690531"/>
+            <a:off x="5936651" y="2461931"/>
             <a:ext cx="215067" cy="215067"/>
           </a:xfrm>
           <a:prstGeom prst="rect">
@@ -12705,7 +12841,7 @@
         </p:nvSpPr>
         <p:spPr>
           <a:xfrm>
-            <a:off x="6355080" y="2569464"/>
+            <a:off x="6355080" y="2340864"/>
             <a:ext cx="2331720" cy="868680"/>
           </a:xfrm>
           <a:prstGeom prst="rect">
@@ -12741,7 +12877,7 @@
         </p:nvSpPr>
         <p:spPr>
           <a:xfrm>
-            <a:off x="5852160" y="3566160"/>
+            <a:off x="5852160" y="3108960"/>
             <a:ext cx="384048" cy="384048"/>
           </a:xfrm>
           <a:prstGeom prst="ellipse">
@@ -12774,7 +12910,7 @@
         </p:blipFill>
         <p:spPr>
           <a:xfrm>
-            <a:off x="5936651" y="3650651"/>
+            <a:off x="5936651" y="3193451"/>
             <a:ext cx="215067" cy="215067"/>
           </a:xfrm>
           <a:prstGeom prst="rect">
@@ -12790,7 +12926,7 @@
         </p:nvSpPr>
         <p:spPr>
           <a:xfrm>
-            <a:off x="6355080" y="3529584"/>
+            <a:off x="6355080" y="3072384"/>
             <a:ext cx="2331720" cy="868680"/>
           </a:xfrm>
           <a:prstGeom prst="rect">
@@ -12813,6 +12949,91 @@
                 </a:solidFill>
               </a:rPr>
               <a:t>Claude Desktop answers a question and makes a change</a:t>
+            </a:r>
+            <a:endParaRPr lang="en-US" sz="1400" dirty="0"/>
+          </a:p>
+        </p:txBody>
+      </p:sp>
+      <p:sp>
+        <p:nvSpPr>
+          <p:cNvPr id="19" name="Shape 14"/>
+          <p:cNvSpPr/>
+          <p:nvPr/>
+        </p:nvSpPr>
+        <p:spPr>
+          <a:xfrm>
+            <a:off x="5852160" y="3840480"/>
+            <a:ext cx="384048" cy="384048"/>
+          </a:xfrm>
+          <a:prstGeom prst="ellipse">
+            <a:avLst/>
+          </a:prstGeom>
+          <a:solidFill>
+            <a:srgbClr val="1FB68A"/>
+          </a:solidFill>
+          <a:ln w="12700">
+            <a:solidFill>
+              <a:srgbClr val="1FB68A"/>
+            </a:solidFill>
+            <a:prstDash val="solid"/>
+          </a:ln>
+        </p:spPr>
+      </p:sp>
+      <p:pic>
+        <p:nvPicPr>
+          <p:cNvPr id="20" name="Image 3" descr="preencoded.png">    </p:cNvPr>
+          <p:cNvPicPr>
+            <a:picLocks noChangeAspect="1"/>
+          </p:cNvPicPr>
+          <p:nvPr/>
+        </p:nvPicPr>
+        <p:blipFill>
+          <a:blip r:embed="rId4"/>
+          <a:stretch>
+            <a:fillRect/>
+          </a:stretch>
+        </p:blipFill>
+        <p:spPr>
+          <a:xfrm>
+            <a:off x="5936651" y="3924971"/>
+            <a:ext cx="215067" cy="215067"/>
+          </a:xfrm>
+          <a:prstGeom prst="rect">
+            <a:avLst/>
+          </a:prstGeom>
+        </p:spPr>
+      </p:pic>
+      <p:sp>
+        <p:nvSpPr>
+          <p:cNvPr id="21" name="Text 15"/>
+          <p:cNvSpPr txBox="1"/>
+          <p:nvPr/>
+        </p:nvSpPr>
+        <p:spPr>
+          <a:xfrm>
+            <a:off x="6355080" y="3803904"/>
+            <a:ext cx="2331720" cy="868680"/>
+          </a:xfrm>
+          <a:prstGeom prst="rect">
+            <a:avLst/>
+          </a:prstGeom>
+          <a:noFill/>
+          <a:ln/>
+        </p:spPr>
+        <p:txBody>
+          <a:bodyPr wrap="square" lIns="0" tIns="0" rIns="0" bIns="0" rtlCol="0" anchor="t"/>
+          <a:lstStyle/>
+          <a:p>
+            <a:pPr indent="0" marL="0">
+              <a:buNone/>
+            </a:pPr>
+            <a:r>
+              <a:rPr lang="en-US" sz="1400" dirty="0">
+                <a:solidFill>
+                  <a:srgbClr val="1B1F24"/>
+                </a:solidFill>
+              </a:rPr>
+              <a:t>your agent stopped and is waiting</a:t>
             </a:r>
             <a:endParaRPr lang="en-US" sz="1400" dirty="0"/>
           </a:p>

</xml_diff>

<commit_message>
course: the instructions as files in steps/, referenced from the slides
Each instruction is boilerplate/nest-ai-starter/steps/NN-*.md; learners can tell their
agent 'Read steps/01-set-up.md and do what it says'. The deck reads the text from those
files and shows the path; the build fails if a step lacks its instruction or the stop.
CLAUDE.md: do only the step file you are pointed at. Tested: an agent given steps/03 built
notes and stopped before the MCP server. Also: the zod trap is .overwrite(), not
.transform() (measured on 4.6.7).

Co-Authored-By: Claude Opus 5.5 (1M context) <noreply@anthropic.com>
</commit_message>
<xml_diff>
--- a/docs/ai-agent-training/slides/lab-companion.pptx
+++ b/docs/ai-agent-training/slides/lab-companion.pptx
@@ -877,7 +877,7 @@
           <a:p>
             <a:r>
               <a:rPr lang="en-US" dirty="0"/>
-              <a:t>Measured: a fresh agent got lab 01 15/15 and verify 43 unit / 46 e2e. Its first dueAt answered 500 for "next tuesday" (zod 4 runs a transform after a failed format check); it found and fixed it. The filters and share routes go outside the markers, on purpose.</a:t>
+              <a:t>Measured: a fresh agent got lab 01 15/15 and verify 43 unit / 46 e2e. Its first dueAt answered 500 for "next tuesday" (it converted with .overwrite(), a zod 4 check that still runs after the format check failed); it found and fixed it. The filters and share routes go outside the markers, on purpose.</a:t>
             </a:r>
             <a:endParaRPr lang="en-US" dirty="0"/>
           </a:p>
@@ -4349,7 +4349,7 @@
                 <a:ea typeface="Calibri" pitchFamily="34" charset="-122"/>
                 <a:cs typeface="Calibri" pitchFamily="34" charset="-120"/>
               </a:rPr>
-              <a:t>instruction · give it to your agent</a:t>
+              <a:t>steps/01-set-up.md · give it to your agent</a:t>
             </a:r>
             <a:endParaRPr lang="en-US" sz="1000" dirty="0"/>
           </a:p>
@@ -4375,6 +4375,57 @@
         <p:txBody>
           <a:bodyPr wrap="square" lIns="0" tIns="0" rIns="0" bIns="0" rtlCol="0" anchor="t"/>
           <a:lstStyle/>
+          <a:p>
+            <a:pPr indent="0" marL="0">
+              <a:buNone/>
+            </a:pPr>
+            <a:r>
+              <a:rPr lang="en-US" sz="1100" dirty="0">
+                <a:solidFill>
+                  <a:srgbClr val="E6EDF3"/>
+                </a:solidFill>
+                <a:latin typeface="Courier New" pitchFamily="34" charset="0"/>
+                <a:ea typeface="Courier New" pitchFamily="34" charset="-122"/>
+                <a:cs typeface="Courier New" pitchFamily="34" charset="-120"/>
+              </a:rPr>
+              <a:t>&gt; Read steps/01-set-up.md and do what it says.</a:t>
+            </a:r>
+            <a:endParaRPr lang="en-US" sz="1100" dirty="0"/>
+          </a:p>
+          <a:p>
+            <a:pPr indent="0" marL="0">
+              <a:buNone/>
+            </a:pPr>
+            <a:r>
+              <a:rPr lang="en-US" sz="1100" dirty="0">
+                <a:solidFill>
+                  <a:srgbClr val="E6EDF3"/>
+                </a:solidFill>
+                <a:latin typeface="Courier New" pitchFamily="34" charset="0"/>
+                <a:ea typeface="Courier New" pitchFamily="34" charset="-122"/>
+                <a:cs typeface="Courier New" pitchFamily="34" charset="-120"/>
+              </a:rPr>
+              <a:t> </a:t>
+            </a:r>
+            <a:endParaRPr lang="en-US" sz="1100" dirty="0"/>
+          </a:p>
+          <a:p>
+            <a:pPr indent="0" marL="0">
+              <a:buNone/>
+            </a:pPr>
+            <a:r>
+              <a:rPr lang="en-US" sz="1100" dirty="0">
+                <a:solidFill>
+                  <a:srgbClr val="8B98A5"/>
+                </a:solidFill>
+                <a:latin typeface="Courier New" pitchFamily="34" charset="0"/>
+                <a:ea typeface="Courier New" pitchFamily="34" charset="-122"/>
+                <a:cs typeface="Courier New" pitchFamily="34" charset="-120"/>
+              </a:rPr>
+              <a:t># steps/01-set-up.md says:</a:t>
+            </a:r>
+            <a:endParaRPr lang="en-US" sz="1100" dirty="0"/>
+          </a:p>
           <a:p>
             <a:pPr indent="0" marL="0">
               <a:buNone/>
@@ -5119,7 +5170,7 @@
                 <a:ea typeface="Calibri" pitchFamily="34" charset="-122"/>
                 <a:cs typeface="Calibri" pitchFamily="34" charset="-120"/>
               </a:rPr>
-              <a:t>instruction · give it to your agent</a:t>
+              <a:t>steps/02-users.md · give it to your agent</a:t>
             </a:r>
             <a:endParaRPr lang="en-US" sz="1000" dirty="0"/>
           </a:p>
@@ -5145,6 +5196,57 @@
         <p:txBody>
           <a:bodyPr wrap="square" lIns="0" tIns="0" rIns="0" bIns="0" rtlCol="0" anchor="t"/>
           <a:lstStyle/>
+          <a:p>
+            <a:pPr indent="0" marL="0">
+              <a:buNone/>
+            </a:pPr>
+            <a:r>
+              <a:rPr lang="en-US" sz="1100" dirty="0">
+                <a:solidFill>
+                  <a:srgbClr val="E6EDF3"/>
+                </a:solidFill>
+                <a:latin typeface="Courier New" pitchFamily="34" charset="0"/>
+                <a:ea typeface="Courier New" pitchFamily="34" charset="-122"/>
+                <a:cs typeface="Courier New" pitchFamily="34" charset="-120"/>
+              </a:rPr>
+              <a:t>&gt; Read steps/02-users.md and do what it says.</a:t>
+            </a:r>
+            <a:endParaRPr lang="en-US" sz="1100" dirty="0"/>
+          </a:p>
+          <a:p>
+            <a:pPr indent="0" marL="0">
+              <a:buNone/>
+            </a:pPr>
+            <a:r>
+              <a:rPr lang="en-US" sz="1100" dirty="0">
+                <a:solidFill>
+                  <a:srgbClr val="E6EDF3"/>
+                </a:solidFill>
+                <a:latin typeface="Courier New" pitchFamily="34" charset="0"/>
+                <a:ea typeface="Courier New" pitchFamily="34" charset="-122"/>
+                <a:cs typeface="Courier New" pitchFamily="34" charset="-120"/>
+              </a:rPr>
+              <a:t> </a:t>
+            </a:r>
+            <a:endParaRPr lang="en-US" sz="1100" dirty="0"/>
+          </a:p>
+          <a:p>
+            <a:pPr indent="0" marL="0">
+              <a:buNone/>
+            </a:pPr>
+            <a:r>
+              <a:rPr lang="en-US" sz="1100" dirty="0">
+                <a:solidFill>
+                  <a:srgbClr val="8B98A5"/>
+                </a:solidFill>
+                <a:latin typeface="Courier New" pitchFamily="34" charset="0"/>
+                <a:ea typeface="Courier New" pitchFamily="34" charset="-122"/>
+                <a:cs typeface="Courier New" pitchFamily="34" charset="-120"/>
+              </a:rPr>
+              <a:t># steps/02-users.md says:</a:t>
+            </a:r>
+            <a:endParaRPr lang="en-US" sz="1100" dirty="0"/>
+          </a:p>
           <a:p>
             <a:pPr indent="0" marL="0">
               <a:buNone/>
@@ -5889,7 +5991,7 @@
                 <a:ea typeface="Calibri" pitchFamily="34" charset="-122"/>
                 <a:cs typeface="Calibri" pitchFamily="34" charset="-120"/>
               </a:rPr>
-              <a:t>instruction · give it to your agent</a:t>
+              <a:t>steps/03-notes.md · give it to your agent</a:t>
             </a:r>
             <a:endParaRPr lang="en-US" sz="1000" dirty="0"/>
           </a:p>
@@ -5915,6 +6017,57 @@
         <p:txBody>
           <a:bodyPr wrap="square" lIns="0" tIns="0" rIns="0" bIns="0" rtlCol="0" anchor="t"/>
           <a:lstStyle/>
+          <a:p>
+            <a:pPr indent="0" marL="0">
+              <a:buNone/>
+            </a:pPr>
+            <a:r>
+              <a:rPr lang="en-US" sz="1000" dirty="0">
+                <a:solidFill>
+                  <a:srgbClr val="E6EDF3"/>
+                </a:solidFill>
+                <a:latin typeface="Courier New" pitchFamily="34" charset="0"/>
+                <a:ea typeface="Courier New" pitchFamily="34" charset="-122"/>
+                <a:cs typeface="Courier New" pitchFamily="34" charset="-120"/>
+              </a:rPr>
+              <a:t>&gt; Read steps/03-notes.md and do what it says.</a:t>
+            </a:r>
+            <a:endParaRPr lang="en-US" sz="1000" dirty="0"/>
+          </a:p>
+          <a:p>
+            <a:pPr indent="0" marL="0">
+              <a:buNone/>
+            </a:pPr>
+            <a:r>
+              <a:rPr lang="en-US" sz="1000" dirty="0">
+                <a:solidFill>
+                  <a:srgbClr val="E6EDF3"/>
+                </a:solidFill>
+                <a:latin typeface="Courier New" pitchFamily="34" charset="0"/>
+                <a:ea typeface="Courier New" pitchFamily="34" charset="-122"/>
+                <a:cs typeface="Courier New" pitchFamily="34" charset="-120"/>
+              </a:rPr>
+              <a:t> </a:t>
+            </a:r>
+            <a:endParaRPr lang="en-US" sz="1000" dirty="0"/>
+          </a:p>
+          <a:p>
+            <a:pPr indent="0" marL="0">
+              <a:buNone/>
+            </a:pPr>
+            <a:r>
+              <a:rPr lang="en-US" sz="1000" dirty="0">
+                <a:solidFill>
+                  <a:srgbClr val="8B98A5"/>
+                </a:solidFill>
+                <a:latin typeface="Courier New" pitchFamily="34" charset="0"/>
+                <a:ea typeface="Courier New" pitchFamily="34" charset="-122"/>
+                <a:cs typeface="Courier New" pitchFamily="34" charset="-120"/>
+              </a:rPr>
+              <a:t># steps/03-notes.md says:</a:t>
+            </a:r>
+            <a:endParaRPr lang="en-US" sz="1000" dirty="0"/>
+          </a:p>
           <a:p>
             <a:pPr indent="0" marL="0">
               <a:buNone/>
@@ -8761,7 +8914,7 @@
                   <a:srgbClr val="2B3440"/>
                 </a:solidFill>
               </a:rPr>
-              <a:t>Zod 4 runs the transform after a failed datetime check. Guard it; the scaffold skill lists the trap.</a:t>
+              <a:t>An .overwrite() still runs after the date check failed and throws. Use .transform(), or guard first; the scaffold skill lists it.</a:t>
             </a:r>
             <a:endParaRPr lang="en-US" sz="1600" dirty="0"/>
           </a:p>
@@ -11292,7 +11445,7 @@
                 <a:ea typeface="Calibri" pitchFamily="34" charset="-122"/>
                 <a:cs typeface="Calibri" pitchFamily="34" charset="-120"/>
               </a:rPr>
-              <a:t>instruction · give it to your agent</a:t>
+              <a:t>steps/04-mcp-server.md · give it to your agent</a:t>
             </a:r>
             <a:endParaRPr lang="en-US" sz="1000" dirty="0"/>
           </a:p>
@@ -11318,6 +11471,57 @@
         <p:txBody>
           <a:bodyPr wrap="square" lIns="0" tIns="0" rIns="0" bIns="0" rtlCol="0" anchor="t"/>
           <a:lstStyle/>
+          <a:p>
+            <a:pPr indent="0" marL="0">
+              <a:buNone/>
+            </a:pPr>
+            <a:r>
+              <a:rPr lang="en-US" sz="1000" dirty="0">
+                <a:solidFill>
+                  <a:srgbClr val="E6EDF3"/>
+                </a:solidFill>
+                <a:latin typeface="Courier New" pitchFamily="34" charset="0"/>
+                <a:ea typeface="Courier New" pitchFamily="34" charset="-122"/>
+                <a:cs typeface="Courier New" pitchFamily="34" charset="-120"/>
+              </a:rPr>
+              <a:t>&gt; Read steps/04-mcp-server.md and do what it says.</a:t>
+            </a:r>
+            <a:endParaRPr lang="en-US" sz="1000" dirty="0"/>
+          </a:p>
+          <a:p>
+            <a:pPr indent="0" marL="0">
+              <a:buNone/>
+            </a:pPr>
+            <a:r>
+              <a:rPr lang="en-US" sz="1000" dirty="0">
+                <a:solidFill>
+                  <a:srgbClr val="E6EDF3"/>
+                </a:solidFill>
+                <a:latin typeface="Courier New" pitchFamily="34" charset="0"/>
+                <a:ea typeface="Courier New" pitchFamily="34" charset="-122"/>
+                <a:cs typeface="Courier New" pitchFamily="34" charset="-120"/>
+              </a:rPr>
+              <a:t> </a:t>
+            </a:r>
+            <a:endParaRPr lang="en-US" sz="1000" dirty="0"/>
+          </a:p>
+          <a:p>
+            <a:pPr indent="0" marL="0">
+              <a:buNone/>
+            </a:pPr>
+            <a:r>
+              <a:rPr lang="en-US" sz="1000" dirty="0">
+                <a:solidFill>
+                  <a:srgbClr val="8B98A5"/>
+                </a:solidFill>
+                <a:latin typeface="Courier New" pitchFamily="34" charset="0"/>
+                <a:ea typeface="Courier New" pitchFamily="34" charset="-122"/>
+                <a:cs typeface="Courier New" pitchFamily="34" charset="-120"/>
+              </a:rPr>
+              <a:t># steps/04-mcp-server.md says:</a:t>
+            </a:r>
+            <a:endParaRPr lang="en-US" sz="1000" dirty="0"/>
+          </a:p>
           <a:p>
             <a:pPr indent="0" marL="0">
               <a:buNone/>

</xml_diff>

<commit_message>
steps/01: create the local .env from .env.example during setup
The step 01 instruction now names the copy explicitly (PowerShell command included); the
Instruction 1 slide reads it from the file.

Co-Authored-By: Claude Opus 5.5 (1M context) <noreply@anthropic.com>
</commit_message>
<xml_diff>
--- a/docs/ai-agent-training/slides/lab-companion.pptx
+++ b/docs/ai-agent-training/slides/lab-companion.pptx
@@ -3884,7 +3884,7 @@
               <a:buNone/>
             </a:pPr>
             <a:r>
-              <a:rPr lang="en-US" sz="1100" dirty="0">
+              <a:rPr lang="en-US" sz="1000" dirty="0">
                 <a:solidFill>
                   <a:srgbClr val="E6EDF3"/>
                 </a:solidFill>
@@ -3894,14 +3894,14 @@
               </a:rPr>
               <a:t>&gt; Read steps/01-set-up.md and do what it says.</a:t>
             </a:r>
-            <a:endParaRPr lang="en-US" sz="1100" dirty="0"/>
-          </a:p>
-          <a:p>
-            <a:pPr indent="0" marL="0">
-              <a:buNone/>
-            </a:pPr>
-            <a:r>
-              <a:rPr lang="en-US" sz="1100" dirty="0">
+            <a:endParaRPr lang="en-US" sz="1000" dirty="0"/>
+          </a:p>
+          <a:p>
+            <a:pPr indent="0" marL="0">
+              <a:buNone/>
+            </a:pPr>
+            <a:r>
+              <a:rPr lang="en-US" sz="1000" dirty="0">
                 <a:solidFill>
                   <a:srgbClr val="E6EDF3"/>
                 </a:solidFill>
@@ -3911,14 +3911,14 @@
               </a:rPr>
               <a:t> </a:t>
             </a:r>
-            <a:endParaRPr lang="en-US" sz="1100" dirty="0"/>
-          </a:p>
-          <a:p>
-            <a:pPr indent="0" marL="0">
-              <a:buNone/>
-            </a:pPr>
-            <a:r>
-              <a:rPr lang="en-US" sz="1100" dirty="0">
+            <a:endParaRPr lang="en-US" sz="1000" dirty="0"/>
+          </a:p>
+          <a:p>
+            <a:pPr indent="0" marL="0">
+              <a:buNone/>
+            </a:pPr>
+            <a:r>
+              <a:rPr lang="en-US" sz="1000" dirty="0">
                 <a:solidFill>
                   <a:srgbClr val="8B98A5"/>
                 </a:solidFill>
@@ -3928,14 +3928,14 @@
               </a:rPr>
               <a:t># steps/01-set-up.md says:</a:t>
             </a:r>
-            <a:endParaRPr lang="en-US" sz="1100" dirty="0"/>
-          </a:p>
-          <a:p>
-            <a:pPr indent="0" marL="0">
-              <a:buNone/>
-            </a:pPr>
-            <a:r>
-              <a:rPr lang="en-US" sz="1100" dirty="0">
+            <a:endParaRPr lang="en-US" sz="1000" dirty="0"/>
+          </a:p>
+          <a:p>
+            <a:pPr indent="0" marL="0">
+              <a:buNone/>
+            </a:pPr>
+            <a:r>
+              <a:rPr lang="en-US" sz="1000" dirty="0">
                 <a:solidFill>
                   <a:srgbClr val="E6EDF3"/>
                 </a:solidFill>
@@ -3943,16 +3943,16 @@
                 <a:ea typeface="Courier New" pitchFamily="34" charset="-122"/>
                 <a:cs typeface="Courier New" pitchFamily="34" charset="-120"/>
               </a:rPr>
-              <a:t>Set this project up on this machine and prove it works:</a:t>
-            </a:r>
-            <a:endParaRPr lang="en-US" sz="1100" dirty="0"/>
-          </a:p>
-          <a:p>
-            <a:pPr indent="0" marL="0">
-              <a:buNone/>
-            </a:pPr>
-            <a:r>
-              <a:rPr lang="en-US" sz="1100" dirty="0">
+              <a:t>Set this project up on this machine: install it, and</a:t>
+            </a:r>
+            <a:endParaRPr lang="en-US" sz="1000" dirty="0"/>
+          </a:p>
+          <a:p>
+            <a:pPr indent="0" marL="0">
+              <a:buNone/>
+            </a:pPr>
+            <a:r>
+              <a:rPr lang="en-US" sz="1000" dirty="0">
                 <a:solidFill>
                   <a:srgbClr val="E6EDF3"/>
                 </a:solidFill>
@@ -3960,16 +3960,16 @@
                 <a:ea typeface="Courier New" pitchFamily="34" charset="-122"/>
                 <a:cs typeface="Courier New" pitchFamily="34" charset="-120"/>
               </a:rPr>
-              <a:t>counts, not "it works". Then show me what is in the</a:t>
-            </a:r>
-            <a:endParaRPr lang="en-US" sz="1100" dirty="0"/>
-          </a:p>
-          <a:p>
-            <a:pPr indent="0" marL="0">
-              <a:buNone/>
-            </a:pPr>
-            <a:r>
-              <a:rPr lang="en-US" sz="1100" dirty="0">
+              <a:t>create your local .env by copying .env.example (on Windows</a:t>
+            </a:r>
+            <a:endParaRPr lang="en-US" sz="1000" dirty="0"/>
+          </a:p>
+          <a:p>
+            <a:pPr indent="0" marL="0">
+              <a:buNone/>
+            </a:pPr>
+            <a:r>
+              <a:rPr lang="en-US" sz="1000" dirty="0">
                 <a:solidFill>
                   <a:srgbClr val="E6EDF3"/>
                 </a:solidFill>
@@ -3977,9 +3977,43 @@
                 <a:ea typeface="Courier New" pitchFamily="34" charset="-122"/>
                 <a:cs typeface="Courier New" pitchFamily="34" charset="-120"/>
               </a:rPr>
+              <a:t>PowerShell: Copy-Item .env.example .env). Then prove it</a:t>
+            </a:r>
+            <a:endParaRPr lang="en-US" sz="1000" dirty="0"/>
+          </a:p>
+          <a:p>
+            <a:pPr indent="0" marL="0">
+              <a:buNone/>
+            </a:pPr>
+            <a:r>
+              <a:rPr lang="en-US" sz="1000" dirty="0">
+                <a:solidFill>
+                  <a:srgbClr val="E6EDF3"/>
+                </a:solidFill>
+                <a:latin typeface="Courier New" pitchFamily="34" charset="0"/>
+                <a:ea typeface="Courier New" pitchFamily="34" charset="-122"/>
+                <a:cs typeface="Courier New" pitchFamily="34" charset="-120"/>
+              </a:rPr>
+              <a:t>works: counts, not "it works". Then show me what is in the</a:t>
+            </a:r>
+            <a:endParaRPr lang="en-US" sz="1000" dirty="0"/>
+          </a:p>
+          <a:p>
+            <a:pPr indent="0" marL="0">
+              <a:buNone/>
+            </a:pPr>
+            <a:r>
+              <a:rPr lang="en-US" sz="1000" dirty="0">
+                <a:solidFill>
+                  <a:srgbClr val="E6EDF3"/>
+                </a:solidFill>
+                <a:latin typeface="Courier New" pitchFamily="34" charset="0"/>
+                <a:ea typeface="Courier New" pitchFamily="34" charset="-122"/>
+                <a:cs typeface="Courier New" pitchFamily="34" charset="-120"/>
+              </a:rPr>
               <a:t>database. Then stop and wait for my next instruction.</a:t>
             </a:r>
-            <a:endParaRPr lang="en-US" sz="1100" dirty="0"/>
+            <a:endParaRPr lang="en-US" sz="1000" dirty="0"/>
           </a:p>
         </p:txBody>
       </p:sp>

</xml_diff>

<commit_message>
module 2: the agent connects the server to Claude Desktop; the learner restarts it
steps/04 asks the agent to connect notes-db to Claude Desktop (keeping other servers) and
to tell the learner to quit and reopen it. claude-desktop-config.mjs --install backs the
config up, keeps every other server, replaces only notes-db, and refuses an invalid file or
an unbuilt server. Spec, chapter 04 and slides follow. Tested on config files and with a
fresh agent on step 04.

Co-Authored-By: Claude Opus 5.5 (1M context) <noreply@anthropic.com>
</commit_message>
<xml_diff>
--- a/docs/ai-agent-training/slides/lab-companion.pptx
+++ b/docs/ai-agent-training/slides/lab-companion.pptx
@@ -1580,7 +1580,7 @@
           <a:p>
             <a:r>
               <a:rPr lang="en-US" dirty="0"/>
-              <a:t>Claude Desktop starts the server from its own folder with a minimal PATH, so the entry needs absolute paths for node, the server and the database: the script prints them. Quit Claude Desktop completely (not just the window) before reopening. The lab runs on a COPY of data/app.db; Claude Desktop writes to the real one, and npm run db:seed puts it back.</a:t>
+              <a:t>Claude Desktop starts the server from its own folder with a minimal PATH, so the entry needs absolute paths for node, the server and the database. The agent connects it with node scripts/claude-desktop-config.mjs --install, which backs the config file up, keeps every other server in it and adds only notes-db; it refuses a file it cannot parse. The one step the agent cannot do is the restart: each learner quits Claude Desktop completely (not just the window; on Windows also from the tray) and reopens it. The lab runs on a COPY of data/app.db; Claude Desktop writes to the real one, and npm run db:seed puts it back.</a:t>
             </a:r>
             <a:endParaRPr lang="en-US" dirty="0"/>
           </a:p>
@@ -10202,7 +10202,7 @@
                 <a:ea typeface="Courier New" pitchFamily="34" charset="-122"/>
                 <a:cs typeface="Courier New" pitchFamily="34" charset="-120"/>
               </a:rPr>
-              <a:t>run verify are green; then show me how to connect it to</a:t>
+              <a:t>run verify are green. Then connect it to my Claude Desktop</a:t>
             </a:r>
             <a:endParaRPr lang="en-US" sz="1000" dirty="0"/>
           </a:p>
@@ -10219,7 +10219,7 @@
                 <a:ea typeface="Courier New" pitchFamily="34" charset="-122"/>
                 <a:cs typeface="Courier New" pitchFamily="34" charset="-120"/>
               </a:rPr>
-              <a:t>Claude Desktop, one question I could ask it and one change</a:t>
+              <a:t>(keep any MCP servers I already have there), tell me to</a:t>
             </a:r>
             <a:endParaRPr lang="en-US" sz="1000" dirty="0"/>
           </a:p>
@@ -10236,7 +10236,41 @@
                 <a:ea typeface="Courier New" pitchFamily="34" charset="-122"/>
                 <a:cs typeface="Courier New" pitchFamily="34" charset="-120"/>
               </a:rPr>
-              <a:t>I could ask it to make. Then stop and wait for my next</a:t>
+              <a:t>quit and reopen Claude Desktop so it picks the server up,</a:t>
+            </a:r>
+            <a:endParaRPr lang="en-US" sz="1000" dirty="0"/>
+          </a:p>
+          <a:p>
+            <a:pPr indent="0" marL="0">
+              <a:buNone/>
+            </a:pPr>
+            <a:r>
+              <a:rPr lang="en-US" sz="1000" dirty="0">
+                <a:solidFill>
+                  <a:srgbClr val="E6EDF3"/>
+                </a:solidFill>
+                <a:latin typeface="Courier New" pitchFamily="34" charset="0"/>
+                <a:ea typeface="Courier New" pitchFamily="34" charset="-122"/>
+                <a:cs typeface="Courier New" pitchFamily="34" charset="-120"/>
+              </a:rPr>
+              <a:t>and give me one question I could ask it and one change I</a:t>
+            </a:r>
+            <a:endParaRPr lang="en-US" sz="1000" dirty="0"/>
+          </a:p>
+          <a:p>
+            <a:pPr indent="0" marL="0">
+              <a:buNone/>
+            </a:pPr>
+            <a:r>
+              <a:rPr lang="en-US" sz="1000" dirty="0">
+                <a:solidFill>
+                  <a:srgbClr val="E6EDF3"/>
+                </a:solidFill>
+                <a:latin typeface="Courier New" pitchFamily="34" charset="0"/>
+                <a:ea typeface="Courier New" pitchFamily="34" charset="-122"/>
+                <a:cs typeface="Courier New" pitchFamily="34" charset="-120"/>
+              </a:rPr>
+              <a:t>could ask it to make. Then stop and wait for my next</a:t>
             </a:r>
             <a:endParaRPr lang="en-US" sz="1000" dirty="0"/>
           </a:p>
@@ -10629,7 +10663,7 @@
                   <a:srgbClr val="1B1F24"/>
                 </a:solidFill>
               </a:rPr>
-              <a:t>gives the Claude Desktop entry with absolute paths</a:t>
+              <a:t>connects it to Claude Desktop, keeps your other servers</a:t>
             </a:r>
             <a:endParaRPr lang="en-US" sz="1200" dirty="0"/>
           </a:p>
@@ -11850,13 +11884,13 @@
             <a:r>
               <a:rPr lang="en-US" sz="1400" dirty="0">
                 <a:solidFill>
-                  <a:srgbClr val="E6EDF3"/>
+                  <a:srgbClr val="8B98A5"/>
                 </a:solidFill>
                 <a:latin typeface="Courier New" pitchFamily="34" charset="0"/>
                 <a:ea typeface="Courier New" pitchFamily="34" charset="-122"/>
                 <a:cs typeface="Courier New" pitchFamily="34" charset="-120"/>
               </a:rPr>
-              <a:t>npm run build</a:t>
+              <a:t># your agent connected it: claude-desktop-config.mjs</a:t>
             </a:r>
             <a:endParaRPr lang="en-US" sz="1400" dirty="0"/>
           </a:p>
@@ -11867,13 +11901,13 @@
             <a:r>
               <a:rPr lang="en-US" sz="1400" dirty="0">
                 <a:solidFill>
-                  <a:srgbClr val="E6EDF3"/>
+                  <a:srgbClr val="8B98A5"/>
                 </a:solidFill>
                 <a:latin typeface="Courier New" pitchFamily="34" charset="0"/>
                 <a:ea typeface="Courier New" pitchFamily="34" charset="-122"/>
                 <a:cs typeface="Courier New" pitchFamily="34" charset="-120"/>
               </a:rPr>
-              <a:t>node scripts\claude-desktop-config.mjs</a:t>
+              <a:t>#   --install (your other servers are kept)</a:t>
             </a:r>
             <a:endParaRPr lang="en-US" sz="1400" dirty="0"/>
           </a:p>
@@ -11890,7 +11924,7 @@
                 <a:ea typeface="Courier New" pitchFamily="34" charset="-122"/>
                 <a:cs typeface="Courier New" pitchFamily="34" charset="-120"/>
               </a:rPr>
-              <a:t># paste the entry into the config file it names,</a:t>
+              <a:t># YOU: quit Claude Desktop completely (tray too)</a:t>
             </a:r>
             <a:endParaRPr lang="en-US" sz="1400" dirty="0"/>
           </a:p>
@@ -11907,7 +11941,7 @@
                 <a:ea typeface="Courier New" pitchFamily="34" charset="-122"/>
                 <a:cs typeface="Courier New" pitchFamily="34" charset="-120"/>
               </a:rPr>
-              <a:t># quit and reopen Claude Desktop, then ask:</a:t>
+              <a:t>#   and reopen it: notes-db is in the tools menu</a:t>
             </a:r>
             <a:endParaRPr lang="en-US" sz="1400" dirty="0"/>
           </a:p>
@@ -11924,7 +11958,7 @@
                 <a:ea typeface="Courier New" pitchFamily="34" charset="-122"/>
                 <a:cs typeface="Courier New" pitchFamily="34" charset="-120"/>
               </a:rPr>
-              <a:t># "Which open notes are shared with more</a:t>
+              <a:t># then ask: "Which open notes are shared with more</a:t>
             </a:r>
             <a:endParaRPr lang="en-US" sz="1400" dirty="0"/>
           </a:p>

</xml_diff>

<commit_message>
course: the playground mirrors lab 01, and playground:check tests the running app
A learner's playground showed 404 for the users routes after step 02 while verify was green:
verify and the labs boot their own app. The playground now has 36 requests, each naming the
lab 01 test it reproduces (a test keeps them in step); npm run playground:check sends them to
the RUNNING app, and steps 02/03 end with it after a rebuild and restart. Step 01 leaves the
app running with the playground link. A Nest 'Cannot GET' 404 never counts as a pass.
Reseed with the app stopped. Measured: 36/36 on module 1 (browser and CLI); a fresh agent on
step 02 with the app already running restarted it and passed 8/8. Checkpoints 21/6, 44/50,
47/59, labs 31/31; patch 2 regenerated.

Co-Authored-By: Claude Opus 5.5 (1M context) <noreply@anthropic.com>
</commit_message>
<xml_diff>
--- a/docs/ai-agent-training/slides/lab-companion.pptx
+++ b/docs/ai-agent-training/slides/lab-companion.pptx
@@ -876,7 +876,7 @@
           <a:p>
             <a:r>
               <a:rPr lang="en-US" dirty="0"/>
-              <a:t>Tests first: verify and the lab check run on an empty in-memory database, so a green result there is the proof the code works. Only then start the app and open the playground: it sends every module 1 request to the running app with one click and shows each answer, proving the resources also serve the seeded rows. Nobody needs curl. The playground writes to data/app.db; npm run db:seed puts the data back.</a:t>
+              <a:t>Tests first: verify and the lab check run on an empty in-memory database, so a green result there is the proof the code works. Only then open the playground: the app has been running since step 01, and the agent rebuilds and restarts it after each step that adds routes (the starter CLAUDE.md says so). If it is not running, npm run build then npm start. The playground sends every module 1 request to the running app with one click and shows each answer, proving the resources also serve the seeded rows. Nobody needs curl. The playground writes to data/app.db; npm run db:seed puts the data back.</a:t>
             </a:r>
             <a:endParaRPr lang="en-US" dirty="0"/>
           </a:p>
@@ -964,7 +964,7 @@
           <a:p>
             <a:r>
               <a:rPr lang="en-US" dirty="0"/>
-              <a:t>Captured in a dry run of the previous slide, in Chromium at 1280x720: base plus the module 1 checkpoint and no .env, verify 44 unit / 49 e2e, lab 01 15/15, then Run all in order: 19 of 19 cards green, no page errors, List users showing the 25 seeded users. With DevTools open the two 409 and three 422 requests show in red as failed loads; that is expected, they are the rule checks. If port 3000 is taken, npm start prints "successfully started" and THEN fails: the last line says the port is in use. Set PORT in .env and use that port in the URL. A missing .env does not matter: in development the app uses data/app.db by default. npm run db:seed puts the data back afterwards.</a:t>
+              <a:t>Captured in Chromium at 1280x720 against the module 1 build after Run all in order: 36 of 36 cards green, all five ids carried, no page errors. Every card names the lab 01 test it reproduces, and npm run playground:check sends the same requests from a terminal against the running app (steps 02 and 03 end with it). A 404 from a route that does not exist (Cannot GET) is always red: the module is not built, or the app was not restarted after building it. With DevTools open the rule checks (409, 422) show as red failed loads: expected. To get the data back: stop the app, npm run db:seed, start it again (reseeding under a running app breaks its next write).</a:t>
             </a:r>
             <a:endParaRPr lang="en-US" dirty="0"/>
           </a:p>
@@ -3994,7 +3994,75 @@
                 <a:ea typeface="Courier New" pitchFamily="34" charset="-122"/>
                 <a:cs typeface="Courier New" pitchFamily="34" charset="-120"/>
               </a:rPr>
-              <a:t>works: counts, not "it works". Then show me what is in the</a:t>
+              <a:t>works: counts, not "it works" (lab 01 is red until module</a:t>
+            </a:r>
+            <a:endParaRPr lang="en-US" sz="1000" dirty="0"/>
+          </a:p>
+          <a:p>
+            <a:pPr indent="0" marL="0">
+              <a:buNone/>
+            </a:pPr>
+            <a:r>
+              <a:rPr lang="en-US" sz="1000" dirty="0">
+                <a:solidFill>
+                  <a:srgbClr val="E6EDF3"/>
+                </a:solidFill>
+                <a:latin typeface="Courier New" pitchFamily="34" charset="0"/>
+                <a:ea typeface="Courier New" pitchFamily="34" charset="-122"/>
+                <a:cs typeface="Courier New" pitchFamily="34" charset="-120"/>
+              </a:rPr>
+              <a:t>1 is built: that is expected). Once npm run verify passes,</a:t>
+            </a:r>
+            <a:endParaRPr lang="en-US" sz="1000" dirty="0"/>
+          </a:p>
+          <a:p>
+            <a:pPr indent="0" marL="0">
+              <a:buNone/>
+            </a:pPr>
+            <a:r>
+              <a:rPr lang="en-US" sz="1000" dirty="0">
+                <a:solidFill>
+                  <a:srgbClr val="E6EDF3"/>
+                </a:solidFill>
+                <a:latin typeface="Courier New" pitchFamily="34" charset="0"/>
+                <a:ea typeface="Courier New" pitchFamily="34" charset="-122"/>
+                <a:cs typeface="Courier New" pitchFamily="34" charset="-120"/>
+              </a:rPr>
+              <a:t>start the app, leave it running, and give me the</a:t>
+            </a:r>
+            <a:endParaRPr lang="en-US" sz="1000" dirty="0"/>
+          </a:p>
+          <a:p>
+            <a:pPr indent="0" marL="0">
+              <a:buNone/>
+            </a:pPr>
+            <a:r>
+              <a:rPr lang="en-US" sz="1000" dirty="0">
+                <a:solidFill>
+                  <a:srgbClr val="E6EDF3"/>
+                </a:solidFill>
+                <a:latin typeface="Courier New" pitchFamily="34" charset="0"/>
+                <a:ea typeface="Courier New" pitchFamily="34" charset="-122"/>
+                <a:cs typeface="Courier New" pitchFamily="34" charset="-120"/>
+              </a:rPr>
+              <a:t>playground link (http://localhost:3000/playground, or my</a:t>
+            </a:r>
+            <a:endParaRPr lang="en-US" sz="1000" dirty="0"/>
+          </a:p>
+          <a:p>
+            <a:pPr indent="0" marL="0">
+              <a:buNone/>
+            </a:pPr>
+            <a:r>
+              <a:rPr lang="en-US" sz="1000" dirty="0">
+                <a:solidFill>
+                  <a:srgbClr val="E6EDF3"/>
+                </a:solidFill>
+                <a:latin typeface="Courier New" pitchFamily="34" charset="0"/>
+                <a:ea typeface="Courier New" pitchFamily="34" charset="-122"/>
+                <a:cs typeface="Courier New" pitchFamily="34" charset="-120"/>
+              </a:rPr>
+              <a:t>port) so I can review it. Then show me what is in the</a:t>
             </a:r>
             <a:endParaRPr lang="en-US" sz="1000" dirty="0"/>
           </a:p>
@@ -4146,7 +4214,7 @@
         </p:nvSpPr>
         <p:spPr>
           <a:xfrm>
-            <a:off x="5897880" y="2834640"/>
+            <a:off x="5897880" y="2706624"/>
             <a:ext cx="292608" cy="292608"/>
           </a:xfrm>
           <a:prstGeom prst="ellipse">
@@ -4179,7 +4247,7 @@
         </p:blipFill>
         <p:spPr>
           <a:xfrm>
-            <a:off x="5962254" y="2899014"/>
+            <a:off x="5962254" y="2770998"/>
             <a:ext cx="163860" cy="163860"/>
           </a:xfrm>
           <a:prstGeom prst="rect">
@@ -4195,7 +4263,7 @@
         </p:nvSpPr>
         <p:spPr>
           <a:xfrm>
-            <a:off x="6309360" y="2798064"/>
+            <a:off x="6309360" y="2670048"/>
             <a:ext cx="2377440" cy="566928"/>
           </a:xfrm>
           <a:prstGeom prst="rect">
@@ -4231,7 +4299,7 @@
         </p:nvSpPr>
         <p:spPr>
           <a:xfrm>
-            <a:off x="5897880" y="3438144"/>
+            <a:off x="5897880" y="3182112"/>
             <a:ext cx="292608" cy="292608"/>
           </a:xfrm>
           <a:prstGeom prst="ellipse">
@@ -4264,7 +4332,7 @@
         </p:blipFill>
         <p:spPr>
           <a:xfrm>
-            <a:off x="5962254" y="3502518"/>
+            <a:off x="5962254" y="3246486"/>
             <a:ext cx="163860" cy="163860"/>
           </a:xfrm>
           <a:prstGeom prst="rect">
@@ -4280,7 +4348,7 @@
         </p:nvSpPr>
         <p:spPr>
           <a:xfrm>
-            <a:off x="6309360" y="3401568"/>
+            <a:off x="6309360" y="3145536"/>
             <a:ext cx="2377440" cy="566928"/>
           </a:xfrm>
           <a:prstGeom prst="rect">
@@ -4302,7 +4370,7 @@
                   <a:srgbClr val="1B1F24"/>
                 </a:solidFill>
               </a:rPr>
-              <a:t>counts: 21 unit, 5 e2e, a red lab 01</a:t>
+              <a:t>counts: 21 unit, 6 e2e, a red lab 01</a:t>
             </a:r>
             <a:endParaRPr lang="en-US" sz="1200" dirty="0"/>
           </a:p>
@@ -4316,7 +4384,7 @@
         </p:nvSpPr>
         <p:spPr>
           <a:xfrm>
-            <a:off x="5897880" y="4041648"/>
+            <a:off x="5897880" y="3657600"/>
             <a:ext cx="292608" cy="292608"/>
           </a:xfrm>
           <a:prstGeom prst="ellipse">
@@ -4349,7 +4417,7 @@
         </p:blipFill>
         <p:spPr>
           <a:xfrm>
-            <a:off x="5962254" y="4106022"/>
+            <a:off x="5962254" y="3721974"/>
             <a:ext cx="163860" cy="163860"/>
           </a:xfrm>
           <a:prstGeom prst="rect">
@@ -4365,7 +4433,92 @@
         </p:nvSpPr>
         <p:spPr>
           <a:xfrm>
-            <a:off x="6309360" y="4005072"/>
+            <a:off x="6309360" y="3621024"/>
+            <a:ext cx="2377440" cy="566928"/>
+          </a:xfrm>
+          <a:prstGeom prst="rect">
+            <a:avLst/>
+          </a:prstGeom>
+          <a:noFill/>
+          <a:ln/>
+        </p:spPr>
+        <p:txBody>
+          <a:bodyPr wrap="square" lIns="0" tIns="0" rIns="0" bIns="0" rtlCol="0" anchor="t"/>
+          <a:lstStyle/>
+          <a:p>
+            <a:pPr indent="0" marL="0">
+              <a:buNone/>
+            </a:pPr>
+            <a:r>
+              <a:rPr lang="en-US" sz="1200" dirty="0">
+                <a:solidFill>
+                  <a:srgbClr val="1B1F24"/>
+                </a:solidFill>
+              </a:rPr>
+              <a:t>leaves the app running: the /playground link</a:t>
+            </a:r>
+            <a:endParaRPr lang="en-US" sz="1200" dirty="0"/>
+          </a:p>
+        </p:txBody>
+      </p:sp>
+      <p:sp>
+        <p:nvSpPr>
+          <p:cNvPr id="24" name="Shape 18"/>
+          <p:cNvSpPr/>
+          <p:nvPr/>
+        </p:nvSpPr>
+        <p:spPr>
+          <a:xfrm>
+            <a:off x="5897880" y="4133088"/>
+            <a:ext cx="292608" cy="292608"/>
+          </a:xfrm>
+          <a:prstGeom prst="ellipse">
+            <a:avLst/>
+          </a:prstGeom>
+          <a:solidFill>
+            <a:srgbClr val="1FB68A"/>
+          </a:solidFill>
+          <a:ln w="12700">
+            <a:solidFill>
+              <a:srgbClr val="1FB68A"/>
+            </a:solidFill>
+            <a:prstDash val="solid"/>
+          </a:ln>
+        </p:spPr>
+      </p:sp>
+      <p:pic>
+        <p:nvPicPr>
+          <p:cNvPr id="25" name="Image 4" descr="preencoded.png">    </p:cNvPr>
+          <p:cNvPicPr>
+            <a:picLocks noChangeAspect="1"/>
+          </p:cNvPicPr>
+          <p:nvPr/>
+        </p:nvPicPr>
+        <p:blipFill>
+          <a:blip r:embed="rId5"/>
+          <a:stretch>
+            <a:fillRect/>
+          </a:stretch>
+        </p:blipFill>
+        <p:spPr>
+          <a:xfrm>
+            <a:off x="5962254" y="4197462"/>
+            <a:ext cx="163860" cy="163860"/>
+          </a:xfrm>
+          <a:prstGeom prst="rect">
+            <a:avLst/>
+          </a:prstGeom>
+        </p:spPr>
+      </p:pic>
+      <p:sp>
+        <p:nvSpPr>
+          <p:cNvPr id="26" name="Text 19"/>
+          <p:cNvSpPr txBox="1"/>
+          <p:nvPr/>
+        </p:nvSpPr>
+        <p:spPr>
+          <a:xfrm>
+            <a:off x="6309360" y="4096512"/>
             <a:ext cx="2377440" cy="566928"/>
           </a:xfrm>
           <a:prstGeom prst="rect">
@@ -4739,7 +4892,7 @@
               <a:buNone/>
             </a:pPr>
             <a:r>
-              <a:rPr lang="en-US" sz="1100" dirty="0">
+              <a:rPr lang="en-US" sz="1000" dirty="0">
                 <a:solidFill>
                   <a:srgbClr val="E6EDF3"/>
                 </a:solidFill>
@@ -4749,14 +4902,14 @@
               </a:rPr>
               <a:t>&gt; Read steps/02-users.md and do what it says.</a:t>
             </a:r>
-            <a:endParaRPr lang="en-US" sz="1100" dirty="0"/>
-          </a:p>
-          <a:p>
-            <a:pPr indent="0" marL="0">
-              <a:buNone/>
-            </a:pPr>
-            <a:r>
-              <a:rPr lang="en-US" sz="1100" dirty="0">
+            <a:endParaRPr lang="en-US" sz="1000" dirty="0"/>
+          </a:p>
+          <a:p>
+            <a:pPr indent="0" marL="0">
+              <a:buNone/>
+            </a:pPr>
+            <a:r>
+              <a:rPr lang="en-US" sz="1000" dirty="0">
                 <a:solidFill>
                   <a:srgbClr val="E6EDF3"/>
                 </a:solidFill>
@@ -4766,14 +4919,14 @@
               </a:rPr>
               <a:t> </a:t>
             </a:r>
-            <a:endParaRPr lang="en-US" sz="1100" dirty="0"/>
-          </a:p>
-          <a:p>
-            <a:pPr indent="0" marL="0">
-              <a:buNone/>
-            </a:pPr>
-            <a:r>
-              <a:rPr lang="en-US" sz="1100" dirty="0">
+            <a:endParaRPr lang="en-US" sz="1000" dirty="0"/>
+          </a:p>
+          <a:p>
+            <a:pPr indent="0" marL="0">
+              <a:buNone/>
+            </a:pPr>
+            <a:r>
+              <a:rPr lang="en-US" sz="1000" dirty="0">
                 <a:solidFill>
                   <a:srgbClr val="8B98A5"/>
                 </a:solidFill>
@@ -4783,14 +4936,14 @@
               </a:rPr>
               <a:t># steps/02-users.md says:</a:t>
             </a:r>
-            <a:endParaRPr lang="en-US" sz="1100" dirty="0"/>
-          </a:p>
-          <a:p>
-            <a:pPr indent="0" marL="0">
-              <a:buNone/>
-            </a:pPr>
-            <a:r>
-              <a:rPr lang="en-US" sz="1100" dirty="0">
+            <a:endParaRPr lang="en-US" sz="1000" dirty="0"/>
+          </a:p>
+          <a:p>
+            <a:pPr indent="0" marL="0">
+              <a:buNone/>
+            </a:pPr>
+            <a:r>
+              <a:rPr lang="en-US" sz="1000" dirty="0">
                 <a:solidFill>
                   <a:srgbClr val="E6EDF3"/>
                 </a:solidFill>
@@ -4800,14 +4953,14 @@
               </a:rPr>
               <a:t>Build the users resource on the provided users table:</a:t>
             </a:r>
-            <a:endParaRPr lang="en-US" sz="1100" dirty="0"/>
-          </a:p>
-          <a:p>
-            <a:pPr indent="0" marL="0">
-              <a:buNone/>
-            </a:pPr>
-            <a:r>
-              <a:rPr lang="en-US" sz="1100" dirty="0">
+            <a:endParaRPr lang="en-US" sz="1000" dirty="0"/>
+          </a:p>
+          <a:p>
+            <a:pPr indent="0" marL="0">
+              <a:buNone/>
+            </a:pPr>
+            <a:r>
+              <a:rPr lang="en-US" sz="1000" dirty="0">
                 <a:solidFill>
                   <a:srgbClr val="E6EDF3"/>
                 </a:solidFill>
@@ -4815,16 +4968,16 @@
                 <a:ea typeface="Courier New" pitchFamily="34" charset="-122"/>
                 <a:cs typeface="Courier New" pitchFamily="34" charset="-120"/>
               </a:rPr>
-              <a:t>specs/users.md. Done when npm run verify is green. Then</a:t>
-            </a:r>
-            <a:endParaRPr lang="en-US" sz="1100" dirty="0"/>
-          </a:p>
-          <a:p>
-            <a:pPr indent="0" marL="0">
-              <a:buNone/>
-            </a:pPr>
-            <a:r>
-              <a:rPr lang="en-US" sz="1100" dirty="0">
+              <a:t>specs/users.md. Done when npm run verify is green and,</a:t>
+            </a:r>
+            <a:endParaRPr lang="en-US" sz="1000" dirty="0"/>
+          </a:p>
+          <a:p>
+            <a:pPr indent="0" marL="0">
+              <a:buNone/>
+            </a:pPr>
+            <a:r>
+              <a:rPr lang="en-US" sz="1000" dirty="0">
                 <a:solidFill>
                   <a:srgbClr val="E6EDF3"/>
                 </a:solidFill>
@@ -4832,9 +4985,60 @@
                 <a:ea typeface="Courier New" pitchFamily="34" charset="-122"/>
                 <a:cs typeface="Courier New" pitchFamily="34" charset="-120"/>
               </a:rPr>
-              <a:t>stop and wait for my next instruction.</a:t>
-            </a:r>
-            <a:endParaRPr lang="en-US" sz="1100" dirty="0"/>
+              <a:t>with the app rebuilt and restarted, npm run</a:t>
+            </a:r>
+            <a:endParaRPr lang="en-US" sz="1000" dirty="0"/>
+          </a:p>
+          <a:p>
+            <a:pPr indent="0" marL="0">
+              <a:buNone/>
+            </a:pPr>
+            <a:r>
+              <a:rPr lang="en-US" sz="1000" dirty="0">
+                <a:solidFill>
+                  <a:srgbClr val="E6EDF3"/>
+                </a:solidFill>
+                <a:latin typeface="Courier New" pitchFamily="34" charset="0"/>
+                <a:ea typeface="Courier New" pitchFamily="34" charset="-122"/>
+                <a:cs typeface="Courier New" pitchFamily="34" charset="-120"/>
+              </a:rPr>
+              <a:t>playground:check -- users passes against it (the same</a:t>
+            </a:r>
+            <a:endParaRPr lang="en-US" sz="1000" dirty="0"/>
+          </a:p>
+          <a:p>
+            <a:pPr indent="0" marL="0">
+              <a:buNone/>
+            </a:pPr>
+            <a:r>
+              <a:rPr lang="en-US" sz="1000" dirty="0">
+                <a:solidFill>
+                  <a:srgbClr val="E6EDF3"/>
+                </a:solidFill>
+                <a:latin typeface="Courier New" pitchFamily="34" charset="0"/>
+                <a:ea typeface="Courier New" pitchFamily="34" charset="-122"/>
+                <a:cs typeface="Courier New" pitchFamily="34" charset="-120"/>
+              </a:rPr>
+              <a:t>requests as the playground page). Then stop and wait for</a:t>
+            </a:r>
+            <a:endParaRPr lang="en-US" sz="1000" dirty="0"/>
+          </a:p>
+          <a:p>
+            <a:pPr indent="0" marL="0">
+              <a:buNone/>
+            </a:pPr>
+            <a:r>
+              <a:rPr lang="en-US" sz="1000" dirty="0">
+                <a:solidFill>
+                  <a:srgbClr val="E6EDF3"/>
+                </a:solidFill>
+                <a:latin typeface="Courier New" pitchFamily="34" charset="0"/>
+                <a:ea typeface="Courier New" pitchFamily="34" charset="-122"/>
+                <a:cs typeface="Courier New" pitchFamily="34" charset="-120"/>
+              </a:rPr>
+              <a:t>my next instruction.</a:t>
+            </a:r>
+            <a:endParaRPr lang="en-US" sz="1000" dirty="0"/>
           </a:p>
         </p:txBody>
       </p:sp>
@@ -4967,7 +5171,7 @@
         </p:nvSpPr>
         <p:spPr>
           <a:xfrm>
-            <a:off x="5897880" y="2834640"/>
+            <a:off x="5897880" y="2825496"/>
             <a:ext cx="292608" cy="292608"/>
           </a:xfrm>
           <a:prstGeom prst="ellipse">
@@ -5000,7 +5204,7 @@
         </p:blipFill>
         <p:spPr>
           <a:xfrm>
-            <a:off x="5962254" y="2899014"/>
+            <a:off x="5962254" y="2889870"/>
             <a:ext cx="163860" cy="163860"/>
           </a:xfrm>
           <a:prstGeom prst="rect">
@@ -5016,7 +5220,7 @@
         </p:nvSpPr>
         <p:spPr>
           <a:xfrm>
-            <a:off x="6309360" y="2798064"/>
+            <a:off x="6309360" y="2788920"/>
             <a:ext cx="2377440" cy="566928"/>
           </a:xfrm>
           <a:prstGeom prst="rect">
@@ -5052,7 +5256,7 @@
         </p:nvSpPr>
         <p:spPr>
           <a:xfrm>
-            <a:off x="5897880" y="3438144"/>
+            <a:off x="5897880" y="3419856"/>
             <a:ext cx="292608" cy="292608"/>
           </a:xfrm>
           <a:prstGeom prst="ellipse">
@@ -5085,7 +5289,7 @@
         </p:blipFill>
         <p:spPr>
           <a:xfrm>
-            <a:off x="5962254" y="3502518"/>
+            <a:off x="5962254" y="3484230"/>
             <a:ext cx="163860" cy="163860"/>
           </a:xfrm>
           <a:prstGeom prst="rect">
@@ -5101,7 +5305,7 @@
         </p:nvSpPr>
         <p:spPr>
           <a:xfrm>
-            <a:off x="6309360" y="3401568"/>
+            <a:off x="6309360" y="3383280"/>
             <a:ext cx="2377440" cy="566928"/>
           </a:xfrm>
           <a:prstGeom prst="rect">
@@ -5137,7 +5341,7 @@
         </p:nvSpPr>
         <p:spPr>
           <a:xfrm>
-            <a:off x="5897880" y="4041648"/>
+            <a:off x="5897880" y="4014216"/>
             <a:ext cx="292608" cy="292608"/>
           </a:xfrm>
           <a:prstGeom prst="ellipse">
@@ -5170,7 +5374,7 @@
         </p:blipFill>
         <p:spPr>
           <a:xfrm>
-            <a:off x="5962254" y="4106022"/>
+            <a:off x="5962254" y="4078590"/>
             <a:ext cx="163860" cy="163860"/>
           </a:xfrm>
           <a:prstGeom prst="rect">
@@ -5186,7 +5390,7 @@
         </p:nvSpPr>
         <p:spPr>
           <a:xfrm>
-            <a:off x="6309360" y="4005072"/>
+            <a:off x="6309360" y="3977640"/>
             <a:ext cx="2377440" cy="566928"/>
           </a:xfrm>
           <a:prstGeom prst="rect">
@@ -5636,7 +5840,7 @@
                 <a:ea typeface="Courier New" pitchFamily="34" charset="-122"/>
                 <a:cs typeface="Courier New" pitchFamily="34" charset="-120"/>
               </a:rPr>
-              <a:t>when npm run lab 01 and npm run verify are green. Then</a:t>
+              <a:t>when npm run lab 01 and npm run verify are green and, with</a:t>
             </a:r>
             <a:endParaRPr lang="en-US" sz="1000" dirty="0"/>
           </a:p>
@@ -5653,7 +5857,41 @@
                 <a:ea typeface="Courier New" pitchFamily="34" charset="-122"/>
                 <a:cs typeface="Courier New" pitchFamily="34" charset="-120"/>
               </a:rPr>
-              <a:t>stop and wait for my next instruction.</a:t>
+              <a:t>the app rebuilt and restarted, npm run playground:check</a:t>
+            </a:r>
+            <a:endParaRPr lang="en-US" sz="1000" dirty="0"/>
+          </a:p>
+          <a:p>
+            <a:pPr indent="0" marL="0">
+              <a:buNone/>
+            </a:pPr>
+            <a:r>
+              <a:rPr lang="en-US" sz="1000" dirty="0">
+                <a:solidFill>
+                  <a:srgbClr val="E6EDF3"/>
+                </a:solidFill>
+                <a:latin typeface="Courier New" pitchFamily="34" charset="0"/>
+                <a:ea typeface="Courier New" pitchFamily="34" charset="-122"/>
+                <a:cs typeface="Courier New" pitchFamily="34" charset="-120"/>
+              </a:rPr>
+              <a:t>passes against it (every request of the playground page).</a:t>
+            </a:r>
+            <a:endParaRPr lang="en-US" sz="1000" dirty="0"/>
+          </a:p>
+          <a:p>
+            <a:pPr indent="0" marL="0">
+              <a:buNone/>
+            </a:pPr>
+            <a:r>
+              <a:rPr lang="en-US" sz="1000" dirty="0">
+                <a:solidFill>
+                  <a:srgbClr val="E6EDF3"/>
+                </a:solidFill>
+                <a:latin typeface="Courier New" pitchFamily="34" charset="0"/>
+                <a:ea typeface="Courier New" pitchFamily="34" charset="-122"/>
+                <a:cs typeface="Courier New" pitchFamily="34" charset="-120"/>
+              </a:rPr>
+              <a:t>Then stop and wait for my next instruction.</a:t>
             </a:r>
             <a:endParaRPr lang="en-US" sz="1000" dirty="0"/>
           </a:p>
@@ -5788,7 +6026,7 @@
         </p:nvSpPr>
         <p:spPr>
           <a:xfrm>
-            <a:off x="5897880" y="2834640"/>
+            <a:off x="5897880" y="2825496"/>
             <a:ext cx="292608" cy="292608"/>
           </a:xfrm>
           <a:prstGeom prst="ellipse">
@@ -5821,7 +6059,7 @@
         </p:blipFill>
         <p:spPr>
           <a:xfrm>
-            <a:off x="5962254" y="2899014"/>
+            <a:off x="5962254" y="2889870"/>
             <a:ext cx="163860" cy="163860"/>
           </a:xfrm>
           <a:prstGeom prst="rect">
@@ -5837,7 +6075,7 @@
         </p:nvSpPr>
         <p:spPr>
           <a:xfrm>
-            <a:off x="6309360" y="2798064"/>
+            <a:off x="6309360" y="2788920"/>
             <a:ext cx="2377440" cy="566928"/>
           </a:xfrm>
           <a:prstGeom prst="rect">
@@ -5873,7 +6111,7 @@
         </p:nvSpPr>
         <p:spPr>
           <a:xfrm>
-            <a:off x="5897880" y="3438144"/>
+            <a:off x="5897880" y="3419856"/>
             <a:ext cx="292608" cy="292608"/>
           </a:xfrm>
           <a:prstGeom prst="ellipse">
@@ -5906,7 +6144,7 @@
         </p:blipFill>
         <p:spPr>
           <a:xfrm>
-            <a:off x="5962254" y="3502518"/>
+            <a:off x="5962254" y="3484230"/>
             <a:ext cx="163860" cy="163860"/>
           </a:xfrm>
           <a:prstGeom prst="rect">
@@ -5922,7 +6160,7 @@
         </p:nvSpPr>
         <p:spPr>
           <a:xfrm>
-            <a:off x="6309360" y="3401568"/>
+            <a:off x="6309360" y="3383280"/>
             <a:ext cx="2377440" cy="566928"/>
           </a:xfrm>
           <a:prstGeom prst="rect">
@@ -5958,7 +6196,7 @@
         </p:nvSpPr>
         <p:spPr>
           <a:xfrm>
-            <a:off x="5897880" y="4041648"/>
+            <a:off x="5897880" y="4014216"/>
             <a:ext cx="292608" cy="292608"/>
           </a:xfrm>
           <a:prstGeom prst="ellipse">
@@ -5991,7 +6229,7 @@
         </p:blipFill>
         <p:spPr>
           <a:xfrm>
-            <a:off x="5962254" y="4106022"/>
+            <a:off x="5962254" y="4078590"/>
             <a:ext cx="163860" cy="163860"/>
           </a:xfrm>
           <a:prstGeom prst="rect">
@@ -6007,7 +6245,7 @@
         </p:nvSpPr>
         <p:spPr>
           <a:xfrm>
-            <a:off x="6309360" y="4005072"/>
+            <a:off x="6309360" y="3977640"/>
             <a:ext cx="2377440" cy="566928"/>
           </a:xfrm>
           <a:prstGeom prst="rect">
@@ -6309,7 +6547,7 @@
               <a:buNone/>
             </a:pPr>
             <a:r>
-              <a:rPr lang="en-US" sz="1100" dirty="0">
+              <a:rPr lang="en-US" sz="1200" dirty="0">
                 <a:solidFill>
                   <a:srgbClr val="8B98A5"/>
                 </a:solidFill>
@@ -6319,14 +6557,14 @@
               </a:rPr>
               <a:t># 1. the tests first</a:t>
             </a:r>
-            <a:endParaRPr lang="en-US" sz="1100" dirty="0"/>
-          </a:p>
-          <a:p>
-            <a:pPr indent="0" marL="0">
-              <a:buNone/>
-            </a:pPr>
-            <a:r>
-              <a:rPr lang="en-US" sz="1100" dirty="0">
+            <a:endParaRPr lang="en-US" sz="1200" dirty="0"/>
+          </a:p>
+          <a:p>
+            <a:pPr indent="0" marL="0">
+              <a:buNone/>
+            </a:pPr>
+            <a:r>
+              <a:rPr lang="en-US" sz="1200" dirty="0">
                 <a:solidFill>
                   <a:srgbClr val="E6EDF3"/>
                 </a:solidFill>
@@ -6336,14 +6574,14 @@
               </a:rPr>
               <a:t>npm run verify       # read both Tests lines</a:t>
             </a:r>
-            <a:endParaRPr lang="en-US" sz="1100" dirty="0"/>
-          </a:p>
-          <a:p>
-            <a:pPr indent="0" marL="0">
-              <a:buNone/>
-            </a:pPr>
-            <a:r>
-              <a:rPr lang="en-US" sz="1100" dirty="0">
+            <a:endParaRPr lang="en-US" sz="1200" dirty="0"/>
+          </a:p>
+          <a:p>
+            <a:pPr indent="0" marL="0">
+              <a:buNone/>
+            </a:pPr>
+            <a:r>
+              <a:rPr lang="en-US" sz="1200" dirty="0">
                 <a:solidFill>
                   <a:srgbClr val="E6EDF3"/>
                 </a:solidFill>
@@ -6353,14 +6591,14 @@
               </a:rPr>
               <a:t>npm run lab 01       # the lab check: all green?</a:t>
             </a:r>
-            <a:endParaRPr lang="en-US" sz="1100" dirty="0"/>
-          </a:p>
-          <a:p>
-            <a:pPr indent="0" marL="0">
-              <a:buNone/>
-            </a:pPr>
-            <a:r>
-              <a:rPr lang="en-US" sz="1100" dirty="0">
+            <a:endParaRPr lang="en-US" sz="1200" dirty="0"/>
+          </a:p>
+          <a:p>
+            <a:pPr indent="0" marL="0">
+              <a:buNone/>
+            </a:pPr>
+            <a:r>
+              <a:rPr lang="en-US" sz="1200" dirty="0">
                 <a:solidFill>
                   <a:srgbClr val="8B98A5"/>
                 </a:solidFill>
@@ -6368,16 +6606,16 @@
                 <a:ea typeface="Courier New" pitchFamily="34" charset="-122"/>
                 <a:cs typeface="Courier New" pitchFamily="34" charset="-120"/>
               </a:rPr>
-              <a:t># 2. then the app on the seeded data</a:t>
-            </a:r>
-            <a:endParaRPr lang="en-US" sz="1100" dirty="0"/>
-          </a:p>
-          <a:p>
-            <a:pPr indent="0" marL="0">
-              <a:buNone/>
-            </a:pPr>
-            <a:r>
-              <a:rPr lang="en-US" sz="1100" dirty="0">
+              <a:t># 2. the app is still running from step 01:</a:t>
+            </a:r>
+            <a:endParaRPr lang="en-US" sz="1200" dirty="0"/>
+          </a:p>
+          <a:p>
+            <a:pPr indent="0" marL="0">
+              <a:buNone/>
+            </a:pPr>
+            <a:r>
+              <a:rPr lang="en-US" sz="1200" dirty="0">
                 <a:solidFill>
                   <a:srgbClr val="8B98A5"/>
                 </a:solidFill>
@@ -6385,50 +6623,50 @@
                 <a:ea typeface="Courier New" pitchFamily="34" charset="-122"/>
                 <a:cs typeface="Courier New" pitchFamily="34" charset="-120"/>
               </a:rPr>
-              <a:t>#    (port taken? the last line says so: PORT= in .env)</a:t>
-            </a:r>
-            <a:endParaRPr lang="en-US" sz="1100" dirty="0"/>
-          </a:p>
-          <a:p>
-            <a:pPr indent="0" marL="0">
-              <a:buNone/>
-            </a:pPr>
-            <a:r>
-              <a:rPr lang="en-US" sz="1100" dirty="0">
-                <a:solidFill>
-                  <a:srgbClr val="E6EDF3"/>
+              <a:t>#    your agent restarts it after each build</a:t>
+            </a:r>
+            <a:endParaRPr lang="en-US" sz="1200" dirty="0"/>
+          </a:p>
+          <a:p>
+            <a:pPr indent="0" marL="0">
+              <a:buNone/>
+            </a:pPr>
+            <a:r>
+              <a:rPr lang="en-US" sz="1200" dirty="0">
+                <a:solidFill>
+                  <a:srgbClr val="8B98A5"/>
                 </a:solidFill>
                 <a:latin typeface="Courier New" pitchFamily="34" charset="0"/>
                 <a:ea typeface="Courier New" pitchFamily="34" charset="-122"/>
                 <a:cs typeface="Courier New" pitchFamily="34" charset="-120"/>
               </a:rPr>
-              <a:t>npm run build</a:t>
-            </a:r>
-            <a:endParaRPr lang="en-US" sz="1100" dirty="0"/>
-          </a:p>
-          <a:p>
-            <a:pPr indent="0" marL="0">
-              <a:buNone/>
-            </a:pPr>
-            <a:r>
-              <a:rPr lang="en-US" sz="1100" dirty="0">
-                <a:solidFill>
-                  <a:srgbClr val="E6EDF3"/>
+              <a:t>#    (not running? npm run build, then npm start)</a:t>
+            </a:r>
+            <a:endParaRPr lang="en-US" sz="1200" dirty="0"/>
+          </a:p>
+          <a:p>
+            <a:pPr indent="0" marL="0">
+              <a:buNone/>
+            </a:pPr>
+            <a:r>
+              <a:rPr lang="en-US" sz="1200" dirty="0">
+                <a:solidFill>
+                  <a:srgbClr val="8B98A5"/>
                 </a:solidFill>
                 <a:latin typeface="Courier New" pitchFamily="34" charset="0"/>
                 <a:ea typeface="Courier New" pitchFamily="34" charset="-122"/>
                 <a:cs typeface="Courier New" pitchFamily="34" charset="-120"/>
               </a:rPr>
-              <a:t>npm start</a:t>
-            </a:r>
-            <a:endParaRPr lang="en-US" sz="1100" dirty="0"/>
-          </a:p>
-          <a:p>
-            <a:pPr indent="0" marL="0">
-              <a:buNone/>
-            </a:pPr>
-            <a:r>
-              <a:rPr lang="en-US" sz="1100" dirty="0">
+              <a:t># 3. open localhost:3000/playground (or your PORT)</a:t>
+            </a:r>
+            <a:endParaRPr lang="en-US" sz="1200" dirty="0"/>
+          </a:p>
+          <a:p>
+            <a:pPr indent="0" marL="0">
+              <a:buNone/>
+            </a:pPr>
+            <a:r>
+              <a:rPr lang="en-US" sz="1200" dirty="0">
                 <a:solidFill>
                   <a:srgbClr val="8B98A5"/>
                 </a:solidFill>
@@ -6436,26 +6674,9 @@
                 <a:ea typeface="Courier New" pitchFamily="34" charset="-122"/>
                 <a:cs typeface="Courier New" pitchFamily="34" charset="-120"/>
               </a:rPr>
-              <a:t># 3. open localhost:3000/playground (or your PORT)</a:t>
-            </a:r>
-            <a:endParaRPr lang="en-US" sz="1100" dirty="0"/>
-          </a:p>
-          <a:p>
-            <a:pPr indent="0" marL="0">
-              <a:buNone/>
-            </a:pPr>
-            <a:r>
-              <a:rPr lang="en-US" sz="1100" dirty="0">
-                <a:solidFill>
-                  <a:srgbClr val="8B98A5"/>
-                </a:solidFill>
-                <a:latin typeface="Courier New" pitchFamily="34" charset="0"/>
-                <a:ea typeface="Courier New" pitchFamily="34" charset="-122"/>
-                <a:cs typeface="Courier New" pitchFamily="34" charset="-120"/>
-              </a:rPr>
               <a:t>#    and click Run all in order</a:t>
             </a:r>
-            <a:endParaRPr lang="en-US" sz="1100" dirty="0"/>
+            <a:endParaRPr lang="en-US" sz="1200" dirty="0"/>
           </a:p>
         </p:txBody>
       </p:sp>
@@ -6604,7 +6825,7 @@
                   <a:srgbClr val="FFFFFF"/>
                 </a:solidFill>
               </a:rPr>
-              <a:t>2. List users (seeded)</a:t>
+              <a:t>2. Create user</a:t>
             </a:r>
             <a:endParaRPr lang="en-US" sz="1300" dirty="0"/>
           </a:p>
@@ -6618,7 +6839,7 @@
                   <a:srgbClr val="FFFFFF"/>
                 </a:solidFill>
               </a:rPr>
-              <a:t>3. Create user</a:t>
+              <a:t>3. List users (seeded)</a:t>
             </a:r>
             <a:endParaRPr lang="en-US" sz="1300" dirty="0"/>
           </a:p>
@@ -6952,7 +7173,7 @@
                   <a:srgbClr val="2B3440"/>
                 </a:solidFill>
               </a:rPr>
-              <a:t>19 of 19 cards ✓ in our dry run</a:t>
+              <a:t>36 of 36 cards ✓ in our dry run</a:t>
             </a:r>
             <a:endParaRPr lang="en-US" sz="1200" dirty="0"/>
           </a:p>
@@ -7037,7 +7258,7 @@
                   <a:srgbClr val="2B3440"/>
                 </a:solidFill>
               </a:rPr>
-              <a:t>Variables filled: the ids carry over</a:t>
+              <a:t>Each card names its lab 01 check</a:t>
             </a:r>
             <a:endParaRPr lang="en-US" sz="1200" dirty="0"/>
           </a:p>
@@ -7122,7 +7343,7 @@
                   <a:srgbClr val="2B3440"/>
                 </a:solidFill>
               </a:rPr>
-              <a:t>409 and 422 cards ✓ too: the rule said no</a:t>
+              <a:t>Variables filled: the ids carry over</a:t>
             </a:r>
             <a:endParaRPr lang="en-US" sz="1200" dirty="0"/>
           </a:p>
@@ -7207,7 +7428,7 @@
                   <a:srgbClr val="2B3440"/>
                 </a:solidFill>
               </a:rPr>
-              <a:t>Red in DevTools for those: expected</a:t>
+              <a:t>409 and 422 cards ✓ too: the rule said no</a:t>
             </a:r>
             <a:endParaRPr lang="en-US" sz="1200" dirty="0"/>
           </a:p>
@@ -7292,7 +7513,7 @@
                   <a:srgbClr val="2B3440"/>
                 </a:solidFill>
               </a:rPr>
-              <a:t>List users shows the 25 seeded users</a:t>
+              <a:t>Not built or not restarted: ✗ "no such route"</a:t>
             </a:r>
             <a:endParaRPr lang="en-US" sz="1200" dirty="0"/>
           </a:p>
@@ -7580,7 +7801,7 @@
                 <a:ea typeface="Courier New" pitchFamily="34" charset="-122"/>
                 <a:cs typeface="Courier New" pitchFamily="34" charset="-120"/>
               </a:rPr>
-              <a:t># npm run verify (base: 21 unit, 5 e2e)</a:t>
+              <a:t># npm run verify (base: 21 unit, 6 e2e)</a:t>
             </a:r>
             <a:endParaRPr lang="en-US" sz="1200" dirty="0"/>
           </a:p>
@@ -7614,7 +7835,7 @@
                 <a:ea typeface="Courier New" pitchFamily="34" charset="-122"/>
                 <a:cs typeface="Courier New" pitchFamily="34" charset="-120"/>
               </a:rPr>
-              <a:t>Tests  49 passed (49)</a:t>
+              <a:t>Tests  50 passed (50)</a:t>
             </a:r>
             <a:endParaRPr lang="en-US" sz="1200" dirty="0"/>
           </a:p>
@@ -10422,7 +10643,7 @@
         </p:nvSpPr>
         <p:spPr>
           <a:xfrm>
-            <a:off x="5897880" y="2834640"/>
+            <a:off x="5897880" y="2825496"/>
             <a:ext cx="292608" cy="292608"/>
           </a:xfrm>
           <a:prstGeom prst="ellipse">
@@ -10455,7 +10676,7 @@
         </p:blipFill>
         <p:spPr>
           <a:xfrm>
-            <a:off x="5962254" y="2899014"/>
+            <a:off x="5962254" y="2889870"/>
             <a:ext cx="163860" cy="163860"/>
           </a:xfrm>
           <a:prstGeom prst="rect">
@@ -10471,7 +10692,7 @@
         </p:nvSpPr>
         <p:spPr>
           <a:xfrm>
-            <a:off x="6309360" y="2798064"/>
+            <a:off x="6309360" y="2788920"/>
             <a:ext cx="2377440" cy="566928"/>
           </a:xfrm>
           <a:prstGeom prst="rect">
@@ -10507,7 +10728,7 @@
         </p:nvSpPr>
         <p:spPr>
           <a:xfrm>
-            <a:off x="5897880" y="3438144"/>
+            <a:off x="5897880" y="3419856"/>
             <a:ext cx="292608" cy="292608"/>
           </a:xfrm>
           <a:prstGeom prst="ellipse">
@@ -10540,7 +10761,7 @@
         </p:blipFill>
         <p:spPr>
           <a:xfrm>
-            <a:off x="5962254" y="3502518"/>
+            <a:off x="5962254" y="3484230"/>
             <a:ext cx="163860" cy="163860"/>
           </a:xfrm>
           <a:prstGeom prst="rect">
@@ -10556,7 +10777,7 @@
         </p:nvSpPr>
         <p:spPr>
           <a:xfrm>
-            <a:off x="6309360" y="3401568"/>
+            <a:off x="6309360" y="3383280"/>
             <a:ext cx="2377440" cy="566928"/>
           </a:xfrm>
           <a:prstGeom prst="rect">
@@ -10592,7 +10813,7 @@
         </p:nvSpPr>
         <p:spPr>
           <a:xfrm>
-            <a:off x="5897880" y="4041648"/>
+            <a:off x="5897880" y="4014216"/>
             <a:ext cx="292608" cy="292608"/>
           </a:xfrm>
           <a:prstGeom prst="ellipse">
@@ -10625,7 +10846,7 @@
         </p:blipFill>
         <p:spPr>
           <a:xfrm>
-            <a:off x="5962254" y="4106022"/>
+            <a:off x="5962254" y="4078590"/>
             <a:ext cx="163860" cy="163860"/>
           </a:xfrm>
           <a:prstGeom prst="rect">
@@ -10641,7 +10862,7 @@
         </p:nvSpPr>
         <p:spPr>
           <a:xfrm>
-            <a:off x="6309360" y="4005072"/>
+            <a:off x="6309360" y="3977640"/>
             <a:ext cx="2377440" cy="566928"/>
           </a:xfrm>
           <a:prstGeom prst="rect">
@@ -12314,7 +12535,7 @@
                 <a:ea typeface="Courier New" pitchFamily="34" charset="-122"/>
                 <a:cs typeface="Courier New" pitchFamily="34" charset="-120"/>
               </a:rPr>
-              <a:t>Tests  47 passed (47) · 58 passed (58)</a:t>
+              <a:t>Tests  47 passed (47) · 59 passed (59)</a:t>
             </a:r>
             <a:endParaRPr lang="en-US" sz="1200" dirty="0"/>
           </a:p>
@@ -15576,7 +15797,7 @@
                   <a:srgbClr val="2B3440"/>
                 </a:solidFill>
               </a:rPr>
-              <a:t>data/app.db ships seeded. Change it freely while you try things; </a:t>
+              <a:t>data/app.db ships seeded. Change it freely while you try things; stop the app and </a:t>
             </a:r>
             <a:pPr indent="0" marL="0">
               <a:buNone/>
@@ -15907,7 +16128,7 @@
                   <a:srgbClr val="2B3440"/>
                 </a:solidFill>
               </a:rPr>
-              <a:t>Each Send calls the real controller and shows the status, a ✓ when it is the one the specs expect, and the body. Run all in order chains the ids.</a:t>
+              <a:t>Each request mirrors a lab 01 check; Send calls the real controller and shows the status, a ✓ when it is the one the specs expect, and the body. Run all in order chains the ids.</a:t>
             </a:r>
             <a:endParaRPr lang="en-US" sz="1800" dirty="0"/>
           </a:p>
@@ -16006,7 +16227,7 @@
                   <a:srgbClr val="2B3440"/>
                 </a:solidFill>
               </a:rPr>
-              <a:t>Requests create, change and delete rows in data/app.db. </a:t>
+              <a:t>Requests create, change and delete rows in data/app.db. To restore it: stop the app, </a:t>
             </a:r>
             <a:pPr indent="0" marL="0">
               <a:buNone/>
@@ -16031,7 +16252,7 @@
                   <a:srgbClr val="2B3440"/>
                 </a:solidFill>
               </a:rPr>
-              <a:t> restores the seeded data.</a:t>
+              <a:t>, start it again.</a:t>
             </a:r>
             <a:endParaRPr lang="en-US" sz="1800" dirty="0"/>
           </a:p>

</xml_diff>

<commit_message>
steps/01-03: open the playground for the learner after each step
Once a step's checks pass, the agent opens the playground in the learner's browser (start
<url> on Windows). Slides 10-12 read the text from the step files.

Co-Authored-By: Claude Opus 5.5 (1M context) <noreply@anthropic.com>
</commit_message>
<xml_diff>
--- a/docs/ai-agent-training/slides/lab-companion.pptx
+++ b/docs/ai-agent-training/slides/lab-companion.pptx
@@ -4028,7 +4028,7 @@
                 <a:ea typeface="Courier New" pitchFamily="34" charset="-122"/>
                 <a:cs typeface="Courier New" pitchFamily="34" charset="-120"/>
               </a:rPr>
-              <a:t>start the app, leave it running, and give me the</a:t>
+              <a:t>start the app, leave it running, and open the playground</a:t>
             </a:r>
             <a:endParaRPr lang="en-US" sz="1000" dirty="0"/>
           </a:p>
@@ -4045,7 +4045,7 @@
                 <a:ea typeface="Courier New" pitchFamily="34" charset="-122"/>
                 <a:cs typeface="Courier New" pitchFamily="34" charset="-120"/>
               </a:rPr>
-              <a:t>playground link (http://localhost:3000/playground, or my</a:t>
+              <a:t>in my browser (http://localhost:3000/playground, or my</a:t>
             </a:r>
             <a:endParaRPr lang="en-US" sz="1000" dirty="0"/>
           </a:p>
@@ -4062,7 +4062,7 @@
                 <a:ea typeface="Courier New" pitchFamily="34" charset="-122"/>
                 <a:cs typeface="Courier New" pitchFamily="34" charset="-120"/>
               </a:rPr>
-              <a:t>port) so I can review it. Then show me what is in the</a:t>
+              <a:t>port; on Windows start &lt;url&gt;) so I can review it. Then</a:t>
             </a:r>
             <a:endParaRPr lang="en-US" sz="1000" dirty="0"/>
           </a:p>
@@ -4079,7 +4079,24 @@
                 <a:ea typeface="Courier New" pitchFamily="34" charset="-122"/>
                 <a:cs typeface="Courier New" pitchFamily="34" charset="-120"/>
               </a:rPr>
-              <a:t>database. Then stop and wait for my next instruction.</a:t>
+              <a:t>show me what is in the database. Then stop and wait for my</a:t>
+            </a:r>
+            <a:endParaRPr lang="en-US" sz="1000" dirty="0"/>
+          </a:p>
+          <a:p>
+            <a:pPr indent="0" marL="0">
+              <a:buNone/>
+            </a:pPr>
+            <a:r>
+              <a:rPr lang="en-US" sz="1000" dirty="0">
+                <a:solidFill>
+                  <a:srgbClr val="E6EDF3"/>
+                </a:solidFill>
+                <a:latin typeface="Courier New" pitchFamily="34" charset="0"/>
+                <a:ea typeface="Courier New" pitchFamily="34" charset="-122"/>
+                <a:cs typeface="Courier New" pitchFamily="34" charset="-120"/>
+              </a:rPr>
+              <a:t>next instruction.</a:t>
             </a:r>
             <a:endParaRPr lang="en-US" sz="1000" dirty="0"/>
           </a:p>
@@ -4455,7 +4472,7 @@
                   <a:srgbClr val="1B1F24"/>
                 </a:solidFill>
               </a:rPr>
-              <a:t>leaves the app running: the /playground link</a:t>
+              <a:t>leaves the app running, opens the playground</a:t>
             </a:r>
             <a:endParaRPr lang="en-US" sz="1200" dirty="0"/>
           </a:p>
@@ -5019,7 +5036,24 @@
                 <a:ea typeface="Courier New" pitchFamily="34" charset="-122"/>
                 <a:cs typeface="Courier New" pitchFamily="34" charset="-120"/>
               </a:rPr>
-              <a:t>requests as the playground page). Then stop and wait for</a:t>
+              <a:t>requests as the playground page). Then open the playground</a:t>
+            </a:r>
+            <a:endParaRPr lang="en-US" sz="1000" dirty="0"/>
+          </a:p>
+          <a:p>
+            <a:pPr indent="0" marL="0">
+              <a:buNone/>
+            </a:pPr>
+            <a:r>
+              <a:rPr lang="en-US" sz="1000" dirty="0">
+                <a:solidFill>
+                  <a:srgbClr val="E6EDF3"/>
+                </a:solidFill>
+                <a:latin typeface="Courier New" pitchFamily="34" charset="0"/>
+                <a:ea typeface="Courier New" pitchFamily="34" charset="-122"/>
+                <a:cs typeface="Courier New" pitchFamily="34" charset="-120"/>
+              </a:rPr>
+              <a:t>in my browser so I can review it. Then stop and wait for</a:t>
             </a:r>
             <a:endParaRPr lang="en-US" sz="1000" dirty="0"/>
           </a:p>
@@ -5875,6 +5909,23 @@
                 <a:cs typeface="Courier New" pitchFamily="34" charset="-120"/>
               </a:rPr>
               <a:t>passes against it (every request of the playground page).</a:t>
+            </a:r>
+            <a:endParaRPr lang="en-US" sz="1000" dirty="0"/>
+          </a:p>
+          <a:p>
+            <a:pPr indent="0" marL="0">
+              <a:buNone/>
+            </a:pPr>
+            <a:r>
+              <a:rPr lang="en-US" sz="1000" dirty="0">
+                <a:solidFill>
+                  <a:srgbClr val="E6EDF3"/>
+                </a:solidFill>
+                <a:latin typeface="Courier New" pitchFamily="34" charset="0"/>
+                <a:ea typeface="Courier New" pitchFamily="34" charset="-122"/>
+                <a:cs typeface="Courier New" pitchFamily="34" charset="-120"/>
+              </a:rPr>
+              <a:t>Then open the playground in my browser so I can review it.</a:t>
             </a:r>
             <a:endParaRPr lang="en-US" sz="1000" dirty="0"/>
           </a:p>

</xml_diff>